<commit_message>
fix: deterministic UTF-8 stdio for skill scripts + timeline label overlap
- skill scripts force UTF-8 stdout/stderr (piped subprocess on Windows
  defaults to the ANSI codepage and fails on CJK JSON — CI-visible)
- timeline labels bounded by node spacing (no overlap for 5+ nodes)
- COM render test asserts preview PNGs are 1920x1080 (header-parse, no deps)
</commit_message>
<xml_diff>
--- a/examples/output/draft-dcc-mcp-framework-intro.pptx
+++ b/examples/output/draft-dcc-mcp-framework-intro.pptx
@@ -7658,8 +7658,8 @@
         </p:nvSpPr>
         <p:spPr>
           <a:xfrm>
-            <a:off x="228599" y="3520440"/>
-            <a:ext cx="3291840" cy="1097280"/>
+            <a:off x="891539" y="3520440"/>
+            <a:ext cx="1965960" cy="1097280"/>
           </a:xfrm>
           <a:prstGeom prst="rect">
             <a:avLst/>
@@ -7739,8 +7739,8 @@
         </p:nvSpPr>
         <p:spPr>
           <a:xfrm>
-            <a:off x="2331719" y="3520440"/>
-            <a:ext cx="3291840" cy="1097280"/>
+            <a:off x="2994659" y="3520440"/>
+            <a:ext cx="1965960" cy="1097280"/>
           </a:xfrm>
           <a:prstGeom prst="rect">
             <a:avLst/>
@@ -7820,8 +7820,8 @@
         </p:nvSpPr>
         <p:spPr>
           <a:xfrm>
-            <a:off x="4434840" y="3520440"/>
-            <a:ext cx="3291840" cy="1097280"/>
+            <a:off x="5097780" y="3520440"/>
+            <a:ext cx="1965960" cy="1097280"/>
           </a:xfrm>
           <a:prstGeom prst="rect">
             <a:avLst/>
@@ -7901,8 +7901,8 @@
         </p:nvSpPr>
         <p:spPr>
           <a:xfrm>
-            <a:off x="6537959" y="3520440"/>
-            <a:ext cx="3291840" cy="1097280"/>
+            <a:off x="7200899" y="3520440"/>
+            <a:ext cx="1965960" cy="1097280"/>
           </a:xfrm>
           <a:prstGeom prst="rect">
             <a:avLst/>
@@ -7982,8 +7982,8 @@
         </p:nvSpPr>
         <p:spPr>
           <a:xfrm>
-            <a:off x="8641080" y="3520440"/>
-            <a:ext cx="3291840" cy="1097280"/>
+            <a:off x="9304020" y="3520440"/>
+            <a:ext cx="1965960" cy="1097280"/>
           </a:xfrm>
           <a:prstGeom prst="rect">
             <a:avLst/>

</xml_diff>

<commit_message>
refactor: explicit CJK typeface + page numbers for professional deck polish
- _set_run_font sets a:latin (Segoe UI) and a:ea (Microsoft YaHei)
  separately — no per-character font fallback in PowerPoint
- every slide carries a muted page counter (02 / 12 style)
- regenerated showcase artifacts (examples/output)
</commit_message>
<xml_diff>
--- a/examples/output/draft-dcc-mcp-framework-intro.pptx
+++ b/examples/output/draft-dcc-mcp-framework-intro.pptx
@@ -4451,7 +4451,7 @@
                   <a:srgbClr val="E8ECF2"/>
                 </a:solidFill>
                 <a:latin typeface="Segoe UI"/>
-                <a:ea typeface="Segoe UI"/>
+                <a:ea typeface="Microsoft YaHei"/>
               </a:rPr>
               <a:t>DCC-MCP</a:t>
             </a:r>
@@ -4488,7 +4488,7 @@
                   <a:srgbClr val="9AA7BC"/>
                 </a:solidFill>
                 <a:latin typeface="Segoe UI"/>
-                <a:ea typeface="Segoe UI"/>
+                <a:ea typeface="Microsoft YaHei"/>
               </a:rPr>
               <a:t>多 DCC 统一智能体网关框架</a:t>
             </a:r>
@@ -4501,7 +4501,7 @@
                   <a:srgbClr val="9AA7BC"/>
                 </a:solidFill>
                 <a:latin typeface="Segoe UI"/>
-                <a:ea typeface="Segoe UI"/>
+                <a:ea typeface="Microsoft YaHei"/>
               </a:rPr>
               <a:t>让 AI 进入每一个创作工具 · Maya / Blender / Houdini / Photoshop / Unity / Office</a:t>
             </a:r>
@@ -4538,9 +4538,46 @@
                   <a:srgbClr val="9AA7BC"/>
                 </a:solidFill>
                 <a:latin typeface="Segoe UI"/>
-                <a:ea typeface="Segoe UI"/>
+                <a:ea typeface="Microsoft YaHei"/>
               </a:rPr>
               <a:t>DCC-MCP 框架介绍 · draft:dcc-mcp-framework-intro</a:t>
+            </a:r>
+          </a:p>
+        </p:txBody>
+      </p:sp>
+      <p:sp>
+        <p:nvSpPr>
+          <p:cNvPr id="8" name="TextBox 7"/>
+          <p:cNvSpPr txBox="1"/>
+          <p:nvPr/>
+        </p:nvSpPr>
+        <p:spPr>
+          <a:xfrm>
+            <a:off x="10728655" y="6400800"/>
+            <a:ext cx="1097280" cy="320040"/>
+          </a:xfrm>
+          <a:prstGeom prst="rect">
+            <a:avLst/>
+          </a:prstGeom>
+          <a:noFill/>
+          <a:effectLst/>
+        </p:spPr>
+        <p:txBody>
+          <a:bodyPr wrap="none">
+            <a:spAutoFit/>
+          </a:bodyPr>
+          <a:lstStyle/>
+          <a:p>
+            <a:pPr algn="r"/>
+            <a:r>
+              <a:rPr sz="1000" b="0">
+                <a:solidFill>
+                  <a:srgbClr val="9AA7BC"/>
+                </a:solidFill>
+                <a:latin typeface="Segoe UI"/>
+                <a:ea typeface="Microsoft YaHei"/>
+              </a:rPr>
+              <a:t>01 / 12</a:t>
             </a:r>
           </a:p>
         </p:txBody>
@@ -4637,7 +4674,7 @@
                   <a:srgbClr val="E8ECF2"/>
                 </a:solidFill>
                 <a:latin typeface="Segoe UI"/>
-                <a:ea typeface="Segoe UI"/>
+                <a:ea typeface="Microsoft YaHei"/>
               </a:rPr>
               <a:t>Office 双后端</a:t>
             </a:r>
@@ -4693,7 +4730,7 @@
                   <a:srgbClr val="E8ECF2"/>
                 </a:solidFill>
                 <a:latin typeface="Segoe UI"/>
-                <a:ea typeface="Segoe UI"/>
+                <a:ea typeface="Microsoft YaHei"/>
               </a:rPr>
               <a:t>Rust Gateway（dcc-mcp-core）：控制面 · Job · Artifact · 安全策略</a:t>
             </a:r>
@@ -4749,7 +4786,7 @@
                   <a:srgbClr val="E8ECF2"/>
                 </a:solidFill>
                 <a:latin typeface="Segoe UI"/>
-                <a:ea typeface="Segoe UI"/>
+                <a:ea typeface="Microsoft YaHei"/>
               </a:rPr>
               <a:t>office-host.exe（C#）：每应用独立 Sidecar · 单 STA 队列</a:t>
             </a:r>
@@ -4805,7 +4842,7 @@
                   <a:srgbClr val="E8ECF2"/>
                 </a:solidFill>
                 <a:latin typeface="Segoe UI"/>
-                <a:ea typeface="Segoe UI"/>
+                <a:ea typeface="Microsoft YaHei"/>
               </a:rPr>
               <a:t>POWERPNT / WINWORD / EXCEL（COM 数据面）</a:t>
             </a:r>
@@ -4861,7 +4898,7 @@
                   <a:srgbClr val="E8ECF2"/>
                 </a:solidFill>
                 <a:latin typeface="Segoe UI"/>
-                <a:ea typeface="Segoe UI"/>
+                <a:ea typeface="Microsoft YaHei"/>
               </a:rPr>
               <a:t>Open XML Worker：批量结构处理（编译器，非渲染器）</a:t>
             </a:r>
@@ -4917,7 +4954,7 @@
                   <a:srgbClr val="E8ECF2"/>
                 </a:solidFill>
                 <a:latin typeface="Segoe UI"/>
-                <a:ea typeface="Segoe UI"/>
+                <a:ea typeface="Microsoft YaHei"/>
               </a:rPr>
               <a:t>Microsoft Graph / Office.js / UIA-CUA：云与兜底路径</a:t>
             </a:r>
@@ -4960,6 +4997,43 @@
           </a:fontRef>
         </p:style>
       </p:cxnSp>
+      <p:sp>
+        <p:nvSpPr>
+          <p:cNvPr id="10" name="TextBox 9"/>
+          <p:cNvSpPr txBox="1"/>
+          <p:nvPr/>
+        </p:nvSpPr>
+        <p:spPr>
+          <a:xfrm>
+            <a:off x="10728655" y="6400800"/>
+            <a:ext cx="1097280" cy="320040"/>
+          </a:xfrm>
+          <a:prstGeom prst="rect">
+            <a:avLst/>
+          </a:prstGeom>
+          <a:noFill/>
+          <a:effectLst/>
+        </p:spPr>
+        <p:txBody>
+          <a:bodyPr wrap="none">
+            <a:spAutoFit/>
+          </a:bodyPr>
+          <a:lstStyle/>
+          <a:p>
+            <a:pPr algn="r"/>
+            <a:r>
+              <a:rPr sz="1000" b="0">
+                <a:solidFill>
+                  <a:srgbClr val="9AA7BC"/>
+                </a:solidFill>
+                <a:latin typeface="Segoe UI"/>
+                <a:ea typeface="Microsoft YaHei"/>
+              </a:rPr>
+              <a:t>10 / 12</a:t>
+            </a:r>
+          </a:p>
+        </p:txBody>
+      </p:sp>
     </p:spTree>
   </p:cSld>
   <p:clrMapOvr>
@@ -5052,7 +5126,7 @@
                   <a:srgbClr val="E8ECF2"/>
                 </a:solidFill>
                 <a:latin typeface="Segoe UI"/>
-                <a:ea typeface="Segoe UI"/>
+                <a:ea typeface="Microsoft YaHei"/>
               </a:rPr>
               <a:t>设计取舍</a:t>
             </a:r>
@@ -5108,7 +5182,7 @@
                   <a:srgbClr val="E8ECF2"/>
                 </a:solidFill>
                 <a:latin typeface="Segoe UI"/>
-                <a:ea typeface="Segoe UI"/>
+                <a:ea typeface="Microsoft YaHei"/>
               </a:rPr>
               <a:t>结构化 API 优先</a:t>
             </a:r>
@@ -5164,7 +5238,7 @@
                   <a:srgbClr val="E8ECF2"/>
                 </a:solidFill>
                 <a:latin typeface="Segoe UI"/>
-                <a:ea typeface="Segoe UI"/>
+                <a:ea typeface="Microsoft YaHei"/>
               </a:rPr>
               <a:t>●  确定性、可验证、可审计</a:t>
             </a:r>
@@ -5177,7 +5251,7 @@
                   <a:srgbClr val="E8ECF2"/>
                 </a:solidFill>
                 <a:latin typeface="Segoe UI"/>
-                <a:ea typeface="Segoe UI"/>
+                <a:ea typeface="Microsoft YaHei"/>
               </a:rPr>
               <a:t>●  UIA/CUA 只做最后兜底</a:t>
             </a:r>
@@ -5190,7 +5264,7 @@
                   <a:srgbClr val="E8ECF2"/>
                 </a:solidFill>
                 <a:latin typeface="Segoe UI"/>
-                <a:ea typeface="Segoe UI"/>
+                <a:ea typeface="Microsoft YaHei"/>
               </a:rPr>
               <a:t>●  写操作不得静默降级</a:t>
             </a:r>
@@ -5246,7 +5320,7 @@
                   <a:srgbClr val="E8ECF2"/>
                 </a:solidFill>
                 <a:latin typeface="Segoe UI"/>
-                <a:ea typeface="Segoe UI"/>
+                <a:ea typeface="Microsoft YaHei"/>
               </a:rPr>
               <a:t>任务级能力</a:t>
             </a:r>
@@ -5302,7 +5376,7 @@
                   <a:srgbClr val="E8ECF2"/>
                 </a:solidFill>
                 <a:latin typeface="Segoe UI"/>
-                <a:ea typeface="Segoe UI"/>
+                <a:ea typeface="Microsoft YaHei"/>
               </a:rPr>
               <a:t>●  不暴露原始 COM 成员</a:t>
             </a:r>
@@ -5315,7 +5389,7 @@
                   <a:srgbClr val="E8ECF2"/>
                 </a:solidFill>
                 <a:latin typeface="Segoe UI"/>
-                <a:ea typeface="Segoe UI"/>
+                <a:ea typeface="Microsoft YaHei"/>
               </a:rPr>
               <a:t>●  模板优先于自由坐标</a:t>
             </a:r>
@@ -5328,9 +5402,46 @@
                   <a:srgbClr val="E8ECF2"/>
                 </a:solidFill>
                 <a:latin typeface="Segoe UI"/>
-                <a:ea typeface="Segoe UI"/>
+                <a:ea typeface="Microsoft YaHei"/>
               </a:rPr>
               <a:t>●  检查点 + 预览 + 可追踪结果</a:t>
+            </a:r>
+          </a:p>
+        </p:txBody>
+      </p:sp>
+      <p:sp>
+        <p:nvSpPr>
+          <p:cNvPr id="8" name="TextBox 7"/>
+          <p:cNvSpPr txBox="1"/>
+          <p:nvPr/>
+        </p:nvSpPr>
+        <p:spPr>
+          <a:xfrm>
+            <a:off x="10728655" y="6400800"/>
+            <a:ext cx="1097280" cy="320040"/>
+          </a:xfrm>
+          <a:prstGeom prst="rect">
+            <a:avLst/>
+          </a:prstGeom>
+          <a:noFill/>
+          <a:effectLst/>
+        </p:spPr>
+        <p:txBody>
+          <a:bodyPr wrap="none">
+            <a:spAutoFit/>
+          </a:bodyPr>
+          <a:lstStyle/>
+          <a:p>
+            <a:pPr algn="r"/>
+            <a:r>
+              <a:rPr sz="1000" b="0">
+                <a:solidFill>
+                  <a:srgbClr val="9AA7BC"/>
+                </a:solidFill>
+                <a:latin typeface="Segoe UI"/>
+                <a:ea typeface="Microsoft YaHei"/>
+              </a:rPr>
+              <a:t>11 / 12</a:t>
             </a:r>
           </a:p>
         </p:txBody>
@@ -5471,7 +5582,7 @@
                   <a:srgbClr val="E8ECF2"/>
                 </a:solidFill>
                 <a:latin typeface="Segoe UI"/>
-                <a:ea typeface="Segoe UI"/>
+                <a:ea typeface="Microsoft YaHei"/>
               </a:rPr>
               <a:t>Thanks</a:t>
             </a:r>
@@ -5508,9 +5619,46 @@
                   <a:srgbClr val="9AA7BC"/>
                 </a:solidFill>
                 <a:latin typeface="Segoe UI"/>
-                <a:ea typeface="Segoe UI"/>
+                <a:ea typeface="Microsoft YaHei"/>
               </a:rPr>
               <a:t>dcc-mcp · 让 AI 进入每一个创作工具</a:t>
+            </a:r>
+          </a:p>
+        </p:txBody>
+      </p:sp>
+      <p:sp>
+        <p:nvSpPr>
+          <p:cNvPr id="6" name="TextBox 5"/>
+          <p:cNvSpPr txBox="1"/>
+          <p:nvPr/>
+        </p:nvSpPr>
+        <p:spPr>
+          <a:xfrm>
+            <a:off x="10728655" y="6400800"/>
+            <a:ext cx="1097280" cy="320040"/>
+          </a:xfrm>
+          <a:prstGeom prst="rect">
+            <a:avLst/>
+          </a:prstGeom>
+          <a:noFill/>
+          <a:effectLst/>
+        </p:spPr>
+        <p:txBody>
+          <a:bodyPr wrap="none">
+            <a:spAutoFit/>
+          </a:bodyPr>
+          <a:lstStyle/>
+          <a:p>
+            <a:pPr algn="r"/>
+            <a:r>
+              <a:rPr sz="1000" b="0">
+                <a:solidFill>
+                  <a:srgbClr val="9AA7BC"/>
+                </a:solidFill>
+                <a:latin typeface="Segoe UI"/>
+                <a:ea typeface="Microsoft YaHei"/>
+              </a:rPr>
+              <a:t>12 / 12</a:t>
             </a:r>
           </a:p>
         </p:txBody>
@@ -5695,9 +5843,46 @@
                   <a:srgbClr val="E8ECF2"/>
                 </a:solidFill>
                 <a:latin typeface="Segoe UI"/>
-                <a:ea typeface="Segoe UI"/>
+                <a:ea typeface="Microsoft YaHei"/>
               </a:rPr>
               <a:t>01 · 框架总览</a:t>
+            </a:r>
+          </a:p>
+        </p:txBody>
+      </p:sp>
+      <p:sp>
+        <p:nvSpPr>
+          <p:cNvPr id="6" name="TextBox 5"/>
+          <p:cNvSpPr txBox="1"/>
+          <p:nvPr/>
+        </p:nvSpPr>
+        <p:spPr>
+          <a:xfrm>
+            <a:off x="10728655" y="6400800"/>
+            <a:ext cx="1097280" cy="320040"/>
+          </a:xfrm>
+          <a:prstGeom prst="rect">
+            <a:avLst/>
+          </a:prstGeom>
+          <a:noFill/>
+          <a:effectLst/>
+        </p:spPr>
+        <p:txBody>
+          <a:bodyPr wrap="none">
+            <a:spAutoFit/>
+          </a:bodyPr>
+          <a:lstStyle/>
+          <a:p>
+            <a:pPr algn="r"/>
+            <a:r>
+              <a:rPr sz="1000" b="0">
+                <a:solidFill>
+                  <a:srgbClr val="9AA7BC"/>
+                </a:solidFill>
+                <a:latin typeface="Segoe UI"/>
+                <a:ea typeface="Microsoft YaHei"/>
+              </a:rPr>
+              <a:t>02 / 12</a:t>
             </a:r>
           </a:p>
         </p:txBody>
@@ -5794,7 +5979,7 @@
                   <a:srgbClr val="E8ECF2"/>
                 </a:solidFill>
                 <a:latin typeface="Segoe UI"/>
-                <a:ea typeface="Segoe UI"/>
+                <a:ea typeface="Microsoft YaHei"/>
               </a:rPr>
               <a:t>什么是 DCC-MCP</a:t>
             </a:r>
@@ -5850,7 +6035,7 @@
                   <a:srgbClr val="E8ECF2"/>
                 </a:solidFill>
                 <a:latin typeface="Segoe UI"/>
-                <a:ea typeface="Segoe UI"/>
+                <a:ea typeface="Microsoft YaHei"/>
               </a:rPr>
               <a:t>●  面向数字内容创作（DCC）工具的统一 MCP 网关生态</a:t>
             </a:r>
@@ -5906,7 +6091,7 @@
                   <a:srgbClr val="E8ECF2"/>
                 </a:solidFill>
                 <a:latin typeface="Segoe UI"/>
-                <a:ea typeface="Segoe UI"/>
+                <a:ea typeface="Microsoft YaHei"/>
               </a:rPr>
               <a:t>●  一个 DCC 一个适配器仓库：Maya、Blender、Houdini、Photoshop、Unity、Office…</a:t>
             </a:r>
@@ -5962,7 +6147,7 @@
                   <a:srgbClr val="E8ECF2"/>
                 </a:solidFill>
                 <a:latin typeface="Segoe UI"/>
-                <a:ea typeface="Segoe UI"/>
+                <a:ea typeface="Microsoft YaHei"/>
               </a:rPr>
               <a:t>●  统一的能力发现机制：list → search → load_skill → call</a:t>
             </a:r>
@@ -6018,9 +6203,46 @@
                   <a:srgbClr val="E8ECF2"/>
                 </a:solidFill>
                 <a:latin typeface="Segoe UI"/>
-                <a:ea typeface="Segoe UI"/>
+                <a:ea typeface="Microsoft YaHei"/>
               </a:rPr>
               <a:t>●  Skills 机制：把稳定流程固化为可复用的技能包</a:t>
+            </a:r>
+          </a:p>
+        </p:txBody>
+      </p:sp>
+      <p:sp>
+        <p:nvSpPr>
+          <p:cNvPr id="8" name="TextBox 7"/>
+          <p:cNvSpPr txBox="1"/>
+          <p:nvPr/>
+        </p:nvSpPr>
+        <p:spPr>
+          <a:xfrm>
+            <a:off x="10728655" y="6400800"/>
+            <a:ext cx="1097280" cy="320040"/>
+          </a:xfrm>
+          <a:prstGeom prst="rect">
+            <a:avLst/>
+          </a:prstGeom>
+          <a:noFill/>
+          <a:effectLst/>
+        </p:spPr>
+        <p:txBody>
+          <a:bodyPr wrap="none">
+            <a:spAutoFit/>
+          </a:bodyPr>
+          <a:lstStyle/>
+          <a:p>
+            <a:pPr algn="r"/>
+            <a:r>
+              <a:rPr sz="1000" b="0">
+                <a:solidFill>
+                  <a:srgbClr val="9AA7BC"/>
+                </a:solidFill>
+                <a:latin typeface="Segoe UI"/>
+                <a:ea typeface="Microsoft YaHei"/>
+              </a:rPr>
+              <a:t>03 / 12</a:t>
             </a:r>
           </a:p>
         </p:txBody>
@@ -6117,7 +6339,7 @@
                   <a:srgbClr val="E8ECF2"/>
                 </a:solidFill>
                 <a:latin typeface="Segoe UI"/>
-                <a:ea typeface="Segoe UI"/>
+                <a:ea typeface="Microsoft YaHei"/>
               </a:rPr>
               <a:t>总体架构</a:t>
             </a:r>
@@ -6173,7 +6395,7 @@
                   <a:srgbClr val="E8ECF2"/>
                 </a:solidFill>
                 <a:latin typeface="Segoe UI"/>
-                <a:ea typeface="Segoe UI"/>
+                <a:ea typeface="Microsoft YaHei"/>
               </a:rPr>
               <a:t>Agent / MCP Client / IDE / CI</a:t>
             </a:r>
@@ -6229,7 +6451,7 @@
                   <a:srgbClr val="E8ECF2"/>
                 </a:solidFill>
                 <a:latin typeface="Segoe UI"/>
-                <a:ea typeface="Segoe UI"/>
+                <a:ea typeface="Microsoft YaHei"/>
               </a:rPr>
               <a:t>dcc-mcp-gateway（Rust）：路由 · 能力索引 · Job · Artifact · 策略</a:t>
             </a:r>
@@ -6285,7 +6507,7 @@
                   <a:srgbClr val="E8ECF2"/>
                 </a:solidFill>
                 <a:latin typeface="Segoe UI"/>
-                <a:ea typeface="Segoe UI"/>
+                <a:ea typeface="Microsoft YaHei"/>
               </a:rPr>
               <a:t>Sidecar（RFC #998）：进程生命周期 · PPID 守护 · HostRpcClient</a:t>
             </a:r>
@@ -6341,7 +6563,7 @@
                   <a:srgbClr val="E8ECF2"/>
                 </a:solidFill>
                 <a:latin typeface="Segoe UI"/>
-                <a:ea typeface="Segoe UI"/>
+                <a:ea typeface="Microsoft YaHei"/>
               </a:rPr>
               <a:t>各 DCC 适配器：Maya commandPort · Blender HTTP · Houdini hrpyc · …</a:t>
             </a:r>
@@ -6397,7 +6619,7 @@
                   <a:srgbClr val="E8ECF2"/>
                 </a:solidFill>
                 <a:latin typeface="Segoe UI"/>
-                <a:ea typeface="Segoe UI"/>
+                <a:ea typeface="Microsoft YaHei"/>
               </a:rPr>
               <a:t>DCC 应用：Maya / Blender / Houdini / Photoshop / Unity / Office</a:t>
             </a:r>
@@ -6440,6 +6662,43 @@
           </a:fontRef>
         </p:style>
       </p:cxnSp>
+      <p:sp>
+        <p:nvSpPr>
+          <p:cNvPr id="10" name="TextBox 9"/>
+          <p:cNvSpPr txBox="1"/>
+          <p:nvPr/>
+        </p:nvSpPr>
+        <p:spPr>
+          <a:xfrm>
+            <a:off x="10728655" y="6400800"/>
+            <a:ext cx="1097280" cy="320040"/>
+          </a:xfrm>
+          <a:prstGeom prst="rect">
+            <a:avLst/>
+          </a:prstGeom>
+          <a:noFill/>
+          <a:effectLst/>
+        </p:spPr>
+        <p:txBody>
+          <a:bodyPr wrap="none">
+            <a:spAutoFit/>
+          </a:bodyPr>
+          <a:lstStyle/>
+          <a:p>
+            <a:pPr algn="r"/>
+            <a:r>
+              <a:rPr sz="1000" b="0">
+                <a:solidFill>
+                  <a:srgbClr val="9AA7BC"/>
+                </a:solidFill>
+                <a:latin typeface="Segoe UI"/>
+                <a:ea typeface="Microsoft YaHei"/>
+              </a:rPr>
+              <a:t>04 / 12</a:t>
+            </a:r>
+          </a:p>
+        </p:txBody>
+      </p:sp>
     </p:spTree>
   </p:cSld>
   <p:clrMapOvr>
@@ -6532,7 +6791,7 @@
                   <a:srgbClr val="E8ECF2"/>
                 </a:solidFill>
                 <a:latin typeface="Segoe UI"/>
-                <a:ea typeface="Segoe UI"/>
+                <a:ea typeface="Microsoft YaHei"/>
               </a:rPr>
               <a:t>能力与 Skills</a:t>
             </a:r>
@@ -6588,7 +6847,7 @@
                   <a:srgbClr val="E8ECF2"/>
                 </a:solidFill>
                 <a:latin typeface="Segoe UI"/>
-                <a:ea typeface="Segoe UI"/>
+                <a:ea typeface="Microsoft YaHei"/>
               </a:rPr>
               <a:t>●  任务级 Capability，不暴露原始对象模型</a:t>
             </a:r>
@@ -6644,7 +6903,7 @@
                   <a:srgbClr val="E8ECF2"/>
                 </a:solidFill>
                 <a:latin typeface="Segoe UI"/>
-                <a:ea typeface="Segoe UI"/>
+                <a:ea typeface="Microsoft YaHei"/>
               </a:rPr>
               <a:t>●  渐进式发现：初始上下文不塞满数百个工具</a:t>
             </a:r>
@@ -6700,7 +6959,7 @@
                   <a:srgbClr val="E8ECF2"/>
                 </a:solidFill>
                 <a:latin typeface="Segoe UI"/>
-                <a:ea typeface="Segoe UI"/>
+                <a:ea typeface="Microsoft YaHei"/>
               </a:rPr>
               <a:t>●  契约化技能包：SKILL.md + tools.yaml + scripts/&lt;name&gt;.py</a:t>
             </a:r>
@@ -6756,9 +7015,46 @@
                   <a:srgbClr val="E8ECF2"/>
                 </a:solidFill>
                 <a:latin typeface="Segoe UI"/>
-                <a:ea typeface="Segoe UI"/>
+                <a:ea typeface="Microsoft YaHei"/>
               </a:rPr>
               <a:t>●  Maya 单仓 25+ 域技能包、198 个结构化操作</a:t>
+            </a:r>
+          </a:p>
+        </p:txBody>
+      </p:sp>
+      <p:sp>
+        <p:nvSpPr>
+          <p:cNvPr id="8" name="TextBox 7"/>
+          <p:cNvSpPr txBox="1"/>
+          <p:nvPr/>
+        </p:nvSpPr>
+        <p:spPr>
+          <a:xfrm>
+            <a:off x="10728655" y="6400800"/>
+            <a:ext cx="1097280" cy="320040"/>
+          </a:xfrm>
+          <a:prstGeom prst="rect">
+            <a:avLst/>
+          </a:prstGeom>
+          <a:noFill/>
+          <a:effectLst/>
+        </p:spPr>
+        <p:txBody>
+          <a:bodyPr wrap="none">
+            <a:spAutoFit/>
+          </a:bodyPr>
+          <a:lstStyle/>
+          <a:p>
+            <a:pPr algn="r"/>
+            <a:r>
+              <a:rPr sz="1000" b="0">
+                <a:solidFill>
+                  <a:srgbClr val="9AA7BC"/>
+                </a:solidFill>
+                <a:latin typeface="Segoe UI"/>
+                <a:ea typeface="Microsoft YaHei"/>
+              </a:rPr>
+              <a:t>05 / 12</a:t>
             </a:r>
           </a:p>
         </p:txBody>
@@ -6855,7 +7151,7 @@
                   <a:srgbClr val="E8ECF2"/>
                 </a:solidFill>
                 <a:latin typeface="Segoe UI"/>
-                <a:ea typeface="Segoe UI"/>
+                <a:ea typeface="Microsoft YaHei"/>
               </a:rPr>
               <a:t>生态现状</a:t>
             </a:r>
@@ -6911,7 +7207,7 @@
                   <a:srgbClr val="7FC8A9"/>
                 </a:solidFill>
                 <a:latin typeface="Segoe UI"/>
-                <a:ea typeface="Segoe UI"/>
+                <a:ea typeface="Microsoft YaHei"/>
               </a:rPr>
               <a:t>30+</a:t>
             </a:r>
@@ -6924,7 +7220,7 @@
                   <a:srgbClr val="7FC8A9"/>
                 </a:solidFill>
                 <a:latin typeface="Segoe UI"/>
-                <a:ea typeface="Segoe UI"/>
+                <a:ea typeface="Microsoft YaHei"/>
               </a:rPr>
               <a:t>DCC 适配器仓库</a:t>
             </a:r>
@@ -6980,7 +7276,7 @@
                   <a:srgbClr val="7FC8A9"/>
                 </a:solidFill>
                 <a:latin typeface="Segoe UI"/>
-                <a:ea typeface="Segoe UI"/>
+                <a:ea typeface="Microsoft YaHei"/>
               </a:rPr>
               <a:t>198</a:t>
             </a:r>
@@ -6993,7 +7289,7 @@
                   <a:srgbClr val="7FC8A9"/>
                 </a:solidFill>
                 <a:latin typeface="Segoe UI"/>
-                <a:ea typeface="Segoe UI"/>
+                <a:ea typeface="Microsoft YaHei"/>
               </a:rPr>
               <a:t>Maya 结构化操作</a:t>
             </a:r>
@@ -7049,7 +7345,7 @@
                   <a:srgbClr val="7FC8A9"/>
                 </a:solidFill>
                 <a:latin typeface="Segoe UI"/>
-                <a:ea typeface="Segoe UI"/>
+                <a:ea typeface="Microsoft YaHei"/>
               </a:rPr>
               <a:t>25+</a:t>
             </a:r>
@@ -7062,7 +7358,7 @@
                   <a:srgbClr val="7FC8A9"/>
                 </a:solidFill>
                 <a:latin typeface="Segoe UI"/>
-                <a:ea typeface="Segoe UI"/>
+                <a:ea typeface="Microsoft YaHei"/>
               </a:rPr>
               <a:t>Maya 域技能包</a:t>
             </a:r>
@@ -7118,7 +7414,7 @@
                   <a:srgbClr val="7FC8A9"/>
                 </a:solidFill>
                 <a:latin typeface="Segoe UI"/>
-                <a:ea typeface="Segoe UI"/>
+                <a:ea typeface="Microsoft YaHei"/>
               </a:rPr>
               <a:t>5</a:t>
             </a:r>
@@ -7131,7 +7427,7 @@
                   <a:srgbClr val="7FC8A9"/>
                 </a:solidFill>
                 <a:latin typeface="Segoe UI"/>
-                <a:ea typeface="Segoe UI"/>
+                <a:ea typeface="Microsoft YaHei"/>
               </a:rPr>
               <a:t>Office 新域仓库（office / PPT / Word / Excel / Outlook）</a:t>
             </a:r>
@@ -7187,7 +7483,7 @@
                   <a:srgbClr val="7FC8A9"/>
                 </a:solidFill>
                 <a:latin typeface="Segoe UI"/>
-                <a:ea typeface="Segoe UI"/>
+                <a:ea typeface="Microsoft YaHei"/>
               </a:rPr>
               <a:t>6</a:t>
             </a:r>
@@ -7200,7 +7496,7 @@
                   <a:srgbClr val="7FC8A9"/>
                 </a:solidFill>
                 <a:latin typeface="Segoe UI"/>
-                <a:ea typeface="Segoe UI"/>
+                <a:ea typeface="Microsoft YaHei"/>
               </a:rPr>
               <a:t>执行后端路径（OpenXML / COM / Graph / Office.js / UIA / CUA）</a:t>
             </a:r>
@@ -7256,7 +7552,7 @@
                   <a:srgbClr val="7FC8A9"/>
                 </a:solidFill>
                 <a:latin typeface="Segoe UI"/>
-                <a:ea typeface="Segoe UI"/>
+                <a:ea typeface="Microsoft YaHei"/>
               </a:rPr>
               <a:t>12</a:t>
             </a:r>
@@ -7269,9 +7565,46 @@
                   <a:srgbClr val="7FC8A9"/>
                 </a:solidFill>
                 <a:latin typeface="Segoe UI"/>
-                <a:ea typeface="Segoe UI"/>
+                <a:ea typeface="Microsoft YaHei"/>
               </a:rPr>
               <a:t>Office MVP 验收标准</a:t>
+            </a:r>
+          </a:p>
+        </p:txBody>
+      </p:sp>
+      <p:sp>
+        <p:nvSpPr>
+          <p:cNvPr id="10" name="TextBox 9"/>
+          <p:cNvSpPr txBox="1"/>
+          <p:nvPr/>
+        </p:nvSpPr>
+        <p:spPr>
+          <a:xfrm>
+            <a:off x="10728655" y="6400800"/>
+            <a:ext cx="1097280" cy="320040"/>
+          </a:xfrm>
+          <a:prstGeom prst="rect">
+            <a:avLst/>
+          </a:prstGeom>
+          <a:noFill/>
+          <a:effectLst/>
+        </p:spPr>
+        <p:txBody>
+          <a:bodyPr wrap="none">
+            <a:spAutoFit/>
+          </a:bodyPr>
+          <a:lstStyle/>
+          <a:p>
+            <a:pPr algn="r"/>
+            <a:r>
+              <a:rPr sz="1000" b="0">
+                <a:solidFill>
+                  <a:srgbClr val="9AA7BC"/>
+                </a:solidFill>
+                <a:latin typeface="Segoe UI"/>
+                <a:ea typeface="Microsoft YaHei"/>
+              </a:rPr>
+              <a:t>06 / 12</a:t>
             </a:r>
           </a:p>
         </p:txBody>
@@ -7456,9 +7789,46 @@
                   <a:srgbClr val="E8ECF2"/>
                 </a:solidFill>
                 <a:latin typeface="Segoe UI"/>
-                <a:ea typeface="Segoe UI"/>
+                <a:ea typeface="Microsoft YaHei"/>
               </a:rPr>
               <a:t>02 · 执行模型</a:t>
+            </a:r>
+          </a:p>
+        </p:txBody>
+      </p:sp>
+      <p:sp>
+        <p:nvSpPr>
+          <p:cNvPr id="6" name="TextBox 5"/>
+          <p:cNvSpPr txBox="1"/>
+          <p:nvPr/>
+        </p:nvSpPr>
+        <p:spPr>
+          <a:xfrm>
+            <a:off x="10728655" y="6400800"/>
+            <a:ext cx="1097280" cy="320040"/>
+          </a:xfrm>
+          <a:prstGeom prst="rect">
+            <a:avLst/>
+          </a:prstGeom>
+          <a:noFill/>
+          <a:effectLst/>
+        </p:spPr>
+        <p:txBody>
+          <a:bodyPr wrap="none">
+            <a:spAutoFit/>
+          </a:bodyPr>
+          <a:lstStyle/>
+          <a:p>
+            <a:pPr algn="r"/>
+            <a:r>
+              <a:rPr sz="1000" b="0">
+                <a:solidFill>
+                  <a:srgbClr val="9AA7BC"/>
+                </a:solidFill>
+                <a:latin typeface="Segoe UI"/>
+                <a:ea typeface="Microsoft YaHei"/>
+              </a:rPr>
+              <a:t>07 / 12</a:t>
             </a:r>
           </a:p>
         </p:txBody>
@@ -7555,7 +7925,7 @@
                   <a:srgbClr val="E8ECF2"/>
                 </a:solidFill>
                 <a:latin typeface="Segoe UI"/>
-                <a:ea typeface="Segoe UI"/>
+                <a:ea typeface="Microsoft YaHei"/>
               </a:rPr>
               <a:t>一次调用的旅程</a:t>
             </a:r>
@@ -7680,7 +8050,7 @@
                   <a:srgbClr val="E8ECF2"/>
                 </a:solidFill>
                 <a:latin typeface="Segoe UI"/>
-                <a:ea typeface="Segoe UI"/>
+                <a:ea typeface="Microsoft YaHei"/>
               </a:rPr>
               <a:t>01  list / search — 渐进式能力发现</a:t>
             </a:r>
@@ -7761,7 +8131,7 @@
                   <a:srgbClr val="E8ECF2"/>
                 </a:solidFill>
                 <a:latin typeface="Segoe UI"/>
-                <a:ea typeface="Segoe UI"/>
+                <a:ea typeface="Microsoft YaHei"/>
               </a:rPr>
               <a:t>02  load_skill / describe — 契约与确认级别</a:t>
             </a:r>
@@ -7842,7 +8212,7 @@
                   <a:srgbClr val="E8ECF2"/>
                 </a:solidFill>
                 <a:latin typeface="Segoe UI"/>
-                <a:ea typeface="Segoe UI"/>
+                <a:ea typeface="Microsoft YaHei"/>
               </a:rPr>
               <a:t>03  call — 任务级 Capability</a:t>
             </a:r>
@@ -7923,7 +8293,7 @@
                   <a:srgbClr val="E8ECF2"/>
                 </a:solidFill>
                 <a:latin typeface="Segoe UI"/>
-                <a:ea typeface="Segoe UI"/>
+                <a:ea typeface="Microsoft YaHei"/>
               </a:rPr>
               <a:t>04  Job — 批处理永不占住连接</a:t>
             </a:r>
@@ -8004,9 +8374,46 @@
                   <a:srgbClr val="E8ECF2"/>
                 </a:solidFill>
                 <a:latin typeface="Segoe UI"/>
-                <a:ea typeface="Segoe UI"/>
+                <a:ea typeface="Microsoft YaHei"/>
               </a:rPr>
               <a:t>05  Artifact — 结果、预览、审计可追踪</a:t>
+            </a:r>
+          </a:p>
+        </p:txBody>
+      </p:sp>
+      <p:sp>
+        <p:nvSpPr>
+          <p:cNvPr id="15" name="TextBox 14"/>
+          <p:cNvSpPr txBox="1"/>
+          <p:nvPr/>
+        </p:nvSpPr>
+        <p:spPr>
+          <a:xfrm>
+            <a:off x="10728655" y="6400800"/>
+            <a:ext cx="1097280" cy="320040"/>
+          </a:xfrm>
+          <a:prstGeom prst="rect">
+            <a:avLst/>
+          </a:prstGeom>
+          <a:noFill/>
+          <a:effectLst/>
+        </p:spPr>
+        <p:txBody>
+          <a:bodyPr wrap="none">
+            <a:spAutoFit/>
+          </a:bodyPr>
+          <a:lstStyle/>
+          <a:p>
+            <a:pPr algn="r"/>
+            <a:r>
+              <a:rPr sz="1000" b="0">
+                <a:solidFill>
+                  <a:srgbClr val="9AA7BC"/>
+                </a:solidFill>
+                <a:latin typeface="Segoe UI"/>
+                <a:ea typeface="Microsoft YaHei"/>
+              </a:rPr>
+              <a:t>08 / 12</a:t>
             </a:r>
           </a:p>
         </p:txBody>
@@ -8191,9 +8598,46 @@
                   <a:srgbClr val="E8ECF2"/>
                 </a:solidFill>
                 <a:latin typeface="Segoe UI"/>
-                <a:ea typeface="Segoe UI"/>
+                <a:ea typeface="Microsoft YaHei"/>
               </a:rPr>
               <a:t>03 · Office 自动化平台</a:t>
+            </a:r>
+          </a:p>
+        </p:txBody>
+      </p:sp>
+      <p:sp>
+        <p:nvSpPr>
+          <p:cNvPr id="6" name="TextBox 5"/>
+          <p:cNvSpPr txBox="1"/>
+          <p:nvPr/>
+        </p:nvSpPr>
+        <p:spPr>
+          <a:xfrm>
+            <a:off x="10728655" y="6400800"/>
+            <a:ext cx="1097280" cy="320040"/>
+          </a:xfrm>
+          <a:prstGeom prst="rect">
+            <a:avLst/>
+          </a:prstGeom>
+          <a:noFill/>
+          <a:effectLst/>
+        </p:spPr>
+        <p:txBody>
+          <a:bodyPr wrap="none">
+            <a:spAutoFit/>
+          </a:bodyPr>
+          <a:lstStyle/>
+          <a:p>
+            <a:pPr algn="r"/>
+            <a:r>
+              <a:rPr sz="1000" b="0">
+                <a:solidFill>
+                  <a:srgbClr val="9AA7BC"/>
+                </a:solidFill>
+                <a:latin typeface="Segoe UI"/>
+                <a:ea typeface="Microsoft YaHei"/>
+              </a:rPr>
+              <a:t>09 / 12</a:t>
             </a:r>
           </a:p>
         </p:txBody>

</xml_diff>

<commit_message>
feat: official brand identity on deck + pixel-level visual QA
- brand/: packaged master logos (light/dark) resolved from
  brand://dcc-mcp/* template URIs; title + closing slides carry the
  official lockup, unknown brands render without a logo (never a look-alike)
- section covers gain a ghost chapter number (richer, still minimal)
- visual QA: background-adaptive pixel checks on every rendered preview
  (content coverage + edge bleed via histogram math, no heavy deps)
- regenerated showcase artifacts
</commit_message>
<xml_diff>
--- a/examples/output/draft-dcc-mcp-framework-intro.pptx
+++ b/examples/output/draft-dcc-mcp-framework-intro.pptx
@@ -4377,9 +4377,33 @@
           </a:p>
         </p:txBody>
       </p:sp>
-      <p:sp>
-        <p:nvSpPr>
-          <p:cNvPr id="4" name="Rectangle 3"/>
+      <p:pic>
+        <p:nvPicPr>
+          <p:cNvPr id="4" name="Picture 3" descr="dcc-mcp-logo-light.png"/>
+          <p:cNvPicPr>
+            <a:picLocks noChangeAspect="1"/>
+          </p:cNvPicPr>
+          <p:nvPr/>
+        </p:nvPicPr>
+        <p:blipFill>
+          <a:blip r:embed="rId2"/>
+          <a:stretch>
+            <a:fillRect/>
+          </a:stretch>
+        </p:blipFill>
+        <p:spPr>
+          <a:xfrm>
+            <a:off x="822960" y="411480"/>
+            <a:ext cx="1131570" cy="502920"/>
+          </a:xfrm>
+          <a:prstGeom prst="rect">
+            <a:avLst/>
+          </a:prstGeom>
+        </p:spPr>
+      </p:pic>
+      <p:sp>
+        <p:nvSpPr>
+          <p:cNvPr id="5" name="Rectangle 4"/>
           <p:cNvSpPr/>
           <p:nvPr/>
         </p:nvSpPr>
@@ -4423,7 +4447,7 @@
       </p:sp>
       <p:sp>
         <p:nvSpPr>
-          <p:cNvPr id="5" name="TextBox 4"/>
+          <p:cNvPr id="6" name="TextBox 5"/>
           <p:cNvSpPr txBox="1"/>
           <p:nvPr/>
         </p:nvSpPr>
@@ -4460,7 +4484,7 @@
       </p:sp>
       <p:sp>
         <p:nvSpPr>
-          <p:cNvPr id="6" name="TextBox 5"/>
+          <p:cNvPr id="7" name="TextBox 6"/>
           <p:cNvSpPr txBox="1"/>
           <p:nvPr/>
         </p:nvSpPr>
@@ -4510,7 +4534,7 @@
       </p:sp>
       <p:sp>
         <p:nvSpPr>
-          <p:cNvPr id="7" name="TextBox 6"/>
+          <p:cNvPr id="8" name="TextBox 7"/>
           <p:cNvSpPr txBox="1"/>
           <p:nvPr/>
         </p:nvSpPr>
@@ -4547,7 +4571,7 @@
       </p:sp>
       <p:sp>
         <p:nvSpPr>
-          <p:cNvPr id="8" name="TextBox 7"/>
+          <p:cNvPr id="9" name="TextBox 8"/>
           <p:cNvSpPr txBox="1"/>
           <p:nvPr/>
         </p:nvSpPr>
@@ -5552,15 +5576,39 @@
           </a:p>
         </p:txBody>
       </p:sp>
-      <p:sp>
-        <p:nvSpPr>
-          <p:cNvPr id="4" name="TextBox 3"/>
+      <p:pic>
+        <p:nvPicPr>
+          <p:cNvPr id="4" name="Picture 3" descr="dcc-mcp-logo-light.png"/>
+          <p:cNvPicPr>
+            <a:picLocks noChangeAspect="1"/>
+          </p:cNvPicPr>
+          <p:nvPr/>
+        </p:nvPicPr>
+        <p:blipFill>
+          <a:blip r:embed="rId2"/>
+          <a:stretch>
+            <a:fillRect/>
+          </a:stretch>
+        </p:blipFill>
+        <p:spPr>
+          <a:xfrm>
+            <a:off x="5413248" y="1371600"/>
+            <a:ext cx="1851660" cy="822960"/>
+          </a:xfrm>
+          <a:prstGeom prst="rect">
+            <a:avLst/>
+          </a:prstGeom>
+        </p:spPr>
+      </p:pic>
+      <p:sp>
+        <p:nvSpPr>
+          <p:cNvPr id="5" name="TextBox 4"/>
           <p:cNvSpPr txBox="1"/>
           <p:nvPr/>
         </p:nvSpPr>
         <p:spPr>
           <a:xfrm>
-            <a:off x="1371600" y="2560320"/>
+            <a:off x="1371600" y="2468880"/>
             <a:ext cx="9418320" cy="1371600"/>
           </a:xfrm>
           <a:prstGeom prst="rect">
@@ -5591,7 +5639,7 @@
       </p:sp>
       <p:sp>
         <p:nvSpPr>
-          <p:cNvPr id="5" name="TextBox 4"/>
+          <p:cNvPr id="6" name="TextBox 5"/>
           <p:cNvSpPr txBox="1"/>
           <p:nvPr/>
         </p:nvSpPr>
@@ -5628,7 +5676,7 @@
       </p:sp>
       <p:sp>
         <p:nvSpPr>
-          <p:cNvPr id="6" name="TextBox 5"/>
+          <p:cNvPr id="7" name="TextBox 6"/>
           <p:cNvSpPr txBox="1"/>
           <p:nvPr/>
         </p:nvSpPr>
@@ -5771,7 +5819,44 @@
       </p:sp>
       <p:sp>
         <p:nvSpPr>
-          <p:cNvPr id="4" name="Rectangle 3"/>
+          <p:cNvPr id="4" name="TextBox 3"/>
+          <p:cNvSpPr txBox="1"/>
+          <p:nvPr/>
+        </p:nvSpPr>
+        <p:spPr>
+          <a:xfrm>
+            <a:off x="640080" y="548640"/>
+            <a:ext cx="4572000" cy="3840480"/>
+          </a:xfrm>
+          <a:prstGeom prst="rect">
+            <a:avLst/>
+          </a:prstGeom>
+          <a:noFill/>
+          <a:effectLst/>
+        </p:spPr>
+        <p:txBody>
+          <a:bodyPr wrap="square" lIns="50800" rIns="50800">
+            <a:spAutoFit/>
+          </a:bodyPr>
+          <a:lstStyle/>
+          <a:p>
+            <a:pPr algn="l"/>
+            <a:r>
+              <a:rPr sz="20000" b="1">
+                <a:solidFill>
+                  <a:srgbClr val="223047"/>
+                </a:solidFill>
+                <a:latin typeface="Segoe UI"/>
+                <a:ea typeface="Microsoft YaHei"/>
+              </a:rPr>
+              <a:t>01</a:t>
+            </a:r>
+          </a:p>
+        </p:txBody>
+      </p:sp>
+      <p:sp>
+        <p:nvSpPr>
+          <p:cNvPr id="5" name="Rectangle 4"/>
           <p:cNvSpPr/>
           <p:nvPr/>
         </p:nvSpPr>
@@ -5815,7 +5900,7 @@
       </p:sp>
       <p:sp>
         <p:nvSpPr>
-          <p:cNvPr id="5" name="TextBox 4"/>
+          <p:cNvPr id="6" name="TextBox 5"/>
           <p:cNvSpPr txBox="1"/>
           <p:nvPr/>
         </p:nvSpPr>
@@ -5845,14 +5930,14 @@
                 <a:latin typeface="Segoe UI"/>
                 <a:ea typeface="Microsoft YaHei"/>
               </a:rPr>
-              <a:t>01 · 框架总览</a:t>
-            </a:r>
-          </a:p>
-        </p:txBody>
-      </p:sp>
-      <p:sp>
-        <p:nvSpPr>
-          <p:cNvPr id="6" name="TextBox 5"/>
+              <a:t>框架总览</a:t>
+            </a:r>
+          </a:p>
+        </p:txBody>
+      </p:sp>
+      <p:sp>
+        <p:nvSpPr>
+          <p:cNvPr id="7" name="TextBox 6"/>
           <p:cNvSpPr txBox="1"/>
           <p:nvPr/>
         </p:nvSpPr>
@@ -7717,7 +7802,44 @@
       </p:sp>
       <p:sp>
         <p:nvSpPr>
-          <p:cNvPr id="4" name="Rectangle 3"/>
+          <p:cNvPr id="4" name="TextBox 3"/>
+          <p:cNvSpPr txBox="1"/>
+          <p:nvPr/>
+        </p:nvSpPr>
+        <p:spPr>
+          <a:xfrm>
+            <a:off x="640080" y="548640"/>
+            <a:ext cx="4572000" cy="3840480"/>
+          </a:xfrm>
+          <a:prstGeom prst="rect">
+            <a:avLst/>
+          </a:prstGeom>
+          <a:noFill/>
+          <a:effectLst/>
+        </p:spPr>
+        <p:txBody>
+          <a:bodyPr wrap="square" lIns="50800" rIns="50800">
+            <a:spAutoFit/>
+          </a:bodyPr>
+          <a:lstStyle/>
+          <a:p>
+            <a:pPr algn="l"/>
+            <a:r>
+              <a:rPr sz="20000" b="1">
+                <a:solidFill>
+                  <a:srgbClr val="223047"/>
+                </a:solidFill>
+                <a:latin typeface="Segoe UI"/>
+                <a:ea typeface="Microsoft YaHei"/>
+              </a:rPr>
+              <a:t>02</a:t>
+            </a:r>
+          </a:p>
+        </p:txBody>
+      </p:sp>
+      <p:sp>
+        <p:nvSpPr>
+          <p:cNvPr id="5" name="Rectangle 4"/>
           <p:cNvSpPr/>
           <p:nvPr/>
         </p:nvSpPr>
@@ -7761,7 +7883,7 @@
       </p:sp>
       <p:sp>
         <p:nvSpPr>
-          <p:cNvPr id="5" name="TextBox 4"/>
+          <p:cNvPr id="6" name="TextBox 5"/>
           <p:cNvSpPr txBox="1"/>
           <p:nvPr/>
         </p:nvSpPr>
@@ -7791,14 +7913,14 @@
                 <a:latin typeface="Segoe UI"/>
                 <a:ea typeface="Microsoft YaHei"/>
               </a:rPr>
-              <a:t>02 · 执行模型</a:t>
-            </a:r>
-          </a:p>
-        </p:txBody>
-      </p:sp>
-      <p:sp>
-        <p:nvSpPr>
-          <p:cNvPr id="6" name="TextBox 5"/>
+              <a:t>执行模型</a:t>
+            </a:r>
+          </a:p>
+        </p:txBody>
+      </p:sp>
+      <p:sp>
+        <p:nvSpPr>
+          <p:cNvPr id="7" name="TextBox 6"/>
           <p:cNvSpPr txBox="1"/>
           <p:nvPr/>
         </p:nvSpPr>
@@ -8526,7 +8648,44 @@
       </p:sp>
       <p:sp>
         <p:nvSpPr>
-          <p:cNvPr id="4" name="Rectangle 3"/>
+          <p:cNvPr id="4" name="TextBox 3"/>
+          <p:cNvSpPr txBox="1"/>
+          <p:nvPr/>
+        </p:nvSpPr>
+        <p:spPr>
+          <a:xfrm>
+            <a:off x="640080" y="548640"/>
+            <a:ext cx="4572000" cy="3840480"/>
+          </a:xfrm>
+          <a:prstGeom prst="rect">
+            <a:avLst/>
+          </a:prstGeom>
+          <a:noFill/>
+          <a:effectLst/>
+        </p:spPr>
+        <p:txBody>
+          <a:bodyPr wrap="square" lIns="50800" rIns="50800">
+            <a:spAutoFit/>
+          </a:bodyPr>
+          <a:lstStyle/>
+          <a:p>
+            <a:pPr algn="l"/>
+            <a:r>
+              <a:rPr sz="20000" b="1">
+                <a:solidFill>
+                  <a:srgbClr val="223047"/>
+                </a:solidFill>
+                <a:latin typeface="Segoe UI"/>
+                <a:ea typeface="Microsoft YaHei"/>
+              </a:rPr>
+              <a:t>03</a:t>
+            </a:r>
+          </a:p>
+        </p:txBody>
+      </p:sp>
+      <p:sp>
+        <p:nvSpPr>
+          <p:cNvPr id="5" name="Rectangle 4"/>
           <p:cNvSpPr/>
           <p:nvPr/>
         </p:nvSpPr>
@@ -8570,7 +8729,7 @@
       </p:sp>
       <p:sp>
         <p:nvSpPr>
-          <p:cNvPr id="5" name="TextBox 4"/>
+          <p:cNvPr id="6" name="TextBox 5"/>
           <p:cNvSpPr txBox="1"/>
           <p:nvPr/>
         </p:nvSpPr>
@@ -8600,14 +8759,14 @@
                 <a:latin typeface="Segoe UI"/>
                 <a:ea typeface="Microsoft YaHei"/>
               </a:rPr>
-              <a:t>03 · Office 自动化平台</a:t>
-            </a:r>
-          </a:p>
-        </p:txBody>
-      </p:sp>
-      <p:sp>
-        <p:nvSpPr>
-          <p:cNvPr id="6" name="TextBox 5"/>
+              <a:t>Office 自动化平台</a:t>
+            </a:r>
+          </a:p>
+        </p:txBody>
+      </p:sp>
+      <p:sp>
+        <p:nvSpPr>
+          <p:cNvPr id="7" name="TextBox 6"/>
           <p:cNvSpPr txBox="1"/>
           <p:nvPr/>
         </p:nvSpPr>

</xml_diff>

<commit_message>
feat: official brand identity on deck + pixel-level visual QA (#2)
- brand/: packaged master logos (light/dark) resolved from
  brand://dcc-mcp/* template URIs; title + closing slides carry the
  official lockup, unknown brands render without a logo (never a look-alike)
- section covers gain a ghost chapter number (richer, still minimal)
- visual QA: background-adaptive pixel checks on every rendered preview
  (content coverage + edge bleed via histogram math, no heavy deps)
- regenerated showcase artifacts
</commit_message>
<xml_diff>
--- a/examples/output/draft-dcc-mcp-framework-intro.pptx
+++ b/examples/output/draft-dcc-mcp-framework-intro.pptx
@@ -4377,9 +4377,33 @@
           </a:p>
         </p:txBody>
       </p:sp>
-      <p:sp>
-        <p:nvSpPr>
-          <p:cNvPr id="4" name="Rectangle 3"/>
+      <p:pic>
+        <p:nvPicPr>
+          <p:cNvPr id="4" name="Picture 3" descr="dcc-mcp-logo-light.png"/>
+          <p:cNvPicPr>
+            <a:picLocks noChangeAspect="1"/>
+          </p:cNvPicPr>
+          <p:nvPr/>
+        </p:nvPicPr>
+        <p:blipFill>
+          <a:blip r:embed="rId2"/>
+          <a:stretch>
+            <a:fillRect/>
+          </a:stretch>
+        </p:blipFill>
+        <p:spPr>
+          <a:xfrm>
+            <a:off x="822960" y="411480"/>
+            <a:ext cx="1131570" cy="502920"/>
+          </a:xfrm>
+          <a:prstGeom prst="rect">
+            <a:avLst/>
+          </a:prstGeom>
+        </p:spPr>
+      </p:pic>
+      <p:sp>
+        <p:nvSpPr>
+          <p:cNvPr id="5" name="Rectangle 4"/>
           <p:cNvSpPr/>
           <p:nvPr/>
         </p:nvSpPr>
@@ -4423,7 +4447,7 @@
       </p:sp>
       <p:sp>
         <p:nvSpPr>
-          <p:cNvPr id="5" name="TextBox 4"/>
+          <p:cNvPr id="6" name="TextBox 5"/>
           <p:cNvSpPr txBox="1"/>
           <p:nvPr/>
         </p:nvSpPr>
@@ -4460,7 +4484,7 @@
       </p:sp>
       <p:sp>
         <p:nvSpPr>
-          <p:cNvPr id="6" name="TextBox 5"/>
+          <p:cNvPr id="7" name="TextBox 6"/>
           <p:cNvSpPr txBox="1"/>
           <p:nvPr/>
         </p:nvSpPr>
@@ -4510,7 +4534,7 @@
       </p:sp>
       <p:sp>
         <p:nvSpPr>
-          <p:cNvPr id="7" name="TextBox 6"/>
+          <p:cNvPr id="8" name="TextBox 7"/>
           <p:cNvSpPr txBox="1"/>
           <p:nvPr/>
         </p:nvSpPr>
@@ -4547,7 +4571,7 @@
       </p:sp>
       <p:sp>
         <p:nvSpPr>
-          <p:cNvPr id="8" name="TextBox 7"/>
+          <p:cNvPr id="9" name="TextBox 8"/>
           <p:cNvSpPr txBox="1"/>
           <p:nvPr/>
         </p:nvSpPr>
@@ -5552,15 +5576,39 @@
           </a:p>
         </p:txBody>
       </p:sp>
-      <p:sp>
-        <p:nvSpPr>
-          <p:cNvPr id="4" name="TextBox 3"/>
+      <p:pic>
+        <p:nvPicPr>
+          <p:cNvPr id="4" name="Picture 3" descr="dcc-mcp-logo-light.png"/>
+          <p:cNvPicPr>
+            <a:picLocks noChangeAspect="1"/>
+          </p:cNvPicPr>
+          <p:nvPr/>
+        </p:nvPicPr>
+        <p:blipFill>
+          <a:blip r:embed="rId2"/>
+          <a:stretch>
+            <a:fillRect/>
+          </a:stretch>
+        </p:blipFill>
+        <p:spPr>
+          <a:xfrm>
+            <a:off x="5413248" y="1371600"/>
+            <a:ext cx="1851660" cy="822960"/>
+          </a:xfrm>
+          <a:prstGeom prst="rect">
+            <a:avLst/>
+          </a:prstGeom>
+        </p:spPr>
+      </p:pic>
+      <p:sp>
+        <p:nvSpPr>
+          <p:cNvPr id="5" name="TextBox 4"/>
           <p:cNvSpPr txBox="1"/>
           <p:nvPr/>
         </p:nvSpPr>
         <p:spPr>
           <a:xfrm>
-            <a:off x="1371600" y="2560320"/>
+            <a:off x="1371600" y="2468880"/>
             <a:ext cx="9418320" cy="1371600"/>
           </a:xfrm>
           <a:prstGeom prst="rect">
@@ -5591,7 +5639,7 @@
       </p:sp>
       <p:sp>
         <p:nvSpPr>
-          <p:cNvPr id="5" name="TextBox 4"/>
+          <p:cNvPr id="6" name="TextBox 5"/>
           <p:cNvSpPr txBox="1"/>
           <p:nvPr/>
         </p:nvSpPr>
@@ -5628,7 +5676,7 @@
       </p:sp>
       <p:sp>
         <p:nvSpPr>
-          <p:cNvPr id="6" name="TextBox 5"/>
+          <p:cNvPr id="7" name="TextBox 6"/>
           <p:cNvSpPr txBox="1"/>
           <p:nvPr/>
         </p:nvSpPr>
@@ -5771,7 +5819,44 @@
       </p:sp>
       <p:sp>
         <p:nvSpPr>
-          <p:cNvPr id="4" name="Rectangle 3"/>
+          <p:cNvPr id="4" name="TextBox 3"/>
+          <p:cNvSpPr txBox="1"/>
+          <p:nvPr/>
+        </p:nvSpPr>
+        <p:spPr>
+          <a:xfrm>
+            <a:off x="640080" y="548640"/>
+            <a:ext cx="4572000" cy="3840480"/>
+          </a:xfrm>
+          <a:prstGeom prst="rect">
+            <a:avLst/>
+          </a:prstGeom>
+          <a:noFill/>
+          <a:effectLst/>
+        </p:spPr>
+        <p:txBody>
+          <a:bodyPr wrap="square" lIns="50800" rIns="50800">
+            <a:spAutoFit/>
+          </a:bodyPr>
+          <a:lstStyle/>
+          <a:p>
+            <a:pPr algn="l"/>
+            <a:r>
+              <a:rPr sz="20000" b="1">
+                <a:solidFill>
+                  <a:srgbClr val="223047"/>
+                </a:solidFill>
+                <a:latin typeface="Segoe UI"/>
+                <a:ea typeface="Microsoft YaHei"/>
+              </a:rPr>
+              <a:t>01</a:t>
+            </a:r>
+          </a:p>
+        </p:txBody>
+      </p:sp>
+      <p:sp>
+        <p:nvSpPr>
+          <p:cNvPr id="5" name="Rectangle 4"/>
           <p:cNvSpPr/>
           <p:nvPr/>
         </p:nvSpPr>
@@ -5815,7 +5900,7 @@
       </p:sp>
       <p:sp>
         <p:nvSpPr>
-          <p:cNvPr id="5" name="TextBox 4"/>
+          <p:cNvPr id="6" name="TextBox 5"/>
           <p:cNvSpPr txBox="1"/>
           <p:nvPr/>
         </p:nvSpPr>
@@ -5845,14 +5930,14 @@
                 <a:latin typeface="Segoe UI"/>
                 <a:ea typeface="Microsoft YaHei"/>
               </a:rPr>
-              <a:t>01 · 框架总览</a:t>
-            </a:r>
-          </a:p>
-        </p:txBody>
-      </p:sp>
-      <p:sp>
-        <p:nvSpPr>
-          <p:cNvPr id="6" name="TextBox 5"/>
+              <a:t>框架总览</a:t>
+            </a:r>
+          </a:p>
+        </p:txBody>
+      </p:sp>
+      <p:sp>
+        <p:nvSpPr>
+          <p:cNvPr id="7" name="TextBox 6"/>
           <p:cNvSpPr txBox="1"/>
           <p:nvPr/>
         </p:nvSpPr>
@@ -7717,7 +7802,44 @@
       </p:sp>
       <p:sp>
         <p:nvSpPr>
-          <p:cNvPr id="4" name="Rectangle 3"/>
+          <p:cNvPr id="4" name="TextBox 3"/>
+          <p:cNvSpPr txBox="1"/>
+          <p:nvPr/>
+        </p:nvSpPr>
+        <p:spPr>
+          <a:xfrm>
+            <a:off x="640080" y="548640"/>
+            <a:ext cx="4572000" cy="3840480"/>
+          </a:xfrm>
+          <a:prstGeom prst="rect">
+            <a:avLst/>
+          </a:prstGeom>
+          <a:noFill/>
+          <a:effectLst/>
+        </p:spPr>
+        <p:txBody>
+          <a:bodyPr wrap="square" lIns="50800" rIns="50800">
+            <a:spAutoFit/>
+          </a:bodyPr>
+          <a:lstStyle/>
+          <a:p>
+            <a:pPr algn="l"/>
+            <a:r>
+              <a:rPr sz="20000" b="1">
+                <a:solidFill>
+                  <a:srgbClr val="223047"/>
+                </a:solidFill>
+                <a:latin typeface="Segoe UI"/>
+                <a:ea typeface="Microsoft YaHei"/>
+              </a:rPr>
+              <a:t>02</a:t>
+            </a:r>
+          </a:p>
+        </p:txBody>
+      </p:sp>
+      <p:sp>
+        <p:nvSpPr>
+          <p:cNvPr id="5" name="Rectangle 4"/>
           <p:cNvSpPr/>
           <p:nvPr/>
         </p:nvSpPr>
@@ -7761,7 +7883,7 @@
       </p:sp>
       <p:sp>
         <p:nvSpPr>
-          <p:cNvPr id="5" name="TextBox 4"/>
+          <p:cNvPr id="6" name="TextBox 5"/>
           <p:cNvSpPr txBox="1"/>
           <p:nvPr/>
         </p:nvSpPr>
@@ -7791,14 +7913,14 @@
                 <a:latin typeface="Segoe UI"/>
                 <a:ea typeface="Microsoft YaHei"/>
               </a:rPr>
-              <a:t>02 · 执行模型</a:t>
-            </a:r>
-          </a:p>
-        </p:txBody>
-      </p:sp>
-      <p:sp>
-        <p:nvSpPr>
-          <p:cNvPr id="6" name="TextBox 5"/>
+              <a:t>执行模型</a:t>
+            </a:r>
+          </a:p>
+        </p:txBody>
+      </p:sp>
+      <p:sp>
+        <p:nvSpPr>
+          <p:cNvPr id="7" name="TextBox 6"/>
           <p:cNvSpPr txBox="1"/>
           <p:nvPr/>
         </p:nvSpPr>
@@ -8526,7 +8648,44 @@
       </p:sp>
       <p:sp>
         <p:nvSpPr>
-          <p:cNvPr id="4" name="Rectangle 3"/>
+          <p:cNvPr id="4" name="TextBox 3"/>
+          <p:cNvSpPr txBox="1"/>
+          <p:nvPr/>
+        </p:nvSpPr>
+        <p:spPr>
+          <a:xfrm>
+            <a:off x="640080" y="548640"/>
+            <a:ext cx="4572000" cy="3840480"/>
+          </a:xfrm>
+          <a:prstGeom prst="rect">
+            <a:avLst/>
+          </a:prstGeom>
+          <a:noFill/>
+          <a:effectLst/>
+        </p:spPr>
+        <p:txBody>
+          <a:bodyPr wrap="square" lIns="50800" rIns="50800">
+            <a:spAutoFit/>
+          </a:bodyPr>
+          <a:lstStyle/>
+          <a:p>
+            <a:pPr algn="l"/>
+            <a:r>
+              <a:rPr sz="20000" b="1">
+                <a:solidFill>
+                  <a:srgbClr val="223047"/>
+                </a:solidFill>
+                <a:latin typeface="Segoe UI"/>
+                <a:ea typeface="Microsoft YaHei"/>
+              </a:rPr>
+              <a:t>03</a:t>
+            </a:r>
+          </a:p>
+        </p:txBody>
+      </p:sp>
+      <p:sp>
+        <p:nvSpPr>
+          <p:cNvPr id="5" name="Rectangle 4"/>
           <p:cNvSpPr/>
           <p:nvPr/>
         </p:nvSpPr>
@@ -8570,7 +8729,7 @@
       </p:sp>
       <p:sp>
         <p:nvSpPr>
-          <p:cNvPr id="5" name="TextBox 4"/>
+          <p:cNvPr id="6" name="TextBox 5"/>
           <p:cNvSpPr txBox="1"/>
           <p:nvPr/>
         </p:nvSpPr>
@@ -8600,14 +8759,14 @@
                 <a:latin typeface="Segoe UI"/>
                 <a:ea typeface="Microsoft YaHei"/>
               </a:rPr>
-              <a:t>03 · Office 自动化平台</a:t>
-            </a:r>
-          </a:p>
-        </p:txBody>
-      </p:sp>
-      <p:sp>
-        <p:nvSpPr>
-          <p:cNvPr id="6" name="TextBox 5"/>
+              <a:t>Office 自动化平台</a:t>
+            </a:r>
+          </a:p>
+        </p:txBody>
+      </p:sp>
+      <p:sp>
+        <p:nvSpPr>
+          <p:cNvPr id="7" name="TextBox 6"/>
           <p:cNvSpPr txBox="1"/>
           <p:nvPr/>
         </p:nvSpPr>

</xml_diff>

<commit_message>
feat: showcase-grade layout system for all deck layouts
Design-system overhaul (showcase quality):
- unified content header (28pt title + accent rule) on every content slide
- editorial bullet rows (accent dot + hairline separators) replace box rows
- two-column/comparison panels with colored header strips
- kpi cards with accent top strip; architecture layers with numbered chips
  on a vertical spine; timeline with alternating above/below labels
- centered hero title cover + ghost circle accents (inset within the safe
  margin band — caught by the pixel-level bleed check)
- deck-title footer on all slides
- regenerated framework deck + review demo artifacts
</commit_message>
<xml_diff>
--- a/examples/output/draft-dcc-mcp-framework-intro.pptx
+++ b/examples/output/draft-dcc-mcp-framework-intro.pptx
@@ -4377,9 +4377,53 @@
           </a:p>
         </p:txBody>
       </p:sp>
+      <p:sp>
+        <p:nvSpPr>
+          <p:cNvPr id="4" name="Oval 3"/>
+          <p:cNvSpPr/>
+          <p:nvPr/>
+        </p:nvSpPr>
+        <p:spPr>
+          <a:xfrm>
+            <a:off x="9281160" y="4434840"/>
+            <a:ext cx="2788920" cy="2286000"/>
+          </a:xfrm>
+          <a:prstGeom prst="ellipse">
+            <a:avLst/>
+          </a:prstGeom>
+          <a:solidFill>
+            <a:srgbClr val="223047"/>
+          </a:solidFill>
+          <a:ln>
+            <a:noFill/>
+          </a:ln>
+          <a:effectLst/>
+        </p:spPr>
+        <p:style>
+          <a:lnRef idx="1">
+            <a:schemeClr val="accent1"/>
+          </a:lnRef>
+          <a:fillRef idx="3">
+            <a:schemeClr val="accent1"/>
+          </a:fillRef>
+          <a:effectRef idx="2">
+            <a:schemeClr val="accent1"/>
+          </a:effectRef>
+          <a:fontRef idx="minor">
+            <a:schemeClr val="lt1"/>
+          </a:fontRef>
+        </p:style>
+        <p:txBody>
+          <a:bodyPr rtlCol="0" anchor="ctr"/>
+          <a:lstStyle/>
+          <a:p>
+            <a:pPr algn="ctr"/>
+          </a:p>
+        </p:txBody>
+      </p:sp>
       <p:pic>
         <p:nvPicPr>
-          <p:cNvPr id="4" name="Picture 3" descr="dcc-mcp-logo-light.png"/>
+          <p:cNvPr id="5" name="Picture 4" descr="dcc-mcp-logo-light.png"/>
           <p:cNvPicPr>
             <a:picLocks noChangeAspect="1"/>
           </p:cNvPicPr>
@@ -4393,8 +4437,8 @@
         </p:blipFill>
         <p:spPr>
           <a:xfrm>
-            <a:off x="822960" y="411480"/>
-            <a:ext cx="1131570" cy="502920"/>
+            <a:off x="5413248" y="685800"/>
+            <a:ext cx="1234440" cy="548640"/>
           </a:xfrm>
           <a:prstGeom prst="rect">
             <a:avLst/>
@@ -4403,14 +4447,51 @@
       </p:pic>
       <p:sp>
         <p:nvSpPr>
-          <p:cNvPr id="5" name="Rectangle 4"/>
+          <p:cNvPr id="6" name="TextBox 5"/>
+          <p:cNvSpPr txBox="1"/>
+          <p:nvPr/>
+        </p:nvSpPr>
+        <p:spPr>
+          <a:xfrm>
+            <a:off x="1371600" y="2651760"/>
+            <a:ext cx="9418320" cy="1280160"/>
+          </a:xfrm>
+          <a:prstGeom prst="rect">
+            <a:avLst/>
+          </a:prstGeom>
+          <a:noFill/>
+          <a:effectLst/>
+        </p:spPr>
+        <p:txBody>
+          <a:bodyPr wrap="square" lIns="50800" rIns="50800">
+            <a:spAutoFit/>
+          </a:bodyPr>
+          <a:lstStyle/>
+          <a:p>
+            <a:pPr algn="ctr"/>
+            <a:r>
+              <a:rPr sz="5400" b="1">
+                <a:solidFill>
+                  <a:srgbClr val="E8ECF2"/>
+                </a:solidFill>
+                <a:latin typeface="Segoe UI"/>
+                <a:ea typeface="Microsoft YaHei"/>
+              </a:rPr>
+              <a:t>DCC-MCP</a:t>
+            </a:r>
+          </a:p>
+        </p:txBody>
+      </p:sp>
+      <p:sp>
+        <p:nvSpPr>
+          <p:cNvPr id="7" name="Rectangle 6"/>
           <p:cNvSpPr/>
           <p:nvPr/>
         </p:nvSpPr>
         <p:spPr>
           <a:xfrm>
-            <a:off x="822960" y="2377440"/>
-            <a:ext cx="2011680" cy="50800"/>
+            <a:off x="5687568" y="3977639"/>
+            <a:ext cx="822960" cy="50800"/>
           </a:xfrm>
           <a:prstGeom prst="rect">
             <a:avLst/>
@@ -4447,14 +4528,14 @@
       </p:sp>
       <p:sp>
         <p:nvSpPr>
-          <p:cNvPr id="6" name="TextBox 5"/>
+          <p:cNvPr id="8" name="TextBox 7"/>
           <p:cNvSpPr txBox="1"/>
           <p:nvPr/>
         </p:nvSpPr>
         <p:spPr>
           <a:xfrm>
-            <a:off x="822960" y="2514600"/>
-            <a:ext cx="10515600" cy="1463040"/>
+            <a:off x="1371600" y="4251960"/>
+            <a:ext cx="9418320" cy="914400"/>
           </a:xfrm>
           <a:prstGeom prst="rect">
             <a:avLst/>
@@ -4468,46 +4549,9 @@
           </a:bodyPr>
           <a:lstStyle/>
           <a:p>
-            <a:pPr algn="l"/>
-            <a:r>
-              <a:rPr sz="5400" b="1">
-                <a:solidFill>
-                  <a:srgbClr val="E8ECF2"/>
-                </a:solidFill>
-                <a:latin typeface="Segoe UI"/>
-                <a:ea typeface="Microsoft YaHei"/>
-              </a:rPr>
-              <a:t>DCC-MCP</a:t>
-            </a:r>
-          </a:p>
-        </p:txBody>
-      </p:sp>
-      <p:sp>
-        <p:nvSpPr>
-          <p:cNvPr id="7" name="TextBox 6"/>
-          <p:cNvSpPr txBox="1"/>
-          <p:nvPr/>
-        </p:nvSpPr>
-        <p:spPr>
-          <a:xfrm>
-            <a:off x="822960" y="4023360"/>
-            <a:ext cx="10058400" cy="1097280"/>
-          </a:xfrm>
-          <a:prstGeom prst="rect">
-            <a:avLst/>
-          </a:prstGeom>
-          <a:noFill/>
-          <a:effectLst/>
-        </p:spPr>
-        <p:txBody>
-          <a:bodyPr wrap="square" lIns="50800" rIns="50800">
-            <a:spAutoFit/>
-          </a:bodyPr>
-          <a:lstStyle/>
-          <a:p>
-            <a:pPr algn="l"/>
-            <a:r>
-              <a:rPr sz="2000" b="0">
+            <a:pPr algn="ctr"/>
+            <a:r>
+              <a:rPr sz="1800" b="0">
                 <a:solidFill>
                   <a:srgbClr val="9AA7BC"/>
                 </a:solidFill>
@@ -4518,9 +4562,9 @@
             </a:r>
           </a:p>
           <a:p>
-            <a:pPr algn="l"/>
-            <a:r>
-              <a:rPr sz="2000" b="0">
+            <a:pPr algn="ctr"/>
+            <a:r>
+              <a:rPr sz="1800" b="0">
                 <a:solidFill>
                   <a:srgbClr val="9AA7BC"/>
                 </a:solidFill>
@@ -4534,14 +4578,14 @@
       </p:sp>
       <p:sp>
         <p:nvSpPr>
-          <p:cNvPr id="8" name="TextBox 7"/>
+          <p:cNvPr id="9" name="TextBox 8"/>
           <p:cNvSpPr txBox="1"/>
           <p:nvPr/>
         </p:nvSpPr>
         <p:spPr>
           <a:xfrm>
-            <a:off x="822960" y="6126480"/>
-            <a:ext cx="10058400" cy="365760"/>
+            <a:off x="1371600" y="6263640"/>
+            <a:ext cx="9418320" cy="320040"/>
           </a:xfrm>
           <a:prstGeom prst="rect">
             <a:avLst/>
@@ -4555,9 +4599,9 @@
           </a:bodyPr>
           <a:lstStyle/>
           <a:p>
-            <a:pPr algn="l"/>
-            <a:r>
-              <a:rPr sz="1200" b="0">
+            <a:pPr algn="ctr"/>
+            <a:r>
+              <a:rPr sz="1100" b="0">
                 <a:solidFill>
                   <a:srgbClr val="9AA7BC"/>
                 </a:solidFill>
@@ -4571,7 +4615,44 @@
       </p:sp>
       <p:sp>
         <p:nvSpPr>
-          <p:cNvPr id="9" name="TextBox 8"/>
+          <p:cNvPr id="10" name="TextBox 9"/>
+          <p:cNvSpPr txBox="1"/>
+          <p:nvPr/>
+        </p:nvSpPr>
+        <p:spPr>
+          <a:xfrm>
+            <a:off x="822960" y="6473952"/>
+            <a:ext cx="7315200" cy="274320"/>
+          </a:xfrm>
+          <a:prstGeom prst="rect">
+            <a:avLst/>
+          </a:prstGeom>
+          <a:noFill/>
+          <a:effectLst/>
+        </p:spPr>
+        <p:txBody>
+          <a:bodyPr wrap="square" lIns="50800" rIns="50800">
+            <a:spAutoFit/>
+          </a:bodyPr>
+          <a:lstStyle/>
+          <a:p>
+            <a:pPr algn="l"/>
+            <a:r>
+              <a:rPr sz="1000" b="0">
+                <a:solidFill>
+                  <a:srgbClr val="9AA7BC"/>
+                </a:solidFill>
+                <a:latin typeface="Segoe UI"/>
+                <a:ea typeface="Microsoft YaHei"/>
+              </a:rPr>
+              <a:t>DCC-MCP 框架介绍</a:t>
+            </a:r>
+          </a:p>
+        </p:txBody>
+      </p:sp>
+      <p:sp>
+        <p:nvSpPr>
+          <p:cNvPr id="11" name="TextBox 10"/>
           <p:cNvSpPr txBox="1"/>
           <p:nvPr/>
         </p:nvSpPr>
@@ -4676,8 +4757,8 @@
         </p:nvSpPr>
         <p:spPr>
           <a:xfrm>
-            <a:off x="822960" y="457200"/>
-            <a:ext cx="10515600" cy="731520"/>
+            <a:off x="822960" y="502920"/>
+            <a:ext cx="10515600" cy="685800"/>
           </a:xfrm>
           <a:prstGeom prst="rect">
             <a:avLst/>
@@ -4693,7 +4774,7 @@
           <a:p>
             <a:pPr algn="l"/>
             <a:r>
-              <a:rPr sz="3000" b="1">
+              <a:rPr sz="2800" b="1">
                 <a:solidFill>
                   <a:srgbClr val="E8ECF2"/>
                 </a:solidFill>
@@ -4707,14 +4788,114 @@
       </p:sp>
       <p:sp>
         <p:nvSpPr>
-          <p:cNvPr id="4" name="Rounded Rectangle 3"/>
+          <p:cNvPr id="4" name="Rectangle 3"/>
           <p:cNvSpPr/>
           <p:nvPr/>
         </p:nvSpPr>
         <p:spPr>
           <a:xfrm>
-            <a:off x="2560320" y="1463040"/>
-            <a:ext cx="7040880" cy="777240"/>
+            <a:off x="822960" y="1298448"/>
+            <a:ext cx="822960" cy="44450"/>
+          </a:xfrm>
+          <a:prstGeom prst="rect">
+            <a:avLst/>
+          </a:prstGeom>
+          <a:solidFill>
+            <a:srgbClr val="4D9DE0"/>
+          </a:solidFill>
+          <a:ln>
+            <a:noFill/>
+          </a:ln>
+          <a:effectLst/>
+        </p:spPr>
+        <p:style>
+          <a:lnRef idx="1">
+            <a:schemeClr val="accent1"/>
+          </a:lnRef>
+          <a:fillRef idx="3">
+            <a:schemeClr val="accent1"/>
+          </a:fillRef>
+          <a:effectRef idx="2">
+            <a:schemeClr val="accent1"/>
+          </a:effectRef>
+          <a:fontRef idx="minor">
+            <a:schemeClr val="lt1"/>
+          </a:fontRef>
+        </p:style>
+        <p:txBody>
+          <a:bodyPr rtlCol="0" anchor="ctr" wrap="square"/>
+          <a:lstStyle/>
+          <a:p>
+            <a:pPr algn="ctr"/>
+          </a:p>
+        </p:txBody>
+      </p:sp>
+      <p:sp>
+        <p:nvSpPr>
+          <p:cNvPr id="5" name="Oval 4"/>
+          <p:cNvSpPr/>
+          <p:nvPr/>
+        </p:nvSpPr>
+        <p:spPr>
+          <a:xfrm>
+            <a:off x="2148840" y="1819656"/>
+            <a:ext cx="384048" cy="384048"/>
+          </a:xfrm>
+          <a:prstGeom prst="ellipse">
+            <a:avLst/>
+          </a:prstGeom>
+          <a:solidFill>
+            <a:srgbClr val="171F2E"/>
+          </a:solidFill>
+          <a:ln w="15240">
+            <a:solidFill>
+              <a:srgbClr val="4D9DE0"/>
+            </a:solidFill>
+          </a:ln>
+          <a:effectLst/>
+        </p:spPr>
+        <p:style>
+          <a:lnRef idx="1">
+            <a:schemeClr val="accent1"/>
+          </a:lnRef>
+          <a:fillRef idx="3">
+            <a:schemeClr val="accent1"/>
+          </a:fillRef>
+          <a:effectRef idx="2">
+            <a:schemeClr val="accent1"/>
+          </a:effectRef>
+          <a:fontRef idx="minor">
+            <a:schemeClr val="lt1"/>
+          </a:fontRef>
+        </p:style>
+        <p:txBody>
+          <a:bodyPr rtlCol="0" anchor="ctr" wrap="square" lIns="101600" rIns="101600" tIns="76200" bIns="76200"/>
+          <a:lstStyle/>
+          <a:p>
+            <a:pPr algn="ctr"/>
+            <a:r>
+              <a:rPr sz="1200" b="1">
+                <a:solidFill>
+                  <a:srgbClr val="4D9DE0"/>
+                </a:solidFill>
+                <a:latin typeface="Segoe UI"/>
+                <a:ea typeface="Microsoft YaHei"/>
+              </a:rPr>
+              <a:t>1</a:t>
+            </a:r>
+          </a:p>
+        </p:txBody>
+      </p:sp>
+      <p:sp>
+        <p:nvSpPr>
+          <p:cNvPr id="6" name="Rounded Rectangle 5"/>
+          <p:cNvSpPr/>
+          <p:nvPr/>
+        </p:nvSpPr>
+        <p:spPr>
+          <a:xfrm>
+            <a:off x="2788920" y="1673352"/>
+            <a:ext cx="8412480" cy="713232"/>
           </a:xfrm>
           <a:prstGeom prst="roundRect">
             <a:avLst>
@@ -4749,7 +4930,7 @@
           <a:p>
             <a:pPr algn="ctr"/>
             <a:r>
-              <a:rPr sz="1500" b="0">
+              <a:rPr sz="1450" b="0">
                 <a:solidFill>
                   <a:srgbClr val="E8ECF2"/>
                 </a:solidFill>
@@ -4763,14 +4944,70 @@
       </p:sp>
       <p:sp>
         <p:nvSpPr>
-          <p:cNvPr id="5" name="Rounded Rectangle 4"/>
+          <p:cNvPr id="7" name="Oval 6"/>
           <p:cNvSpPr/>
           <p:nvPr/>
         </p:nvSpPr>
         <p:spPr>
           <a:xfrm>
-            <a:off x="2560320" y="2331720"/>
-            <a:ext cx="7040880" cy="777240"/>
+            <a:off x="2148840" y="2688336"/>
+            <a:ext cx="384048" cy="384048"/>
+          </a:xfrm>
+          <a:prstGeom prst="ellipse">
+            <a:avLst/>
+          </a:prstGeom>
+          <a:solidFill>
+            <a:srgbClr val="171F2E"/>
+          </a:solidFill>
+          <a:ln w="15240">
+            <a:solidFill>
+              <a:srgbClr val="4D9DE0"/>
+            </a:solidFill>
+          </a:ln>
+          <a:effectLst/>
+        </p:spPr>
+        <p:style>
+          <a:lnRef idx="1">
+            <a:schemeClr val="accent1"/>
+          </a:lnRef>
+          <a:fillRef idx="3">
+            <a:schemeClr val="accent1"/>
+          </a:fillRef>
+          <a:effectRef idx="2">
+            <a:schemeClr val="accent1"/>
+          </a:effectRef>
+          <a:fontRef idx="minor">
+            <a:schemeClr val="lt1"/>
+          </a:fontRef>
+        </p:style>
+        <p:txBody>
+          <a:bodyPr rtlCol="0" anchor="ctr" wrap="square" lIns="101600" rIns="101600" tIns="76200" bIns="76200"/>
+          <a:lstStyle/>
+          <a:p>
+            <a:pPr algn="ctr"/>
+            <a:r>
+              <a:rPr sz="1200" b="1">
+                <a:solidFill>
+                  <a:srgbClr val="4D9DE0"/>
+                </a:solidFill>
+                <a:latin typeface="Segoe UI"/>
+                <a:ea typeface="Microsoft YaHei"/>
+              </a:rPr>
+              <a:t>2</a:t>
+            </a:r>
+          </a:p>
+        </p:txBody>
+      </p:sp>
+      <p:sp>
+        <p:nvSpPr>
+          <p:cNvPr id="8" name="Rounded Rectangle 7"/>
+          <p:cNvSpPr/>
+          <p:nvPr/>
+        </p:nvSpPr>
+        <p:spPr>
+          <a:xfrm>
+            <a:off x="2788920" y="2542032"/>
+            <a:ext cx="8412480" cy="713232"/>
           </a:xfrm>
           <a:prstGeom prst="roundRect">
             <a:avLst>
@@ -4805,7 +5042,7 @@
           <a:p>
             <a:pPr algn="ctr"/>
             <a:r>
-              <a:rPr sz="1500" b="0">
+              <a:rPr sz="1450" b="0">
                 <a:solidFill>
                   <a:srgbClr val="E8ECF2"/>
                 </a:solidFill>
@@ -4819,14 +5056,70 @@
       </p:sp>
       <p:sp>
         <p:nvSpPr>
-          <p:cNvPr id="6" name="Rounded Rectangle 5"/>
+          <p:cNvPr id="9" name="Oval 8"/>
           <p:cNvSpPr/>
           <p:nvPr/>
         </p:nvSpPr>
         <p:spPr>
           <a:xfrm>
-            <a:off x="2560320" y="3200400"/>
-            <a:ext cx="7040880" cy="777240"/>
+            <a:off x="2148840" y="3557016"/>
+            <a:ext cx="384048" cy="384048"/>
+          </a:xfrm>
+          <a:prstGeom prst="ellipse">
+            <a:avLst/>
+          </a:prstGeom>
+          <a:solidFill>
+            <a:srgbClr val="171F2E"/>
+          </a:solidFill>
+          <a:ln w="15240">
+            <a:solidFill>
+              <a:srgbClr val="4D9DE0"/>
+            </a:solidFill>
+          </a:ln>
+          <a:effectLst/>
+        </p:spPr>
+        <p:style>
+          <a:lnRef idx="1">
+            <a:schemeClr val="accent1"/>
+          </a:lnRef>
+          <a:fillRef idx="3">
+            <a:schemeClr val="accent1"/>
+          </a:fillRef>
+          <a:effectRef idx="2">
+            <a:schemeClr val="accent1"/>
+          </a:effectRef>
+          <a:fontRef idx="minor">
+            <a:schemeClr val="lt1"/>
+          </a:fontRef>
+        </p:style>
+        <p:txBody>
+          <a:bodyPr rtlCol="0" anchor="ctr" wrap="square" lIns="101600" rIns="101600" tIns="76200" bIns="76200"/>
+          <a:lstStyle/>
+          <a:p>
+            <a:pPr algn="ctr"/>
+            <a:r>
+              <a:rPr sz="1200" b="1">
+                <a:solidFill>
+                  <a:srgbClr val="4D9DE0"/>
+                </a:solidFill>
+                <a:latin typeface="Segoe UI"/>
+                <a:ea typeface="Microsoft YaHei"/>
+              </a:rPr>
+              <a:t>3</a:t>
+            </a:r>
+          </a:p>
+        </p:txBody>
+      </p:sp>
+      <p:sp>
+        <p:nvSpPr>
+          <p:cNvPr id="10" name="Rounded Rectangle 9"/>
+          <p:cNvSpPr/>
+          <p:nvPr/>
+        </p:nvSpPr>
+        <p:spPr>
+          <a:xfrm>
+            <a:off x="2788920" y="3410712"/>
+            <a:ext cx="8412480" cy="713232"/>
           </a:xfrm>
           <a:prstGeom prst="roundRect">
             <a:avLst>
@@ -4861,7 +5154,7 @@
           <a:p>
             <a:pPr algn="ctr"/>
             <a:r>
-              <a:rPr sz="1500" b="0">
+              <a:rPr sz="1450" b="0">
                 <a:solidFill>
                   <a:srgbClr val="E8ECF2"/>
                 </a:solidFill>
@@ -4875,14 +5168,70 @@
       </p:sp>
       <p:sp>
         <p:nvSpPr>
-          <p:cNvPr id="7" name="Rounded Rectangle 6"/>
+          <p:cNvPr id="11" name="Oval 10"/>
           <p:cNvSpPr/>
           <p:nvPr/>
         </p:nvSpPr>
         <p:spPr>
           <a:xfrm>
-            <a:off x="2560320" y="4069079"/>
-            <a:ext cx="7040880" cy="777240"/>
+            <a:off x="2148840" y="4425696"/>
+            <a:ext cx="384048" cy="384048"/>
+          </a:xfrm>
+          <a:prstGeom prst="ellipse">
+            <a:avLst/>
+          </a:prstGeom>
+          <a:solidFill>
+            <a:srgbClr val="171F2E"/>
+          </a:solidFill>
+          <a:ln w="15240">
+            <a:solidFill>
+              <a:srgbClr val="4D9DE0"/>
+            </a:solidFill>
+          </a:ln>
+          <a:effectLst/>
+        </p:spPr>
+        <p:style>
+          <a:lnRef idx="1">
+            <a:schemeClr val="accent1"/>
+          </a:lnRef>
+          <a:fillRef idx="3">
+            <a:schemeClr val="accent1"/>
+          </a:fillRef>
+          <a:effectRef idx="2">
+            <a:schemeClr val="accent1"/>
+          </a:effectRef>
+          <a:fontRef idx="minor">
+            <a:schemeClr val="lt1"/>
+          </a:fontRef>
+        </p:style>
+        <p:txBody>
+          <a:bodyPr rtlCol="0" anchor="ctr" wrap="square" lIns="101600" rIns="101600" tIns="76200" bIns="76200"/>
+          <a:lstStyle/>
+          <a:p>
+            <a:pPr algn="ctr"/>
+            <a:r>
+              <a:rPr sz="1200" b="1">
+                <a:solidFill>
+                  <a:srgbClr val="4D9DE0"/>
+                </a:solidFill>
+                <a:latin typeface="Segoe UI"/>
+                <a:ea typeface="Microsoft YaHei"/>
+              </a:rPr>
+              <a:t>4</a:t>
+            </a:r>
+          </a:p>
+        </p:txBody>
+      </p:sp>
+      <p:sp>
+        <p:nvSpPr>
+          <p:cNvPr id="12" name="Rounded Rectangle 11"/>
+          <p:cNvSpPr/>
+          <p:nvPr/>
+        </p:nvSpPr>
+        <p:spPr>
+          <a:xfrm>
+            <a:off x="2788920" y="4279392"/>
+            <a:ext cx="8412480" cy="713232"/>
           </a:xfrm>
           <a:prstGeom prst="roundRect">
             <a:avLst>
@@ -4917,7 +5266,7 @@
           <a:p>
             <a:pPr algn="ctr"/>
             <a:r>
-              <a:rPr sz="1500" b="0">
+              <a:rPr sz="1450" b="0">
                 <a:solidFill>
                   <a:srgbClr val="E8ECF2"/>
                 </a:solidFill>
@@ -4931,14 +5280,70 @@
       </p:sp>
       <p:sp>
         <p:nvSpPr>
-          <p:cNvPr id="8" name="Rounded Rectangle 7"/>
+          <p:cNvPr id="13" name="Oval 12"/>
           <p:cNvSpPr/>
           <p:nvPr/>
         </p:nvSpPr>
         <p:spPr>
           <a:xfrm>
-            <a:off x="2560320" y="4937760"/>
-            <a:ext cx="7040880" cy="777240"/>
+            <a:off x="2148840" y="5294376"/>
+            <a:ext cx="384048" cy="384048"/>
+          </a:xfrm>
+          <a:prstGeom prst="ellipse">
+            <a:avLst/>
+          </a:prstGeom>
+          <a:solidFill>
+            <a:srgbClr val="171F2E"/>
+          </a:solidFill>
+          <a:ln w="15240">
+            <a:solidFill>
+              <a:srgbClr val="4D9DE0"/>
+            </a:solidFill>
+          </a:ln>
+          <a:effectLst/>
+        </p:spPr>
+        <p:style>
+          <a:lnRef idx="1">
+            <a:schemeClr val="accent1"/>
+          </a:lnRef>
+          <a:fillRef idx="3">
+            <a:schemeClr val="accent1"/>
+          </a:fillRef>
+          <a:effectRef idx="2">
+            <a:schemeClr val="accent1"/>
+          </a:effectRef>
+          <a:fontRef idx="minor">
+            <a:schemeClr val="lt1"/>
+          </a:fontRef>
+        </p:style>
+        <p:txBody>
+          <a:bodyPr rtlCol="0" anchor="ctr" wrap="square" lIns="101600" rIns="101600" tIns="76200" bIns="76200"/>
+          <a:lstStyle/>
+          <a:p>
+            <a:pPr algn="ctr"/>
+            <a:r>
+              <a:rPr sz="1200" b="1">
+                <a:solidFill>
+                  <a:srgbClr val="4D9DE0"/>
+                </a:solidFill>
+                <a:latin typeface="Segoe UI"/>
+                <a:ea typeface="Microsoft YaHei"/>
+              </a:rPr>
+              <a:t>5</a:t>
+            </a:r>
+          </a:p>
+        </p:txBody>
+      </p:sp>
+      <p:sp>
+        <p:nvSpPr>
+          <p:cNvPr id="14" name="Rounded Rectangle 13"/>
+          <p:cNvSpPr/>
+          <p:nvPr/>
+        </p:nvSpPr>
+        <p:spPr>
+          <a:xfrm>
+            <a:off x="2788920" y="5148072"/>
+            <a:ext cx="8412480" cy="713232"/>
           </a:xfrm>
           <a:prstGeom prst="roundRect">
             <a:avLst>
@@ -4973,7 +5378,7 @@
           <a:p>
             <a:pPr algn="ctr"/>
             <a:r>
-              <a:rPr sz="1500" b="0">
+              <a:rPr sz="1450" b="0">
                 <a:solidFill>
                   <a:srgbClr val="E8ECF2"/>
                 </a:solidFill>
@@ -4987,14 +5392,14 @@
       </p:sp>
       <p:cxnSp>
         <p:nvCxnSpPr>
-          <p:cNvPr id="9" name="Connector 8"/>
+          <p:cNvPr id="15" name="Connector 14"/>
           <p:cNvCxnSpPr/>
           <p:nvPr/>
         </p:nvCxnSpPr>
         <p:spPr>
           <a:xfrm>
-            <a:off x="6080760" y="1851660"/>
-            <a:ext cx="0" cy="3474720"/>
+            <a:off x="2340864" y="2194560"/>
+            <a:ext cx="0" cy="3474719"/>
           </a:xfrm>
           <a:prstGeom prst="line">
             <a:avLst/>
@@ -5023,7 +5428,44 @@
       </p:cxnSp>
       <p:sp>
         <p:nvSpPr>
-          <p:cNvPr id="10" name="TextBox 9"/>
+          <p:cNvPr id="16" name="TextBox 15"/>
+          <p:cNvSpPr txBox="1"/>
+          <p:nvPr/>
+        </p:nvSpPr>
+        <p:spPr>
+          <a:xfrm>
+            <a:off x="822960" y="6473952"/>
+            <a:ext cx="7315200" cy="274320"/>
+          </a:xfrm>
+          <a:prstGeom prst="rect">
+            <a:avLst/>
+          </a:prstGeom>
+          <a:noFill/>
+          <a:effectLst/>
+        </p:spPr>
+        <p:txBody>
+          <a:bodyPr wrap="square" lIns="50800" rIns="50800">
+            <a:spAutoFit/>
+          </a:bodyPr>
+          <a:lstStyle/>
+          <a:p>
+            <a:pPr algn="l"/>
+            <a:r>
+              <a:rPr sz="1000" b="0">
+                <a:solidFill>
+                  <a:srgbClr val="9AA7BC"/>
+                </a:solidFill>
+                <a:latin typeface="Segoe UI"/>
+                <a:ea typeface="Microsoft YaHei"/>
+              </a:rPr>
+              <a:t>DCC-MCP 框架介绍</a:t>
+            </a:r>
+          </a:p>
+        </p:txBody>
+      </p:sp>
+      <p:sp>
+        <p:nvSpPr>
+          <p:cNvPr id="17" name="TextBox 16"/>
           <p:cNvSpPr txBox="1"/>
           <p:nvPr/>
         </p:nvSpPr>
@@ -5128,8 +5570,8 @@
         </p:nvSpPr>
         <p:spPr>
           <a:xfrm>
-            <a:off x="822960" y="457200"/>
-            <a:ext cx="10515600" cy="731520"/>
+            <a:off x="822960" y="502920"/>
+            <a:ext cx="10515600" cy="685800"/>
           </a:xfrm>
           <a:prstGeom prst="rect">
             <a:avLst/>
@@ -5145,7 +5587,7 @@
           <a:p>
             <a:pPr algn="l"/>
             <a:r>
-              <a:rPr sz="3000" b="1">
+              <a:rPr sz="2800" b="1">
                 <a:solidFill>
                   <a:srgbClr val="E8ECF2"/>
                 </a:solidFill>
@@ -5159,19 +5601,17 @@
       </p:sp>
       <p:sp>
         <p:nvSpPr>
-          <p:cNvPr id="4" name="Rounded Rectangle 3"/>
+          <p:cNvPr id="4" name="Rectangle 3"/>
           <p:cNvSpPr/>
           <p:nvPr/>
         </p:nvSpPr>
         <p:spPr>
           <a:xfrm>
-            <a:off x="822960" y="1371600"/>
-            <a:ext cx="5120640" cy="640080"/>
-          </a:xfrm>
-          <a:prstGeom prst="roundRect">
-            <a:avLst>
-              <a:gd name="adj" fmla="val 12000"/>
-            </a:avLst>
+            <a:off x="822960" y="1298448"/>
+            <a:ext cx="822960" cy="44450"/>
+          </a:xfrm>
+          <a:prstGeom prst="rect">
+            <a:avLst/>
           </a:prstGeom>
           <a:solidFill>
             <a:srgbClr val="4D9DE0"/>
@@ -5196,12 +5636,58 @@
           </a:fontRef>
         </p:style>
         <p:txBody>
+          <a:bodyPr rtlCol="0" anchor="ctr" wrap="square"/>
+          <a:lstStyle/>
+          <a:p>
+            <a:pPr algn="ctr"/>
+          </a:p>
+        </p:txBody>
+      </p:sp>
+      <p:sp>
+        <p:nvSpPr>
+          <p:cNvPr id="5" name="Rounded Rectangle 4"/>
+          <p:cNvSpPr/>
+          <p:nvPr/>
+        </p:nvSpPr>
+        <p:spPr>
+          <a:xfrm>
+            <a:off x="822960" y="1627632"/>
+            <a:ext cx="5120640" cy="566928"/>
+          </a:xfrm>
+          <a:prstGeom prst="roundRect">
+            <a:avLst>
+              <a:gd name="adj" fmla="val 16000"/>
+            </a:avLst>
+          </a:prstGeom>
+          <a:solidFill>
+            <a:srgbClr val="4D9DE0"/>
+          </a:solidFill>
+          <a:ln>
+            <a:noFill/>
+          </a:ln>
+          <a:effectLst/>
+        </p:spPr>
+        <p:style>
+          <a:lnRef idx="1">
+            <a:schemeClr val="accent1"/>
+          </a:lnRef>
+          <a:fillRef idx="3">
+            <a:schemeClr val="accent1"/>
+          </a:fillRef>
+          <a:effectRef idx="2">
+            <a:schemeClr val="accent1"/>
+          </a:effectRef>
+          <a:fontRef idx="minor">
+            <a:schemeClr val="lt1"/>
+          </a:fontRef>
+        </p:style>
+        <p:txBody>
           <a:bodyPr rtlCol="0" anchor="ctr" wrap="square" lIns="101600" rIns="101600" tIns="76200" bIns="76200"/>
           <a:lstStyle/>
           <a:p>
             <a:pPr algn="ctr"/>
             <a:r>
-              <a:rPr sz="1800" b="1">
+              <a:rPr sz="1600" b="1">
                 <a:solidFill>
                   <a:srgbClr val="E8ECF2"/>
                 </a:solidFill>
@@ -5215,18 +5701,18 @@
       </p:sp>
       <p:sp>
         <p:nvSpPr>
-          <p:cNvPr id="5" name="Rounded Rectangle 4"/>
+          <p:cNvPr id="6" name="Rounded Rectangle 5"/>
           <p:cNvSpPr/>
           <p:nvPr/>
         </p:nvSpPr>
         <p:spPr>
           <a:xfrm>
-            <a:off x="822960" y="2148840"/>
-            <a:ext cx="5120640" cy="3977639"/>
+            <a:off x="822960" y="2304288"/>
+            <a:ext cx="5120640" cy="3749039"/>
           </a:xfrm>
           <a:prstGeom prst="roundRect">
             <a:avLst>
-              <a:gd name="adj" fmla="val 6000"/>
+              <a:gd name="adj" fmla="val 5000"/>
             </a:avLst>
           </a:prstGeom>
           <a:solidFill>
@@ -5257,58 +5743,58 @@
           <a:p>
             <a:pPr algn="l"/>
             <a:r>
-              <a:rPr sz="1500" b="0">
+              <a:rPr sz="1450" b="0">
                 <a:solidFill>
                   <a:srgbClr val="E8ECF2"/>
                 </a:solidFill>
                 <a:latin typeface="Segoe UI"/>
                 <a:ea typeface="Microsoft YaHei"/>
               </a:rPr>
-              <a:t>●  确定性、可验证、可审计</a:t>
+              <a:t>✓  确定性、可验证、可审计</a:t>
             </a:r>
           </a:p>
           <a:p>
             <a:pPr algn="l"/>
             <a:r>
-              <a:rPr sz="1500" b="0">
+              <a:rPr sz="1450" b="0">
                 <a:solidFill>
                   <a:srgbClr val="E8ECF2"/>
                 </a:solidFill>
                 <a:latin typeface="Segoe UI"/>
                 <a:ea typeface="Microsoft YaHei"/>
               </a:rPr>
-              <a:t>●  UIA/CUA 只做最后兜底</a:t>
+              <a:t>✓  UIA/CUA 只做最后兜底</a:t>
             </a:r>
           </a:p>
           <a:p>
             <a:pPr algn="l"/>
             <a:r>
-              <a:rPr sz="1500" b="0">
+              <a:rPr sz="1450" b="0">
                 <a:solidFill>
                   <a:srgbClr val="E8ECF2"/>
                 </a:solidFill>
                 <a:latin typeface="Segoe UI"/>
                 <a:ea typeface="Microsoft YaHei"/>
               </a:rPr>
-              <a:t>●  写操作不得静默降级</a:t>
-            </a:r>
-          </a:p>
-        </p:txBody>
-      </p:sp>
-      <p:sp>
-        <p:nvSpPr>
-          <p:cNvPr id="6" name="Rounded Rectangle 5"/>
+              <a:t>✓  写操作不得静默降级</a:t>
+            </a:r>
+          </a:p>
+        </p:txBody>
+      </p:sp>
+      <p:sp>
+        <p:nvSpPr>
+          <p:cNvPr id="7" name="Rounded Rectangle 6"/>
           <p:cNvSpPr/>
           <p:nvPr/>
         </p:nvSpPr>
         <p:spPr>
           <a:xfrm>
-            <a:off x="6309360" y="1371600"/>
-            <a:ext cx="5120640" cy="640080"/>
+            <a:off x="6309360" y="1627632"/>
+            <a:ext cx="5120640" cy="566928"/>
           </a:xfrm>
           <a:prstGeom prst="roundRect">
             <a:avLst>
-              <a:gd name="adj" fmla="val 12000"/>
+              <a:gd name="adj" fmla="val 16000"/>
             </a:avLst>
           </a:prstGeom>
           <a:solidFill>
@@ -5339,7 +5825,7 @@
           <a:p>
             <a:pPr algn="ctr"/>
             <a:r>
-              <a:rPr sz="1800" b="1">
+              <a:rPr sz="1600" b="1">
                 <a:solidFill>
                   <a:srgbClr val="E8ECF2"/>
                 </a:solidFill>
@@ -5353,18 +5839,18 @@
       </p:sp>
       <p:sp>
         <p:nvSpPr>
-          <p:cNvPr id="7" name="Rounded Rectangle 6"/>
+          <p:cNvPr id="8" name="Rounded Rectangle 7"/>
           <p:cNvSpPr/>
           <p:nvPr/>
         </p:nvSpPr>
         <p:spPr>
           <a:xfrm>
-            <a:off x="6309360" y="2148840"/>
-            <a:ext cx="5120640" cy="3977639"/>
+            <a:off x="6309360" y="2304288"/>
+            <a:ext cx="5120640" cy="3749039"/>
           </a:xfrm>
           <a:prstGeom prst="roundRect">
             <a:avLst>
-              <a:gd name="adj" fmla="val 6000"/>
+              <a:gd name="adj" fmla="val 5000"/>
             </a:avLst>
           </a:prstGeom>
           <a:solidFill>
@@ -5395,47 +5881,84 @@
           <a:p>
             <a:pPr algn="l"/>
             <a:r>
-              <a:rPr sz="1500" b="0">
+              <a:rPr sz="1450" b="0">
                 <a:solidFill>
                   <a:srgbClr val="E8ECF2"/>
                 </a:solidFill>
                 <a:latin typeface="Segoe UI"/>
                 <a:ea typeface="Microsoft YaHei"/>
               </a:rPr>
-              <a:t>●  不暴露原始 COM 成员</a:t>
+              <a:t>✓  不暴露原始 COM 成员</a:t>
             </a:r>
           </a:p>
           <a:p>
             <a:pPr algn="l"/>
             <a:r>
-              <a:rPr sz="1500" b="0">
+              <a:rPr sz="1450" b="0">
                 <a:solidFill>
                   <a:srgbClr val="E8ECF2"/>
                 </a:solidFill>
                 <a:latin typeface="Segoe UI"/>
                 <a:ea typeface="Microsoft YaHei"/>
               </a:rPr>
-              <a:t>●  模板优先于自由坐标</a:t>
+              <a:t>✓  模板优先于自由坐标</a:t>
             </a:r>
           </a:p>
           <a:p>
             <a:pPr algn="l"/>
             <a:r>
-              <a:rPr sz="1500" b="0">
+              <a:rPr sz="1450" b="0">
                 <a:solidFill>
                   <a:srgbClr val="E8ECF2"/>
                 </a:solidFill>
                 <a:latin typeface="Segoe UI"/>
                 <a:ea typeface="Microsoft YaHei"/>
               </a:rPr>
-              <a:t>●  检查点 + 预览 + 可追踪结果</a:t>
-            </a:r>
-          </a:p>
-        </p:txBody>
-      </p:sp>
-      <p:sp>
-        <p:nvSpPr>
-          <p:cNvPr id="8" name="TextBox 7"/>
+              <a:t>✓  检查点 + 预览 + 可追踪结果</a:t>
+            </a:r>
+          </a:p>
+        </p:txBody>
+      </p:sp>
+      <p:sp>
+        <p:nvSpPr>
+          <p:cNvPr id="9" name="TextBox 8"/>
+          <p:cNvSpPr txBox="1"/>
+          <p:nvPr/>
+        </p:nvSpPr>
+        <p:spPr>
+          <a:xfrm>
+            <a:off x="822960" y="6473952"/>
+            <a:ext cx="7315200" cy="274320"/>
+          </a:xfrm>
+          <a:prstGeom prst="rect">
+            <a:avLst/>
+          </a:prstGeom>
+          <a:noFill/>
+          <a:effectLst/>
+        </p:spPr>
+        <p:txBody>
+          <a:bodyPr wrap="square" lIns="50800" rIns="50800">
+            <a:spAutoFit/>
+          </a:bodyPr>
+          <a:lstStyle/>
+          <a:p>
+            <a:pPr algn="l"/>
+            <a:r>
+              <a:rPr sz="1000" b="0">
+                <a:solidFill>
+                  <a:srgbClr val="9AA7BC"/>
+                </a:solidFill>
+                <a:latin typeface="Segoe UI"/>
+                <a:ea typeface="Microsoft YaHei"/>
+              </a:rPr>
+              <a:t>DCC-MCP 框架介绍</a:t>
+            </a:r>
+          </a:p>
+        </p:txBody>
+      </p:sp>
+      <p:sp>
+        <p:nvSpPr>
+          <p:cNvPr id="10" name="TextBox 9"/>
           <p:cNvSpPr txBox="1"/>
           <p:nvPr/>
         </p:nvSpPr>
@@ -5576,9 +6099,53 @@
           </a:p>
         </p:txBody>
       </p:sp>
+      <p:sp>
+        <p:nvSpPr>
+          <p:cNvPr id="4" name="Oval 3"/>
+          <p:cNvSpPr/>
+          <p:nvPr/>
+        </p:nvSpPr>
+        <p:spPr>
+          <a:xfrm>
+            <a:off x="320040" y="320040"/>
+            <a:ext cx="2651760" cy="2651760"/>
+          </a:xfrm>
+          <a:prstGeom prst="ellipse">
+            <a:avLst/>
+          </a:prstGeom>
+          <a:solidFill>
+            <a:srgbClr val="223047"/>
+          </a:solidFill>
+          <a:ln>
+            <a:noFill/>
+          </a:ln>
+          <a:effectLst/>
+        </p:spPr>
+        <p:style>
+          <a:lnRef idx="1">
+            <a:schemeClr val="accent1"/>
+          </a:lnRef>
+          <a:fillRef idx="3">
+            <a:schemeClr val="accent1"/>
+          </a:fillRef>
+          <a:effectRef idx="2">
+            <a:schemeClr val="accent1"/>
+          </a:effectRef>
+          <a:fontRef idx="minor">
+            <a:schemeClr val="lt1"/>
+          </a:fontRef>
+        </p:style>
+        <p:txBody>
+          <a:bodyPr rtlCol="0" anchor="ctr"/>
+          <a:lstStyle/>
+          <a:p>
+            <a:pPr algn="ctr"/>
+          </a:p>
+        </p:txBody>
+      </p:sp>
       <p:pic>
         <p:nvPicPr>
-          <p:cNvPr id="4" name="Picture 3" descr="dcc-mcp-logo-light.png"/>
+          <p:cNvPr id="5" name="Picture 4" descr="dcc-mcp-logo-light.png"/>
           <p:cNvPicPr>
             <a:picLocks noChangeAspect="1"/>
           </p:cNvPicPr>
@@ -5592,8 +6159,8 @@
         </p:blipFill>
         <p:spPr>
           <a:xfrm>
-            <a:off x="5413248" y="1371600"/>
-            <a:ext cx="1851660" cy="822960"/>
+            <a:off x="5413248" y="1965960"/>
+            <a:ext cx="1645920" cy="731520"/>
           </a:xfrm>
           <a:prstGeom prst="rect">
             <a:avLst/>
@@ -5602,14 +6169,14 @@
       </p:pic>
       <p:sp>
         <p:nvSpPr>
-          <p:cNvPr id="5" name="TextBox 4"/>
+          <p:cNvPr id="6" name="TextBox 5"/>
           <p:cNvSpPr txBox="1"/>
           <p:nvPr/>
         </p:nvSpPr>
         <p:spPr>
           <a:xfrm>
-            <a:off x="1371600" y="2468880"/>
-            <a:ext cx="9418320" cy="1371600"/>
+            <a:off x="1371600" y="3063240"/>
+            <a:ext cx="9418320" cy="1097280"/>
           </a:xfrm>
           <a:prstGeom prst="rect">
             <a:avLst/>
@@ -5625,7 +6192,7 @@
           <a:p>
             <a:pPr algn="ctr"/>
             <a:r>
-              <a:rPr sz="4800" b="1">
+              <a:rPr sz="4600" b="1">
                 <a:solidFill>
                   <a:srgbClr val="E8ECF2"/>
                 </a:solidFill>
@@ -5639,14 +6206,14 @@
       </p:sp>
       <p:sp>
         <p:nvSpPr>
-          <p:cNvPr id="6" name="TextBox 5"/>
+          <p:cNvPr id="7" name="TextBox 6"/>
           <p:cNvSpPr txBox="1"/>
           <p:nvPr/>
         </p:nvSpPr>
         <p:spPr>
           <a:xfrm>
-            <a:off x="1371600" y="4023360"/>
-            <a:ext cx="9418320" cy="731520"/>
+            <a:off x="1371600" y="4343400"/>
+            <a:ext cx="9418320" cy="640080"/>
           </a:xfrm>
           <a:prstGeom prst="rect">
             <a:avLst/>
@@ -5662,7 +6229,7 @@
           <a:p>
             <a:pPr algn="ctr"/>
             <a:r>
-              <a:rPr sz="1800" b="0">
+              <a:rPr sz="1600" b="0">
                 <a:solidFill>
                   <a:srgbClr val="9AA7BC"/>
                 </a:solidFill>
@@ -5676,7 +6243,44 @@
       </p:sp>
       <p:sp>
         <p:nvSpPr>
-          <p:cNvPr id="7" name="TextBox 6"/>
+          <p:cNvPr id="8" name="TextBox 7"/>
+          <p:cNvSpPr txBox="1"/>
+          <p:nvPr/>
+        </p:nvSpPr>
+        <p:spPr>
+          <a:xfrm>
+            <a:off x="822960" y="6473952"/>
+            <a:ext cx="7315200" cy="274320"/>
+          </a:xfrm>
+          <a:prstGeom prst="rect">
+            <a:avLst/>
+          </a:prstGeom>
+          <a:noFill/>
+          <a:effectLst/>
+        </p:spPr>
+        <p:txBody>
+          <a:bodyPr wrap="square" lIns="50800" rIns="50800">
+            <a:spAutoFit/>
+          </a:bodyPr>
+          <a:lstStyle/>
+          <a:p>
+            <a:pPr algn="l"/>
+            <a:r>
+              <a:rPr sz="1000" b="0">
+                <a:solidFill>
+                  <a:srgbClr val="9AA7BC"/>
+                </a:solidFill>
+                <a:latin typeface="Segoe UI"/>
+                <a:ea typeface="Microsoft YaHei"/>
+              </a:rPr>
+              <a:t>DCC-MCP 框架介绍</a:t>
+            </a:r>
+          </a:p>
+        </p:txBody>
+      </p:sp>
+      <p:sp>
+        <p:nvSpPr>
+          <p:cNvPr id="9" name="TextBox 8"/>
           <p:cNvSpPr txBox="1"/>
           <p:nvPr/>
         </p:nvSpPr>
@@ -5819,13 +6423,57 @@
       </p:sp>
       <p:sp>
         <p:nvSpPr>
-          <p:cNvPr id="4" name="TextBox 3"/>
+          <p:cNvPr id="4" name="Oval 3"/>
+          <p:cNvSpPr/>
+          <p:nvPr/>
+        </p:nvSpPr>
+        <p:spPr>
+          <a:xfrm>
+            <a:off x="9601200" y="320040"/>
+            <a:ext cx="2468880" cy="2468880"/>
+          </a:xfrm>
+          <a:prstGeom prst="ellipse">
+            <a:avLst/>
+          </a:prstGeom>
+          <a:solidFill>
+            <a:srgbClr val="223047"/>
+          </a:solidFill>
+          <a:ln>
+            <a:noFill/>
+          </a:ln>
+          <a:effectLst/>
+        </p:spPr>
+        <p:style>
+          <a:lnRef idx="1">
+            <a:schemeClr val="accent1"/>
+          </a:lnRef>
+          <a:fillRef idx="3">
+            <a:schemeClr val="accent1"/>
+          </a:fillRef>
+          <a:effectRef idx="2">
+            <a:schemeClr val="accent1"/>
+          </a:effectRef>
+          <a:fontRef idx="minor">
+            <a:schemeClr val="lt1"/>
+          </a:fontRef>
+        </p:style>
+        <p:txBody>
+          <a:bodyPr rtlCol="0" anchor="ctr"/>
+          <a:lstStyle/>
+          <a:p>
+            <a:pPr algn="ctr"/>
+          </a:p>
+        </p:txBody>
+      </p:sp>
+      <p:sp>
+        <p:nvSpPr>
+          <p:cNvPr id="5" name="TextBox 4"/>
           <p:cNvSpPr txBox="1"/>
           <p:nvPr/>
         </p:nvSpPr>
         <p:spPr>
           <a:xfrm>
-            <a:off x="640080" y="548640"/>
+            <a:off x="640080" y="640080"/>
             <a:ext cx="4572000" cy="3840480"/>
           </a:xfrm>
           <a:prstGeom prst="rect">
@@ -5856,13 +6504,13 @@
       </p:sp>
       <p:sp>
         <p:nvSpPr>
-          <p:cNvPr id="5" name="Rectangle 4"/>
+          <p:cNvPr id="6" name="Rectangle 5"/>
           <p:cNvSpPr/>
           <p:nvPr/>
         </p:nvSpPr>
         <p:spPr>
           <a:xfrm>
-            <a:off x="822960" y="2880360"/>
+            <a:off x="822960" y="2788920"/>
             <a:ext cx="164592" cy="1097280"/>
           </a:xfrm>
           <a:prstGeom prst="rect">
@@ -5900,13 +6548,13 @@
       </p:sp>
       <p:sp>
         <p:nvSpPr>
-          <p:cNvPr id="6" name="TextBox 5"/>
+          <p:cNvPr id="7" name="TextBox 6"/>
           <p:cNvSpPr txBox="1"/>
           <p:nvPr/>
         </p:nvSpPr>
         <p:spPr>
           <a:xfrm>
-            <a:off x="1188720" y="2834640"/>
+            <a:off x="1188720" y="2743200"/>
             <a:ext cx="10058400" cy="1280160"/>
           </a:xfrm>
           <a:prstGeom prst="rect">
@@ -5937,7 +6585,44 @@
       </p:sp>
       <p:sp>
         <p:nvSpPr>
-          <p:cNvPr id="7" name="TextBox 6"/>
+          <p:cNvPr id="8" name="TextBox 7"/>
+          <p:cNvSpPr txBox="1"/>
+          <p:nvPr/>
+        </p:nvSpPr>
+        <p:spPr>
+          <a:xfrm>
+            <a:off x="822960" y="6473952"/>
+            <a:ext cx="7315200" cy="274320"/>
+          </a:xfrm>
+          <a:prstGeom prst="rect">
+            <a:avLst/>
+          </a:prstGeom>
+          <a:noFill/>
+          <a:effectLst/>
+        </p:spPr>
+        <p:txBody>
+          <a:bodyPr wrap="square" lIns="50800" rIns="50800">
+            <a:spAutoFit/>
+          </a:bodyPr>
+          <a:lstStyle/>
+          <a:p>
+            <a:pPr algn="l"/>
+            <a:r>
+              <a:rPr sz="1000" b="0">
+                <a:solidFill>
+                  <a:srgbClr val="9AA7BC"/>
+                </a:solidFill>
+                <a:latin typeface="Segoe UI"/>
+                <a:ea typeface="Microsoft YaHei"/>
+              </a:rPr>
+              <a:t>DCC-MCP 框架介绍</a:t>
+            </a:r>
+          </a:p>
+        </p:txBody>
+      </p:sp>
+      <p:sp>
+        <p:nvSpPr>
+          <p:cNvPr id="9" name="TextBox 8"/>
           <p:cNvSpPr txBox="1"/>
           <p:nvPr/>
         </p:nvSpPr>
@@ -6042,8 +6727,8 @@
         </p:nvSpPr>
         <p:spPr>
           <a:xfrm>
-            <a:off x="822960" y="457200"/>
-            <a:ext cx="10515600" cy="731520"/>
+            <a:off x="822960" y="502920"/>
+            <a:ext cx="10515600" cy="685800"/>
           </a:xfrm>
           <a:prstGeom prst="rect">
             <a:avLst/>
@@ -6059,7 +6744,7 @@
           <a:p>
             <a:pPr algn="l"/>
             <a:r>
-              <a:rPr sz="3000" b="1">
+              <a:rPr sz="2800" b="1">
                 <a:solidFill>
                   <a:srgbClr val="E8ECF2"/>
                 </a:solidFill>
@@ -6073,22 +6758,20 @@
       </p:sp>
       <p:sp>
         <p:nvSpPr>
-          <p:cNvPr id="4" name="Rounded Rectangle 3"/>
+          <p:cNvPr id="4" name="Rectangle 3"/>
           <p:cNvSpPr/>
           <p:nvPr/>
         </p:nvSpPr>
         <p:spPr>
           <a:xfrm>
-            <a:off x="822960" y="1371600"/>
-            <a:ext cx="10515600" cy="777240"/>
-          </a:xfrm>
-          <a:prstGeom prst="roundRect">
-            <a:avLst>
-              <a:gd name="adj" fmla="val 18000"/>
-            </a:avLst>
+            <a:off x="822960" y="1298448"/>
+            <a:ext cx="822960" cy="44450"/>
+          </a:xfrm>
+          <a:prstGeom prst="rect">
+            <a:avLst/>
           </a:prstGeom>
           <a:solidFill>
-            <a:srgbClr val="1E2A3D"/>
+            <a:srgbClr val="4D9DE0"/>
           </a:solidFill>
           <a:ln>
             <a:noFill/>
@@ -6110,41 +6793,29 @@
           </a:fontRef>
         </p:style>
         <p:txBody>
-          <a:bodyPr rtlCol="0" anchor="ctr" wrap="square" lIns="101600" rIns="101600" tIns="76200" bIns="76200"/>
-          <a:lstStyle/>
-          <a:p>
-            <a:pPr algn="l"/>
-            <a:r>
-              <a:rPr sz="1700" b="0">
-                <a:solidFill>
-                  <a:srgbClr val="E8ECF2"/>
-                </a:solidFill>
-                <a:latin typeface="Segoe UI"/>
-                <a:ea typeface="Microsoft YaHei"/>
-              </a:rPr>
-              <a:t>●  面向数字内容创作（DCC）工具的统一 MCP 网关生态</a:t>
-            </a:r>
-          </a:p>
-        </p:txBody>
-      </p:sp>
-      <p:sp>
-        <p:nvSpPr>
-          <p:cNvPr id="5" name="Rounded Rectangle 4"/>
+          <a:bodyPr rtlCol="0" anchor="ctr" wrap="square"/>
+          <a:lstStyle/>
+          <a:p>
+            <a:pPr algn="ctr"/>
+          </a:p>
+        </p:txBody>
+      </p:sp>
+      <p:sp>
+        <p:nvSpPr>
+          <p:cNvPr id="5" name="Oval 4"/>
           <p:cNvSpPr/>
           <p:nvPr/>
         </p:nvSpPr>
         <p:spPr>
           <a:xfrm>
-            <a:off x="822960" y="2286000"/>
-            <a:ext cx="10515600" cy="777240"/>
-          </a:xfrm>
-          <a:prstGeom prst="roundRect">
-            <a:avLst>
-              <a:gd name="adj" fmla="val 18000"/>
-            </a:avLst>
+            <a:off x="868680" y="1783080"/>
+            <a:ext cx="165100" cy="165100"/>
+          </a:xfrm>
+          <a:prstGeom prst="ellipse">
+            <a:avLst/>
           </a:prstGeom>
           <a:solidFill>
-            <a:srgbClr val="1E2A3D"/>
+            <a:srgbClr val="7FC8A9"/>
           </a:solidFill>
           <a:ln>
             <a:noFill/>
@@ -6166,41 +6837,66 @@
           </a:fontRef>
         </p:style>
         <p:txBody>
-          <a:bodyPr rtlCol="0" anchor="ctr" wrap="square" lIns="101600" rIns="101600" tIns="76200" bIns="76200"/>
+          <a:bodyPr rtlCol="0" anchor="ctr" wrap="square"/>
+          <a:lstStyle/>
+          <a:p>
+            <a:pPr algn="ctr"/>
+          </a:p>
+        </p:txBody>
+      </p:sp>
+      <p:sp>
+        <p:nvSpPr>
+          <p:cNvPr id="6" name="TextBox 5"/>
+          <p:cNvSpPr txBox="1"/>
+          <p:nvPr/>
+        </p:nvSpPr>
+        <p:spPr>
+          <a:xfrm>
+            <a:off x="1234440" y="1627632"/>
+            <a:ext cx="10012680" cy="822960"/>
+          </a:xfrm>
+          <a:prstGeom prst="rect">
+            <a:avLst/>
+          </a:prstGeom>
+          <a:noFill/>
+          <a:effectLst/>
+        </p:spPr>
+        <p:txBody>
+          <a:bodyPr wrap="square" lIns="50800" rIns="50800">
+            <a:spAutoFit/>
+          </a:bodyPr>
           <a:lstStyle/>
           <a:p>
             <a:pPr algn="l"/>
             <a:r>
-              <a:rPr sz="1700" b="0">
+              <a:rPr sz="1650" b="0">
                 <a:solidFill>
                   <a:srgbClr val="E8ECF2"/>
                 </a:solidFill>
                 <a:latin typeface="Segoe UI"/>
                 <a:ea typeface="Microsoft YaHei"/>
               </a:rPr>
-              <a:t>●  一个 DCC 一个适配器仓库：Maya、Blender、Houdini、Photoshop、Unity、Office…</a:t>
-            </a:r>
-          </a:p>
-        </p:txBody>
-      </p:sp>
-      <p:sp>
-        <p:nvSpPr>
-          <p:cNvPr id="6" name="Rounded Rectangle 5"/>
+              <a:t>面向数字内容创作（DCC）工具的统一 MCP 网关生态</a:t>
+            </a:r>
+          </a:p>
+        </p:txBody>
+      </p:sp>
+      <p:sp>
+        <p:nvSpPr>
+          <p:cNvPr id="7" name="Rectangle 6"/>
           <p:cNvSpPr/>
           <p:nvPr/>
         </p:nvSpPr>
         <p:spPr>
           <a:xfrm>
-            <a:off x="822960" y="3200400"/>
-            <a:ext cx="10515600" cy="777240"/>
-          </a:xfrm>
-          <a:prstGeom prst="roundRect">
-            <a:avLst>
-              <a:gd name="adj" fmla="val 18000"/>
-            </a:avLst>
+            <a:off x="822960" y="2496312"/>
+            <a:ext cx="10515600" cy="15240"/>
+          </a:xfrm>
+          <a:prstGeom prst="rect">
+            <a:avLst/>
           </a:prstGeom>
           <a:solidFill>
-            <a:srgbClr val="1E2A3D"/>
+            <a:srgbClr val="223047"/>
           </a:solidFill>
           <a:ln>
             <a:noFill/>
@@ -6222,41 +6918,29 @@
           </a:fontRef>
         </p:style>
         <p:txBody>
-          <a:bodyPr rtlCol="0" anchor="ctr" wrap="square" lIns="101600" rIns="101600" tIns="76200" bIns="76200"/>
-          <a:lstStyle/>
-          <a:p>
-            <a:pPr algn="l"/>
-            <a:r>
-              <a:rPr sz="1700" b="0">
-                <a:solidFill>
-                  <a:srgbClr val="E8ECF2"/>
-                </a:solidFill>
-                <a:latin typeface="Segoe UI"/>
-                <a:ea typeface="Microsoft YaHei"/>
-              </a:rPr>
-              <a:t>●  统一的能力发现机制：list → search → load_skill → call</a:t>
-            </a:r>
-          </a:p>
-        </p:txBody>
-      </p:sp>
-      <p:sp>
-        <p:nvSpPr>
-          <p:cNvPr id="7" name="Rounded Rectangle 6"/>
+          <a:bodyPr rtlCol="0" anchor="ctr" wrap="square"/>
+          <a:lstStyle/>
+          <a:p>
+            <a:pPr algn="ctr"/>
+          </a:p>
+        </p:txBody>
+      </p:sp>
+      <p:sp>
+        <p:nvSpPr>
+          <p:cNvPr id="8" name="Oval 7"/>
           <p:cNvSpPr/>
           <p:nvPr/>
         </p:nvSpPr>
         <p:spPr>
           <a:xfrm>
-            <a:off x="822960" y="4114800"/>
-            <a:ext cx="10515600" cy="777240"/>
-          </a:xfrm>
-          <a:prstGeom prst="roundRect">
-            <a:avLst>
-              <a:gd name="adj" fmla="val 18000"/>
-            </a:avLst>
+            <a:off x="868680" y="2715768"/>
+            <a:ext cx="165100" cy="165100"/>
+          </a:xfrm>
+          <a:prstGeom prst="ellipse">
+            <a:avLst/>
           </a:prstGeom>
           <a:solidFill>
-            <a:srgbClr val="1E2A3D"/>
+            <a:srgbClr val="7FC8A9"/>
           </a:solidFill>
           <a:ln>
             <a:noFill/>
@@ -6278,26 +6962,340 @@
           </a:fontRef>
         </p:style>
         <p:txBody>
-          <a:bodyPr rtlCol="0" anchor="ctr" wrap="square" lIns="101600" rIns="101600" tIns="76200" bIns="76200"/>
+          <a:bodyPr rtlCol="0" anchor="ctr" wrap="square"/>
+          <a:lstStyle/>
+          <a:p>
+            <a:pPr algn="ctr"/>
+          </a:p>
+        </p:txBody>
+      </p:sp>
+      <p:sp>
+        <p:nvSpPr>
+          <p:cNvPr id="9" name="TextBox 8"/>
+          <p:cNvSpPr txBox="1"/>
+          <p:nvPr/>
+        </p:nvSpPr>
+        <p:spPr>
+          <a:xfrm>
+            <a:off x="1234440" y="2560320"/>
+            <a:ext cx="10012680" cy="822960"/>
+          </a:xfrm>
+          <a:prstGeom prst="rect">
+            <a:avLst/>
+          </a:prstGeom>
+          <a:noFill/>
+          <a:effectLst/>
+        </p:spPr>
+        <p:txBody>
+          <a:bodyPr wrap="square" lIns="50800" rIns="50800">
+            <a:spAutoFit/>
+          </a:bodyPr>
           <a:lstStyle/>
           <a:p>
             <a:pPr algn="l"/>
             <a:r>
-              <a:rPr sz="1700" b="0">
+              <a:rPr sz="1650" b="0">
                 <a:solidFill>
                   <a:srgbClr val="E8ECF2"/>
                 </a:solidFill>
                 <a:latin typeface="Segoe UI"/>
                 <a:ea typeface="Microsoft YaHei"/>
               </a:rPr>
-              <a:t>●  Skills 机制：把稳定流程固化为可复用的技能包</a:t>
-            </a:r>
-          </a:p>
-        </p:txBody>
-      </p:sp>
-      <p:sp>
-        <p:nvSpPr>
-          <p:cNvPr id="8" name="TextBox 7"/>
+              <a:t>一个 DCC 一个适配器仓库：Maya、Blender、Houdini、Photoshop、Unity、Office…</a:t>
+            </a:r>
+          </a:p>
+        </p:txBody>
+      </p:sp>
+      <p:sp>
+        <p:nvSpPr>
+          <p:cNvPr id="10" name="Rectangle 9"/>
+          <p:cNvSpPr/>
+          <p:nvPr/>
+        </p:nvSpPr>
+        <p:spPr>
+          <a:xfrm>
+            <a:off x="822960" y="3429000"/>
+            <a:ext cx="10515600" cy="15240"/>
+          </a:xfrm>
+          <a:prstGeom prst="rect">
+            <a:avLst/>
+          </a:prstGeom>
+          <a:solidFill>
+            <a:srgbClr val="223047"/>
+          </a:solidFill>
+          <a:ln>
+            <a:noFill/>
+          </a:ln>
+          <a:effectLst/>
+        </p:spPr>
+        <p:style>
+          <a:lnRef idx="1">
+            <a:schemeClr val="accent1"/>
+          </a:lnRef>
+          <a:fillRef idx="3">
+            <a:schemeClr val="accent1"/>
+          </a:fillRef>
+          <a:effectRef idx="2">
+            <a:schemeClr val="accent1"/>
+          </a:effectRef>
+          <a:fontRef idx="minor">
+            <a:schemeClr val="lt1"/>
+          </a:fontRef>
+        </p:style>
+        <p:txBody>
+          <a:bodyPr rtlCol="0" anchor="ctr" wrap="square"/>
+          <a:lstStyle/>
+          <a:p>
+            <a:pPr algn="ctr"/>
+          </a:p>
+        </p:txBody>
+      </p:sp>
+      <p:sp>
+        <p:nvSpPr>
+          <p:cNvPr id="11" name="Oval 10"/>
+          <p:cNvSpPr/>
+          <p:nvPr/>
+        </p:nvSpPr>
+        <p:spPr>
+          <a:xfrm>
+            <a:off x="868680" y="3648456"/>
+            <a:ext cx="165100" cy="165100"/>
+          </a:xfrm>
+          <a:prstGeom prst="ellipse">
+            <a:avLst/>
+          </a:prstGeom>
+          <a:solidFill>
+            <a:srgbClr val="7FC8A9"/>
+          </a:solidFill>
+          <a:ln>
+            <a:noFill/>
+          </a:ln>
+          <a:effectLst/>
+        </p:spPr>
+        <p:style>
+          <a:lnRef idx="1">
+            <a:schemeClr val="accent1"/>
+          </a:lnRef>
+          <a:fillRef idx="3">
+            <a:schemeClr val="accent1"/>
+          </a:fillRef>
+          <a:effectRef idx="2">
+            <a:schemeClr val="accent1"/>
+          </a:effectRef>
+          <a:fontRef idx="minor">
+            <a:schemeClr val="lt1"/>
+          </a:fontRef>
+        </p:style>
+        <p:txBody>
+          <a:bodyPr rtlCol="0" anchor="ctr" wrap="square"/>
+          <a:lstStyle/>
+          <a:p>
+            <a:pPr algn="ctr"/>
+          </a:p>
+        </p:txBody>
+      </p:sp>
+      <p:sp>
+        <p:nvSpPr>
+          <p:cNvPr id="12" name="TextBox 11"/>
+          <p:cNvSpPr txBox="1"/>
+          <p:nvPr/>
+        </p:nvSpPr>
+        <p:spPr>
+          <a:xfrm>
+            <a:off x="1234440" y="3493008"/>
+            <a:ext cx="10012680" cy="822960"/>
+          </a:xfrm>
+          <a:prstGeom prst="rect">
+            <a:avLst/>
+          </a:prstGeom>
+          <a:noFill/>
+          <a:effectLst/>
+        </p:spPr>
+        <p:txBody>
+          <a:bodyPr wrap="square" lIns="50800" rIns="50800">
+            <a:spAutoFit/>
+          </a:bodyPr>
+          <a:lstStyle/>
+          <a:p>
+            <a:pPr algn="l"/>
+            <a:r>
+              <a:rPr sz="1650" b="0">
+                <a:solidFill>
+                  <a:srgbClr val="E8ECF2"/>
+                </a:solidFill>
+                <a:latin typeface="Segoe UI"/>
+                <a:ea typeface="Microsoft YaHei"/>
+              </a:rPr>
+              <a:t>统一的能力发现机制：list → search → load_skill → call</a:t>
+            </a:r>
+          </a:p>
+        </p:txBody>
+      </p:sp>
+      <p:sp>
+        <p:nvSpPr>
+          <p:cNvPr id="13" name="Rectangle 12"/>
+          <p:cNvSpPr/>
+          <p:nvPr/>
+        </p:nvSpPr>
+        <p:spPr>
+          <a:xfrm>
+            <a:off x="822960" y="4361688"/>
+            <a:ext cx="10515600" cy="15240"/>
+          </a:xfrm>
+          <a:prstGeom prst="rect">
+            <a:avLst/>
+          </a:prstGeom>
+          <a:solidFill>
+            <a:srgbClr val="223047"/>
+          </a:solidFill>
+          <a:ln>
+            <a:noFill/>
+          </a:ln>
+          <a:effectLst/>
+        </p:spPr>
+        <p:style>
+          <a:lnRef idx="1">
+            <a:schemeClr val="accent1"/>
+          </a:lnRef>
+          <a:fillRef idx="3">
+            <a:schemeClr val="accent1"/>
+          </a:fillRef>
+          <a:effectRef idx="2">
+            <a:schemeClr val="accent1"/>
+          </a:effectRef>
+          <a:fontRef idx="minor">
+            <a:schemeClr val="lt1"/>
+          </a:fontRef>
+        </p:style>
+        <p:txBody>
+          <a:bodyPr rtlCol="0" anchor="ctr" wrap="square"/>
+          <a:lstStyle/>
+          <a:p>
+            <a:pPr algn="ctr"/>
+          </a:p>
+        </p:txBody>
+      </p:sp>
+      <p:sp>
+        <p:nvSpPr>
+          <p:cNvPr id="14" name="Oval 13"/>
+          <p:cNvSpPr/>
+          <p:nvPr/>
+        </p:nvSpPr>
+        <p:spPr>
+          <a:xfrm>
+            <a:off x="868680" y="4581144"/>
+            <a:ext cx="165100" cy="165100"/>
+          </a:xfrm>
+          <a:prstGeom prst="ellipse">
+            <a:avLst/>
+          </a:prstGeom>
+          <a:solidFill>
+            <a:srgbClr val="7FC8A9"/>
+          </a:solidFill>
+          <a:ln>
+            <a:noFill/>
+          </a:ln>
+          <a:effectLst/>
+        </p:spPr>
+        <p:style>
+          <a:lnRef idx="1">
+            <a:schemeClr val="accent1"/>
+          </a:lnRef>
+          <a:fillRef idx="3">
+            <a:schemeClr val="accent1"/>
+          </a:fillRef>
+          <a:effectRef idx="2">
+            <a:schemeClr val="accent1"/>
+          </a:effectRef>
+          <a:fontRef idx="minor">
+            <a:schemeClr val="lt1"/>
+          </a:fontRef>
+        </p:style>
+        <p:txBody>
+          <a:bodyPr rtlCol="0" anchor="ctr" wrap="square"/>
+          <a:lstStyle/>
+          <a:p>
+            <a:pPr algn="ctr"/>
+          </a:p>
+        </p:txBody>
+      </p:sp>
+      <p:sp>
+        <p:nvSpPr>
+          <p:cNvPr id="15" name="TextBox 14"/>
+          <p:cNvSpPr txBox="1"/>
+          <p:nvPr/>
+        </p:nvSpPr>
+        <p:spPr>
+          <a:xfrm>
+            <a:off x="1234440" y="4425696"/>
+            <a:ext cx="10012680" cy="822960"/>
+          </a:xfrm>
+          <a:prstGeom prst="rect">
+            <a:avLst/>
+          </a:prstGeom>
+          <a:noFill/>
+          <a:effectLst/>
+        </p:spPr>
+        <p:txBody>
+          <a:bodyPr wrap="square" lIns="50800" rIns="50800">
+            <a:spAutoFit/>
+          </a:bodyPr>
+          <a:lstStyle/>
+          <a:p>
+            <a:pPr algn="l"/>
+            <a:r>
+              <a:rPr sz="1650" b="0">
+                <a:solidFill>
+                  <a:srgbClr val="E8ECF2"/>
+                </a:solidFill>
+                <a:latin typeface="Segoe UI"/>
+                <a:ea typeface="Microsoft YaHei"/>
+              </a:rPr>
+              <a:t>Skills 机制：把稳定流程固化为可复用的技能包</a:t>
+            </a:r>
+          </a:p>
+        </p:txBody>
+      </p:sp>
+      <p:sp>
+        <p:nvSpPr>
+          <p:cNvPr id="16" name="TextBox 15"/>
+          <p:cNvSpPr txBox="1"/>
+          <p:nvPr/>
+        </p:nvSpPr>
+        <p:spPr>
+          <a:xfrm>
+            <a:off x="822960" y="6473952"/>
+            <a:ext cx="7315200" cy="274320"/>
+          </a:xfrm>
+          <a:prstGeom prst="rect">
+            <a:avLst/>
+          </a:prstGeom>
+          <a:noFill/>
+          <a:effectLst/>
+        </p:spPr>
+        <p:txBody>
+          <a:bodyPr wrap="square" lIns="50800" rIns="50800">
+            <a:spAutoFit/>
+          </a:bodyPr>
+          <a:lstStyle/>
+          <a:p>
+            <a:pPr algn="l"/>
+            <a:r>
+              <a:rPr sz="1000" b="0">
+                <a:solidFill>
+                  <a:srgbClr val="9AA7BC"/>
+                </a:solidFill>
+                <a:latin typeface="Segoe UI"/>
+                <a:ea typeface="Microsoft YaHei"/>
+              </a:rPr>
+              <a:t>DCC-MCP 框架介绍</a:t>
+            </a:r>
+          </a:p>
+        </p:txBody>
+      </p:sp>
+      <p:sp>
+        <p:nvSpPr>
+          <p:cNvPr id="17" name="TextBox 16"/>
           <p:cNvSpPr txBox="1"/>
           <p:nvPr/>
         </p:nvSpPr>
@@ -6402,8 +7400,8 @@
         </p:nvSpPr>
         <p:spPr>
           <a:xfrm>
-            <a:off x="822960" y="457200"/>
-            <a:ext cx="10515600" cy="731520"/>
+            <a:off x="822960" y="502920"/>
+            <a:ext cx="10515600" cy="685800"/>
           </a:xfrm>
           <a:prstGeom prst="rect">
             <a:avLst/>
@@ -6419,7 +7417,7 @@
           <a:p>
             <a:pPr algn="l"/>
             <a:r>
-              <a:rPr sz="3000" b="1">
+              <a:rPr sz="2800" b="1">
                 <a:solidFill>
                   <a:srgbClr val="E8ECF2"/>
                 </a:solidFill>
@@ -6433,14 +7431,114 @@
       </p:sp>
       <p:sp>
         <p:nvSpPr>
-          <p:cNvPr id="4" name="Rounded Rectangle 3"/>
+          <p:cNvPr id="4" name="Rectangle 3"/>
           <p:cNvSpPr/>
           <p:nvPr/>
         </p:nvSpPr>
         <p:spPr>
           <a:xfrm>
-            <a:off x="2560320" y="1463040"/>
-            <a:ext cx="7040880" cy="777240"/>
+            <a:off x="822960" y="1298448"/>
+            <a:ext cx="822960" cy="44450"/>
+          </a:xfrm>
+          <a:prstGeom prst="rect">
+            <a:avLst/>
+          </a:prstGeom>
+          <a:solidFill>
+            <a:srgbClr val="4D9DE0"/>
+          </a:solidFill>
+          <a:ln>
+            <a:noFill/>
+          </a:ln>
+          <a:effectLst/>
+        </p:spPr>
+        <p:style>
+          <a:lnRef idx="1">
+            <a:schemeClr val="accent1"/>
+          </a:lnRef>
+          <a:fillRef idx="3">
+            <a:schemeClr val="accent1"/>
+          </a:fillRef>
+          <a:effectRef idx="2">
+            <a:schemeClr val="accent1"/>
+          </a:effectRef>
+          <a:fontRef idx="minor">
+            <a:schemeClr val="lt1"/>
+          </a:fontRef>
+        </p:style>
+        <p:txBody>
+          <a:bodyPr rtlCol="0" anchor="ctr" wrap="square"/>
+          <a:lstStyle/>
+          <a:p>
+            <a:pPr algn="ctr"/>
+          </a:p>
+        </p:txBody>
+      </p:sp>
+      <p:sp>
+        <p:nvSpPr>
+          <p:cNvPr id="5" name="Oval 4"/>
+          <p:cNvSpPr/>
+          <p:nvPr/>
+        </p:nvSpPr>
+        <p:spPr>
+          <a:xfrm>
+            <a:off x="2148840" y="1819656"/>
+            <a:ext cx="384048" cy="384048"/>
+          </a:xfrm>
+          <a:prstGeom prst="ellipse">
+            <a:avLst/>
+          </a:prstGeom>
+          <a:solidFill>
+            <a:srgbClr val="171F2E"/>
+          </a:solidFill>
+          <a:ln w="15240">
+            <a:solidFill>
+              <a:srgbClr val="4D9DE0"/>
+            </a:solidFill>
+          </a:ln>
+          <a:effectLst/>
+        </p:spPr>
+        <p:style>
+          <a:lnRef idx="1">
+            <a:schemeClr val="accent1"/>
+          </a:lnRef>
+          <a:fillRef idx="3">
+            <a:schemeClr val="accent1"/>
+          </a:fillRef>
+          <a:effectRef idx="2">
+            <a:schemeClr val="accent1"/>
+          </a:effectRef>
+          <a:fontRef idx="minor">
+            <a:schemeClr val="lt1"/>
+          </a:fontRef>
+        </p:style>
+        <p:txBody>
+          <a:bodyPr rtlCol="0" anchor="ctr" wrap="square" lIns="101600" rIns="101600" tIns="76200" bIns="76200"/>
+          <a:lstStyle/>
+          <a:p>
+            <a:pPr algn="ctr"/>
+            <a:r>
+              <a:rPr sz="1200" b="1">
+                <a:solidFill>
+                  <a:srgbClr val="4D9DE0"/>
+                </a:solidFill>
+                <a:latin typeface="Segoe UI"/>
+                <a:ea typeface="Microsoft YaHei"/>
+              </a:rPr>
+              <a:t>1</a:t>
+            </a:r>
+          </a:p>
+        </p:txBody>
+      </p:sp>
+      <p:sp>
+        <p:nvSpPr>
+          <p:cNvPr id="6" name="Rounded Rectangle 5"/>
+          <p:cNvSpPr/>
+          <p:nvPr/>
+        </p:nvSpPr>
+        <p:spPr>
+          <a:xfrm>
+            <a:off x="2788920" y="1673352"/>
+            <a:ext cx="8412480" cy="713232"/>
           </a:xfrm>
           <a:prstGeom prst="roundRect">
             <a:avLst>
@@ -6475,7 +7573,7 @@
           <a:p>
             <a:pPr algn="ctr"/>
             <a:r>
-              <a:rPr sz="1500" b="0">
+              <a:rPr sz="1450" b="0">
                 <a:solidFill>
                   <a:srgbClr val="E8ECF2"/>
                 </a:solidFill>
@@ -6489,14 +7587,70 @@
       </p:sp>
       <p:sp>
         <p:nvSpPr>
-          <p:cNvPr id="5" name="Rounded Rectangle 4"/>
+          <p:cNvPr id="7" name="Oval 6"/>
           <p:cNvSpPr/>
           <p:nvPr/>
         </p:nvSpPr>
         <p:spPr>
           <a:xfrm>
-            <a:off x="2560320" y="2331720"/>
-            <a:ext cx="7040880" cy="777240"/>
+            <a:off x="2148840" y="2688336"/>
+            <a:ext cx="384048" cy="384048"/>
+          </a:xfrm>
+          <a:prstGeom prst="ellipse">
+            <a:avLst/>
+          </a:prstGeom>
+          <a:solidFill>
+            <a:srgbClr val="171F2E"/>
+          </a:solidFill>
+          <a:ln w="15240">
+            <a:solidFill>
+              <a:srgbClr val="4D9DE0"/>
+            </a:solidFill>
+          </a:ln>
+          <a:effectLst/>
+        </p:spPr>
+        <p:style>
+          <a:lnRef idx="1">
+            <a:schemeClr val="accent1"/>
+          </a:lnRef>
+          <a:fillRef idx="3">
+            <a:schemeClr val="accent1"/>
+          </a:fillRef>
+          <a:effectRef idx="2">
+            <a:schemeClr val="accent1"/>
+          </a:effectRef>
+          <a:fontRef idx="minor">
+            <a:schemeClr val="lt1"/>
+          </a:fontRef>
+        </p:style>
+        <p:txBody>
+          <a:bodyPr rtlCol="0" anchor="ctr" wrap="square" lIns="101600" rIns="101600" tIns="76200" bIns="76200"/>
+          <a:lstStyle/>
+          <a:p>
+            <a:pPr algn="ctr"/>
+            <a:r>
+              <a:rPr sz="1200" b="1">
+                <a:solidFill>
+                  <a:srgbClr val="4D9DE0"/>
+                </a:solidFill>
+                <a:latin typeface="Segoe UI"/>
+                <a:ea typeface="Microsoft YaHei"/>
+              </a:rPr>
+              <a:t>2</a:t>
+            </a:r>
+          </a:p>
+        </p:txBody>
+      </p:sp>
+      <p:sp>
+        <p:nvSpPr>
+          <p:cNvPr id="8" name="Rounded Rectangle 7"/>
+          <p:cNvSpPr/>
+          <p:nvPr/>
+        </p:nvSpPr>
+        <p:spPr>
+          <a:xfrm>
+            <a:off x="2788920" y="2542032"/>
+            <a:ext cx="8412480" cy="713232"/>
           </a:xfrm>
           <a:prstGeom prst="roundRect">
             <a:avLst>
@@ -6531,7 +7685,7 @@
           <a:p>
             <a:pPr algn="ctr"/>
             <a:r>
-              <a:rPr sz="1500" b="0">
+              <a:rPr sz="1450" b="0">
                 <a:solidFill>
                   <a:srgbClr val="E8ECF2"/>
                 </a:solidFill>
@@ -6545,14 +7699,70 @@
       </p:sp>
       <p:sp>
         <p:nvSpPr>
-          <p:cNvPr id="6" name="Rounded Rectangle 5"/>
+          <p:cNvPr id="9" name="Oval 8"/>
           <p:cNvSpPr/>
           <p:nvPr/>
         </p:nvSpPr>
         <p:spPr>
           <a:xfrm>
-            <a:off x="2560320" y="3200400"/>
-            <a:ext cx="7040880" cy="777240"/>
+            <a:off x="2148840" y="3557016"/>
+            <a:ext cx="384048" cy="384048"/>
+          </a:xfrm>
+          <a:prstGeom prst="ellipse">
+            <a:avLst/>
+          </a:prstGeom>
+          <a:solidFill>
+            <a:srgbClr val="171F2E"/>
+          </a:solidFill>
+          <a:ln w="15240">
+            <a:solidFill>
+              <a:srgbClr val="4D9DE0"/>
+            </a:solidFill>
+          </a:ln>
+          <a:effectLst/>
+        </p:spPr>
+        <p:style>
+          <a:lnRef idx="1">
+            <a:schemeClr val="accent1"/>
+          </a:lnRef>
+          <a:fillRef idx="3">
+            <a:schemeClr val="accent1"/>
+          </a:fillRef>
+          <a:effectRef idx="2">
+            <a:schemeClr val="accent1"/>
+          </a:effectRef>
+          <a:fontRef idx="minor">
+            <a:schemeClr val="lt1"/>
+          </a:fontRef>
+        </p:style>
+        <p:txBody>
+          <a:bodyPr rtlCol="0" anchor="ctr" wrap="square" lIns="101600" rIns="101600" tIns="76200" bIns="76200"/>
+          <a:lstStyle/>
+          <a:p>
+            <a:pPr algn="ctr"/>
+            <a:r>
+              <a:rPr sz="1200" b="1">
+                <a:solidFill>
+                  <a:srgbClr val="4D9DE0"/>
+                </a:solidFill>
+                <a:latin typeface="Segoe UI"/>
+                <a:ea typeface="Microsoft YaHei"/>
+              </a:rPr>
+              <a:t>3</a:t>
+            </a:r>
+          </a:p>
+        </p:txBody>
+      </p:sp>
+      <p:sp>
+        <p:nvSpPr>
+          <p:cNvPr id="10" name="Rounded Rectangle 9"/>
+          <p:cNvSpPr/>
+          <p:nvPr/>
+        </p:nvSpPr>
+        <p:spPr>
+          <a:xfrm>
+            <a:off x="2788920" y="3410712"/>
+            <a:ext cx="8412480" cy="713232"/>
           </a:xfrm>
           <a:prstGeom prst="roundRect">
             <a:avLst>
@@ -6587,7 +7797,7 @@
           <a:p>
             <a:pPr algn="ctr"/>
             <a:r>
-              <a:rPr sz="1500" b="0">
+              <a:rPr sz="1450" b="0">
                 <a:solidFill>
                   <a:srgbClr val="E8ECF2"/>
                 </a:solidFill>
@@ -6601,14 +7811,70 @@
       </p:sp>
       <p:sp>
         <p:nvSpPr>
-          <p:cNvPr id="7" name="Rounded Rectangle 6"/>
+          <p:cNvPr id="11" name="Oval 10"/>
           <p:cNvSpPr/>
           <p:nvPr/>
         </p:nvSpPr>
         <p:spPr>
           <a:xfrm>
-            <a:off x="2560320" y="4069079"/>
-            <a:ext cx="7040880" cy="777240"/>
+            <a:off x="2148840" y="4425696"/>
+            <a:ext cx="384048" cy="384048"/>
+          </a:xfrm>
+          <a:prstGeom prst="ellipse">
+            <a:avLst/>
+          </a:prstGeom>
+          <a:solidFill>
+            <a:srgbClr val="171F2E"/>
+          </a:solidFill>
+          <a:ln w="15240">
+            <a:solidFill>
+              <a:srgbClr val="4D9DE0"/>
+            </a:solidFill>
+          </a:ln>
+          <a:effectLst/>
+        </p:spPr>
+        <p:style>
+          <a:lnRef idx="1">
+            <a:schemeClr val="accent1"/>
+          </a:lnRef>
+          <a:fillRef idx="3">
+            <a:schemeClr val="accent1"/>
+          </a:fillRef>
+          <a:effectRef idx="2">
+            <a:schemeClr val="accent1"/>
+          </a:effectRef>
+          <a:fontRef idx="minor">
+            <a:schemeClr val="lt1"/>
+          </a:fontRef>
+        </p:style>
+        <p:txBody>
+          <a:bodyPr rtlCol="0" anchor="ctr" wrap="square" lIns="101600" rIns="101600" tIns="76200" bIns="76200"/>
+          <a:lstStyle/>
+          <a:p>
+            <a:pPr algn="ctr"/>
+            <a:r>
+              <a:rPr sz="1200" b="1">
+                <a:solidFill>
+                  <a:srgbClr val="4D9DE0"/>
+                </a:solidFill>
+                <a:latin typeface="Segoe UI"/>
+                <a:ea typeface="Microsoft YaHei"/>
+              </a:rPr>
+              <a:t>4</a:t>
+            </a:r>
+          </a:p>
+        </p:txBody>
+      </p:sp>
+      <p:sp>
+        <p:nvSpPr>
+          <p:cNvPr id="12" name="Rounded Rectangle 11"/>
+          <p:cNvSpPr/>
+          <p:nvPr/>
+        </p:nvSpPr>
+        <p:spPr>
+          <a:xfrm>
+            <a:off x="2788920" y="4279392"/>
+            <a:ext cx="8412480" cy="713232"/>
           </a:xfrm>
           <a:prstGeom prst="roundRect">
             <a:avLst>
@@ -6643,7 +7909,7 @@
           <a:p>
             <a:pPr algn="ctr"/>
             <a:r>
-              <a:rPr sz="1500" b="0">
+              <a:rPr sz="1450" b="0">
                 <a:solidFill>
                   <a:srgbClr val="E8ECF2"/>
                 </a:solidFill>
@@ -6657,14 +7923,70 @@
       </p:sp>
       <p:sp>
         <p:nvSpPr>
-          <p:cNvPr id="8" name="Rounded Rectangle 7"/>
+          <p:cNvPr id="13" name="Oval 12"/>
           <p:cNvSpPr/>
           <p:nvPr/>
         </p:nvSpPr>
         <p:spPr>
           <a:xfrm>
-            <a:off x="2560320" y="4937760"/>
-            <a:ext cx="7040880" cy="777240"/>
+            <a:off x="2148840" y="5294376"/>
+            <a:ext cx="384048" cy="384048"/>
+          </a:xfrm>
+          <a:prstGeom prst="ellipse">
+            <a:avLst/>
+          </a:prstGeom>
+          <a:solidFill>
+            <a:srgbClr val="171F2E"/>
+          </a:solidFill>
+          <a:ln w="15240">
+            <a:solidFill>
+              <a:srgbClr val="4D9DE0"/>
+            </a:solidFill>
+          </a:ln>
+          <a:effectLst/>
+        </p:spPr>
+        <p:style>
+          <a:lnRef idx="1">
+            <a:schemeClr val="accent1"/>
+          </a:lnRef>
+          <a:fillRef idx="3">
+            <a:schemeClr val="accent1"/>
+          </a:fillRef>
+          <a:effectRef idx="2">
+            <a:schemeClr val="accent1"/>
+          </a:effectRef>
+          <a:fontRef idx="minor">
+            <a:schemeClr val="lt1"/>
+          </a:fontRef>
+        </p:style>
+        <p:txBody>
+          <a:bodyPr rtlCol="0" anchor="ctr" wrap="square" lIns="101600" rIns="101600" tIns="76200" bIns="76200"/>
+          <a:lstStyle/>
+          <a:p>
+            <a:pPr algn="ctr"/>
+            <a:r>
+              <a:rPr sz="1200" b="1">
+                <a:solidFill>
+                  <a:srgbClr val="4D9DE0"/>
+                </a:solidFill>
+                <a:latin typeface="Segoe UI"/>
+                <a:ea typeface="Microsoft YaHei"/>
+              </a:rPr>
+              <a:t>5</a:t>
+            </a:r>
+          </a:p>
+        </p:txBody>
+      </p:sp>
+      <p:sp>
+        <p:nvSpPr>
+          <p:cNvPr id="14" name="Rounded Rectangle 13"/>
+          <p:cNvSpPr/>
+          <p:nvPr/>
+        </p:nvSpPr>
+        <p:spPr>
+          <a:xfrm>
+            <a:off x="2788920" y="5148072"/>
+            <a:ext cx="8412480" cy="713232"/>
           </a:xfrm>
           <a:prstGeom prst="roundRect">
             <a:avLst>
@@ -6699,7 +8021,7 @@
           <a:p>
             <a:pPr algn="ctr"/>
             <a:r>
-              <a:rPr sz="1500" b="0">
+              <a:rPr sz="1450" b="0">
                 <a:solidFill>
                   <a:srgbClr val="E8ECF2"/>
                 </a:solidFill>
@@ -6713,14 +8035,14 @@
       </p:sp>
       <p:cxnSp>
         <p:nvCxnSpPr>
-          <p:cNvPr id="9" name="Connector 8"/>
+          <p:cNvPr id="15" name="Connector 14"/>
           <p:cNvCxnSpPr/>
           <p:nvPr/>
         </p:nvCxnSpPr>
         <p:spPr>
           <a:xfrm>
-            <a:off x="6080760" y="1851660"/>
-            <a:ext cx="0" cy="3474720"/>
+            <a:off x="2340864" y="2194560"/>
+            <a:ext cx="0" cy="3474719"/>
           </a:xfrm>
           <a:prstGeom prst="line">
             <a:avLst/>
@@ -6749,7 +8071,44 @@
       </p:cxnSp>
       <p:sp>
         <p:nvSpPr>
-          <p:cNvPr id="10" name="TextBox 9"/>
+          <p:cNvPr id="16" name="TextBox 15"/>
+          <p:cNvSpPr txBox="1"/>
+          <p:nvPr/>
+        </p:nvSpPr>
+        <p:spPr>
+          <a:xfrm>
+            <a:off x="822960" y="6473952"/>
+            <a:ext cx="7315200" cy="274320"/>
+          </a:xfrm>
+          <a:prstGeom prst="rect">
+            <a:avLst/>
+          </a:prstGeom>
+          <a:noFill/>
+          <a:effectLst/>
+        </p:spPr>
+        <p:txBody>
+          <a:bodyPr wrap="square" lIns="50800" rIns="50800">
+            <a:spAutoFit/>
+          </a:bodyPr>
+          <a:lstStyle/>
+          <a:p>
+            <a:pPr algn="l"/>
+            <a:r>
+              <a:rPr sz="1000" b="0">
+                <a:solidFill>
+                  <a:srgbClr val="9AA7BC"/>
+                </a:solidFill>
+                <a:latin typeface="Segoe UI"/>
+                <a:ea typeface="Microsoft YaHei"/>
+              </a:rPr>
+              <a:t>DCC-MCP 框架介绍</a:t>
+            </a:r>
+          </a:p>
+        </p:txBody>
+      </p:sp>
+      <p:sp>
+        <p:nvSpPr>
+          <p:cNvPr id="17" name="TextBox 16"/>
           <p:cNvSpPr txBox="1"/>
           <p:nvPr/>
         </p:nvSpPr>
@@ -6854,8 +8213,8 @@
         </p:nvSpPr>
         <p:spPr>
           <a:xfrm>
-            <a:off x="822960" y="457200"/>
-            <a:ext cx="10515600" cy="731520"/>
+            <a:off x="822960" y="502920"/>
+            <a:ext cx="10515600" cy="685800"/>
           </a:xfrm>
           <a:prstGeom prst="rect">
             <a:avLst/>
@@ -6871,7 +8230,7 @@
           <a:p>
             <a:pPr algn="l"/>
             <a:r>
-              <a:rPr sz="3000" b="1">
+              <a:rPr sz="2800" b="1">
                 <a:solidFill>
                   <a:srgbClr val="E8ECF2"/>
                 </a:solidFill>
@@ -6885,22 +8244,20 @@
       </p:sp>
       <p:sp>
         <p:nvSpPr>
-          <p:cNvPr id="4" name="Rounded Rectangle 3"/>
+          <p:cNvPr id="4" name="Rectangle 3"/>
           <p:cNvSpPr/>
           <p:nvPr/>
         </p:nvSpPr>
         <p:spPr>
           <a:xfrm>
-            <a:off x="822960" y="1371600"/>
-            <a:ext cx="10515600" cy="777240"/>
-          </a:xfrm>
-          <a:prstGeom prst="roundRect">
-            <a:avLst>
-              <a:gd name="adj" fmla="val 18000"/>
-            </a:avLst>
+            <a:off x="822960" y="1298448"/>
+            <a:ext cx="822960" cy="44450"/>
+          </a:xfrm>
+          <a:prstGeom prst="rect">
+            <a:avLst/>
           </a:prstGeom>
           <a:solidFill>
-            <a:srgbClr val="1E2A3D"/>
+            <a:srgbClr val="4D9DE0"/>
           </a:solidFill>
           <a:ln>
             <a:noFill/>
@@ -6922,41 +8279,29 @@
           </a:fontRef>
         </p:style>
         <p:txBody>
-          <a:bodyPr rtlCol="0" anchor="ctr" wrap="square" lIns="101600" rIns="101600" tIns="76200" bIns="76200"/>
-          <a:lstStyle/>
-          <a:p>
-            <a:pPr algn="l"/>
-            <a:r>
-              <a:rPr sz="1700" b="0">
-                <a:solidFill>
-                  <a:srgbClr val="E8ECF2"/>
-                </a:solidFill>
-                <a:latin typeface="Segoe UI"/>
-                <a:ea typeface="Microsoft YaHei"/>
-              </a:rPr>
-              <a:t>●  任务级 Capability，不暴露原始对象模型</a:t>
-            </a:r>
-          </a:p>
-        </p:txBody>
-      </p:sp>
-      <p:sp>
-        <p:nvSpPr>
-          <p:cNvPr id="5" name="Rounded Rectangle 4"/>
+          <a:bodyPr rtlCol="0" anchor="ctr" wrap="square"/>
+          <a:lstStyle/>
+          <a:p>
+            <a:pPr algn="ctr"/>
+          </a:p>
+        </p:txBody>
+      </p:sp>
+      <p:sp>
+        <p:nvSpPr>
+          <p:cNvPr id="5" name="Oval 4"/>
           <p:cNvSpPr/>
           <p:nvPr/>
         </p:nvSpPr>
         <p:spPr>
           <a:xfrm>
-            <a:off x="822960" y="2286000"/>
-            <a:ext cx="10515600" cy="777240"/>
-          </a:xfrm>
-          <a:prstGeom prst="roundRect">
-            <a:avLst>
-              <a:gd name="adj" fmla="val 18000"/>
-            </a:avLst>
+            <a:off x="868680" y="1783080"/>
+            <a:ext cx="165100" cy="165100"/>
+          </a:xfrm>
+          <a:prstGeom prst="ellipse">
+            <a:avLst/>
           </a:prstGeom>
           <a:solidFill>
-            <a:srgbClr val="1E2A3D"/>
+            <a:srgbClr val="7FC8A9"/>
           </a:solidFill>
           <a:ln>
             <a:noFill/>
@@ -6978,41 +8323,66 @@
           </a:fontRef>
         </p:style>
         <p:txBody>
-          <a:bodyPr rtlCol="0" anchor="ctr" wrap="square" lIns="101600" rIns="101600" tIns="76200" bIns="76200"/>
+          <a:bodyPr rtlCol="0" anchor="ctr" wrap="square"/>
+          <a:lstStyle/>
+          <a:p>
+            <a:pPr algn="ctr"/>
+          </a:p>
+        </p:txBody>
+      </p:sp>
+      <p:sp>
+        <p:nvSpPr>
+          <p:cNvPr id="6" name="TextBox 5"/>
+          <p:cNvSpPr txBox="1"/>
+          <p:nvPr/>
+        </p:nvSpPr>
+        <p:spPr>
+          <a:xfrm>
+            <a:off x="1234440" y="1627632"/>
+            <a:ext cx="10012680" cy="822960"/>
+          </a:xfrm>
+          <a:prstGeom prst="rect">
+            <a:avLst/>
+          </a:prstGeom>
+          <a:noFill/>
+          <a:effectLst/>
+        </p:spPr>
+        <p:txBody>
+          <a:bodyPr wrap="square" lIns="50800" rIns="50800">
+            <a:spAutoFit/>
+          </a:bodyPr>
           <a:lstStyle/>
           <a:p>
             <a:pPr algn="l"/>
             <a:r>
-              <a:rPr sz="1700" b="0">
+              <a:rPr sz="1650" b="0">
                 <a:solidFill>
                   <a:srgbClr val="E8ECF2"/>
                 </a:solidFill>
                 <a:latin typeface="Segoe UI"/>
                 <a:ea typeface="Microsoft YaHei"/>
               </a:rPr>
-              <a:t>●  渐进式发现：初始上下文不塞满数百个工具</a:t>
-            </a:r>
-          </a:p>
-        </p:txBody>
-      </p:sp>
-      <p:sp>
-        <p:nvSpPr>
-          <p:cNvPr id="6" name="Rounded Rectangle 5"/>
+              <a:t>任务级 Capability，不暴露原始对象模型</a:t>
+            </a:r>
+          </a:p>
+        </p:txBody>
+      </p:sp>
+      <p:sp>
+        <p:nvSpPr>
+          <p:cNvPr id="7" name="Rectangle 6"/>
           <p:cNvSpPr/>
           <p:nvPr/>
         </p:nvSpPr>
         <p:spPr>
           <a:xfrm>
-            <a:off x="822960" y="3200400"/>
-            <a:ext cx="10515600" cy="777240"/>
-          </a:xfrm>
-          <a:prstGeom prst="roundRect">
-            <a:avLst>
-              <a:gd name="adj" fmla="val 18000"/>
-            </a:avLst>
+            <a:off x="822960" y="2496312"/>
+            <a:ext cx="10515600" cy="15240"/>
+          </a:xfrm>
+          <a:prstGeom prst="rect">
+            <a:avLst/>
           </a:prstGeom>
           <a:solidFill>
-            <a:srgbClr val="1E2A3D"/>
+            <a:srgbClr val="223047"/>
           </a:solidFill>
           <a:ln>
             <a:noFill/>
@@ -7034,41 +8404,29 @@
           </a:fontRef>
         </p:style>
         <p:txBody>
-          <a:bodyPr rtlCol="0" anchor="ctr" wrap="square" lIns="101600" rIns="101600" tIns="76200" bIns="76200"/>
-          <a:lstStyle/>
-          <a:p>
-            <a:pPr algn="l"/>
-            <a:r>
-              <a:rPr sz="1700" b="0">
-                <a:solidFill>
-                  <a:srgbClr val="E8ECF2"/>
-                </a:solidFill>
-                <a:latin typeface="Segoe UI"/>
-                <a:ea typeface="Microsoft YaHei"/>
-              </a:rPr>
-              <a:t>●  契约化技能包：SKILL.md + tools.yaml + scripts/&lt;name&gt;.py</a:t>
-            </a:r>
-          </a:p>
-        </p:txBody>
-      </p:sp>
-      <p:sp>
-        <p:nvSpPr>
-          <p:cNvPr id="7" name="Rounded Rectangle 6"/>
+          <a:bodyPr rtlCol="0" anchor="ctr" wrap="square"/>
+          <a:lstStyle/>
+          <a:p>
+            <a:pPr algn="ctr"/>
+          </a:p>
+        </p:txBody>
+      </p:sp>
+      <p:sp>
+        <p:nvSpPr>
+          <p:cNvPr id="8" name="Oval 7"/>
           <p:cNvSpPr/>
           <p:nvPr/>
         </p:nvSpPr>
         <p:spPr>
           <a:xfrm>
-            <a:off x="822960" y="4114800"/>
-            <a:ext cx="10515600" cy="777240"/>
-          </a:xfrm>
-          <a:prstGeom prst="roundRect">
-            <a:avLst>
-              <a:gd name="adj" fmla="val 18000"/>
-            </a:avLst>
+            <a:off x="868680" y="2715768"/>
+            <a:ext cx="165100" cy="165100"/>
+          </a:xfrm>
+          <a:prstGeom prst="ellipse">
+            <a:avLst/>
           </a:prstGeom>
           <a:solidFill>
-            <a:srgbClr val="1E2A3D"/>
+            <a:srgbClr val="7FC8A9"/>
           </a:solidFill>
           <a:ln>
             <a:noFill/>
@@ -7090,26 +8448,340 @@
           </a:fontRef>
         </p:style>
         <p:txBody>
-          <a:bodyPr rtlCol="0" anchor="ctr" wrap="square" lIns="101600" rIns="101600" tIns="76200" bIns="76200"/>
+          <a:bodyPr rtlCol="0" anchor="ctr" wrap="square"/>
+          <a:lstStyle/>
+          <a:p>
+            <a:pPr algn="ctr"/>
+          </a:p>
+        </p:txBody>
+      </p:sp>
+      <p:sp>
+        <p:nvSpPr>
+          <p:cNvPr id="9" name="TextBox 8"/>
+          <p:cNvSpPr txBox="1"/>
+          <p:nvPr/>
+        </p:nvSpPr>
+        <p:spPr>
+          <a:xfrm>
+            <a:off x="1234440" y="2560320"/>
+            <a:ext cx="10012680" cy="822960"/>
+          </a:xfrm>
+          <a:prstGeom prst="rect">
+            <a:avLst/>
+          </a:prstGeom>
+          <a:noFill/>
+          <a:effectLst/>
+        </p:spPr>
+        <p:txBody>
+          <a:bodyPr wrap="square" lIns="50800" rIns="50800">
+            <a:spAutoFit/>
+          </a:bodyPr>
           <a:lstStyle/>
           <a:p>
             <a:pPr algn="l"/>
             <a:r>
-              <a:rPr sz="1700" b="0">
+              <a:rPr sz="1650" b="0">
                 <a:solidFill>
                   <a:srgbClr val="E8ECF2"/>
                 </a:solidFill>
                 <a:latin typeface="Segoe UI"/>
                 <a:ea typeface="Microsoft YaHei"/>
               </a:rPr>
-              <a:t>●  Maya 单仓 25+ 域技能包、198 个结构化操作</a:t>
-            </a:r>
-          </a:p>
-        </p:txBody>
-      </p:sp>
-      <p:sp>
-        <p:nvSpPr>
-          <p:cNvPr id="8" name="TextBox 7"/>
+              <a:t>渐进式发现：初始上下文不塞满数百个工具</a:t>
+            </a:r>
+          </a:p>
+        </p:txBody>
+      </p:sp>
+      <p:sp>
+        <p:nvSpPr>
+          <p:cNvPr id="10" name="Rectangle 9"/>
+          <p:cNvSpPr/>
+          <p:nvPr/>
+        </p:nvSpPr>
+        <p:spPr>
+          <a:xfrm>
+            <a:off x="822960" y="3429000"/>
+            <a:ext cx="10515600" cy="15240"/>
+          </a:xfrm>
+          <a:prstGeom prst="rect">
+            <a:avLst/>
+          </a:prstGeom>
+          <a:solidFill>
+            <a:srgbClr val="223047"/>
+          </a:solidFill>
+          <a:ln>
+            <a:noFill/>
+          </a:ln>
+          <a:effectLst/>
+        </p:spPr>
+        <p:style>
+          <a:lnRef idx="1">
+            <a:schemeClr val="accent1"/>
+          </a:lnRef>
+          <a:fillRef idx="3">
+            <a:schemeClr val="accent1"/>
+          </a:fillRef>
+          <a:effectRef idx="2">
+            <a:schemeClr val="accent1"/>
+          </a:effectRef>
+          <a:fontRef idx="minor">
+            <a:schemeClr val="lt1"/>
+          </a:fontRef>
+        </p:style>
+        <p:txBody>
+          <a:bodyPr rtlCol="0" anchor="ctr" wrap="square"/>
+          <a:lstStyle/>
+          <a:p>
+            <a:pPr algn="ctr"/>
+          </a:p>
+        </p:txBody>
+      </p:sp>
+      <p:sp>
+        <p:nvSpPr>
+          <p:cNvPr id="11" name="Oval 10"/>
+          <p:cNvSpPr/>
+          <p:nvPr/>
+        </p:nvSpPr>
+        <p:spPr>
+          <a:xfrm>
+            <a:off x="868680" y="3648456"/>
+            <a:ext cx="165100" cy="165100"/>
+          </a:xfrm>
+          <a:prstGeom prst="ellipse">
+            <a:avLst/>
+          </a:prstGeom>
+          <a:solidFill>
+            <a:srgbClr val="7FC8A9"/>
+          </a:solidFill>
+          <a:ln>
+            <a:noFill/>
+          </a:ln>
+          <a:effectLst/>
+        </p:spPr>
+        <p:style>
+          <a:lnRef idx="1">
+            <a:schemeClr val="accent1"/>
+          </a:lnRef>
+          <a:fillRef idx="3">
+            <a:schemeClr val="accent1"/>
+          </a:fillRef>
+          <a:effectRef idx="2">
+            <a:schemeClr val="accent1"/>
+          </a:effectRef>
+          <a:fontRef idx="minor">
+            <a:schemeClr val="lt1"/>
+          </a:fontRef>
+        </p:style>
+        <p:txBody>
+          <a:bodyPr rtlCol="0" anchor="ctr" wrap="square"/>
+          <a:lstStyle/>
+          <a:p>
+            <a:pPr algn="ctr"/>
+          </a:p>
+        </p:txBody>
+      </p:sp>
+      <p:sp>
+        <p:nvSpPr>
+          <p:cNvPr id="12" name="TextBox 11"/>
+          <p:cNvSpPr txBox="1"/>
+          <p:nvPr/>
+        </p:nvSpPr>
+        <p:spPr>
+          <a:xfrm>
+            <a:off x="1234440" y="3493008"/>
+            <a:ext cx="10012680" cy="822960"/>
+          </a:xfrm>
+          <a:prstGeom prst="rect">
+            <a:avLst/>
+          </a:prstGeom>
+          <a:noFill/>
+          <a:effectLst/>
+        </p:spPr>
+        <p:txBody>
+          <a:bodyPr wrap="square" lIns="50800" rIns="50800">
+            <a:spAutoFit/>
+          </a:bodyPr>
+          <a:lstStyle/>
+          <a:p>
+            <a:pPr algn="l"/>
+            <a:r>
+              <a:rPr sz="1650" b="0">
+                <a:solidFill>
+                  <a:srgbClr val="E8ECF2"/>
+                </a:solidFill>
+                <a:latin typeface="Segoe UI"/>
+                <a:ea typeface="Microsoft YaHei"/>
+              </a:rPr>
+              <a:t>契约化技能包：SKILL.md + tools.yaml + scripts/&lt;name&gt;.py</a:t>
+            </a:r>
+          </a:p>
+        </p:txBody>
+      </p:sp>
+      <p:sp>
+        <p:nvSpPr>
+          <p:cNvPr id="13" name="Rectangle 12"/>
+          <p:cNvSpPr/>
+          <p:nvPr/>
+        </p:nvSpPr>
+        <p:spPr>
+          <a:xfrm>
+            <a:off x="822960" y="4361688"/>
+            <a:ext cx="10515600" cy="15240"/>
+          </a:xfrm>
+          <a:prstGeom prst="rect">
+            <a:avLst/>
+          </a:prstGeom>
+          <a:solidFill>
+            <a:srgbClr val="223047"/>
+          </a:solidFill>
+          <a:ln>
+            <a:noFill/>
+          </a:ln>
+          <a:effectLst/>
+        </p:spPr>
+        <p:style>
+          <a:lnRef idx="1">
+            <a:schemeClr val="accent1"/>
+          </a:lnRef>
+          <a:fillRef idx="3">
+            <a:schemeClr val="accent1"/>
+          </a:fillRef>
+          <a:effectRef idx="2">
+            <a:schemeClr val="accent1"/>
+          </a:effectRef>
+          <a:fontRef idx="minor">
+            <a:schemeClr val="lt1"/>
+          </a:fontRef>
+        </p:style>
+        <p:txBody>
+          <a:bodyPr rtlCol="0" anchor="ctr" wrap="square"/>
+          <a:lstStyle/>
+          <a:p>
+            <a:pPr algn="ctr"/>
+          </a:p>
+        </p:txBody>
+      </p:sp>
+      <p:sp>
+        <p:nvSpPr>
+          <p:cNvPr id="14" name="Oval 13"/>
+          <p:cNvSpPr/>
+          <p:nvPr/>
+        </p:nvSpPr>
+        <p:spPr>
+          <a:xfrm>
+            <a:off x="868680" y="4581144"/>
+            <a:ext cx="165100" cy="165100"/>
+          </a:xfrm>
+          <a:prstGeom prst="ellipse">
+            <a:avLst/>
+          </a:prstGeom>
+          <a:solidFill>
+            <a:srgbClr val="7FC8A9"/>
+          </a:solidFill>
+          <a:ln>
+            <a:noFill/>
+          </a:ln>
+          <a:effectLst/>
+        </p:spPr>
+        <p:style>
+          <a:lnRef idx="1">
+            <a:schemeClr val="accent1"/>
+          </a:lnRef>
+          <a:fillRef idx="3">
+            <a:schemeClr val="accent1"/>
+          </a:fillRef>
+          <a:effectRef idx="2">
+            <a:schemeClr val="accent1"/>
+          </a:effectRef>
+          <a:fontRef idx="minor">
+            <a:schemeClr val="lt1"/>
+          </a:fontRef>
+        </p:style>
+        <p:txBody>
+          <a:bodyPr rtlCol="0" anchor="ctr" wrap="square"/>
+          <a:lstStyle/>
+          <a:p>
+            <a:pPr algn="ctr"/>
+          </a:p>
+        </p:txBody>
+      </p:sp>
+      <p:sp>
+        <p:nvSpPr>
+          <p:cNvPr id="15" name="TextBox 14"/>
+          <p:cNvSpPr txBox="1"/>
+          <p:nvPr/>
+        </p:nvSpPr>
+        <p:spPr>
+          <a:xfrm>
+            <a:off x="1234440" y="4425696"/>
+            <a:ext cx="10012680" cy="822960"/>
+          </a:xfrm>
+          <a:prstGeom prst="rect">
+            <a:avLst/>
+          </a:prstGeom>
+          <a:noFill/>
+          <a:effectLst/>
+        </p:spPr>
+        <p:txBody>
+          <a:bodyPr wrap="square" lIns="50800" rIns="50800">
+            <a:spAutoFit/>
+          </a:bodyPr>
+          <a:lstStyle/>
+          <a:p>
+            <a:pPr algn="l"/>
+            <a:r>
+              <a:rPr sz="1650" b="0">
+                <a:solidFill>
+                  <a:srgbClr val="E8ECF2"/>
+                </a:solidFill>
+                <a:latin typeface="Segoe UI"/>
+                <a:ea typeface="Microsoft YaHei"/>
+              </a:rPr>
+              <a:t>Maya 单仓 25+ 域技能包、198 个结构化操作</a:t>
+            </a:r>
+          </a:p>
+        </p:txBody>
+      </p:sp>
+      <p:sp>
+        <p:nvSpPr>
+          <p:cNvPr id="16" name="TextBox 15"/>
+          <p:cNvSpPr txBox="1"/>
+          <p:nvPr/>
+        </p:nvSpPr>
+        <p:spPr>
+          <a:xfrm>
+            <a:off x="822960" y="6473952"/>
+            <a:ext cx="7315200" cy="274320"/>
+          </a:xfrm>
+          <a:prstGeom prst="rect">
+            <a:avLst/>
+          </a:prstGeom>
+          <a:noFill/>
+          <a:effectLst/>
+        </p:spPr>
+        <p:txBody>
+          <a:bodyPr wrap="square" lIns="50800" rIns="50800">
+            <a:spAutoFit/>
+          </a:bodyPr>
+          <a:lstStyle/>
+          <a:p>
+            <a:pPr algn="l"/>
+            <a:r>
+              <a:rPr sz="1000" b="0">
+                <a:solidFill>
+                  <a:srgbClr val="9AA7BC"/>
+                </a:solidFill>
+                <a:latin typeface="Segoe UI"/>
+                <a:ea typeface="Microsoft YaHei"/>
+              </a:rPr>
+              <a:t>DCC-MCP 框架介绍</a:t>
+            </a:r>
+          </a:p>
+        </p:txBody>
+      </p:sp>
+      <p:sp>
+        <p:nvSpPr>
+          <p:cNvPr id="17" name="TextBox 16"/>
           <p:cNvSpPr txBox="1"/>
           <p:nvPr/>
         </p:nvSpPr>
@@ -7214,8 +8886,8 @@
         </p:nvSpPr>
         <p:spPr>
           <a:xfrm>
-            <a:off x="822960" y="457200"/>
-            <a:ext cx="10515600" cy="731520"/>
+            <a:off x="822960" y="502920"/>
+            <a:ext cx="10515600" cy="685800"/>
           </a:xfrm>
           <a:prstGeom prst="rect">
             <a:avLst/>
@@ -7231,7 +8903,7 @@
           <a:p>
             <a:pPr algn="l"/>
             <a:r>
-              <a:rPr sz="3000" b="1">
+              <a:rPr sz="2800" b="1">
                 <a:solidFill>
                   <a:srgbClr val="E8ECF2"/>
                 </a:solidFill>
@@ -7245,18 +8917,62 @@
       </p:sp>
       <p:sp>
         <p:nvSpPr>
-          <p:cNvPr id="4" name="Rounded Rectangle 3"/>
+          <p:cNvPr id="4" name="Rectangle 3"/>
           <p:cNvSpPr/>
           <p:nvPr/>
         </p:nvSpPr>
         <p:spPr>
           <a:xfrm>
-            <a:off x="822960" y="1371600"/>
-            <a:ext cx="3291840" cy="1737360"/>
+            <a:off x="822960" y="1298448"/>
+            <a:ext cx="822960" cy="44450"/>
+          </a:xfrm>
+          <a:prstGeom prst="rect">
+            <a:avLst/>
+          </a:prstGeom>
+          <a:solidFill>
+            <a:srgbClr val="4D9DE0"/>
+          </a:solidFill>
+          <a:ln>
+            <a:noFill/>
+          </a:ln>
+          <a:effectLst/>
+        </p:spPr>
+        <p:style>
+          <a:lnRef idx="1">
+            <a:schemeClr val="accent1"/>
+          </a:lnRef>
+          <a:fillRef idx="3">
+            <a:schemeClr val="accent1"/>
+          </a:fillRef>
+          <a:effectRef idx="2">
+            <a:schemeClr val="accent1"/>
+          </a:effectRef>
+          <a:fontRef idx="minor">
+            <a:schemeClr val="lt1"/>
+          </a:fontRef>
+        </p:style>
+        <p:txBody>
+          <a:bodyPr rtlCol="0" anchor="ctr" wrap="square"/>
+          <a:lstStyle/>
+          <a:p>
+            <a:pPr algn="ctr"/>
+          </a:p>
+        </p:txBody>
+      </p:sp>
+      <p:sp>
+        <p:nvSpPr>
+          <p:cNvPr id="5" name="Rounded Rectangle 4"/>
+          <p:cNvSpPr/>
+          <p:nvPr/>
+        </p:nvSpPr>
+        <p:spPr>
+          <a:xfrm>
+            <a:off x="822960" y="1627632"/>
+            <a:ext cx="3291840" cy="1691640"/>
           </a:xfrm>
           <a:prstGeom prst="roundRect">
             <a:avLst>
-              <a:gd name="adj" fmla="val 8000"/>
+              <a:gd name="adj" fmla="val 7000"/>
             </a:avLst>
           </a:prstGeom>
           <a:solidFill>
@@ -7314,18 +9030,62 @@
       </p:sp>
       <p:sp>
         <p:nvSpPr>
-          <p:cNvPr id="5" name="Rounded Rectangle 4"/>
+          <p:cNvPr id="6" name="Rectangle 5"/>
           <p:cNvSpPr/>
           <p:nvPr/>
         </p:nvSpPr>
         <p:spPr>
           <a:xfrm>
-            <a:off x="4389120" y="1371600"/>
-            <a:ext cx="3291840" cy="1737360"/>
+            <a:off x="1188720" y="1627632"/>
+            <a:ext cx="502920" cy="50800"/>
+          </a:xfrm>
+          <a:prstGeom prst="rect">
+            <a:avLst/>
+          </a:prstGeom>
+          <a:solidFill>
+            <a:srgbClr val="7FC8A9"/>
+          </a:solidFill>
+          <a:ln>
+            <a:noFill/>
+          </a:ln>
+          <a:effectLst/>
+        </p:spPr>
+        <p:style>
+          <a:lnRef idx="1">
+            <a:schemeClr val="accent1"/>
+          </a:lnRef>
+          <a:fillRef idx="3">
+            <a:schemeClr val="accent1"/>
+          </a:fillRef>
+          <a:effectRef idx="2">
+            <a:schemeClr val="accent1"/>
+          </a:effectRef>
+          <a:fontRef idx="minor">
+            <a:schemeClr val="lt1"/>
+          </a:fontRef>
+        </p:style>
+        <p:txBody>
+          <a:bodyPr rtlCol="0" anchor="ctr" wrap="square"/>
+          <a:lstStyle/>
+          <a:p>
+            <a:pPr algn="ctr"/>
+          </a:p>
+        </p:txBody>
+      </p:sp>
+      <p:sp>
+        <p:nvSpPr>
+          <p:cNvPr id="7" name="Rounded Rectangle 6"/>
+          <p:cNvSpPr/>
+          <p:nvPr/>
+        </p:nvSpPr>
+        <p:spPr>
+          <a:xfrm>
+            <a:off x="4389120" y="1627632"/>
+            <a:ext cx="3291840" cy="1691640"/>
           </a:xfrm>
           <a:prstGeom prst="roundRect">
             <a:avLst>
-              <a:gd name="adj" fmla="val 8000"/>
+              <a:gd name="adj" fmla="val 7000"/>
             </a:avLst>
           </a:prstGeom>
           <a:solidFill>
@@ -7383,18 +9143,62 @@
       </p:sp>
       <p:sp>
         <p:nvSpPr>
-          <p:cNvPr id="6" name="Rounded Rectangle 5"/>
+          <p:cNvPr id="8" name="Rectangle 7"/>
           <p:cNvSpPr/>
           <p:nvPr/>
         </p:nvSpPr>
         <p:spPr>
           <a:xfrm>
-            <a:off x="7955279" y="1371600"/>
-            <a:ext cx="3291840" cy="1737360"/>
+            <a:off x="4754880" y="1627632"/>
+            <a:ext cx="502920" cy="50800"/>
+          </a:xfrm>
+          <a:prstGeom prst="rect">
+            <a:avLst/>
+          </a:prstGeom>
+          <a:solidFill>
+            <a:srgbClr val="7FC8A9"/>
+          </a:solidFill>
+          <a:ln>
+            <a:noFill/>
+          </a:ln>
+          <a:effectLst/>
+        </p:spPr>
+        <p:style>
+          <a:lnRef idx="1">
+            <a:schemeClr val="accent1"/>
+          </a:lnRef>
+          <a:fillRef idx="3">
+            <a:schemeClr val="accent1"/>
+          </a:fillRef>
+          <a:effectRef idx="2">
+            <a:schemeClr val="accent1"/>
+          </a:effectRef>
+          <a:fontRef idx="minor">
+            <a:schemeClr val="lt1"/>
+          </a:fontRef>
+        </p:style>
+        <p:txBody>
+          <a:bodyPr rtlCol="0" anchor="ctr" wrap="square"/>
+          <a:lstStyle/>
+          <a:p>
+            <a:pPr algn="ctr"/>
+          </a:p>
+        </p:txBody>
+      </p:sp>
+      <p:sp>
+        <p:nvSpPr>
+          <p:cNvPr id="9" name="Rounded Rectangle 8"/>
+          <p:cNvSpPr/>
+          <p:nvPr/>
+        </p:nvSpPr>
+        <p:spPr>
+          <a:xfrm>
+            <a:off x="7955279" y="1627632"/>
+            <a:ext cx="3291840" cy="1691640"/>
           </a:xfrm>
           <a:prstGeom prst="roundRect">
             <a:avLst>
-              <a:gd name="adj" fmla="val 8000"/>
+              <a:gd name="adj" fmla="val 7000"/>
             </a:avLst>
           </a:prstGeom>
           <a:solidFill>
@@ -7452,18 +9256,62 @@
       </p:sp>
       <p:sp>
         <p:nvSpPr>
-          <p:cNvPr id="7" name="Rounded Rectangle 6"/>
+          <p:cNvPr id="10" name="Rectangle 9"/>
           <p:cNvSpPr/>
           <p:nvPr/>
         </p:nvSpPr>
         <p:spPr>
           <a:xfrm>
-            <a:off x="822960" y="3337560"/>
-            <a:ext cx="3291840" cy="1737360"/>
+            <a:off x="8321039" y="1627632"/>
+            <a:ext cx="502920" cy="50800"/>
+          </a:xfrm>
+          <a:prstGeom prst="rect">
+            <a:avLst/>
+          </a:prstGeom>
+          <a:solidFill>
+            <a:srgbClr val="7FC8A9"/>
+          </a:solidFill>
+          <a:ln>
+            <a:noFill/>
+          </a:ln>
+          <a:effectLst/>
+        </p:spPr>
+        <p:style>
+          <a:lnRef idx="1">
+            <a:schemeClr val="accent1"/>
+          </a:lnRef>
+          <a:fillRef idx="3">
+            <a:schemeClr val="accent1"/>
+          </a:fillRef>
+          <a:effectRef idx="2">
+            <a:schemeClr val="accent1"/>
+          </a:effectRef>
+          <a:fontRef idx="minor">
+            <a:schemeClr val="lt1"/>
+          </a:fontRef>
+        </p:style>
+        <p:txBody>
+          <a:bodyPr rtlCol="0" anchor="ctr" wrap="square"/>
+          <a:lstStyle/>
+          <a:p>
+            <a:pPr algn="ctr"/>
+          </a:p>
+        </p:txBody>
+      </p:sp>
+      <p:sp>
+        <p:nvSpPr>
+          <p:cNvPr id="11" name="Rounded Rectangle 10"/>
+          <p:cNvSpPr/>
+          <p:nvPr/>
+        </p:nvSpPr>
+        <p:spPr>
+          <a:xfrm>
+            <a:off x="822960" y="3547872"/>
+            <a:ext cx="3291840" cy="1691640"/>
           </a:xfrm>
           <a:prstGeom prst="roundRect">
             <a:avLst>
-              <a:gd name="adj" fmla="val 8000"/>
+              <a:gd name="adj" fmla="val 7000"/>
             </a:avLst>
           </a:prstGeom>
           <a:solidFill>
@@ -7521,18 +9369,62 @@
       </p:sp>
       <p:sp>
         <p:nvSpPr>
-          <p:cNvPr id="8" name="Rounded Rectangle 7"/>
+          <p:cNvPr id="12" name="Rectangle 11"/>
           <p:cNvSpPr/>
           <p:nvPr/>
         </p:nvSpPr>
         <p:spPr>
           <a:xfrm>
-            <a:off x="4389120" y="3337560"/>
-            <a:ext cx="3291840" cy="1737360"/>
+            <a:off x="1188720" y="3547872"/>
+            <a:ext cx="502920" cy="50800"/>
+          </a:xfrm>
+          <a:prstGeom prst="rect">
+            <a:avLst/>
+          </a:prstGeom>
+          <a:solidFill>
+            <a:srgbClr val="7FC8A9"/>
+          </a:solidFill>
+          <a:ln>
+            <a:noFill/>
+          </a:ln>
+          <a:effectLst/>
+        </p:spPr>
+        <p:style>
+          <a:lnRef idx="1">
+            <a:schemeClr val="accent1"/>
+          </a:lnRef>
+          <a:fillRef idx="3">
+            <a:schemeClr val="accent1"/>
+          </a:fillRef>
+          <a:effectRef idx="2">
+            <a:schemeClr val="accent1"/>
+          </a:effectRef>
+          <a:fontRef idx="minor">
+            <a:schemeClr val="lt1"/>
+          </a:fontRef>
+        </p:style>
+        <p:txBody>
+          <a:bodyPr rtlCol="0" anchor="ctr" wrap="square"/>
+          <a:lstStyle/>
+          <a:p>
+            <a:pPr algn="ctr"/>
+          </a:p>
+        </p:txBody>
+      </p:sp>
+      <p:sp>
+        <p:nvSpPr>
+          <p:cNvPr id="13" name="Rounded Rectangle 12"/>
+          <p:cNvSpPr/>
+          <p:nvPr/>
+        </p:nvSpPr>
+        <p:spPr>
+          <a:xfrm>
+            <a:off x="4389120" y="3547872"/>
+            <a:ext cx="3291840" cy="1691640"/>
           </a:xfrm>
           <a:prstGeom prst="roundRect">
             <a:avLst>
-              <a:gd name="adj" fmla="val 8000"/>
+              <a:gd name="adj" fmla="val 7000"/>
             </a:avLst>
           </a:prstGeom>
           <a:solidFill>
@@ -7590,18 +9482,62 @@
       </p:sp>
       <p:sp>
         <p:nvSpPr>
-          <p:cNvPr id="9" name="Rounded Rectangle 8"/>
+          <p:cNvPr id="14" name="Rectangle 13"/>
           <p:cNvSpPr/>
           <p:nvPr/>
         </p:nvSpPr>
         <p:spPr>
           <a:xfrm>
-            <a:off x="7955279" y="3337560"/>
-            <a:ext cx="3291840" cy="1737360"/>
+            <a:off x="4754880" y="3547872"/>
+            <a:ext cx="502920" cy="50800"/>
+          </a:xfrm>
+          <a:prstGeom prst="rect">
+            <a:avLst/>
+          </a:prstGeom>
+          <a:solidFill>
+            <a:srgbClr val="7FC8A9"/>
+          </a:solidFill>
+          <a:ln>
+            <a:noFill/>
+          </a:ln>
+          <a:effectLst/>
+        </p:spPr>
+        <p:style>
+          <a:lnRef idx="1">
+            <a:schemeClr val="accent1"/>
+          </a:lnRef>
+          <a:fillRef idx="3">
+            <a:schemeClr val="accent1"/>
+          </a:fillRef>
+          <a:effectRef idx="2">
+            <a:schemeClr val="accent1"/>
+          </a:effectRef>
+          <a:fontRef idx="minor">
+            <a:schemeClr val="lt1"/>
+          </a:fontRef>
+        </p:style>
+        <p:txBody>
+          <a:bodyPr rtlCol="0" anchor="ctr" wrap="square"/>
+          <a:lstStyle/>
+          <a:p>
+            <a:pPr algn="ctr"/>
+          </a:p>
+        </p:txBody>
+      </p:sp>
+      <p:sp>
+        <p:nvSpPr>
+          <p:cNvPr id="15" name="Rounded Rectangle 14"/>
+          <p:cNvSpPr/>
+          <p:nvPr/>
+        </p:nvSpPr>
+        <p:spPr>
+          <a:xfrm>
+            <a:off x="7955279" y="3547872"/>
+            <a:ext cx="3291840" cy="1691640"/>
           </a:xfrm>
           <a:prstGeom prst="roundRect">
             <a:avLst>
-              <a:gd name="adj" fmla="val 8000"/>
+              <a:gd name="adj" fmla="val 7000"/>
             </a:avLst>
           </a:prstGeom>
           <a:solidFill>
@@ -7659,7 +9595,88 @@
       </p:sp>
       <p:sp>
         <p:nvSpPr>
-          <p:cNvPr id="10" name="TextBox 9"/>
+          <p:cNvPr id="16" name="Rectangle 15"/>
+          <p:cNvSpPr/>
+          <p:nvPr/>
+        </p:nvSpPr>
+        <p:spPr>
+          <a:xfrm>
+            <a:off x="8321039" y="3547872"/>
+            <a:ext cx="502920" cy="50800"/>
+          </a:xfrm>
+          <a:prstGeom prst="rect">
+            <a:avLst/>
+          </a:prstGeom>
+          <a:solidFill>
+            <a:srgbClr val="7FC8A9"/>
+          </a:solidFill>
+          <a:ln>
+            <a:noFill/>
+          </a:ln>
+          <a:effectLst/>
+        </p:spPr>
+        <p:style>
+          <a:lnRef idx="1">
+            <a:schemeClr val="accent1"/>
+          </a:lnRef>
+          <a:fillRef idx="3">
+            <a:schemeClr val="accent1"/>
+          </a:fillRef>
+          <a:effectRef idx="2">
+            <a:schemeClr val="accent1"/>
+          </a:effectRef>
+          <a:fontRef idx="minor">
+            <a:schemeClr val="lt1"/>
+          </a:fontRef>
+        </p:style>
+        <p:txBody>
+          <a:bodyPr rtlCol="0" anchor="ctr" wrap="square"/>
+          <a:lstStyle/>
+          <a:p>
+            <a:pPr algn="ctr"/>
+          </a:p>
+        </p:txBody>
+      </p:sp>
+      <p:sp>
+        <p:nvSpPr>
+          <p:cNvPr id="17" name="TextBox 16"/>
+          <p:cNvSpPr txBox="1"/>
+          <p:nvPr/>
+        </p:nvSpPr>
+        <p:spPr>
+          <a:xfrm>
+            <a:off x="822960" y="6473952"/>
+            <a:ext cx="7315200" cy="274320"/>
+          </a:xfrm>
+          <a:prstGeom prst="rect">
+            <a:avLst/>
+          </a:prstGeom>
+          <a:noFill/>
+          <a:effectLst/>
+        </p:spPr>
+        <p:txBody>
+          <a:bodyPr wrap="square" lIns="50800" rIns="50800">
+            <a:spAutoFit/>
+          </a:bodyPr>
+          <a:lstStyle/>
+          <a:p>
+            <a:pPr algn="l"/>
+            <a:r>
+              <a:rPr sz="1000" b="0">
+                <a:solidFill>
+                  <a:srgbClr val="9AA7BC"/>
+                </a:solidFill>
+                <a:latin typeface="Segoe UI"/>
+                <a:ea typeface="Microsoft YaHei"/>
+              </a:rPr>
+              <a:t>DCC-MCP 框架介绍</a:t>
+            </a:r>
+          </a:p>
+        </p:txBody>
+      </p:sp>
+      <p:sp>
+        <p:nvSpPr>
+          <p:cNvPr id="18" name="TextBox 17"/>
           <p:cNvSpPr txBox="1"/>
           <p:nvPr/>
         </p:nvSpPr>
@@ -7802,13 +9819,57 @@
       </p:sp>
       <p:sp>
         <p:nvSpPr>
-          <p:cNvPr id="4" name="TextBox 3"/>
+          <p:cNvPr id="4" name="Oval 3"/>
+          <p:cNvSpPr/>
+          <p:nvPr/>
+        </p:nvSpPr>
+        <p:spPr>
+          <a:xfrm>
+            <a:off x="9601200" y="320040"/>
+            <a:ext cx="2468880" cy="2468880"/>
+          </a:xfrm>
+          <a:prstGeom prst="ellipse">
+            <a:avLst/>
+          </a:prstGeom>
+          <a:solidFill>
+            <a:srgbClr val="223047"/>
+          </a:solidFill>
+          <a:ln>
+            <a:noFill/>
+          </a:ln>
+          <a:effectLst/>
+        </p:spPr>
+        <p:style>
+          <a:lnRef idx="1">
+            <a:schemeClr val="accent1"/>
+          </a:lnRef>
+          <a:fillRef idx="3">
+            <a:schemeClr val="accent1"/>
+          </a:fillRef>
+          <a:effectRef idx="2">
+            <a:schemeClr val="accent1"/>
+          </a:effectRef>
+          <a:fontRef idx="minor">
+            <a:schemeClr val="lt1"/>
+          </a:fontRef>
+        </p:style>
+        <p:txBody>
+          <a:bodyPr rtlCol="0" anchor="ctr"/>
+          <a:lstStyle/>
+          <a:p>
+            <a:pPr algn="ctr"/>
+          </a:p>
+        </p:txBody>
+      </p:sp>
+      <p:sp>
+        <p:nvSpPr>
+          <p:cNvPr id="5" name="TextBox 4"/>
           <p:cNvSpPr txBox="1"/>
           <p:nvPr/>
         </p:nvSpPr>
         <p:spPr>
           <a:xfrm>
-            <a:off x="640080" y="548640"/>
+            <a:off x="640080" y="640080"/>
             <a:ext cx="4572000" cy="3840480"/>
           </a:xfrm>
           <a:prstGeom prst="rect">
@@ -7839,13 +9900,13 @@
       </p:sp>
       <p:sp>
         <p:nvSpPr>
-          <p:cNvPr id="5" name="Rectangle 4"/>
+          <p:cNvPr id="6" name="Rectangle 5"/>
           <p:cNvSpPr/>
           <p:nvPr/>
         </p:nvSpPr>
         <p:spPr>
           <a:xfrm>
-            <a:off x="822960" y="2880360"/>
+            <a:off x="822960" y="2788920"/>
             <a:ext cx="164592" cy="1097280"/>
           </a:xfrm>
           <a:prstGeom prst="rect">
@@ -7883,13 +9944,13 @@
       </p:sp>
       <p:sp>
         <p:nvSpPr>
-          <p:cNvPr id="6" name="TextBox 5"/>
+          <p:cNvPr id="7" name="TextBox 6"/>
           <p:cNvSpPr txBox="1"/>
           <p:nvPr/>
         </p:nvSpPr>
         <p:spPr>
           <a:xfrm>
-            <a:off x="1188720" y="2834640"/>
+            <a:off x="1188720" y="2743200"/>
             <a:ext cx="10058400" cy="1280160"/>
           </a:xfrm>
           <a:prstGeom prst="rect">
@@ -7920,7 +9981,44 @@
       </p:sp>
       <p:sp>
         <p:nvSpPr>
-          <p:cNvPr id="7" name="TextBox 6"/>
+          <p:cNvPr id="8" name="TextBox 7"/>
+          <p:cNvSpPr txBox="1"/>
+          <p:nvPr/>
+        </p:nvSpPr>
+        <p:spPr>
+          <a:xfrm>
+            <a:off x="822960" y="6473952"/>
+            <a:ext cx="7315200" cy="274320"/>
+          </a:xfrm>
+          <a:prstGeom prst="rect">
+            <a:avLst/>
+          </a:prstGeom>
+          <a:noFill/>
+          <a:effectLst/>
+        </p:spPr>
+        <p:txBody>
+          <a:bodyPr wrap="square" lIns="50800" rIns="50800">
+            <a:spAutoFit/>
+          </a:bodyPr>
+          <a:lstStyle/>
+          <a:p>
+            <a:pPr algn="l"/>
+            <a:r>
+              <a:rPr sz="1000" b="0">
+                <a:solidFill>
+                  <a:srgbClr val="9AA7BC"/>
+                </a:solidFill>
+                <a:latin typeface="Segoe UI"/>
+                <a:ea typeface="Microsoft YaHei"/>
+              </a:rPr>
+              <a:t>DCC-MCP 框架介绍</a:t>
+            </a:r>
+          </a:p>
+        </p:txBody>
+      </p:sp>
+      <p:sp>
+        <p:nvSpPr>
+          <p:cNvPr id="9" name="TextBox 8"/>
           <p:cNvSpPr txBox="1"/>
           <p:nvPr/>
         </p:nvSpPr>
@@ -8025,8 +10123,8 @@
         </p:nvSpPr>
         <p:spPr>
           <a:xfrm>
-            <a:off x="822960" y="457200"/>
-            <a:ext cx="10515600" cy="731520"/>
+            <a:off x="822960" y="502920"/>
+            <a:ext cx="10515600" cy="685800"/>
           </a:xfrm>
           <a:prstGeom prst="rect">
             <a:avLst/>
@@ -8042,7 +10140,7 @@
           <a:p>
             <a:pPr algn="l"/>
             <a:r>
-              <a:rPr sz="3000" b="1">
+              <a:rPr sz="2800" b="1">
                 <a:solidFill>
                   <a:srgbClr val="E8ECF2"/>
                 </a:solidFill>
@@ -8062,8 +10160,8 @@
         </p:nvSpPr>
         <p:spPr>
           <a:xfrm>
-            <a:off x="822960" y="3291840"/>
-            <a:ext cx="10515600" cy="38100"/>
+            <a:off x="822960" y="1298448"/>
+            <a:ext cx="822960" cy="44450"/>
           </a:xfrm>
           <a:prstGeom prst="rect">
             <a:avLst/>
@@ -8100,20 +10198,20 @@
       </p:sp>
       <p:sp>
         <p:nvSpPr>
-          <p:cNvPr id="5" name="Oval 4"/>
+          <p:cNvPr id="5" name="Rectangle 4"/>
           <p:cNvSpPr/>
           <p:nvPr/>
         </p:nvSpPr>
         <p:spPr>
           <a:xfrm>
-            <a:off x="1760219" y="3241040"/>
-            <a:ext cx="228600" cy="228600"/>
-          </a:xfrm>
-          <a:prstGeom prst="ellipse">
+            <a:off x="822960" y="3246120"/>
+            <a:ext cx="10515600" cy="38100"/>
+          </a:xfrm>
+          <a:prstGeom prst="rect">
             <a:avLst/>
           </a:prstGeom>
           <a:solidFill>
-            <a:srgbClr val="7FC8A9"/>
+            <a:srgbClr val="4D9DE0"/>
           </a:solidFill>
           <a:ln>
             <a:noFill/>
@@ -8144,60 +10242,25 @@
       </p:sp>
       <p:sp>
         <p:nvSpPr>
-          <p:cNvPr id="6" name="TextBox 5"/>
-          <p:cNvSpPr txBox="1"/>
-          <p:nvPr/>
-        </p:nvSpPr>
-        <p:spPr>
-          <a:xfrm>
-            <a:off x="891539" y="3520440"/>
-            <a:ext cx="1965960" cy="1097280"/>
-          </a:xfrm>
-          <a:prstGeom prst="rect">
-            <a:avLst/>
-          </a:prstGeom>
-          <a:noFill/>
-          <a:effectLst/>
-        </p:spPr>
-        <p:txBody>
-          <a:bodyPr wrap="square" lIns="50800" rIns="50800">
-            <a:spAutoFit/>
-          </a:bodyPr>
-          <a:lstStyle/>
-          <a:p>
-            <a:pPr algn="ctr"/>
-            <a:r>
-              <a:rPr sz="1500" b="0">
-                <a:solidFill>
-                  <a:srgbClr val="E8ECF2"/>
-                </a:solidFill>
-                <a:latin typeface="Segoe UI"/>
-                <a:ea typeface="Microsoft YaHei"/>
-              </a:rPr>
-              <a:t>01  list / search — 渐进式能力发现</a:t>
-            </a:r>
-          </a:p>
-        </p:txBody>
-      </p:sp>
-      <p:sp>
-        <p:nvSpPr>
-          <p:cNvPr id="7" name="Oval 6"/>
+          <p:cNvPr id="6" name="Oval 5"/>
           <p:cNvSpPr/>
           <p:nvPr/>
         </p:nvSpPr>
         <p:spPr>
           <a:xfrm>
-            <a:off x="3863339" y="3241040"/>
-            <a:ext cx="228600" cy="228600"/>
+            <a:off x="1719071" y="3090672"/>
+            <a:ext cx="310896" cy="310896"/>
           </a:xfrm>
           <a:prstGeom prst="ellipse">
             <a:avLst/>
           </a:prstGeom>
           <a:solidFill>
-            <a:srgbClr val="7FC8A9"/>
+            <a:srgbClr val="0F141E"/>
           </a:solidFill>
-          <a:ln>
-            <a:noFill/>
+          <a:ln w="19050">
+            <a:solidFill>
+              <a:srgbClr val="7FC8A9"/>
+            </a:solidFill>
           </a:ln>
           <a:effectLst/>
         </p:spPr>
@@ -8216,23 +10279,33 @@
           </a:fontRef>
         </p:style>
         <p:txBody>
-          <a:bodyPr rtlCol="0" anchor="ctr" wrap="square"/>
+          <a:bodyPr rtlCol="0" anchor="ctr" wrap="square" lIns="101600" rIns="101600" tIns="76200" bIns="76200"/>
           <a:lstStyle/>
           <a:p>
             <a:pPr algn="ctr"/>
-          </a:p>
-        </p:txBody>
-      </p:sp>
-      <p:sp>
-        <p:nvSpPr>
-          <p:cNvPr id="8" name="TextBox 7"/>
+            <a:r>
+              <a:rPr sz="1200" b="1">
+                <a:solidFill>
+                  <a:srgbClr val="7FC8A9"/>
+                </a:solidFill>
+                <a:latin typeface="Segoe UI"/>
+                <a:ea typeface="Microsoft YaHei"/>
+              </a:rPr>
+              <a:t>1</a:t>
+            </a:r>
+          </a:p>
+        </p:txBody>
+      </p:sp>
+      <p:sp>
+        <p:nvSpPr>
+          <p:cNvPr id="7" name="TextBox 6"/>
           <p:cNvSpPr txBox="1"/>
           <p:nvPr/>
         </p:nvSpPr>
         <p:spPr>
           <a:xfrm>
-            <a:off x="2994659" y="3520440"/>
-            <a:ext cx="1965960" cy="1097280"/>
+            <a:off x="960120" y="2103120"/>
+            <a:ext cx="1828799" cy="960120"/>
           </a:xfrm>
           <a:prstGeom prst="rect">
             <a:avLst/>
@@ -8248,37 +10321,39 @@
           <a:p>
             <a:pPr algn="ctr"/>
             <a:r>
-              <a:rPr sz="1500" b="0">
+              <a:rPr sz="1350" b="0">
                 <a:solidFill>
                   <a:srgbClr val="E8ECF2"/>
                 </a:solidFill>
                 <a:latin typeface="Segoe UI"/>
                 <a:ea typeface="Microsoft YaHei"/>
               </a:rPr>
-              <a:t>02  load_skill / describe — 契约与确认级别</a:t>
-            </a:r>
-          </a:p>
-        </p:txBody>
-      </p:sp>
-      <p:sp>
-        <p:nvSpPr>
-          <p:cNvPr id="9" name="Oval 8"/>
+              <a:t>list / search — 渐进式能力发现</a:t>
+            </a:r>
+          </a:p>
+        </p:txBody>
+      </p:sp>
+      <p:sp>
+        <p:nvSpPr>
+          <p:cNvPr id="8" name="Oval 7"/>
           <p:cNvSpPr/>
           <p:nvPr/>
         </p:nvSpPr>
         <p:spPr>
           <a:xfrm>
-            <a:off x="5966460" y="3241040"/>
-            <a:ext cx="228600" cy="228600"/>
+            <a:off x="3822191" y="3090672"/>
+            <a:ext cx="310896" cy="310896"/>
           </a:xfrm>
           <a:prstGeom prst="ellipse">
             <a:avLst/>
           </a:prstGeom>
           <a:solidFill>
-            <a:srgbClr val="7FC8A9"/>
+            <a:srgbClr val="0F141E"/>
           </a:solidFill>
-          <a:ln>
-            <a:noFill/>
+          <a:ln w="19050">
+            <a:solidFill>
+              <a:srgbClr val="7FC8A9"/>
+            </a:solidFill>
           </a:ln>
           <a:effectLst/>
         </p:spPr>
@@ -8297,23 +10372,33 @@
           </a:fontRef>
         </p:style>
         <p:txBody>
-          <a:bodyPr rtlCol="0" anchor="ctr" wrap="square"/>
+          <a:bodyPr rtlCol="0" anchor="ctr" wrap="square" lIns="101600" rIns="101600" tIns="76200" bIns="76200"/>
           <a:lstStyle/>
           <a:p>
             <a:pPr algn="ctr"/>
-          </a:p>
-        </p:txBody>
-      </p:sp>
-      <p:sp>
-        <p:nvSpPr>
-          <p:cNvPr id="10" name="TextBox 9"/>
+            <a:r>
+              <a:rPr sz="1200" b="1">
+                <a:solidFill>
+                  <a:srgbClr val="7FC8A9"/>
+                </a:solidFill>
+                <a:latin typeface="Segoe UI"/>
+                <a:ea typeface="Microsoft YaHei"/>
+              </a:rPr>
+              <a:t>2</a:t>
+            </a:r>
+          </a:p>
+        </p:txBody>
+      </p:sp>
+      <p:sp>
+        <p:nvSpPr>
+          <p:cNvPr id="9" name="TextBox 8"/>
           <p:cNvSpPr txBox="1"/>
           <p:nvPr/>
         </p:nvSpPr>
         <p:spPr>
           <a:xfrm>
-            <a:off x="5097780" y="3520440"/>
-            <a:ext cx="1965960" cy="1097280"/>
+            <a:off x="3063240" y="3566160"/>
+            <a:ext cx="1828799" cy="960120"/>
           </a:xfrm>
           <a:prstGeom prst="rect">
             <a:avLst/>
@@ -8329,37 +10414,39 @@
           <a:p>
             <a:pPr algn="ctr"/>
             <a:r>
-              <a:rPr sz="1500" b="0">
+              <a:rPr sz="1350" b="0">
                 <a:solidFill>
                   <a:srgbClr val="E8ECF2"/>
                 </a:solidFill>
                 <a:latin typeface="Segoe UI"/>
                 <a:ea typeface="Microsoft YaHei"/>
               </a:rPr>
-              <a:t>03  call — 任务级 Capability</a:t>
-            </a:r>
-          </a:p>
-        </p:txBody>
-      </p:sp>
-      <p:sp>
-        <p:nvSpPr>
-          <p:cNvPr id="11" name="Oval 10"/>
+              <a:t>load_skill / describe — 契约与确认级别</a:t>
+            </a:r>
+          </a:p>
+        </p:txBody>
+      </p:sp>
+      <p:sp>
+        <p:nvSpPr>
+          <p:cNvPr id="10" name="Oval 9"/>
           <p:cNvSpPr/>
           <p:nvPr/>
         </p:nvSpPr>
         <p:spPr>
           <a:xfrm>
-            <a:off x="8069579" y="3241040"/>
-            <a:ext cx="228600" cy="228600"/>
+            <a:off x="5925312" y="3090672"/>
+            <a:ext cx="310896" cy="310896"/>
           </a:xfrm>
           <a:prstGeom prst="ellipse">
             <a:avLst/>
           </a:prstGeom>
           <a:solidFill>
-            <a:srgbClr val="7FC8A9"/>
+            <a:srgbClr val="0F141E"/>
           </a:solidFill>
-          <a:ln>
-            <a:noFill/>
+          <a:ln w="19050">
+            <a:solidFill>
+              <a:srgbClr val="7FC8A9"/>
+            </a:solidFill>
           </a:ln>
           <a:effectLst/>
         </p:spPr>
@@ -8378,23 +10465,33 @@
           </a:fontRef>
         </p:style>
         <p:txBody>
-          <a:bodyPr rtlCol="0" anchor="ctr" wrap="square"/>
+          <a:bodyPr rtlCol="0" anchor="ctr" wrap="square" lIns="101600" rIns="101600" tIns="76200" bIns="76200"/>
           <a:lstStyle/>
           <a:p>
             <a:pPr algn="ctr"/>
-          </a:p>
-        </p:txBody>
-      </p:sp>
-      <p:sp>
-        <p:nvSpPr>
-          <p:cNvPr id="12" name="TextBox 11"/>
+            <a:r>
+              <a:rPr sz="1200" b="1">
+                <a:solidFill>
+                  <a:srgbClr val="7FC8A9"/>
+                </a:solidFill>
+                <a:latin typeface="Segoe UI"/>
+                <a:ea typeface="Microsoft YaHei"/>
+              </a:rPr>
+              <a:t>3</a:t>
+            </a:r>
+          </a:p>
+        </p:txBody>
+      </p:sp>
+      <p:sp>
+        <p:nvSpPr>
+          <p:cNvPr id="11" name="TextBox 10"/>
           <p:cNvSpPr txBox="1"/>
           <p:nvPr/>
         </p:nvSpPr>
         <p:spPr>
           <a:xfrm>
-            <a:off x="7200899" y="3520440"/>
-            <a:ext cx="1965960" cy="1097280"/>
+            <a:off x="5166361" y="2103120"/>
+            <a:ext cx="1828799" cy="960120"/>
           </a:xfrm>
           <a:prstGeom prst="rect">
             <a:avLst/>
@@ -8410,37 +10507,39 @@
           <a:p>
             <a:pPr algn="ctr"/>
             <a:r>
-              <a:rPr sz="1500" b="0">
+              <a:rPr sz="1350" b="0">
                 <a:solidFill>
                   <a:srgbClr val="E8ECF2"/>
                 </a:solidFill>
                 <a:latin typeface="Segoe UI"/>
                 <a:ea typeface="Microsoft YaHei"/>
               </a:rPr>
-              <a:t>04  Job — 批处理永不占住连接</a:t>
-            </a:r>
-          </a:p>
-        </p:txBody>
-      </p:sp>
-      <p:sp>
-        <p:nvSpPr>
-          <p:cNvPr id="13" name="Oval 12"/>
+              <a:t>call — 任务级 Capability</a:t>
+            </a:r>
+          </a:p>
+        </p:txBody>
+      </p:sp>
+      <p:sp>
+        <p:nvSpPr>
+          <p:cNvPr id="12" name="Oval 11"/>
           <p:cNvSpPr/>
           <p:nvPr/>
         </p:nvSpPr>
         <p:spPr>
           <a:xfrm>
-            <a:off x="10172700" y="3241040"/>
-            <a:ext cx="228600" cy="228600"/>
+            <a:off x="8028431" y="3090672"/>
+            <a:ext cx="310896" cy="310896"/>
           </a:xfrm>
           <a:prstGeom prst="ellipse">
             <a:avLst/>
           </a:prstGeom>
           <a:solidFill>
-            <a:srgbClr val="7FC8A9"/>
+            <a:srgbClr val="0F141E"/>
           </a:solidFill>
-          <a:ln>
-            <a:noFill/>
+          <a:ln w="19050">
+            <a:solidFill>
+              <a:srgbClr val="7FC8A9"/>
+            </a:solidFill>
           </a:ln>
           <a:effectLst/>
         </p:spPr>
@@ -8459,23 +10558,33 @@
           </a:fontRef>
         </p:style>
         <p:txBody>
-          <a:bodyPr rtlCol="0" anchor="ctr" wrap="square"/>
+          <a:bodyPr rtlCol="0" anchor="ctr" wrap="square" lIns="101600" rIns="101600" tIns="76200" bIns="76200"/>
           <a:lstStyle/>
           <a:p>
             <a:pPr algn="ctr"/>
-          </a:p>
-        </p:txBody>
-      </p:sp>
-      <p:sp>
-        <p:nvSpPr>
-          <p:cNvPr id="14" name="TextBox 13"/>
+            <a:r>
+              <a:rPr sz="1200" b="1">
+                <a:solidFill>
+                  <a:srgbClr val="7FC8A9"/>
+                </a:solidFill>
+                <a:latin typeface="Segoe UI"/>
+                <a:ea typeface="Microsoft YaHei"/>
+              </a:rPr>
+              <a:t>4</a:t>
+            </a:r>
+          </a:p>
+        </p:txBody>
+      </p:sp>
+      <p:sp>
+        <p:nvSpPr>
+          <p:cNvPr id="13" name="TextBox 12"/>
           <p:cNvSpPr txBox="1"/>
           <p:nvPr/>
         </p:nvSpPr>
         <p:spPr>
           <a:xfrm>
-            <a:off x="9304020" y="3520440"/>
-            <a:ext cx="1965960" cy="1097280"/>
+            <a:off x="7269480" y="3566160"/>
+            <a:ext cx="1828799" cy="960120"/>
           </a:xfrm>
           <a:prstGeom prst="rect">
             <a:avLst/>
@@ -8491,14 +10600,70 @@
           <a:p>
             <a:pPr algn="ctr"/>
             <a:r>
-              <a:rPr sz="1500" b="0">
+              <a:rPr sz="1350" b="0">
                 <a:solidFill>
                   <a:srgbClr val="E8ECF2"/>
                 </a:solidFill>
                 <a:latin typeface="Segoe UI"/>
                 <a:ea typeface="Microsoft YaHei"/>
               </a:rPr>
-              <a:t>05  Artifact — 结果、预览、审计可追踪</a:t>
+              <a:t>Job — 批处理永不占住连接</a:t>
+            </a:r>
+          </a:p>
+        </p:txBody>
+      </p:sp>
+      <p:sp>
+        <p:nvSpPr>
+          <p:cNvPr id="14" name="Oval 13"/>
+          <p:cNvSpPr/>
+          <p:nvPr/>
+        </p:nvSpPr>
+        <p:spPr>
+          <a:xfrm>
+            <a:off x="10131552" y="3090672"/>
+            <a:ext cx="310896" cy="310896"/>
+          </a:xfrm>
+          <a:prstGeom prst="ellipse">
+            <a:avLst/>
+          </a:prstGeom>
+          <a:solidFill>
+            <a:srgbClr val="0F141E"/>
+          </a:solidFill>
+          <a:ln w="19050">
+            <a:solidFill>
+              <a:srgbClr val="7FC8A9"/>
+            </a:solidFill>
+          </a:ln>
+          <a:effectLst/>
+        </p:spPr>
+        <p:style>
+          <a:lnRef idx="1">
+            <a:schemeClr val="accent1"/>
+          </a:lnRef>
+          <a:fillRef idx="3">
+            <a:schemeClr val="accent1"/>
+          </a:fillRef>
+          <a:effectRef idx="2">
+            <a:schemeClr val="accent1"/>
+          </a:effectRef>
+          <a:fontRef idx="minor">
+            <a:schemeClr val="lt1"/>
+          </a:fontRef>
+        </p:style>
+        <p:txBody>
+          <a:bodyPr rtlCol="0" anchor="ctr" wrap="square" lIns="101600" rIns="101600" tIns="76200" bIns="76200"/>
+          <a:lstStyle/>
+          <a:p>
+            <a:pPr algn="ctr"/>
+            <a:r>
+              <a:rPr sz="1200" b="1">
+                <a:solidFill>
+                  <a:srgbClr val="7FC8A9"/>
+                </a:solidFill>
+                <a:latin typeface="Segoe UI"/>
+                <a:ea typeface="Microsoft YaHei"/>
+              </a:rPr>
+              <a:t>5</a:t>
             </a:r>
           </a:p>
         </p:txBody>
@@ -8506,6 +10671,80 @@
       <p:sp>
         <p:nvSpPr>
           <p:cNvPr id="15" name="TextBox 14"/>
+          <p:cNvSpPr txBox="1"/>
+          <p:nvPr/>
+        </p:nvSpPr>
+        <p:spPr>
+          <a:xfrm>
+            <a:off x="9372601" y="2103120"/>
+            <a:ext cx="1828799" cy="960120"/>
+          </a:xfrm>
+          <a:prstGeom prst="rect">
+            <a:avLst/>
+          </a:prstGeom>
+          <a:noFill/>
+          <a:effectLst/>
+        </p:spPr>
+        <p:txBody>
+          <a:bodyPr wrap="square" lIns="50800" rIns="50800">
+            <a:spAutoFit/>
+          </a:bodyPr>
+          <a:lstStyle/>
+          <a:p>
+            <a:pPr algn="ctr"/>
+            <a:r>
+              <a:rPr sz="1350" b="0">
+                <a:solidFill>
+                  <a:srgbClr val="E8ECF2"/>
+                </a:solidFill>
+                <a:latin typeface="Segoe UI"/>
+                <a:ea typeface="Microsoft YaHei"/>
+              </a:rPr>
+              <a:t>Artifact — 结果、预览、审计可追踪</a:t>
+            </a:r>
+          </a:p>
+        </p:txBody>
+      </p:sp>
+      <p:sp>
+        <p:nvSpPr>
+          <p:cNvPr id="16" name="TextBox 15"/>
+          <p:cNvSpPr txBox="1"/>
+          <p:nvPr/>
+        </p:nvSpPr>
+        <p:spPr>
+          <a:xfrm>
+            <a:off x="822960" y="6473952"/>
+            <a:ext cx="7315200" cy="274320"/>
+          </a:xfrm>
+          <a:prstGeom prst="rect">
+            <a:avLst/>
+          </a:prstGeom>
+          <a:noFill/>
+          <a:effectLst/>
+        </p:spPr>
+        <p:txBody>
+          <a:bodyPr wrap="square" lIns="50800" rIns="50800">
+            <a:spAutoFit/>
+          </a:bodyPr>
+          <a:lstStyle/>
+          <a:p>
+            <a:pPr algn="l"/>
+            <a:r>
+              <a:rPr sz="1000" b="0">
+                <a:solidFill>
+                  <a:srgbClr val="9AA7BC"/>
+                </a:solidFill>
+                <a:latin typeface="Segoe UI"/>
+                <a:ea typeface="Microsoft YaHei"/>
+              </a:rPr>
+              <a:t>DCC-MCP 框架介绍</a:t>
+            </a:r>
+          </a:p>
+        </p:txBody>
+      </p:sp>
+      <p:sp>
+        <p:nvSpPr>
+          <p:cNvPr id="17" name="TextBox 16"/>
           <p:cNvSpPr txBox="1"/>
           <p:nvPr/>
         </p:nvSpPr>
@@ -8648,13 +10887,57 @@
       </p:sp>
       <p:sp>
         <p:nvSpPr>
-          <p:cNvPr id="4" name="TextBox 3"/>
+          <p:cNvPr id="4" name="Oval 3"/>
+          <p:cNvSpPr/>
+          <p:nvPr/>
+        </p:nvSpPr>
+        <p:spPr>
+          <a:xfrm>
+            <a:off x="9601200" y="320040"/>
+            <a:ext cx="2468880" cy="2468880"/>
+          </a:xfrm>
+          <a:prstGeom prst="ellipse">
+            <a:avLst/>
+          </a:prstGeom>
+          <a:solidFill>
+            <a:srgbClr val="223047"/>
+          </a:solidFill>
+          <a:ln>
+            <a:noFill/>
+          </a:ln>
+          <a:effectLst/>
+        </p:spPr>
+        <p:style>
+          <a:lnRef idx="1">
+            <a:schemeClr val="accent1"/>
+          </a:lnRef>
+          <a:fillRef idx="3">
+            <a:schemeClr val="accent1"/>
+          </a:fillRef>
+          <a:effectRef idx="2">
+            <a:schemeClr val="accent1"/>
+          </a:effectRef>
+          <a:fontRef idx="minor">
+            <a:schemeClr val="lt1"/>
+          </a:fontRef>
+        </p:style>
+        <p:txBody>
+          <a:bodyPr rtlCol="0" anchor="ctr"/>
+          <a:lstStyle/>
+          <a:p>
+            <a:pPr algn="ctr"/>
+          </a:p>
+        </p:txBody>
+      </p:sp>
+      <p:sp>
+        <p:nvSpPr>
+          <p:cNvPr id="5" name="TextBox 4"/>
           <p:cNvSpPr txBox="1"/>
           <p:nvPr/>
         </p:nvSpPr>
         <p:spPr>
           <a:xfrm>
-            <a:off x="640080" y="548640"/>
+            <a:off x="640080" y="640080"/>
             <a:ext cx="4572000" cy="3840480"/>
           </a:xfrm>
           <a:prstGeom prst="rect">
@@ -8685,13 +10968,13 @@
       </p:sp>
       <p:sp>
         <p:nvSpPr>
-          <p:cNvPr id="5" name="Rectangle 4"/>
+          <p:cNvPr id="6" name="Rectangle 5"/>
           <p:cNvSpPr/>
           <p:nvPr/>
         </p:nvSpPr>
         <p:spPr>
           <a:xfrm>
-            <a:off x="822960" y="2880360"/>
+            <a:off x="822960" y="2788920"/>
             <a:ext cx="164592" cy="1097280"/>
           </a:xfrm>
           <a:prstGeom prst="rect">
@@ -8729,13 +11012,13 @@
       </p:sp>
       <p:sp>
         <p:nvSpPr>
-          <p:cNvPr id="6" name="TextBox 5"/>
+          <p:cNvPr id="7" name="TextBox 6"/>
           <p:cNvSpPr txBox="1"/>
           <p:nvPr/>
         </p:nvSpPr>
         <p:spPr>
           <a:xfrm>
-            <a:off x="1188720" y="2834640"/>
+            <a:off x="1188720" y="2743200"/>
             <a:ext cx="10058400" cy="1280160"/>
           </a:xfrm>
           <a:prstGeom prst="rect">
@@ -8766,7 +11049,44 @@
       </p:sp>
       <p:sp>
         <p:nvSpPr>
-          <p:cNvPr id="7" name="TextBox 6"/>
+          <p:cNvPr id="8" name="TextBox 7"/>
+          <p:cNvSpPr txBox="1"/>
+          <p:nvPr/>
+        </p:nvSpPr>
+        <p:spPr>
+          <a:xfrm>
+            <a:off x="822960" y="6473952"/>
+            <a:ext cx="7315200" cy="274320"/>
+          </a:xfrm>
+          <a:prstGeom prst="rect">
+            <a:avLst/>
+          </a:prstGeom>
+          <a:noFill/>
+          <a:effectLst/>
+        </p:spPr>
+        <p:txBody>
+          <a:bodyPr wrap="square" lIns="50800" rIns="50800">
+            <a:spAutoFit/>
+          </a:bodyPr>
+          <a:lstStyle/>
+          <a:p>
+            <a:pPr algn="l"/>
+            <a:r>
+              <a:rPr sz="1000" b="0">
+                <a:solidFill>
+                  <a:srgbClr val="9AA7BC"/>
+                </a:solidFill>
+                <a:latin typeface="Segoe UI"/>
+                <a:ea typeface="Microsoft YaHei"/>
+              </a:rPr>
+              <a:t>DCC-MCP 框架介绍</a:t>
+            </a:r>
+          </a:p>
+        </p:txBody>
+      </p:sp>
+      <p:sp>
+        <p:nvSpPr>
+          <p:cNvPr id="9" name="TextBox 8"/>
           <p:cNvSpPr txBox="1"/>
           <p:nvPr/>
         </p:nvSpPr>

</xml_diff>

<commit_message>
feat: showcase-grade layout system for all deck layouts (#6)
Design-system overhaul (showcase quality):
- unified content header (28pt title + accent rule) on every content slide
- editorial bullet rows (accent dot + hairline separators) replace box rows
- two-column/comparison panels with colored header strips
- kpi cards with accent top strip; architecture layers with numbered chips
  on a vertical spine; timeline with alternating above/below labels
- centered hero title cover + ghost circle accents (inset within the safe
  margin band — caught by the pixel-level bleed check)
- deck-title footer on all slides
- regenerated framework deck + review demo artifacts
</commit_message>
<xml_diff>
--- a/examples/output/draft-dcc-mcp-framework-intro.pptx
+++ b/examples/output/draft-dcc-mcp-framework-intro.pptx
@@ -4377,9 +4377,53 @@
           </a:p>
         </p:txBody>
       </p:sp>
+      <p:sp>
+        <p:nvSpPr>
+          <p:cNvPr id="4" name="Oval 3"/>
+          <p:cNvSpPr/>
+          <p:nvPr/>
+        </p:nvSpPr>
+        <p:spPr>
+          <a:xfrm>
+            <a:off x="9281160" y="4434840"/>
+            <a:ext cx="2788920" cy="2286000"/>
+          </a:xfrm>
+          <a:prstGeom prst="ellipse">
+            <a:avLst/>
+          </a:prstGeom>
+          <a:solidFill>
+            <a:srgbClr val="223047"/>
+          </a:solidFill>
+          <a:ln>
+            <a:noFill/>
+          </a:ln>
+          <a:effectLst/>
+        </p:spPr>
+        <p:style>
+          <a:lnRef idx="1">
+            <a:schemeClr val="accent1"/>
+          </a:lnRef>
+          <a:fillRef idx="3">
+            <a:schemeClr val="accent1"/>
+          </a:fillRef>
+          <a:effectRef idx="2">
+            <a:schemeClr val="accent1"/>
+          </a:effectRef>
+          <a:fontRef idx="minor">
+            <a:schemeClr val="lt1"/>
+          </a:fontRef>
+        </p:style>
+        <p:txBody>
+          <a:bodyPr rtlCol="0" anchor="ctr"/>
+          <a:lstStyle/>
+          <a:p>
+            <a:pPr algn="ctr"/>
+          </a:p>
+        </p:txBody>
+      </p:sp>
       <p:pic>
         <p:nvPicPr>
-          <p:cNvPr id="4" name="Picture 3" descr="dcc-mcp-logo-light.png"/>
+          <p:cNvPr id="5" name="Picture 4" descr="dcc-mcp-logo-light.png"/>
           <p:cNvPicPr>
             <a:picLocks noChangeAspect="1"/>
           </p:cNvPicPr>
@@ -4393,8 +4437,8 @@
         </p:blipFill>
         <p:spPr>
           <a:xfrm>
-            <a:off x="822960" y="411480"/>
-            <a:ext cx="1131570" cy="502920"/>
+            <a:off x="5413248" y="685800"/>
+            <a:ext cx="1234440" cy="548640"/>
           </a:xfrm>
           <a:prstGeom prst="rect">
             <a:avLst/>
@@ -4403,14 +4447,51 @@
       </p:pic>
       <p:sp>
         <p:nvSpPr>
-          <p:cNvPr id="5" name="Rectangle 4"/>
+          <p:cNvPr id="6" name="TextBox 5"/>
+          <p:cNvSpPr txBox="1"/>
+          <p:nvPr/>
+        </p:nvSpPr>
+        <p:spPr>
+          <a:xfrm>
+            <a:off x="1371600" y="2651760"/>
+            <a:ext cx="9418320" cy="1280160"/>
+          </a:xfrm>
+          <a:prstGeom prst="rect">
+            <a:avLst/>
+          </a:prstGeom>
+          <a:noFill/>
+          <a:effectLst/>
+        </p:spPr>
+        <p:txBody>
+          <a:bodyPr wrap="square" lIns="50800" rIns="50800">
+            <a:spAutoFit/>
+          </a:bodyPr>
+          <a:lstStyle/>
+          <a:p>
+            <a:pPr algn="ctr"/>
+            <a:r>
+              <a:rPr sz="5400" b="1">
+                <a:solidFill>
+                  <a:srgbClr val="E8ECF2"/>
+                </a:solidFill>
+                <a:latin typeface="Segoe UI"/>
+                <a:ea typeface="Microsoft YaHei"/>
+              </a:rPr>
+              <a:t>DCC-MCP</a:t>
+            </a:r>
+          </a:p>
+        </p:txBody>
+      </p:sp>
+      <p:sp>
+        <p:nvSpPr>
+          <p:cNvPr id="7" name="Rectangle 6"/>
           <p:cNvSpPr/>
           <p:nvPr/>
         </p:nvSpPr>
         <p:spPr>
           <a:xfrm>
-            <a:off x="822960" y="2377440"/>
-            <a:ext cx="2011680" cy="50800"/>
+            <a:off x="5687568" y="3977639"/>
+            <a:ext cx="822960" cy="50800"/>
           </a:xfrm>
           <a:prstGeom prst="rect">
             <a:avLst/>
@@ -4447,14 +4528,14 @@
       </p:sp>
       <p:sp>
         <p:nvSpPr>
-          <p:cNvPr id="6" name="TextBox 5"/>
+          <p:cNvPr id="8" name="TextBox 7"/>
           <p:cNvSpPr txBox="1"/>
           <p:nvPr/>
         </p:nvSpPr>
         <p:spPr>
           <a:xfrm>
-            <a:off x="822960" y="2514600"/>
-            <a:ext cx="10515600" cy="1463040"/>
+            <a:off x="1371600" y="4251960"/>
+            <a:ext cx="9418320" cy="914400"/>
           </a:xfrm>
           <a:prstGeom prst="rect">
             <a:avLst/>
@@ -4468,46 +4549,9 @@
           </a:bodyPr>
           <a:lstStyle/>
           <a:p>
-            <a:pPr algn="l"/>
-            <a:r>
-              <a:rPr sz="5400" b="1">
-                <a:solidFill>
-                  <a:srgbClr val="E8ECF2"/>
-                </a:solidFill>
-                <a:latin typeface="Segoe UI"/>
-                <a:ea typeface="Microsoft YaHei"/>
-              </a:rPr>
-              <a:t>DCC-MCP</a:t>
-            </a:r>
-          </a:p>
-        </p:txBody>
-      </p:sp>
-      <p:sp>
-        <p:nvSpPr>
-          <p:cNvPr id="7" name="TextBox 6"/>
-          <p:cNvSpPr txBox="1"/>
-          <p:nvPr/>
-        </p:nvSpPr>
-        <p:spPr>
-          <a:xfrm>
-            <a:off x="822960" y="4023360"/>
-            <a:ext cx="10058400" cy="1097280"/>
-          </a:xfrm>
-          <a:prstGeom prst="rect">
-            <a:avLst/>
-          </a:prstGeom>
-          <a:noFill/>
-          <a:effectLst/>
-        </p:spPr>
-        <p:txBody>
-          <a:bodyPr wrap="square" lIns="50800" rIns="50800">
-            <a:spAutoFit/>
-          </a:bodyPr>
-          <a:lstStyle/>
-          <a:p>
-            <a:pPr algn="l"/>
-            <a:r>
-              <a:rPr sz="2000" b="0">
+            <a:pPr algn="ctr"/>
+            <a:r>
+              <a:rPr sz="1800" b="0">
                 <a:solidFill>
                   <a:srgbClr val="9AA7BC"/>
                 </a:solidFill>
@@ -4518,9 +4562,9 @@
             </a:r>
           </a:p>
           <a:p>
-            <a:pPr algn="l"/>
-            <a:r>
-              <a:rPr sz="2000" b="0">
+            <a:pPr algn="ctr"/>
+            <a:r>
+              <a:rPr sz="1800" b="0">
                 <a:solidFill>
                   <a:srgbClr val="9AA7BC"/>
                 </a:solidFill>
@@ -4534,14 +4578,14 @@
       </p:sp>
       <p:sp>
         <p:nvSpPr>
-          <p:cNvPr id="8" name="TextBox 7"/>
+          <p:cNvPr id="9" name="TextBox 8"/>
           <p:cNvSpPr txBox="1"/>
           <p:nvPr/>
         </p:nvSpPr>
         <p:spPr>
           <a:xfrm>
-            <a:off x="822960" y="6126480"/>
-            <a:ext cx="10058400" cy="365760"/>
+            <a:off x="1371600" y="6263640"/>
+            <a:ext cx="9418320" cy="320040"/>
           </a:xfrm>
           <a:prstGeom prst="rect">
             <a:avLst/>
@@ -4555,9 +4599,9 @@
           </a:bodyPr>
           <a:lstStyle/>
           <a:p>
-            <a:pPr algn="l"/>
-            <a:r>
-              <a:rPr sz="1200" b="0">
+            <a:pPr algn="ctr"/>
+            <a:r>
+              <a:rPr sz="1100" b="0">
                 <a:solidFill>
                   <a:srgbClr val="9AA7BC"/>
                 </a:solidFill>
@@ -4571,7 +4615,44 @@
       </p:sp>
       <p:sp>
         <p:nvSpPr>
-          <p:cNvPr id="9" name="TextBox 8"/>
+          <p:cNvPr id="10" name="TextBox 9"/>
+          <p:cNvSpPr txBox="1"/>
+          <p:nvPr/>
+        </p:nvSpPr>
+        <p:spPr>
+          <a:xfrm>
+            <a:off x="822960" y="6473952"/>
+            <a:ext cx="7315200" cy="274320"/>
+          </a:xfrm>
+          <a:prstGeom prst="rect">
+            <a:avLst/>
+          </a:prstGeom>
+          <a:noFill/>
+          <a:effectLst/>
+        </p:spPr>
+        <p:txBody>
+          <a:bodyPr wrap="square" lIns="50800" rIns="50800">
+            <a:spAutoFit/>
+          </a:bodyPr>
+          <a:lstStyle/>
+          <a:p>
+            <a:pPr algn="l"/>
+            <a:r>
+              <a:rPr sz="1000" b="0">
+                <a:solidFill>
+                  <a:srgbClr val="9AA7BC"/>
+                </a:solidFill>
+                <a:latin typeface="Segoe UI"/>
+                <a:ea typeface="Microsoft YaHei"/>
+              </a:rPr>
+              <a:t>DCC-MCP 框架介绍</a:t>
+            </a:r>
+          </a:p>
+        </p:txBody>
+      </p:sp>
+      <p:sp>
+        <p:nvSpPr>
+          <p:cNvPr id="11" name="TextBox 10"/>
           <p:cNvSpPr txBox="1"/>
           <p:nvPr/>
         </p:nvSpPr>
@@ -4676,8 +4757,8 @@
         </p:nvSpPr>
         <p:spPr>
           <a:xfrm>
-            <a:off x="822960" y="457200"/>
-            <a:ext cx="10515600" cy="731520"/>
+            <a:off x="822960" y="502920"/>
+            <a:ext cx="10515600" cy="685800"/>
           </a:xfrm>
           <a:prstGeom prst="rect">
             <a:avLst/>
@@ -4693,7 +4774,7 @@
           <a:p>
             <a:pPr algn="l"/>
             <a:r>
-              <a:rPr sz="3000" b="1">
+              <a:rPr sz="2800" b="1">
                 <a:solidFill>
                   <a:srgbClr val="E8ECF2"/>
                 </a:solidFill>
@@ -4707,14 +4788,114 @@
       </p:sp>
       <p:sp>
         <p:nvSpPr>
-          <p:cNvPr id="4" name="Rounded Rectangle 3"/>
+          <p:cNvPr id="4" name="Rectangle 3"/>
           <p:cNvSpPr/>
           <p:nvPr/>
         </p:nvSpPr>
         <p:spPr>
           <a:xfrm>
-            <a:off x="2560320" y="1463040"/>
-            <a:ext cx="7040880" cy="777240"/>
+            <a:off x="822960" y="1298448"/>
+            <a:ext cx="822960" cy="44450"/>
+          </a:xfrm>
+          <a:prstGeom prst="rect">
+            <a:avLst/>
+          </a:prstGeom>
+          <a:solidFill>
+            <a:srgbClr val="4D9DE0"/>
+          </a:solidFill>
+          <a:ln>
+            <a:noFill/>
+          </a:ln>
+          <a:effectLst/>
+        </p:spPr>
+        <p:style>
+          <a:lnRef idx="1">
+            <a:schemeClr val="accent1"/>
+          </a:lnRef>
+          <a:fillRef idx="3">
+            <a:schemeClr val="accent1"/>
+          </a:fillRef>
+          <a:effectRef idx="2">
+            <a:schemeClr val="accent1"/>
+          </a:effectRef>
+          <a:fontRef idx="minor">
+            <a:schemeClr val="lt1"/>
+          </a:fontRef>
+        </p:style>
+        <p:txBody>
+          <a:bodyPr rtlCol="0" anchor="ctr" wrap="square"/>
+          <a:lstStyle/>
+          <a:p>
+            <a:pPr algn="ctr"/>
+          </a:p>
+        </p:txBody>
+      </p:sp>
+      <p:sp>
+        <p:nvSpPr>
+          <p:cNvPr id="5" name="Oval 4"/>
+          <p:cNvSpPr/>
+          <p:nvPr/>
+        </p:nvSpPr>
+        <p:spPr>
+          <a:xfrm>
+            <a:off x="2148840" y="1819656"/>
+            <a:ext cx="384048" cy="384048"/>
+          </a:xfrm>
+          <a:prstGeom prst="ellipse">
+            <a:avLst/>
+          </a:prstGeom>
+          <a:solidFill>
+            <a:srgbClr val="171F2E"/>
+          </a:solidFill>
+          <a:ln w="15240">
+            <a:solidFill>
+              <a:srgbClr val="4D9DE0"/>
+            </a:solidFill>
+          </a:ln>
+          <a:effectLst/>
+        </p:spPr>
+        <p:style>
+          <a:lnRef idx="1">
+            <a:schemeClr val="accent1"/>
+          </a:lnRef>
+          <a:fillRef idx="3">
+            <a:schemeClr val="accent1"/>
+          </a:fillRef>
+          <a:effectRef idx="2">
+            <a:schemeClr val="accent1"/>
+          </a:effectRef>
+          <a:fontRef idx="minor">
+            <a:schemeClr val="lt1"/>
+          </a:fontRef>
+        </p:style>
+        <p:txBody>
+          <a:bodyPr rtlCol="0" anchor="ctr" wrap="square" lIns="101600" rIns="101600" tIns="76200" bIns="76200"/>
+          <a:lstStyle/>
+          <a:p>
+            <a:pPr algn="ctr"/>
+            <a:r>
+              <a:rPr sz="1200" b="1">
+                <a:solidFill>
+                  <a:srgbClr val="4D9DE0"/>
+                </a:solidFill>
+                <a:latin typeface="Segoe UI"/>
+                <a:ea typeface="Microsoft YaHei"/>
+              </a:rPr>
+              <a:t>1</a:t>
+            </a:r>
+          </a:p>
+        </p:txBody>
+      </p:sp>
+      <p:sp>
+        <p:nvSpPr>
+          <p:cNvPr id="6" name="Rounded Rectangle 5"/>
+          <p:cNvSpPr/>
+          <p:nvPr/>
+        </p:nvSpPr>
+        <p:spPr>
+          <a:xfrm>
+            <a:off x="2788920" y="1673352"/>
+            <a:ext cx="8412480" cy="713232"/>
           </a:xfrm>
           <a:prstGeom prst="roundRect">
             <a:avLst>
@@ -4749,7 +4930,7 @@
           <a:p>
             <a:pPr algn="ctr"/>
             <a:r>
-              <a:rPr sz="1500" b="0">
+              <a:rPr sz="1450" b="0">
                 <a:solidFill>
                   <a:srgbClr val="E8ECF2"/>
                 </a:solidFill>
@@ -4763,14 +4944,70 @@
       </p:sp>
       <p:sp>
         <p:nvSpPr>
-          <p:cNvPr id="5" name="Rounded Rectangle 4"/>
+          <p:cNvPr id="7" name="Oval 6"/>
           <p:cNvSpPr/>
           <p:nvPr/>
         </p:nvSpPr>
         <p:spPr>
           <a:xfrm>
-            <a:off x="2560320" y="2331720"/>
-            <a:ext cx="7040880" cy="777240"/>
+            <a:off x="2148840" y="2688336"/>
+            <a:ext cx="384048" cy="384048"/>
+          </a:xfrm>
+          <a:prstGeom prst="ellipse">
+            <a:avLst/>
+          </a:prstGeom>
+          <a:solidFill>
+            <a:srgbClr val="171F2E"/>
+          </a:solidFill>
+          <a:ln w="15240">
+            <a:solidFill>
+              <a:srgbClr val="4D9DE0"/>
+            </a:solidFill>
+          </a:ln>
+          <a:effectLst/>
+        </p:spPr>
+        <p:style>
+          <a:lnRef idx="1">
+            <a:schemeClr val="accent1"/>
+          </a:lnRef>
+          <a:fillRef idx="3">
+            <a:schemeClr val="accent1"/>
+          </a:fillRef>
+          <a:effectRef idx="2">
+            <a:schemeClr val="accent1"/>
+          </a:effectRef>
+          <a:fontRef idx="minor">
+            <a:schemeClr val="lt1"/>
+          </a:fontRef>
+        </p:style>
+        <p:txBody>
+          <a:bodyPr rtlCol="0" anchor="ctr" wrap="square" lIns="101600" rIns="101600" tIns="76200" bIns="76200"/>
+          <a:lstStyle/>
+          <a:p>
+            <a:pPr algn="ctr"/>
+            <a:r>
+              <a:rPr sz="1200" b="1">
+                <a:solidFill>
+                  <a:srgbClr val="4D9DE0"/>
+                </a:solidFill>
+                <a:latin typeface="Segoe UI"/>
+                <a:ea typeface="Microsoft YaHei"/>
+              </a:rPr>
+              <a:t>2</a:t>
+            </a:r>
+          </a:p>
+        </p:txBody>
+      </p:sp>
+      <p:sp>
+        <p:nvSpPr>
+          <p:cNvPr id="8" name="Rounded Rectangle 7"/>
+          <p:cNvSpPr/>
+          <p:nvPr/>
+        </p:nvSpPr>
+        <p:spPr>
+          <a:xfrm>
+            <a:off x="2788920" y="2542032"/>
+            <a:ext cx="8412480" cy="713232"/>
           </a:xfrm>
           <a:prstGeom prst="roundRect">
             <a:avLst>
@@ -4805,7 +5042,7 @@
           <a:p>
             <a:pPr algn="ctr"/>
             <a:r>
-              <a:rPr sz="1500" b="0">
+              <a:rPr sz="1450" b="0">
                 <a:solidFill>
                   <a:srgbClr val="E8ECF2"/>
                 </a:solidFill>
@@ -4819,14 +5056,70 @@
       </p:sp>
       <p:sp>
         <p:nvSpPr>
-          <p:cNvPr id="6" name="Rounded Rectangle 5"/>
+          <p:cNvPr id="9" name="Oval 8"/>
           <p:cNvSpPr/>
           <p:nvPr/>
         </p:nvSpPr>
         <p:spPr>
           <a:xfrm>
-            <a:off x="2560320" y="3200400"/>
-            <a:ext cx="7040880" cy="777240"/>
+            <a:off x="2148840" y="3557016"/>
+            <a:ext cx="384048" cy="384048"/>
+          </a:xfrm>
+          <a:prstGeom prst="ellipse">
+            <a:avLst/>
+          </a:prstGeom>
+          <a:solidFill>
+            <a:srgbClr val="171F2E"/>
+          </a:solidFill>
+          <a:ln w="15240">
+            <a:solidFill>
+              <a:srgbClr val="4D9DE0"/>
+            </a:solidFill>
+          </a:ln>
+          <a:effectLst/>
+        </p:spPr>
+        <p:style>
+          <a:lnRef idx="1">
+            <a:schemeClr val="accent1"/>
+          </a:lnRef>
+          <a:fillRef idx="3">
+            <a:schemeClr val="accent1"/>
+          </a:fillRef>
+          <a:effectRef idx="2">
+            <a:schemeClr val="accent1"/>
+          </a:effectRef>
+          <a:fontRef idx="minor">
+            <a:schemeClr val="lt1"/>
+          </a:fontRef>
+        </p:style>
+        <p:txBody>
+          <a:bodyPr rtlCol="0" anchor="ctr" wrap="square" lIns="101600" rIns="101600" tIns="76200" bIns="76200"/>
+          <a:lstStyle/>
+          <a:p>
+            <a:pPr algn="ctr"/>
+            <a:r>
+              <a:rPr sz="1200" b="1">
+                <a:solidFill>
+                  <a:srgbClr val="4D9DE0"/>
+                </a:solidFill>
+                <a:latin typeface="Segoe UI"/>
+                <a:ea typeface="Microsoft YaHei"/>
+              </a:rPr>
+              <a:t>3</a:t>
+            </a:r>
+          </a:p>
+        </p:txBody>
+      </p:sp>
+      <p:sp>
+        <p:nvSpPr>
+          <p:cNvPr id="10" name="Rounded Rectangle 9"/>
+          <p:cNvSpPr/>
+          <p:nvPr/>
+        </p:nvSpPr>
+        <p:spPr>
+          <a:xfrm>
+            <a:off x="2788920" y="3410712"/>
+            <a:ext cx="8412480" cy="713232"/>
           </a:xfrm>
           <a:prstGeom prst="roundRect">
             <a:avLst>
@@ -4861,7 +5154,7 @@
           <a:p>
             <a:pPr algn="ctr"/>
             <a:r>
-              <a:rPr sz="1500" b="0">
+              <a:rPr sz="1450" b="0">
                 <a:solidFill>
                   <a:srgbClr val="E8ECF2"/>
                 </a:solidFill>
@@ -4875,14 +5168,70 @@
       </p:sp>
       <p:sp>
         <p:nvSpPr>
-          <p:cNvPr id="7" name="Rounded Rectangle 6"/>
+          <p:cNvPr id="11" name="Oval 10"/>
           <p:cNvSpPr/>
           <p:nvPr/>
         </p:nvSpPr>
         <p:spPr>
           <a:xfrm>
-            <a:off x="2560320" y="4069079"/>
-            <a:ext cx="7040880" cy="777240"/>
+            <a:off x="2148840" y="4425696"/>
+            <a:ext cx="384048" cy="384048"/>
+          </a:xfrm>
+          <a:prstGeom prst="ellipse">
+            <a:avLst/>
+          </a:prstGeom>
+          <a:solidFill>
+            <a:srgbClr val="171F2E"/>
+          </a:solidFill>
+          <a:ln w="15240">
+            <a:solidFill>
+              <a:srgbClr val="4D9DE0"/>
+            </a:solidFill>
+          </a:ln>
+          <a:effectLst/>
+        </p:spPr>
+        <p:style>
+          <a:lnRef idx="1">
+            <a:schemeClr val="accent1"/>
+          </a:lnRef>
+          <a:fillRef idx="3">
+            <a:schemeClr val="accent1"/>
+          </a:fillRef>
+          <a:effectRef idx="2">
+            <a:schemeClr val="accent1"/>
+          </a:effectRef>
+          <a:fontRef idx="minor">
+            <a:schemeClr val="lt1"/>
+          </a:fontRef>
+        </p:style>
+        <p:txBody>
+          <a:bodyPr rtlCol="0" anchor="ctr" wrap="square" lIns="101600" rIns="101600" tIns="76200" bIns="76200"/>
+          <a:lstStyle/>
+          <a:p>
+            <a:pPr algn="ctr"/>
+            <a:r>
+              <a:rPr sz="1200" b="1">
+                <a:solidFill>
+                  <a:srgbClr val="4D9DE0"/>
+                </a:solidFill>
+                <a:latin typeface="Segoe UI"/>
+                <a:ea typeface="Microsoft YaHei"/>
+              </a:rPr>
+              <a:t>4</a:t>
+            </a:r>
+          </a:p>
+        </p:txBody>
+      </p:sp>
+      <p:sp>
+        <p:nvSpPr>
+          <p:cNvPr id="12" name="Rounded Rectangle 11"/>
+          <p:cNvSpPr/>
+          <p:nvPr/>
+        </p:nvSpPr>
+        <p:spPr>
+          <a:xfrm>
+            <a:off x="2788920" y="4279392"/>
+            <a:ext cx="8412480" cy="713232"/>
           </a:xfrm>
           <a:prstGeom prst="roundRect">
             <a:avLst>
@@ -4917,7 +5266,7 @@
           <a:p>
             <a:pPr algn="ctr"/>
             <a:r>
-              <a:rPr sz="1500" b="0">
+              <a:rPr sz="1450" b="0">
                 <a:solidFill>
                   <a:srgbClr val="E8ECF2"/>
                 </a:solidFill>
@@ -4931,14 +5280,70 @@
       </p:sp>
       <p:sp>
         <p:nvSpPr>
-          <p:cNvPr id="8" name="Rounded Rectangle 7"/>
+          <p:cNvPr id="13" name="Oval 12"/>
           <p:cNvSpPr/>
           <p:nvPr/>
         </p:nvSpPr>
         <p:spPr>
           <a:xfrm>
-            <a:off x="2560320" y="4937760"/>
-            <a:ext cx="7040880" cy="777240"/>
+            <a:off x="2148840" y="5294376"/>
+            <a:ext cx="384048" cy="384048"/>
+          </a:xfrm>
+          <a:prstGeom prst="ellipse">
+            <a:avLst/>
+          </a:prstGeom>
+          <a:solidFill>
+            <a:srgbClr val="171F2E"/>
+          </a:solidFill>
+          <a:ln w="15240">
+            <a:solidFill>
+              <a:srgbClr val="4D9DE0"/>
+            </a:solidFill>
+          </a:ln>
+          <a:effectLst/>
+        </p:spPr>
+        <p:style>
+          <a:lnRef idx="1">
+            <a:schemeClr val="accent1"/>
+          </a:lnRef>
+          <a:fillRef idx="3">
+            <a:schemeClr val="accent1"/>
+          </a:fillRef>
+          <a:effectRef idx="2">
+            <a:schemeClr val="accent1"/>
+          </a:effectRef>
+          <a:fontRef idx="minor">
+            <a:schemeClr val="lt1"/>
+          </a:fontRef>
+        </p:style>
+        <p:txBody>
+          <a:bodyPr rtlCol="0" anchor="ctr" wrap="square" lIns="101600" rIns="101600" tIns="76200" bIns="76200"/>
+          <a:lstStyle/>
+          <a:p>
+            <a:pPr algn="ctr"/>
+            <a:r>
+              <a:rPr sz="1200" b="1">
+                <a:solidFill>
+                  <a:srgbClr val="4D9DE0"/>
+                </a:solidFill>
+                <a:latin typeface="Segoe UI"/>
+                <a:ea typeface="Microsoft YaHei"/>
+              </a:rPr>
+              <a:t>5</a:t>
+            </a:r>
+          </a:p>
+        </p:txBody>
+      </p:sp>
+      <p:sp>
+        <p:nvSpPr>
+          <p:cNvPr id="14" name="Rounded Rectangle 13"/>
+          <p:cNvSpPr/>
+          <p:nvPr/>
+        </p:nvSpPr>
+        <p:spPr>
+          <a:xfrm>
+            <a:off x="2788920" y="5148072"/>
+            <a:ext cx="8412480" cy="713232"/>
           </a:xfrm>
           <a:prstGeom prst="roundRect">
             <a:avLst>
@@ -4973,7 +5378,7 @@
           <a:p>
             <a:pPr algn="ctr"/>
             <a:r>
-              <a:rPr sz="1500" b="0">
+              <a:rPr sz="1450" b="0">
                 <a:solidFill>
                   <a:srgbClr val="E8ECF2"/>
                 </a:solidFill>
@@ -4987,14 +5392,14 @@
       </p:sp>
       <p:cxnSp>
         <p:nvCxnSpPr>
-          <p:cNvPr id="9" name="Connector 8"/>
+          <p:cNvPr id="15" name="Connector 14"/>
           <p:cNvCxnSpPr/>
           <p:nvPr/>
         </p:nvCxnSpPr>
         <p:spPr>
           <a:xfrm>
-            <a:off x="6080760" y="1851660"/>
-            <a:ext cx="0" cy="3474720"/>
+            <a:off x="2340864" y="2194560"/>
+            <a:ext cx="0" cy="3474719"/>
           </a:xfrm>
           <a:prstGeom prst="line">
             <a:avLst/>
@@ -5023,7 +5428,44 @@
       </p:cxnSp>
       <p:sp>
         <p:nvSpPr>
-          <p:cNvPr id="10" name="TextBox 9"/>
+          <p:cNvPr id="16" name="TextBox 15"/>
+          <p:cNvSpPr txBox="1"/>
+          <p:nvPr/>
+        </p:nvSpPr>
+        <p:spPr>
+          <a:xfrm>
+            <a:off x="822960" y="6473952"/>
+            <a:ext cx="7315200" cy="274320"/>
+          </a:xfrm>
+          <a:prstGeom prst="rect">
+            <a:avLst/>
+          </a:prstGeom>
+          <a:noFill/>
+          <a:effectLst/>
+        </p:spPr>
+        <p:txBody>
+          <a:bodyPr wrap="square" lIns="50800" rIns="50800">
+            <a:spAutoFit/>
+          </a:bodyPr>
+          <a:lstStyle/>
+          <a:p>
+            <a:pPr algn="l"/>
+            <a:r>
+              <a:rPr sz="1000" b="0">
+                <a:solidFill>
+                  <a:srgbClr val="9AA7BC"/>
+                </a:solidFill>
+                <a:latin typeface="Segoe UI"/>
+                <a:ea typeface="Microsoft YaHei"/>
+              </a:rPr>
+              <a:t>DCC-MCP 框架介绍</a:t>
+            </a:r>
+          </a:p>
+        </p:txBody>
+      </p:sp>
+      <p:sp>
+        <p:nvSpPr>
+          <p:cNvPr id="17" name="TextBox 16"/>
           <p:cNvSpPr txBox="1"/>
           <p:nvPr/>
         </p:nvSpPr>
@@ -5128,8 +5570,8 @@
         </p:nvSpPr>
         <p:spPr>
           <a:xfrm>
-            <a:off x="822960" y="457200"/>
-            <a:ext cx="10515600" cy="731520"/>
+            <a:off x="822960" y="502920"/>
+            <a:ext cx="10515600" cy="685800"/>
           </a:xfrm>
           <a:prstGeom prst="rect">
             <a:avLst/>
@@ -5145,7 +5587,7 @@
           <a:p>
             <a:pPr algn="l"/>
             <a:r>
-              <a:rPr sz="3000" b="1">
+              <a:rPr sz="2800" b="1">
                 <a:solidFill>
                   <a:srgbClr val="E8ECF2"/>
                 </a:solidFill>
@@ -5159,19 +5601,17 @@
       </p:sp>
       <p:sp>
         <p:nvSpPr>
-          <p:cNvPr id="4" name="Rounded Rectangle 3"/>
+          <p:cNvPr id="4" name="Rectangle 3"/>
           <p:cNvSpPr/>
           <p:nvPr/>
         </p:nvSpPr>
         <p:spPr>
           <a:xfrm>
-            <a:off x="822960" y="1371600"/>
-            <a:ext cx="5120640" cy="640080"/>
-          </a:xfrm>
-          <a:prstGeom prst="roundRect">
-            <a:avLst>
-              <a:gd name="adj" fmla="val 12000"/>
-            </a:avLst>
+            <a:off x="822960" y="1298448"/>
+            <a:ext cx="822960" cy="44450"/>
+          </a:xfrm>
+          <a:prstGeom prst="rect">
+            <a:avLst/>
           </a:prstGeom>
           <a:solidFill>
             <a:srgbClr val="4D9DE0"/>
@@ -5196,12 +5636,58 @@
           </a:fontRef>
         </p:style>
         <p:txBody>
+          <a:bodyPr rtlCol="0" anchor="ctr" wrap="square"/>
+          <a:lstStyle/>
+          <a:p>
+            <a:pPr algn="ctr"/>
+          </a:p>
+        </p:txBody>
+      </p:sp>
+      <p:sp>
+        <p:nvSpPr>
+          <p:cNvPr id="5" name="Rounded Rectangle 4"/>
+          <p:cNvSpPr/>
+          <p:nvPr/>
+        </p:nvSpPr>
+        <p:spPr>
+          <a:xfrm>
+            <a:off x="822960" y="1627632"/>
+            <a:ext cx="5120640" cy="566928"/>
+          </a:xfrm>
+          <a:prstGeom prst="roundRect">
+            <a:avLst>
+              <a:gd name="adj" fmla="val 16000"/>
+            </a:avLst>
+          </a:prstGeom>
+          <a:solidFill>
+            <a:srgbClr val="4D9DE0"/>
+          </a:solidFill>
+          <a:ln>
+            <a:noFill/>
+          </a:ln>
+          <a:effectLst/>
+        </p:spPr>
+        <p:style>
+          <a:lnRef idx="1">
+            <a:schemeClr val="accent1"/>
+          </a:lnRef>
+          <a:fillRef idx="3">
+            <a:schemeClr val="accent1"/>
+          </a:fillRef>
+          <a:effectRef idx="2">
+            <a:schemeClr val="accent1"/>
+          </a:effectRef>
+          <a:fontRef idx="minor">
+            <a:schemeClr val="lt1"/>
+          </a:fontRef>
+        </p:style>
+        <p:txBody>
           <a:bodyPr rtlCol="0" anchor="ctr" wrap="square" lIns="101600" rIns="101600" tIns="76200" bIns="76200"/>
           <a:lstStyle/>
           <a:p>
             <a:pPr algn="ctr"/>
             <a:r>
-              <a:rPr sz="1800" b="1">
+              <a:rPr sz="1600" b="1">
                 <a:solidFill>
                   <a:srgbClr val="E8ECF2"/>
                 </a:solidFill>
@@ -5215,18 +5701,18 @@
       </p:sp>
       <p:sp>
         <p:nvSpPr>
-          <p:cNvPr id="5" name="Rounded Rectangle 4"/>
+          <p:cNvPr id="6" name="Rounded Rectangle 5"/>
           <p:cNvSpPr/>
           <p:nvPr/>
         </p:nvSpPr>
         <p:spPr>
           <a:xfrm>
-            <a:off x="822960" y="2148840"/>
-            <a:ext cx="5120640" cy="3977639"/>
+            <a:off x="822960" y="2304288"/>
+            <a:ext cx="5120640" cy="3749039"/>
           </a:xfrm>
           <a:prstGeom prst="roundRect">
             <a:avLst>
-              <a:gd name="adj" fmla="val 6000"/>
+              <a:gd name="adj" fmla="val 5000"/>
             </a:avLst>
           </a:prstGeom>
           <a:solidFill>
@@ -5257,58 +5743,58 @@
           <a:p>
             <a:pPr algn="l"/>
             <a:r>
-              <a:rPr sz="1500" b="0">
+              <a:rPr sz="1450" b="0">
                 <a:solidFill>
                   <a:srgbClr val="E8ECF2"/>
                 </a:solidFill>
                 <a:latin typeface="Segoe UI"/>
                 <a:ea typeface="Microsoft YaHei"/>
               </a:rPr>
-              <a:t>●  确定性、可验证、可审计</a:t>
+              <a:t>✓  确定性、可验证、可审计</a:t>
             </a:r>
           </a:p>
           <a:p>
             <a:pPr algn="l"/>
             <a:r>
-              <a:rPr sz="1500" b="0">
+              <a:rPr sz="1450" b="0">
                 <a:solidFill>
                   <a:srgbClr val="E8ECF2"/>
                 </a:solidFill>
                 <a:latin typeface="Segoe UI"/>
                 <a:ea typeface="Microsoft YaHei"/>
               </a:rPr>
-              <a:t>●  UIA/CUA 只做最后兜底</a:t>
+              <a:t>✓  UIA/CUA 只做最后兜底</a:t>
             </a:r>
           </a:p>
           <a:p>
             <a:pPr algn="l"/>
             <a:r>
-              <a:rPr sz="1500" b="0">
+              <a:rPr sz="1450" b="0">
                 <a:solidFill>
                   <a:srgbClr val="E8ECF2"/>
                 </a:solidFill>
                 <a:latin typeface="Segoe UI"/>
                 <a:ea typeface="Microsoft YaHei"/>
               </a:rPr>
-              <a:t>●  写操作不得静默降级</a:t>
-            </a:r>
-          </a:p>
-        </p:txBody>
-      </p:sp>
-      <p:sp>
-        <p:nvSpPr>
-          <p:cNvPr id="6" name="Rounded Rectangle 5"/>
+              <a:t>✓  写操作不得静默降级</a:t>
+            </a:r>
+          </a:p>
+        </p:txBody>
+      </p:sp>
+      <p:sp>
+        <p:nvSpPr>
+          <p:cNvPr id="7" name="Rounded Rectangle 6"/>
           <p:cNvSpPr/>
           <p:nvPr/>
         </p:nvSpPr>
         <p:spPr>
           <a:xfrm>
-            <a:off x="6309360" y="1371600"/>
-            <a:ext cx="5120640" cy="640080"/>
+            <a:off x="6309360" y="1627632"/>
+            <a:ext cx="5120640" cy="566928"/>
           </a:xfrm>
           <a:prstGeom prst="roundRect">
             <a:avLst>
-              <a:gd name="adj" fmla="val 12000"/>
+              <a:gd name="adj" fmla="val 16000"/>
             </a:avLst>
           </a:prstGeom>
           <a:solidFill>
@@ -5339,7 +5825,7 @@
           <a:p>
             <a:pPr algn="ctr"/>
             <a:r>
-              <a:rPr sz="1800" b="1">
+              <a:rPr sz="1600" b="1">
                 <a:solidFill>
                   <a:srgbClr val="E8ECF2"/>
                 </a:solidFill>
@@ -5353,18 +5839,18 @@
       </p:sp>
       <p:sp>
         <p:nvSpPr>
-          <p:cNvPr id="7" name="Rounded Rectangle 6"/>
+          <p:cNvPr id="8" name="Rounded Rectangle 7"/>
           <p:cNvSpPr/>
           <p:nvPr/>
         </p:nvSpPr>
         <p:spPr>
           <a:xfrm>
-            <a:off x="6309360" y="2148840"/>
-            <a:ext cx="5120640" cy="3977639"/>
+            <a:off x="6309360" y="2304288"/>
+            <a:ext cx="5120640" cy="3749039"/>
           </a:xfrm>
           <a:prstGeom prst="roundRect">
             <a:avLst>
-              <a:gd name="adj" fmla="val 6000"/>
+              <a:gd name="adj" fmla="val 5000"/>
             </a:avLst>
           </a:prstGeom>
           <a:solidFill>
@@ -5395,47 +5881,84 @@
           <a:p>
             <a:pPr algn="l"/>
             <a:r>
-              <a:rPr sz="1500" b="0">
+              <a:rPr sz="1450" b="0">
                 <a:solidFill>
                   <a:srgbClr val="E8ECF2"/>
                 </a:solidFill>
                 <a:latin typeface="Segoe UI"/>
                 <a:ea typeface="Microsoft YaHei"/>
               </a:rPr>
-              <a:t>●  不暴露原始 COM 成员</a:t>
+              <a:t>✓  不暴露原始 COM 成员</a:t>
             </a:r>
           </a:p>
           <a:p>
             <a:pPr algn="l"/>
             <a:r>
-              <a:rPr sz="1500" b="0">
+              <a:rPr sz="1450" b="0">
                 <a:solidFill>
                   <a:srgbClr val="E8ECF2"/>
                 </a:solidFill>
                 <a:latin typeface="Segoe UI"/>
                 <a:ea typeface="Microsoft YaHei"/>
               </a:rPr>
-              <a:t>●  模板优先于自由坐标</a:t>
+              <a:t>✓  模板优先于自由坐标</a:t>
             </a:r>
           </a:p>
           <a:p>
             <a:pPr algn="l"/>
             <a:r>
-              <a:rPr sz="1500" b="0">
+              <a:rPr sz="1450" b="0">
                 <a:solidFill>
                   <a:srgbClr val="E8ECF2"/>
                 </a:solidFill>
                 <a:latin typeface="Segoe UI"/>
                 <a:ea typeface="Microsoft YaHei"/>
               </a:rPr>
-              <a:t>●  检查点 + 预览 + 可追踪结果</a:t>
-            </a:r>
-          </a:p>
-        </p:txBody>
-      </p:sp>
-      <p:sp>
-        <p:nvSpPr>
-          <p:cNvPr id="8" name="TextBox 7"/>
+              <a:t>✓  检查点 + 预览 + 可追踪结果</a:t>
+            </a:r>
+          </a:p>
+        </p:txBody>
+      </p:sp>
+      <p:sp>
+        <p:nvSpPr>
+          <p:cNvPr id="9" name="TextBox 8"/>
+          <p:cNvSpPr txBox="1"/>
+          <p:nvPr/>
+        </p:nvSpPr>
+        <p:spPr>
+          <a:xfrm>
+            <a:off x="822960" y="6473952"/>
+            <a:ext cx="7315200" cy="274320"/>
+          </a:xfrm>
+          <a:prstGeom prst="rect">
+            <a:avLst/>
+          </a:prstGeom>
+          <a:noFill/>
+          <a:effectLst/>
+        </p:spPr>
+        <p:txBody>
+          <a:bodyPr wrap="square" lIns="50800" rIns="50800">
+            <a:spAutoFit/>
+          </a:bodyPr>
+          <a:lstStyle/>
+          <a:p>
+            <a:pPr algn="l"/>
+            <a:r>
+              <a:rPr sz="1000" b="0">
+                <a:solidFill>
+                  <a:srgbClr val="9AA7BC"/>
+                </a:solidFill>
+                <a:latin typeface="Segoe UI"/>
+                <a:ea typeface="Microsoft YaHei"/>
+              </a:rPr>
+              <a:t>DCC-MCP 框架介绍</a:t>
+            </a:r>
+          </a:p>
+        </p:txBody>
+      </p:sp>
+      <p:sp>
+        <p:nvSpPr>
+          <p:cNvPr id="10" name="TextBox 9"/>
           <p:cNvSpPr txBox="1"/>
           <p:nvPr/>
         </p:nvSpPr>
@@ -5576,9 +6099,53 @@
           </a:p>
         </p:txBody>
       </p:sp>
+      <p:sp>
+        <p:nvSpPr>
+          <p:cNvPr id="4" name="Oval 3"/>
+          <p:cNvSpPr/>
+          <p:nvPr/>
+        </p:nvSpPr>
+        <p:spPr>
+          <a:xfrm>
+            <a:off x="320040" y="320040"/>
+            <a:ext cx="2651760" cy="2651760"/>
+          </a:xfrm>
+          <a:prstGeom prst="ellipse">
+            <a:avLst/>
+          </a:prstGeom>
+          <a:solidFill>
+            <a:srgbClr val="223047"/>
+          </a:solidFill>
+          <a:ln>
+            <a:noFill/>
+          </a:ln>
+          <a:effectLst/>
+        </p:spPr>
+        <p:style>
+          <a:lnRef idx="1">
+            <a:schemeClr val="accent1"/>
+          </a:lnRef>
+          <a:fillRef idx="3">
+            <a:schemeClr val="accent1"/>
+          </a:fillRef>
+          <a:effectRef idx="2">
+            <a:schemeClr val="accent1"/>
+          </a:effectRef>
+          <a:fontRef idx="minor">
+            <a:schemeClr val="lt1"/>
+          </a:fontRef>
+        </p:style>
+        <p:txBody>
+          <a:bodyPr rtlCol="0" anchor="ctr"/>
+          <a:lstStyle/>
+          <a:p>
+            <a:pPr algn="ctr"/>
+          </a:p>
+        </p:txBody>
+      </p:sp>
       <p:pic>
         <p:nvPicPr>
-          <p:cNvPr id="4" name="Picture 3" descr="dcc-mcp-logo-light.png"/>
+          <p:cNvPr id="5" name="Picture 4" descr="dcc-mcp-logo-light.png"/>
           <p:cNvPicPr>
             <a:picLocks noChangeAspect="1"/>
           </p:cNvPicPr>
@@ -5592,8 +6159,8 @@
         </p:blipFill>
         <p:spPr>
           <a:xfrm>
-            <a:off x="5413248" y="1371600"/>
-            <a:ext cx="1851660" cy="822960"/>
+            <a:off x="5413248" y="1965960"/>
+            <a:ext cx="1645920" cy="731520"/>
           </a:xfrm>
           <a:prstGeom prst="rect">
             <a:avLst/>
@@ -5602,14 +6169,14 @@
       </p:pic>
       <p:sp>
         <p:nvSpPr>
-          <p:cNvPr id="5" name="TextBox 4"/>
+          <p:cNvPr id="6" name="TextBox 5"/>
           <p:cNvSpPr txBox="1"/>
           <p:nvPr/>
         </p:nvSpPr>
         <p:spPr>
           <a:xfrm>
-            <a:off x="1371600" y="2468880"/>
-            <a:ext cx="9418320" cy="1371600"/>
+            <a:off x="1371600" y="3063240"/>
+            <a:ext cx="9418320" cy="1097280"/>
           </a:xfrm>
           <a:prstGeom prst="rect">
             <a:avLst/>
@@ -5625,7 +6192,7 @@
           <a:p>
             <a:pPr algn="ctr"/>
             <a:r>
-              <a:rPr sz="4800" b="1">
+              <a:rPr sz="4600" b="1">
                 <a:solidFill>
                   <a:srgbClr val="E8ECF2"/>
                 </a:solidFill>
@@ -5639,14 +6206,14 @@
       </p:sp>
       <p:sp>
         <p:nvSpPr>
-          <p:cNvPr id="6" name="TextBox 5"/>
+          <p:cNvPr id="7" name="TextBox 6"/>
           <p:cNvSpPr txBox="1"/>
           <p:nvPr/>
         </p:nvSpPr>
         <p:spPr>
           <a:xfrm>
-            <a:off x="1371600" y="4023360"/>
-            <a:ext cx="9418320" cy="731520"/>
+            <a:off x="1371600" y="4343400"/>
+            <a:ext cx="9418320" cy="640080"/>
           </a:xfrm>
           <a:prstGeom prst="rect">
             <a:avLst/>
@@ -5662,7 +6229,7 @@
           <a:p>
             <a:pPr algn="ctr"/>
             <a:r>
-              <a:rPr sz="1800" b="0">
+              <a:rPr sz="1600" b="0">
                 <a:solidFill>
                   <a:srgbClr val="9AA7BC"/>
                 </a:solidFill>
@@ -5676,7 +6243,44 @@
       </p:sp>
       <p:sp>
         <p:nvSpPr>
-          <p:cNvPr id="7" name="TextBox 6"/>
+          <p:cNvPr id="8" name="TextBox 7"/>
+          <p:cNvSpPr txBox="1"/>
+          <p:nvPr/>
+        </p:nvSpPr>
+        <p:spPr>
+          <a:xfrm>
+            <a:off x="822960" y="6473952"/>
+            <a:ext cx="7315200" cy="274320"/>
+          </a:xfrm>
+          <a:prstGeom prst="rect">
+            <a:avLst/>
+          </a:prstGeom>
+          <a:noFill/>
+          <a:effectLst/>
+        </p:spPr>
+        <p:txBody>
+          <a:bodyPr wrap="square" lIns="50800" rIns="50800">
+            <a:spAutoFit/>
+          </a:bodyPr>
+          <a:lstStyle/>
+          <a:p>
+            <a:pPr algn="l"/>
+            <a:r>
+              <a:rPr sz="1000" b="0">
+                <a:solidFill>
+                  <a:srgbClr val="9AA7BC"/>
+                </a:solidFill>
+                <a:latin typeface="Segoe UI"/>
+                <a:ea typeface="Microsoft YaHei"/>
+              </a:rPr>
+              <a:t>DCC-MCP 框架介绍</a:t>
+            </a:r>
+          </a:p>
+        </p:txBody>
+      </p:sp>
+      <p:sp>
+        <p:nvSpPr>
+          <p:cNvPr id="9" name="TextBox 8"/>
           <p:cNvSpPr txBox="1"/>
           <p:nvPr/>
         </p:nvSpPr>
@@ -5819,13 +6423,57 @@
       </p:sp>
       <p:sp>
         <p:nvSpPr>
-          <p:cNvPr id="4" name="TextBox 3"/>
+          <p:cNvPr id="4" name="Oval 3"/>
+          <p:cNvSpPr/>
+          <p:nvPr/>
+        </p:nvSpPr>
+        <p:spPr>
+          <a:xfrm>
+            <a:off x="9601200" y="320040"/>
+            <a:ext cx="2468880" cy="2468880"/>
+          </a:xfrm>
+          <a:prstGeom prst="ellipse">
+            <a:avLst/>
+          </a:prstGeom>
+          <a:solidFill>
+            <a:srgbClr val="223047"/>
+          </a:solidFill>
+          <a:ln>
+            <a:noFill/>
+          </a:ln>
+          <a:effectLst/>
+        </p:spPr>
+        <p:style>
+          <a:lnRef idx="1">
+            <a:schemeClr val="accent1"/>
+          </a:lnRef>
+          <a:fillRef idx="3">
+            <a:schemeClr val="accent1"/>
+          </a:fillRef>
+          <a:effectRef idx="2">
+            <a:schemeClr val="accent1"/>
+          </a:effectRef>
+          <a:fontRef idx="minor">
+            <a:schemeClr val="lt1"/>
+          </a:fontRef>
+        </p:style>
+        <p:txBody>
+          <a:bodyPr rtlCol="0" anchor="ctr"/>
+          <a:lstStyle/>
+          <a:p>
+            <a:pPr algn="ctr"/>
+          </a:p>
+        </p:txBody>
+      </p:sp>
+      <p:sp>
+        <p:nvSpPr>
+          <p:cNvPr id="5" name="TextBox 4"/>
           <p:cNvSpPr txBox="1"/>
           <p:nvPr/>
         </p:nvSpPr>
         <p:spPr>
           <a:xfrm>
-            <a:off x="640080" y="548640"/>
+            <a:off x="640080" y="640080"/>
             <a:ext cx="4572000" cy="3840480"/>
           </a:xfrm>
           <a:prstGeom prst="rect">
@@ -5856,13 +6504,13 @@
       </p:sp>
       <p:sp>
         <p:nvSpPr>
-          <p:cNvPr id="5" name="Rectangle 4"/>
+          <p:cNvPr id="6" name="Rectangle 5"/>
           <p:cNvSpPr/>
           <p:nvPr/>
         </p:nvSpPr>
         <p:spPr>
           <a:xfrm>
-            <a:off x="822960" y="2880360"/>
+            <a:off x="822960" y="2788920"/>
             <a:ext cx="164592" cy="1097280"/>
           </a:xfrm>
           <a:prstGeom prst="rect">
@@ -5900,13 +6548,13 @@
       </p:sp>
       <p:sp>
         <p:nvSpPr>
-          <p:cNvPr id="6" name="TextBox 5"/>
+          <p:cNvPr id="7" name="TextBox 6"/>
           <p:cNvSpPr txBox="1"/>
           <p:nvPr/>
         </p:nvSpPr>
         <p:spPr>
           <a:xfrm>
-            <a:off x="1188720" y="2834640"/>
+            <a:off x="1188720" y="2743200"/>
             <a:ext cx="10058400" cy="1280160"/>
           </a:xfrm>
           <a:prstGeom prst="rect">
@@ -5937,7 +6585,44 @@
       </p:sp>
       <p:sp>
         <p:nvSpPr>
-          <p:cNvPr id="7" name="TextBox 6"/>
+          <p:cNvPr id="8" name="TextBox 7"/>
+          <p:cNvSpPr txBox="1"/>
+          <p:nvPr/>
+        </p:nvSpPr>
+        <p:spPr>
+          <a:xfrm>
+            <a:off x="822960" y="6473952"/>
+            <a:ext cx="7315200" cy="274320"/>
+          </a:xfrm>
+          <a:prstGeom prst="rect">
+            <a:avLst/>
+          </a:prstGeom>
+          <a:noFill/>
+          <a:effectLst/>
+        </p:spPr>
+        <p:txBody>
+          <a:bodyPr wrap="square" lIns="50800" rIns="50800">
+            <a:spAutoFit/>
+          </a:bodyPr>
+          <a:lstStyle/>
+          <a:p>
+            <a:pPr algn="l"/>
+            <a:r>
+              <a:rPr sz="1000" b="0">
+                <a:solidFill>
+                  <a:srgbClr val="9AA7BC"/>
+                </a:solidFill>
+                <a:latin typeface="Segoe UI"/>
+                <a:ea typeface="Microsoft YaHei"/>
+              </a:rPr>
+              <a:t>DCC-MCP 框架介绍</a:t>
+            </a:r>
+          </a:p>
+        </p:txBody>
+      </p:sp>
+      <p:sp>
+        <p:nvSpPr>
+          <p:cNvPr id="9" name="TextBox 8"/>
           <p:cNvSpPr txBox="1"/>
           <p:nvPr/>
         </p:nvSpPr>
@@ -6042,8 +6727,8 @@
         </p:nvSpPr>
         <p:spPr>
           <a:xfrm>
-            <a:off x="822960" y="457200"/>
-            <a:ext cx="10515600" cy="731520"/>
+            <a:off x="822960" y="502920"/>
+            <a:ext cx="10515600" cy="685800"/>
           </a:xfrm>
           <a:prstGeom prst="rect">
             <a:avLst/>
@@ -6059,7 +6744,7 @@
           <a:p>
             <a:pPr algn="l"/>
             <a:r>
-              <a:rPr sz="3000" b="1">
+              <a:rPr sz="2800" b="1">
                 <a:solidFill>
                   <a:srgbClr val="E8ECF2"/>
                 </a:solidFill>
@@ -6073,22 +6758,20 @@
       </p:sp>
       <p:sp>
         <p:nvSpPr>
-          <p:cNvPr id="4" name="Rounded Rectangle 3"/>
+          <p:cNvPr id="4" name="Rectangle 3"/>
           <p:cNvSpPr/>
           <p:nvPr/>
         </p:nvSpPr>
         <p:spPr>
           <a:xfrm>
-            <a:off x="822960" y="1371600"/>
-            <a:ext cx="10515600" cy="777240"/>
-          </a:xfrm>
-          <a:prstGeom prst="roundRect">
-            <a:avLst>
-              <a:gd name="adj" fmla="val 18000"/>
-            </a:avLst>
+            <a:off x="822960" y="1298448"/>
+            <a:ext cx="822960" cy="44450"/>
+          </a:xfrm>
+          <a:prstGeom prst="rect">
+            <a:avLst/>
           </a:prstGeom>
           <a:solidFill>
-            <a:srgbClr val="1E2A3D"/>
+            <a:srgbClr val="4D9DE0"/>
           </a:solidFill>
           <a:ln>
             <a:noFill/>
@@ -6110,41 +6793,29 @@
           </a:fontRef>
         </p:style>
         <p:txBody>
-          <a:bodyPr rtlCol="0" anchor="ctr" wrap="square" lIns="101600" rIns="101600" tIns="76200" bIns="76200"/>
-          <a:lstStyle/>
-          <a:p>
-            <a:pPr algn="l"/>
-            <a:r>
-              <a:rPr sz="1700" b="0">
-                <a:solidFill>
-                  <a:srgbClr val="E8ECF2"/>
-                </a:solidFill>
-                <a:latin typeface="Segoe UI"/>
-                <a:ea typeface="Microsoft YaHei"/>
-              </a:rPr>
-              <a:t>●  面向数字内容创作（DCC）工具的统一 MCP 网关生态</a:t>
-            </a:r>
-          </a:p>
-        </p:txBody>
-      </p:sp>
-      <p:sp>
-        <p:nvSpPr>
-          <p:cNvPr id="5" name="Rounded Rectangle 4"/>
+          <a:bodyPr rtlCol="0" anchor="ctr" wrap="square"/>
+          <a:lstStyle/>
+          <a:p>
+            <a:pPr algn="ctr"/>
+          </a:p>
+        </p:txBody>
+      </p:sp>
+      <p:sp>
+        <p:nvSpPr>
+          <p:cNvPr id="5" name="Oval 4"/>
           <p:cNvSpPr/>
           <p:nvPr/>
         </p:nvSpPr>
         <p:spPr>
           <a:xfrm>
-            <a:off x="822960" y="2286000"/>
-            <a:ext cx="10515600" cy="777240"/>
-          </a:xfrm>
-          <a:prstGeom prst="roundRect">
-            <a:avLst>
-              <a:gd name="adj" fmla="val 18000"/>
-            </a:avLst>
+            <a:off x="868680" y="1783080"/>
+            <a:ext cx="165100" cy="165100"/>
+          </a:xfrm>
+          <a:prstGeom prst="ellipse">
+            <a:avLst/>
           </a:prstGeom>
           <a:solidFill>
-            <a:srgbClr val="1E2A3D"/>
+            <a:srgbClr val="7FC8A9"/>
           </a:solidFill>
           <a:ln>
             <a:noFill/>
@@ -6166,41 +6837,66 @@
           </a:fontRef>
         </p:style>
         <p:txBody>
-          <a:bodyPr rtlCol="0" anchor="ctr" wrap="square" lIns="101600" rIns="101600" tIns="76200" bIns="76200"/>
+          <a:bodyPr rtlCol="0" anchor="ctr" wrap="square"/>
+          <a:lstStyle/>
+          <a:p>
+            <a:pPr algn="ctr"/>
+          </a:p>
+        </p:txBody>
+      </p:sp>
+      <p:sp>
+        <p:nvSpPr>
+          <p:cNvPr id="6" name="TextBox 5"/>
+          <p:cNvSpPr txBox="1"/>
+          <p:nvPr/>
+        </p:nvSpPr>
+        <p:spPr>
+          <a:xfrm>
+            <a:off x="1234440" y="1627632"/>
+            <a:ext cx="10012680" cy="822960"/>
+          </a:xfrm>
+          <a:prstGeom prst="rect">
+            <a:avLst/>
+          </a:prstGeom>
+          <a:noFill/>
+          <a:effectLst/>
+        </p:spPr>
+        <p:txBody>
+          <a:bodyPr wrap="square" lIns="50800" rIns="50800">
+            <a:spAutoFit/>
+          </a:bodyPr>
           <a:lstStyle/>
           <a:p>
             <a:pPr algn="l"/>
             <a:r>
-              <a:rPr sz="1700" b="0">
+              <a:rPr sz="1650" b="0">
                 <a:solidFill>
                   <a:srgbClr val="E8ECF2"/>
                 </a:solidFill>
                 <a:latin typeface="Segoe UI"/>
                 <a:ea typeface="Microsoft YaHei"/>
               </a:rPr>
-              <a:t>●  一个 DCC 一个适配器仓库：Maya、Blender、Houdini、Photoshop、Unity、Office…</a:t>
-            </a:r>
-          </a:p>
-        </p:txBody>
-      </p:sp>
-      <p:sp>
-        <p:nvSpPr>
-          <p:cNvPr id="6" name="Rounded Rectangle 5"/>
+              <a:t>面向数字内容创作（DCC）工具的统一 MCP 网关生态</a:t>
+            </a:r>
+          </a:p>
+        </p:txBody>
+      </p:sp>
+      <p:sp>
+        <p:nvSpPr>
+          <p:cNvPr id="7" name="Rectangle 6"/>
           <p:cNvSpPr/>
           <p:nvPr/>
         </p:nvSpPr>
         <p:spPr>
           <a:xfrm>
-            <a:off x="822960" y="3200400"/>
-            <a:ext cx="10515600" cy="777240"/>
-          </a:xfrm>
-          <a:prstGeom prst="roundRect">
-            <a:avLst>
-              <a:gd name="adj" fmla="val 18000"/>
-            </a:avLst>
+            <a:off x="822960" y="2496312"/>
+            <a:ext cx="10515600" cy="15240"/>
+          </a:xfrm>
+          <a:prstGeom prst="rect">
+            <a:avLst/>
           </a:prstGeom>
           <a:solidFill>
-            <a:srgbClr val="1E2A3D"/>
+            <a:srgbClr val="223047"/>
           </a:solidFill>
           <a:ln>
             <a:noFill/>
@@ -6222,41 +6918,29 @@
           </a:fontRef>
         </p:style>
         <p:txBody>
-          <a:bodyPr rtlCol="0" anchor="ctr" wrap="square" lIns="101600" rIns="101600" tIns="76200" bIns="76200"/>
-          <a:lstStyle/>
-          <a:p>
-            <a:pPr algn="l"/>
-            <a:r>
-              <a:rPr sz="1700" b="0">
-                <a:solidFill>
-                  <a:srgbClr val="E8ECF2"/>
-                </a:solidFill>
-                <a:latin typeface="Segoe UI"/>
-                <a:ea typeface="Microsoft YaHei"/>
-              </a:rPr>
-              <a:t>●  统一的能力发现机制：list → search → load_skill → call</a:t>
-            </a:r>
-          </a:p>
-        </p:txBody>
-      </p:sp>
-      <p:sp>
-        <p:nvSpPr>
-          <p:cNvPr id="7" name="Rounded Rectangle 6"/>
+          <a:bodyPr rtlCol="0" anchor="ctr" wrap="square"/>
+          <a:lstStyle/>
+          <a:p>
+            <a:pPr algn="ctr"/>
+          </a:p>
+        </p:txBody>
+      </p:sp>
+      <p:sp>
+        <p:nvSpPr>
+          <p:cNvPr id="8" name="Oval 7"/>
           <p:cNvSpPr/>
           <p:nvPr/>
         </p:nvSpPr>
         <p:spPr>
           <a:xfrm>
-            <a:off x="822960" y="4114800"/>
-            <a:ext cx="10515600" cy="777240"/>
-          </a:xfrm>
-          <a:prstGeom prst="roundRect">
-            <a:avLst>
-              <a:gd name="adj" fmla="val 18000"/>
-            </a:avLst>
+            <a:off x="868680" y="2715768"/>
+            <a:ext cx="165100" cy="165100"/>
+          </a:xfrm>
+          <a:prstGeom prst="ellipse">
+            <a:avLst/>
           </a:prstGeom>
           <a:solidFill>
-            <a:srgbClr val="1E2A3D"/>
+            <a:srgbClr val="7FC8A9"/>
           </a:solidFill>
           <a:ln>
             <a:noFill/>
@@ -6278,26 +6962,340 @@
           </a:fontRef>
         </p:style>
         <p:txBody>
-          <a:bodyPr rtlCol="0" anchor="ctr" wrap="square" lIns="101600" rIns="101600" tIns="76200" bIns="76200"/>
+          <a:bodyPr rtlCol="0" anchor="ctr" wrap="square"/>
+          <a:lstStyle/>
+          <a:p>
+            <a:pPr algn="ctr"/>
+          </a:p>
+        </p:txBody>
+      </p:sp>
+      <p:sp>
+        <p:nvSpPr>
+          <p:cNvPr id="9" name="TextBox 8"/>
+          <p:cNvSpPr txBox="1"/>
+          <p:nvPr/>
+        </p:nvSpPr>
+        <p:spPr>
+          <a:xfrm>
+            <a:off x="1234440" y="2560320"/>
+            <a:ext cx="10012680" cy="822960"/>
+          </a:xfrm>
+          <a:prstGeom prst="rect">
+            <a:avLst/>
+          </a:prstGeom>
+          <a:noFill/>
+          <a:effectLst/>
+        </p:spPr>
+        <p:txBody>
+          <a:bodyPr wrap="square" lIns="50800" rIns="50800">
+            <a:spAutoFit/>
+          </a:bodyPr>
           <a:lstStyle/>
           <a:p>
             <a:pPr algn="l"/>
             <a:r>
-              <a:rPr sz="1700" b="0">
+              <a:rPr sz="1650" b="0">
                 <a:solidFill>
                   <a:srgbClr val="E8ECF2"/>
                 </a:solidFill>
                 <a:latin typeface="Segoe UI"/>
                 <a:ea typeface="Microsoft YaHei"/>
               </a:rPr>
-              <a:t>●  Skills 机制：把稳定流程固化为可复用的技能包</a:t>
-            </a:r>
-          </a:p>
-        </p:txBody>
-      </p:sp>
-      <p:sp>
-        <p:nvSpPr>
-          <p:cNvPr id="8" name="TextBox 7"/>
+              <a:t>一个 DCC 一个适配器仓库：Maya、Blender、Houdini、Photoshop、Unity、Office…</a:t>
+            </a:r>
+          </a:p>
+        </p:txBody>
+      </p:sp>
+      <p:sp>
+        <p:nvSpPr>
+          <p:cNvPr id="10" name="Rectangle 9"/>
+          <p:cNvSpPr/>
+          <p:nvPr/>
+        </p:nvSpPr>
+        <p:spPr>
+          <a:xfrm>
+            <a:off x="822960" y="3429000"/>
+            <a:ext cx="10515600" cy="15240"/>
+          </a:xfrm>
+          <a:prstGeom prst="rect">
+            <a:avLst/>
+          </a:prstGeom>
+          <a:solidFill>
+            <a:srgbClr val="223047"/>
+          </a:solidFill>
+          <a:ln>
+            <a:noFill/>
+          </a:ln>
+          <a:effectLst/>
+        </p:spPr>
+        <p:style>
+          <a:lnRef idx="1">
+            <a:schemeClr val="accent1"/>
+          </a:lnRef>
+          <a:fillRef idx="3">
+            <a:schemeClr val="accent1"/>
+          </a:fillRef>
+          <a:effectRef idx="2">
+            <a:schemeClr val="accent1"/>
+          </a:effectRef>
+          <a:fontRef idx="minor">
+            <a:schemeClr val="lt1"/>
+          </a:fontRef>
+        </p:style>
+        <p:txBody>
+          <a:bodyPr rtlCol="0" anchor="ctr" wrap="square"/>
+          <a:lstStyle/>
+          <a:p>
+            <a:pPr algn="ctr"/>
+          </a:p>
+        </p:txBody>
+      </p:sp>
+      <p:sp>
+        <p:nvSpPr>
+          <p:cNvPr id="11" name="Oval 10"/>
+          <p:cNvSpPr/>
+          <p:nvPr/>
+        </p:nvSpPr>
+        <p:spPr>
+          <a:xfrm>
+            <a:off x="868680" y="3648456"/>
+            <a:ext cx="165100" cy="165100"/>
+          </a:xfrm>
+          <a:prstGeom prst="ellipse">
+            <a:avLst/>
+          </a:prstGeom>
+          <a:solidFill>
+            <a:srgbClr val="7FC8A9"/>
+          </a:solidFill>
+          <a:ln>
+            <a:noFill/>
+          </a:ln>
+          <a:effectLst/>
+        </p:spPr>
+        <p:style>
+          <a:lnRef idx="1">
+            <a:schemeClr val="accent1"/>
+          </a:lnRef>
+          <a:fillRef idx="3">
+            <a:schemeClr val="accent1"/>
+          </a:fillRef>
+          <a:effectRef idx="2">
+            <a:schemeClr val="accent1"/>
+          </a:effectRef>
+          <a:fontRef idx="minor">
+            <a:schemeClr val="lt1"/>
+          </a:fontRef>
+        </p:style>
+        <p:txBody>
+          <a:bodyPr rtlCol="0" anchor="ctr" wrap="square"/>
+          <a:lstStyle/>
+          <a:p>
+            <a:pPr algn="ctr"/>
+          </a:p>
+        </p:txBody>
+      </p:sp>
+      <p:sp>
+        <p:nvSpPr>
+          <p:cNvPr id="12" name="TextBox 11"/>
+          <p:cNvSpPr txBox="1"/>
+          <p:nvPr/>
+        </p:nvSpPr>
+        <p:spPr>
+          <a:xfrm>
+            <a:off x="1234440" y="3493008"/>
+            <a:ext cx="10012680" cy="822960"/>
+          </a:xfrm>
+          <a:prstGeom prst="rect">
+            <a:avLst/>
+          </a:prstGeom>
+          <a:noFill/>
+          <a:effectLst/>
+        </p:spPr>
+        <p:txBody>
+          <a:bodyPr wrap="square" lIns="50800" rIns="50800">
+            <a:spAutoFit/>
+          </a:bodyPr>
+          <a:lstStyle/>
+          <a:p>
+            <a:pPr algn="l"/>
+            <a:r>
+              <a:rPr sz="1650" b="0">
+                <a:solidFill>
+                  <a:srgbClr val="E8ECF2"/>
+                </a:solidFill>
+                <a:latin typeface="Segoe UI"/>
+                <a:ea typeface="Microsoft YaHei"/>
+              </a:rPr>
+              <a:t>统一的能力发现机制：list → search → load_skill → call</a:t>
+            </a:r>
+          </a:p>
+        </p:txBody>
+      </p:sp>
+      <p:sp>
+        <p:nvSpPr>
+          <p:cNvPr id="13" name="Rectangle 12"/>
+          <p:cNvSpPr/>
+          <p:nvPr/>
+        </p:nvSpPr>
+        <p:spPr>
+          <a:xfrm>
+            <a:off x="822960" y="4361688"/>
+            <a:ext cx="10515600" cy="15240"/>
+          </a:xfrm>
+          <a:prstGeom prst="rect">
+            <a:avLst/>
+          </a:prstGeom>
+          <a:solidFill>
+            <a:srgbClr val="223047"/>
+          </a:solidFill>
+          <a:ln>
+            <a:noFill/>
+          </a:ln>
+          <a:effectLst/>
+        </p:spPr>
+        <p:style>
+          <a:lnRef idx="1">
+            <a:schemeClr val="accent1"/>
+          </a:lnRef>
+          <a:fillRef idx="3">
+            <a:schemeClr val="accent1"/>
+          </a:fillRef>
+          <a:effectRef idx="2">
+            <a:schemeClr val="accent1"/>
+          </a:effectRef>
+          <a:fontRef idx="minor">
+            <a:schemeClr val="lt1"/>
+          </a:fontRef>
+        </p:style>
+        <p:txBody>
+          <a:bodyPr rtlCol="0" anchor="ctr" wrap="square"/>
+          <a:lstStyle/>
+          <a:p>
+            <a:pPr algn="ctr"/>
+          </a:p>
+        </p:txBody>
+      </p:sp>
+      <p:sp>
+        <p:nvSpPr>
+          <p:cNvPr id="14" name="Oval 13"/>
+          <p:cNvSpPr/>
+          <p:nvPr/>
+        </p:nvSpPr>
+        <p:spPr>
+          <a:xfrm>
+            <a:off x="868680" y="4581144"/>
+            <a:ext cx="165100" cy="165100"/>
+          </a:xfrm>
+          <a:prstGeom prst="ellipse">
+            <a:avLst/>
+          </a:prstGeom>
+          <a:solidFill>
+            <a:srgbClr val="7FC8A9"/>
+          </a:solidFill>
+          <a:ln>
+            <a:noFill/>
+          </a:ln>
+          <a:effectLst/>
+        </p:spPr>
+        <p:style>
+          <a:lnRef idx="1">
+            <a:schemeClr val="accent1"/>
+          </a:lnRef>
+          <a:fillRef idx="3">
+            <a:schemeClr val="accent1"/>
+          </a:fillRef>
+          <a:effectRef idx="2">
+            <a:schemeClr val="accent1"/>
+          </a:effectRef>
+          <a:fontRef idx="minor">
+            <a:schemeClr val="lt1"/>
+          </a:fontRef>
+        </p:style>
+        <p:txBody>
+          <a:bodyPr rtlCol="0" anchor="ctr" wrap="square"/>
+          <a:lstStyle/>
+          <a:p>
+            <a:pPr algn="ctr"/>
+          </a:p>
+        </p:txBody>
+      </p:sp>
+      <p:sp>
+        <p:nvSpPr>
+          <p:cNvPr id="15" name="TextBox 14"/>
+          <p:cNvSpPr txBox="1"/>
+          <p:nvPr/>
+        </p:nvSpPr>
+        <p:spPr>
+          <a:xfrm>
+            <a:off x="1234440" y="4425696"/>
+            <a:ext cx="10012680" cy="822960"/>
+          </a:xfrm>
+          <a:prstGeom prst="rect">
+            <a:avLst/>
+          </a:prstGeom>
+          <a:noFill/>
+          <a:effectLst/>
+        </p:spPr>
+        <p:txBody>
+          <a:bodyPr wrap="square" lIns="50800" rIns="50800">
+            <a:spAutoFit/>
+          </a:bodyPr>
+          <a:lstStyle/>
+          <a:p>
+            <a:pPr algn="l"/>
+            <a:r>
+              <a:rPr sz="1650" b="0">
+                <a:solidFill>
+                  <a:srgbClr val="E8ECF2"/>
+                </a:solidFill>
+                <a:latin typeface="Segoe UI"/>
+                <a:ea typeface="Microsoft YaHei"/>
+              </a:rPr>
+              <a:t>Skills 机制：把稳定流程固化为可复用的技能包</a:t>
+            </a:r>
+          </a:p>
+        </p:txBody>
+      </p:sp>
+      <p:sp>
+        <p:nvSpPr>
+          <p:cNvPr id="16" name="TextBox 15"/>
+          <p:cNvSpPr txBox="1"/>
+          <p:nvPr/>
+        </p:nvSpPr>
+        <p:spPr>
+          <a:xfrm>
+            <a:off x="822960" y="6473952"/>
+            <a:ext cx="7315200" cy="274320"/>
+          </a:xfrm>
+          <a:prstGeom prst="rect">
+            <a:avLst/>
+          </a:prstGeom>
+          <a:noFill/>
+          <a:effectLst/>
+        </p:spPr>
+        <p:txBody>
+          <a:bodyPr wrap="square" lIns="50800" rIns="50800">
+            <a:spAutoFit/>
+          </a:bodyPr>
+          <a:lstStyle/>
+          <a:p>
+            <a:pPr algn="l"/>
+            <a:r>
+              <a:rPr sz="1000" b="0">
+                <a:solidFill>
+                  <a:srgbClr val="9AA7BC"/>
+                </a:solidFill>
+                <a:latin typeface="Segoe UI"/>
+                <a:ea typeface="Microsoft YaHei"/>
+              </a:rPr>
+              <a:t>DCC-MCP 框架介绍</a:t>
+            </a:r>
+          </a:p>
+        </p:txBody>
+      </p:sp>
+      <p:sp>
+        <p:nvSpPr>
+          <p:cNvPr id="17" name="TextBox 16"/>
           <p:cNvSpPr txBox="1"/>
           <p:nvPr/>
         </p:nvSpPr>
@@ -6402,8 +7400,8 @@
         </p:nvSpPr>
         <p:spPr>
           <a:xfrm>
-            <a:off x="822960" y="457200"/>
-            <a:ext cx="10515600" cy="731520"/>
+            <a:off x="822960" y="502920"/>
+            <a:ext cx="10515600" cy="685800"/>
           </a:xfrm>
           <a:prstGeom prst="rect">
             <a:avLst/>
@@ -6419,7 +7417,7 @@
           <a:p>
             <a:pPr algn="l"/>
             <a:r>
-              <a:rPr sz="3000" b="1">
+              <a:rPr sz="2800" b="1">
                 <a:solidFill>
                   <a:srgbClr val="E8ECF2"/>
                 </a:solidFill>
@@ -6433,14 +7431,114 @@
       </p:sp>
       <p:sp>
         <p:nvSpPr>
-          <p:cNvPr id="4" name="Rounded Rectangle 3"/>
+          <p:cNvPr id="4" name="Rectangle 3"/>
           <p:cNvSpPr/>
           <p:nvPr/>
         </p:nvSpPr>
         <p:spPr>
           <a:xfrm>
-            <a:off x="2560320" y="1463040"/>
-            <a:ext cx="7040880" cy="777240"/>
+            <a:off x="822960" y="1298448"/>
+            <a:ext cx="822960" cy="44450"/>
+          </a:xfrm>
+          <a:prstGeom prst="rect">
+            <a:avLst/>
+          </a:prstGeom>
+          <a:solidFill>
+            <a:srgbClr val="4D9DE0"/>
+          </a:solidFill>
+          <a:ln>
+            <a:noFill/>
+          </a:ln>
+          <a:effectLst/>
+        </p:spPr>
+        <p:style>
+          <a:lnRef idx="1">
+            <a:schemeClr val="accent1"/>
+          </a:lnRef>
+          <a:fillRef idx="3">
+            <a:schemeClr val="accent1"/>
+          </a:fillRef>
+          <a:effectRef idx="2">
+            <a:schemeClr val="accent1"/>
+          </a:effectRef>
+          <a:fontRef idx="minor">
+            <a:schemeClr val="lt1"/>
+          </a:fontRef>
+        </p:style>
+        <p:txBody>
+          <a:bodyPr rtlCol="0" anchor="ctr" wrap="square"/>
+          <a:lstStyle/>
+          <a:p>
+            <a:pPr algn="ctr"/>
+          </a:p>
+        </p:txBody>
+      </p:sp>
+      <p:sp>
+        <p:nvSpPr>
+          <p:cNvPr id="5" name="Oval 4"/>
+          <p:cNvSpPr/>
+          <p:nvPr/>
+        </p:nvSpPr>
+        <p:spPr>
+          <a:xfrm>
+            <a:off x="2148840" y="1819656"/>
+            <a:ext cx="384048" cy="384048"/>
+          </a:xfrm>
+          <a:prstGeom prst="ellipse">
+            <a:avLst/>
+          </a:prstGeom>
+          <a:solidFill>
+            <a:srgbClr val="171F2E"/>
+          </a:solidFill>
+          <a:ln w="15240">
+            <a:solidFill>
+              <a:srgbClr val="4D9DE0"/>
+            </a:solidFill>
+          </a:ln>
+          <a:effectLst/>
+        </p:spPr>
+        <p:style>
+          <a:lnRef idx="1">
+            <a:schemeClr val="accent1"/>
+          </a:lnRef>
+          <a:fillRef idx="3">
+            <a:schemeClr val="accent1"/>
+          </a:fillRef>
+          <a:effectRef idx="2">
+            <a:schemeClr val="accent1"/>
+          </a:effectRef>
+          <a:fontRef idx="minor">
+            <a:schemeClr val="lt1"/>
+          </a:fontRef>
+        </p:style>
+        <p:txBody>
+          <a:bodyPr rtlCol="0" anchor="ctr" wrap="square" lIns="101600" rIns="101600" tIns="76200" bIns="76200"/>
+          <a:lstStyle/>
+          <a:p>
+            <a:pPr algn="ctr"/>
+            <a:r>
+              <a:rPr sz="1200" b="1">
+                <a:solidFill>
+                  <a:srgbClr val="4D9DE0"/>
+                </a:solidFill>
+                <a:latin typeface="Segoe UI"/>
+                <a:ea typeface="Microsoft YaHei"/>
+              </a:rPr>
+              <a:t>1</a:t>
+            </a:r>
+          </a:p>
+        </p:txBody>
+      </p:sp>
+      <p:sp>
+        <p:nvSpPr>
+          <p:cNvPr id="6" name="Rounded Rectangle 5"/>
+          <p:cNvSpPr/>
+          <p:nvPr/>
+        </p:nvSpPr>
+        <p:spPr>
+          <a:xfrm>
+            <a:off x="2788920" y="1673352"/>
+            <a:ext cx="8412480" cy="713232"/>
           </a:xfrm>
           <a:prstGeom prst="roundRect">
             <a:avLst>
@@ -6475,7 +7573,7 @@
           <a:p>
             <a:pPr algn="ctr"/>
             <a:r>
-              <a:rPr sz="1500" b="0">
+              <a:rPr sz="1450" b="0">
                 <a:solidFill>
                   <a:srgbClr val="E8ECF2"/>
                 </a:solidFill>
@@ -6489,14 +7587,70 @@
       </p:sp>
       <p:sp>
         <p:nvSpPr>
-          <p:cNvPr id="5" name="Rounded Rectangle 4"/>
+          <p:cNvPr id="7" name="Oval 6"/>
           <p:cNvSpPr/>
           <p:nvPr/>
         </p:nvSpPr>
         <p:spPr>
           <a:xfrm>
-            <a:off x="2560320" y="2331720"/>
-            <a:ext cx="7040880" cy="777240"/>
+            <a:off x="2148840" y="2688336"/>
+            <a:ext cx="384048" cy="384048"/>
+          </a:xfrm>
+          <a:prstGeom prst="ellipse">
+            <a:avLst/>
+          </a:prstGeom>
+          <a:solidFill>
+            <a:srgbClr val="171F2E"/>
+          </a:solidFill>
+          <a:ln w="15240">
+            <a:solidFill>
+              <a:srgbClr val="4D9DE0"/>
+            </a:solidFill>
+          </a:ln>
+          <a:effectLst/>
+        </p:spPr>
+        <p:style>
+          <a:lnRef idx="1">
+            <a:schemeClr val="accent1"/>
+          </a:lnRef>
+          <a:fillRef idx="3">
+            <a:schemeClr val="accent1"/>
+          </a:fillRef>
+          <a:effectRef idx="2">
+            <a:schemeClr val="accent1"/>
+          </a:effectRef>
+          <a:fontRef idx="minor">
+            <a:schemeClr val="lt1"/>
+          </a:fontRef>
+        </p:style>
+        <p:txBody>
+          <a:bodyPr rtlCol="0" anchor="ctr" wrap="square" lIns="101600" rIns="101600" tIns="76200" bIns="76200"/>
+          <a:lstStyle/>
+          <a:p>
+            <a:pPr algn="ctr"/>
+            <a:r>
+              <a:rPr sz="1200" b="1">
+                <a:solidFill>
+                  <a:srgbClr val="4D9DE0"/>
+                </a:solidFill>
+                <a:latin typeface="Segoe UI"/>
+                <a:ea typeface="Microsoft YaHei"/>
+              </a:rPr>
+              <a:t>2</a:t>
+            </a:r>
+          </a:p>
+        </p:txBody>
+      </p:sp>
+      <p:sp>
+        <p:nvSpPr>
+          <p:cNvPr id="8" name="Rounded Rectangle 7"/>
+          <p:cNvSpPr/>
+          <p:nvPr/>
+        </p:nvSpPr>
+        <p:spPr>
+          <a:xfrm>
+            <a:off x="2788920" y="2542032"/>
+            <a:ext cx="8412480" cy="713232"/>
           </a:xfrm>
           <a:prstGeom prst="roundRect">
             <a:avLst>
@@ -6531,7 +7685,7 @@
           <a:p>
             <a:pPr algn="ctr"/>
             <a:r>
-              <a:rPr sz="1500" b="0">
+              <a:rPr sz="1450" b="0">
                 <a:solidFill>
                   <a:srgbClr val="E8ECF2"/>
                 </a:solidFill>
@@ -6545,14 +7699,70 @@
       </p:sp>
       <p:sp>
         <p:nvSpPr>
-          <p:cNvPr id="6" name="Rounded Rectangle 5"/>
+          <p:cNvPr id="9" name="Oval 8"/>
           <p:cNvSpPr/>
           <p:nvPr/>
         </p:nvSpPr>
         <p:spPr>
           <a:xfrm>
-            <a:off x="2560320" y="3200400"/>
-            <a:ext cx="7040880" cy="777240"/>
+            <a:off x="2148840" y="3557016"/>
+            <a:ext cx="384048" cy="384048"/>
+          </a:xfrm>
+          <a:prstGeom prst="ellipse">
+            <a:avLst/>
+          </a:prstGeom>
+          <a:solidFill>
+            <a:srgbClr val="171F2E"/>
+          </a:solidFill>
+          <a:ln w="15240">
+            <a:solidFill>
+              <a:srgbClr val="4D9DE0"/>
+            </a:solidFill>
+          </a:ln>
+          <a:effectLst/>
+        </p:spPr>
+        <p:style>
+          <a:lnRef idx="1">
+            <a:schemeClr val="accent1"/>
+          </a:lnRef>
+          <a:fillRef idx="3">
+            <a:schemeClr val="accent1"/>
+          </a:fillRef>
+          <a:effectRef idx="2">
+            <a:schemeClr val="accent1"/>
+          </a:effectRef>
+          <a:fontRef idx="minor">
+            <a:schemeClr val="lt1"/>
+          </a:fontRef>
+        </p:style>
+        <p:txBody>
+          <a:bodyPr rtlCol="0" anchor="ctr" wrap="square" lIns="101600" rIns="101600" tIns="76200" bIns="76200"/>
+          <a:lstStyle/>
+          <a:p>
+            <a:pPr algn="ctr"/>
+            <a:r>
+              <a:rPr sz="1200" b="1">
+                <a:solidFill>
+                  <a:srgbClr val="4D9DE0"/>
+                </a:solidFill>
+                <a:latin typeface="Segoe UI"/>
+                <a:ea typeface="Microsoft YaHei"/>
+              </a:rPr>
+              <a:t>3</a:t>
+            </a:r>
+          </a:p>
+        </p:txBody>
+      </p:sp>
+      <p:sp>
+        <p:nvSpPr>
+          <p:cNvPr id="10" name="Rounded Rectangle 9"/>
+          <p:cNvSpPr/>
+          <p:nvPr/>
+        </p:nvSpPr>
+        <p:spPr>
+          <a:xfrm>
+            <a:off x="2788920" y="3410712"/>
+            <a:ext cx="8412480" cy="713232"/>
           </a:xfrm>
           <a:prstGeom prst="roundRect">
             <a:avLst>
@@ -6587,7 +7797,7 @@
           <a:p>
             <a:pPr algn="ctr"/>
             <a:r>
-              <a:rPr sz="1500" b="0">
+              <a:rPr sz="1450" b="0">
                 <a:solidFill>
                   <a:srgbClr val="E8ECF2"/>
                 </a:solidFill>
@@ -6601,14 +7811,70 @@
       </p:sp>
       <p:sp>
         <p:nvSpPr>
-          <p:cNvPr id="7" name="Rounded Rectangle 6"/>
+          <p:cNvPr id="11" name="Oval 10"/>
           <p:cNvSpPr/>
           <p:nvPr/>
         </p:nvSpPr>
         <p:spPr>
           <a:xfrm>
-            <a:off x="2560320" y="4069079"/>
-            <a:ext cx="7040880" cy="777240"/>
+            <a:off x="2148840" y="4425696"/>
+            <a:ext cx="384048" cy="384048"/>
+          </a:xfrm>
+          <a:prstGeom prst="ellipse">
+            <a:avLst/>
+          </a:prstGeom>
+          <a:solidFill>
+            <a:srgbClr val="171F2E"/>
+          </a:solidFill>
+          <a:ln w="15240">
+            <a:solidFill>
+              <a:srgbClr val="4D9DE0"/>
+            </a:solidFill>
+          </a:ln>
+          <a:effectLst/>
+        </p:spPr>
+        <p:style>
+          <a:lnRef idx="1">
+            <a:schemeClr val="accent1"/>
+          </a:lnRef>
+          <a:fillRef idx="3">
+            <a:schemeClr val="accent1"/>
+          </a:fillRef>
+          <a:effectRef idx="2">
+            <a:schemeClr val="accent1"/>
+          </a:effectRef>
+          <a:fontRef idx="minor">
+            <a:schemeClr val="lt1"/>
+          </a:fontRef>
+        </p:style>
+        <p:txBody>
+          <a:bodyPr rtlCol="0" anchor="ctr" wrap="square" lIns="101600" rIns="101600" tIns="76200" bIns="76200"/>
+          <a:lstStyle/>
+          <a:p>
+            <a:pPr algn="ctr"/>
+            <a:r>
+              <a:rPr sz="1200" b="1">
+                <a:solidFill>
+                  <a:srgbClr val="4D9DE0"/>
+                </a:solidFill>
+                <a:latin typeface="Segoe UI"/>
+                <a:ea typeface="Microsoft YaHei"/>
+              </a:rPr>
+              <a:t>4</a:t>
+            </a:r>
+          </a:p>
+        </p:txBody>
+      </p:sp>
+      <p:sp>
+        <p:nvSpPr>
+          <p:cNvPr id="12" name="Rounded Rectangle 11"/>
+          <p:cNvSpPr/>
+          <p:nvPr/>
+        </p:nvSpPr>
+        <p:spPr>
+          <a:xfrm>
+            <a:off x="2788920" y="4279392"/>
+            <a:ext cx="8412480" cy="713232"/>
           </a:xfrm>
           <a:prstGeom prst="roundRect">
             <a:avLst>
@@ -6643,7 +7909,7 @@
           <a:p>
             <a:pPr algn="ctr"/>
             <a:r>
-              <a:rPr sz="1500" b="0">
+              <a:rPr sz="1450" b="0">
                 <a:solidFill>
                   <a:srgbClr val="E8ECF2"/>
                 </a:solidFill>
@@ -6657,14 +7923,70 @@
       </p:sp>
       <p:sp>
         <p:nvSpPr>
-          <p:cNvPr id="8" name="Rounded Rectangle 7"/>
+          <p:cNvPr id="13" name="Oval 12"/>
           <p:cNvSpPr/>
           <p:nvPr/>
         </p:nvSpPr>
         <p:spPr>
           <a:xfrm>
-            <a:off x="2560320" y="4937760"/>
-            <a:ext cx="7040880" cy="777240"/>
+            <a:off x="2148840" y="5294376"/>
+            <a:ext cx="384048" cy="384048"/>
+          </a:xfrm>
+          <a:prstGeom prst="ellipse">
+            <a:avLst/>
+          </a:prstGeom>
+          <a:solidFill>
+            <a:srgbClr val="171F2E"/>
+          </a:solidFill>
+          <a:ln w="15240">
+            <a:solidFill>
+              <a:srgbClr val="4D9DE0"/>
+            </a:solidFill>
+          </a:ln>
+          <a:effectLst/>
+        </p:spPr>
+        <p:style>
+          <a:lnRef idx="1">
+            <a:schemeClr val="accent1"/>
+          </a:lnRef>
+          <a:fillRef idx="3">
+            <a:schemeClr val="accent1"/>
+          </a:fillRef>
+          <a:effectRef idx="2">
+            <a:schemeClr val="accent1"/>
+          </a:effectRef>
+          <a:fontRef idx="minor">
+            <a:schemeClr val="lt1"/>
+          </a:fontRef>
+        </p:style>
+        <p:txBody>
+          <a:bodyPr rtlCol="0" anchor="ctr" wrap="square" lIns="101600" rIns="101600" tIns="76200" bIns="76200"/>
+          <a:lstStyle/>
+          <a:p>
+            <a:pPr algn="ctr"/>
+            <a:r>
+              <a:rPr sz="1200" b="1">
+                <a:solidFill>
+                  <a:srgbClr val="4D9DE0"/>
+                </a:solidFill>
+                <a:latin typeface="Segoe UI"/>
+                <a:ea typeface="Microsoft YaHei"/>
+              </a:rPr>
+              <a:t>5</a:t>
+            </a:r>
+          </a:p>
+        </p:txBody>
+      </p:sp>
+      <p:sp>
+        <p:nvSpPr>
+          <p:cNvPr id="14" name="Rounded Rectangle 13"/>
+          <p:cNvSpPr/>
+          <p:nvPr/>
+        </p:nvSpPr>
+        <p:spPr>
+          <a:xfrm>
+            <a:off x="2788920" y="5148072"/>
+            <a:ext cx="8412480" cy="713232"/>
           </a:xfrm>
           <a:prstGeom prst="roundRect">
             <a:avLst>
@@ -6699,7 +8021,7 @@
           <a:p>
             <a:pPr algn="ctr"/>
             <a:r>
-              <a:rPr sz="1500" b="0">
+              <a:rPr sz="1450" b="0">
                 <a:solidFill>
                   <a:srgbClr val="E8ECF2"/>
                 </a:solidFill>
@@ -6713,14 +8035,14 @@
       </p:sp>
       <p:cxnSp>
         <p:nvCxnSpPr>
-          <p:cNvPr id="9" name="Connector 8"/>
+          <p:cNvPr id="15" name="Connector 14"/>
           <p:cNvCxnSpPr/>
           <p:nvPr/>
         </p:nvCxnSpPr>
         <p:spPr>
           <a:xfrm>
-            <a:off x="6080760" y="1851660"/>
-            <a:ext cx="0" cy="3474720"/>
+            <a:off x="2340864" y="2194560"/>
+            <a:ext cx="0" cy="3474719"/>
           </a:xfrm>
           <a:prstGeom prst="line">
             <a:avLst/>
@@ -6749,7 +8071,44 @@
       </p:cxnSp>
       <p:sp>
         <p:nvSpPr>
-          <p:cNvPr id="10" name="TextBox 9"/>
+          <p:cNvPr id="16" name="TextBox 15"/>
+          <p:cNvSpPr txBox="1"/>
+          <p:nvPr/>
+        </p:nvSpPr>
+        <p:spPr>
+          <a:xfrm>
+            <a:off x="822960" y="6473952"/>
+            <a:ext cx="7315200" cy="274320"/>
+          </a:xfrm>
+          <a:prstGeom prst="rect">
+            <a:avLst/>
+          </a:prstGeom>
+          <a:noFill/>
+          <a:effectLst/>
+        </p:spPr>
+        <p:txBody>
+          <a:bodyPr wrap="square" lIns="50800" rIns="50800">
+            <a:spAutoFit/>
+          </a:bodyPr>
+          <a:lstStyle/>
+          <a:p>
+            <a:pPr algn="l"/>
+            <a:r>
+              <a:rPr sz="1000" b="0">
+                <a:solidFill>
+                  <a:srgbClr val="9AA7BC"/>
+                </a:solidFill>
+                <a:latin typeface="Segoe UI"/>
+                <a:ea typeface="Microsoft YaHei"/>
+              </a:rPr>
+              <a:t>DCC-MCP 框架介绍</a:t>
+            </a:r>
+          </a:p>
+        </p:txBody>
+      </p:sp>
+      <p:sp>
+        <p:nvSpPr>
+          <p:cNvPr id="17" name="TextBox 16"/>
           <p:cNvSpPr txBox="1"/>
           <p:nvPr/>
         </p:nvSpPr>
@@ -6854,8 +8213,8 @@
         </p:nvSpPr>
         <p:spPr>
           <a:xfrm>
-            <a:off x="822960" y="457200"/>
-            <a:ext cx="10515600" cy="731520"/>
+            <a:off x="822960" y="502920"/>
+            <a:ext cx="10515600" cy="685800"/>
           </a:xfrm>
           <a:prstGeom prst="rect">
             <a:avLst/>
@@ -6871,7 +8230,7 @@
           <a:p>
             <a:pPr algn="l"/>
             <a:r>
-              <a:rPr sz="3000" b="1">
+              <a:rPr sz="2800" b="1">
                 <a:solidFill>
                   <a:srgbClr val="E8ECF2"/>
                 </a:solidFill>
@@ -6885,22 +8244,20 @@
       </p:sp>
       <p:sp>
         <p:nvSpPr>
-          <p:cNvPr id="4" name="Rounded Rectangle 3"/>
+          <p:cNvPr id="4" name="Rectangle 3"/>
           <p:cNvSpPr/>
           <p:nvPr/>
         </p:nvSpPr>
         <p:spPr>
           <a:xfrm>
-            <a:off x="822960" y="1371600"/>
-            <a:ext cx="10515600" cy="777240"/>
-          </a:xfrm>
-          <a:prstGeom prst="roundRect">
-            <a:avLst>
-              <a:gd name="adj" fmla="val 18000"/>
-            </a:avLst>
+            <a:off x="822960" y="1298448"/>
+            <a:ext cx="822960" cy="44450"/>
+          </a:xfrm>
+          <a:prstGeom prst="rect">
+            <a:avLst/>
           </a:prstGeom>
           <a:solidFill>
-            <a:srgbClr val="1E2A3D"/>
+            <a:srgbClr val="4D9DE0"/>
           </a:solidFill>
           <a:ln>
             <a:noFill/>
@@ -6922,41 +8279,29 @@
           </a:fontRef>
         </p:style>
         <p:txBody>
-          <a:bodyPr rtlCol="0" anchor="ctr" wrap="square" lIns="101600" rIns="101600" tIns="76200" bIns="76200"/>
-          <a:lstStyle/>
-          <a:p>
-            <a:pPr algn="l"/>
-            <a:r>
-              <a:rPr sz="1700" b="0">
-                <a:solidFill>
-                  <a:srgbClr val="E8ECF2"/>
-                </a:solidFill>
-                <a:latin typeface="Segoe UI"/>
-                <a:ea typeface="Microsoft YaHei"/>
-              </a:rPr>
-              <a:t>●  任务级 Capability，不暴露原始对象模型</a:t>
-            </a:r>
-          </a:p>
-        </p:txBody>
-      </p:sp>
-      <p:sp>
-        <p:nvSpPr>
-          <p:cNvPr id="5" name="Rounded Rectangle 4"/>
+          <a:bodyPr rtlCol="0" anchor="ctr" wrap="square"/>
+          <a:lstStyle/>
+          <a:p>
+            <a:pPr algn="ctr"/>
+          </a:p>
+        </p:txBody>
+      </p:sp>
+      <p:sp>
+        <p:nvSpPr>
+          <p:cNvPr id="5" name="Oval 4"/>
           <p:cNvSpPr/>
           <p:nvPr/>
         </p:nvSpPr>
         <p:spPr>
           <a:xfrm>
-            <a:off x="822960" y="2286000"/>
-            <a:ext cx="10515600" cy="777240"/>
-          </a:xfrm>
-          <a:prstGeom prst="roundRect">
-            <a:avLst>
-              <a:gd name="adj" fmla="val 18000"/>
-            </a:avLst>
+            <a:off x="868680" y="1783080"/>
+            <a:ext cx="165100" cy="165100"/>
+          </a:xfrm>
+          <a:prstGeom prst="ellipse">
+            <a:avLst/>
           </a:prstGeom>
           <a:solidFill>
-            <a:srgbClr val="1E2A3D"/>
+            <a:srgbClr val="7FC8A9"/>
           </a:solidFill>
           <a:ln>
             <a:noFill/>
@@ -6978,41 +8323,66 @@
           </a:fontRef>
         </p:style>
         <p:txBody>
-          <a:bodyPr rtlCol="0" anchor="ctr" wrap="square" lIns="101600" rIns="101600" tIns="76200" bIns="76200"/>
+          <a:bodyPr rtlCol="0" anchor="ctr" wrap="square"/>
+          <a:lstStyle/>
+          <a:p>
+            <a:pPr algn="ctr"/>
+          </a:p>
+        </p:txBody>
+      </p:sp>
+      <p:sp>
+        <p:nvSpPr>
+          <p:cNvPr id="6" name="TextBox 5"/>
+          <p:cNvSpPr txBox="1"/>
+          <p:nvPr/>
+        </p:nvSpPr>
+        <p:spPr>
+          <a:xfrm>
+            <a:off x="1234440" y="1627632"/>
+            <a:ext cx="10012680" cy="822960"/>
+          </a:xfrm>
+          <a:prstGeom prst="rect">
+            <a:avLst/>
+          </a:prstGeom>
+          <a:noFill/>
+          <a:effectLst/>
+        </p:spPr>
+        <p:txBody>
+          <a:bodyPr wrap="square" lIns="50800" rIns="50800">
+            <a:spAutoFit/>
+          </a:bodyPr>
           <a:lstStyle/>
           <a:p>
             <a:pPr algn="l"/>
             <a:r>
-              <a:rPr sz="1700" b="0">
+              <a:rPr sz="1650" b="0">
                 <a:solidFill>
                   <a:srgbClr val="E8ECF2"/>
                 </a:solidFill>
                 <a:latin typeface="Segoe UI"/>
                 <a:ea typeface="Microsoft YaHei"/>
               </a:rPr>
-              <a:t>●  渐进式发现：初始上下文不塞满数百个工具</a:t>
-            </a:r>
-          </a:p>
-        </p:txBody>
-      </p:sp>
-      <p:sp>
-        <p:nvSpPr>
-          <p:cNvPr id="6" name="Rounded Rectangle 5"/>
+              <a:t>任务级 Capability，不暴露原始对象模型</a:t>
+            </a:r>
+          </a:p>
+        </p:txBody>
+      </p:sp>
+      <p:sp>
+        <p:nvSpPr>
+          <p:cNvPr id="7" name="Rectangle 6"/>
           <p:cNvSpPr/>
           <p:nvPr/>
         </p:nvSpPr>
         <p:spPr>
           <a:xfrm>
-            <a:off x="822960" y="3200400"/>
-            <a:ext cx="10515600" cy="777240"/>
-          </a:xfrm>
-          <a:prstGeom prst="roundRect">
-            <a:avLst>
-              <a:gd name="adj" fmla="val 18000"/>
-            </a:avLst>
+            <a:off x="822960" y="2496312"/>
+            <a:ext cx="10515600" cy="15240"/>
+          </a:xfrm>
+          <a:prstGeom prst="rect">
+            <a:avLst/>
           </a:prstGeom>
           <a:solidFill>
-            <a:srgbClr val="1E2A3D"/>
+            <a:srgbClr val="223047"/>
           </a:solidFill>
           <a:ln>
             <a:noFill/>
@@ -7034,41 +8404,29 @@
           </a:fontRef>
         </p:style>
         <p:txBody>
-          <a:bodyPr rtlCol="0" anchor="ctr" wrap="square" lIns="101600" rIns="101600" tIns="76200" bIns="76200"/>
-          <a:lstStyle/>
-          <a:p>
-            <a:pPr algn="l"/>
-            <a:r>
-              <a:rPr sz="1700" b="0">
-                <a:solidFill>
-                  <a:srgbClr val="E8ECF2"/>
-                </a:solidFill>
-                <a:latin typeface="Segoe UI"/>
-                <a:ea typeface="Microsoft YaHei"/>
-              </a:rPr>
-              <a:t>●  契约化技能包：SKILL.md + tools.yaml + scripts/&lt;name&gt;.py</a:t>
-            </a:r>
-          </a:p>
-        </p:txBody>
-      </p:sp>
-      <p:sp>
-        <p:nvSpPr>
-          <p:cNvPr id="7" name="Rounded Rectangle 6"/>
+          <a:bodyPr rtlCol="0" anchor="ctr" wrap="square"/>
+          <a:lstStyle/>
+          <a:p>
+            <a:pPr algn="ctr"/>
+          </a:p>
+        </p:txBody>
+      </p:sp>
+      <p:sp>
+        <p:nvSpPr>
+          <p:cNvPr id="8" name="Oval 7"/>
           <p:cNvSpPr/>
           <p:nvPr/>
         </p:nvSpPr>
         <p:spPr>
           <a:xfrm>
-            <a:off x="822960" y="4114800"/>
-            <a:ext cx="10515600" cy="777240"/>
-          </a:xfrm>
-          <a:prstGeom prst="roundRect">
-            <a:avLst>
-              <a:gd name="adj" fmla="val 18000"/>
-            </a:avLst>
+            <a:off x="868680" y="2715768"/>
+            <a:ext cx="165100" cy="165100"/>
+          </a:xfrm>
+          <a:prstGeom prst="ellipse">
+            <a:avLst/>
           </a:prstGeom>
           <a:solidFill>
-            <a:srgbClr val="1E2A3D"/>
+            <a:srgbClr val="7FC8A9"/>
           </a:solidFill>
           <a:ln>
             <a:noFill/>
@@ -7090,26 +8448,340 @@
           </a:fontRef>
         </p:style>
         <p:txBody>
-          <a:bodyPr rtlCol="0" anchor="ctr" wrap="square" lIns="101600" rIns="101600" tIns="76200" bIns="76200"/>
+          <a:bodyPr rtlCol="0" anchor="ctr" wrap="square"/>
+          <a:lstStyle/>
+          <a:p>
+            <a:pPr algn="ctr"/>
+          </a:p>
+        </p:txBody>
+      </p:sp>
+      <p:sp>
+        <p:nvSpPr>
+          <p:cNvPr id="9" name="TextBox 8"/>
+          <p:cNvSpPr txBox="1"/>
+          <p:nvPr/>
+        </p:nvSpPr>
+        <p:spPr>
+          <a:xfrm>
+            <a:off x="1234440" y="2560320"/>
+            <a:ext cx="10012680" cy="822960"/>
+          </a:xfrm>
+          <a:prstGeom prst="rect">
+            <a:avLst/>
+          </a:prstGeom>
+          <a:noFill/>
+          <a:effectLst/>
+        </p:spPr>
+        <p:txBody>
+          <a:bodyPr wrap="square" lIns="50800" rIns="50800">
+            <a:spAutoFit/>
+          </a:bodyPr>
           <a:lstStyle/>
           <a:p>
             <a:pPr algn="l"/>
             <a:r>
-              <a:rPr sz="1700" b="0">
+              <a:rPr sz="1650" b="0">
                 <a:solidFill>
                   <a:srgbClr val="E8ECF2"/>
                 </a:solidFill>
                 <a:latin typeface="Segoe UI"/>
                 <a:ea typeface="Microsoft YaHei"/>
               </a:rPr>
-              <a:t>●  Maya 单仓 25+ 域技能包、198 个结构化操作</a:t>
-            </a:r>
-          </a:p>
-        </p:txBody>
-      </p:sp>
-      <p:sp>
-        <p:nvSpPr>
-          <p:cNvPr id="8" name="TextBox 7"/>
+              <a:t>渐进式发现：初始上下文不塞满数百个工具</a:t>
+            </a:r>
+          </a:p>
+        </p:txBody>
+      </p:sp>
+      <p:sp>
+        <p:nvSpPr>
+          <p:cNvPr id="10" name="Rectangle 9"/>
+          <p:cNvSpPr/>
+          <p:nvPr/>
+        </p:nvSpPr>
+        <p:spPr>
+          <a:xfrm>
+            <a:off x="822960" y="3429000"/>
+            <a:ext cx="10515600" cy="15240"/>
+          </a:xfrm>
+          <a:prstGeom prst="rect">
+            <a:avLst/>
+          </a:prstGeom>
+          <a:solidFill>
+            <a:srgbClr val="223047"/>
+          </a:solidFill>
+          <a:ln>
+            <a:noFill/>
+          </a:ln>
+          <a:effectLst/>
+        </p:spPr>
+        <p:style>
+          <a:lnRef idx="1">
+            <a:schemeClr val="accent1"/>
+          </a:lnRef>
+          <a:fillRef idx="3">
+            <a:schemeClr val="accent1"/>
+          </a:fillRef>
+          <a:effectRef idx="2">
+            <a:schemeClr val="accent1"/>
+          </a:effectRef>
+          <a:fontRef idx="minor">
+            <a:schemeClr val="lt1"/>
+          </a:fontRef>
+        </p:style>
+        <p:txBody>
+          <a:bodyPr rtlCol="0" anchor="ctr" wrap="square"/>
+          <a:lstStyle/>
+          <a:p>
+            <a:pPr algn="ctr"/>
+          </a:p>
+        </p:txBody>
+      </p:sp>
+      <p:sp>
+        <p:nvSpPr>
+          <p:cNvPr id="11" name="Oval 10"/>
+          <p:cNvSpPr/>
+          <p:nvPr/>
+        </p:nvSpPr>
+        <p:spPr>
+          <a:xfrm>
+            <a:off x="868680" y="3648456"/>
+            <a:ext cx="165100" cy="165100"/>
+          </a:xfrm>
+          <a:prstGeom prst="ellipse">
+            <a:avLst/>
+          </a:prstGeom>
+          <a:solidFill>
+            <a:srgbClr val="7FC8A9"/>
+          </a:solidFill>
+          <a:ln>
+            <a:noFill/>
+          </a:ln>
+          <a:effectLst/>
+        </p:spPr>
+        <p:style>
+          <a:lnRef idx="1">
+            <a:schemeClr val="accent1"/>
+          </a:lnRef>
+          <a:fillRef idx="3">
+            <a:schemeClr val="accent1"/>
+          </a:fillRef>
+          <a:effectRef idx="2">
+            <a:schemeClr val="accent1"/>
+          </a:effectRef>
+          <a:fontRef idx="minor">
+            <a:schemeClr val="lt1"/>
+          </a:fontRef>
+        </p:style>
+        <p:txBody>
+          <a:bodyPr rtlCol="0" anchor="ctr" wrap="square"/>
+          <a:lstStyle/>
+          <a:p>
+            <a:pPr algn="ctr"/>
+          </a:p>
+        </p:txBody>
+      </p:sp>
+      <p:sp>
+        <p:nvSpPr>
+          <p:cNvPr id="12" name="TextBox 11"/>
+          <p:cNvSpPr txBox="1"/>
+          <p:nvPr/>
+        </p:nvSpPr>
+        <p:spPr>
+          <a:xfrm>
+            <a:off x="1234440" y="3493008"/>
+            <a:ext cx="10012680" cy="822960"/>
+          </a:xfrm>
+          <a:prstGeom prst="rect">
+            <a:avLst/>
+          </a:prstGeom>
+          <a:noFill/>
+          <a:effectLst/>
+        </p:spPr>
+        <p:txBody>
+          <a:bodyPr wrap="square" lIns="50800" rIns="50800">
+            <a:spAutoFit/>
+          </a:bodyPr>
+          <a:lstStyle/>
+          <a:p>
+            <a:pPr algn="l"/>
+            <a:r>
+              <a:rPr sz="1650" b="0">
+                <a:solidFill>
+                  <a:srgbClr val="E8ECF2"/>
+                </a:solidFill>
+                <a:latin typeface="Segoe UI"/>
+                <a:ea typeface="Microsoft YaHei"/>
+              </a:rPr>
+              <a:t>契约化技能包：SKILL.md + tools.yaml + scripts/&lt;name&gt;.py</a:t>
+            </a:r>
+          </a:p>
+        </p:txBody>
+      </p:sp>
+      <p:sp>
+        <p:nvSpPr>
+          <p:cNvPr id="13" name="Rectangle 12"/>
+          <p:cNvSpPr/>
+          <p:nvPr/>
+        </p:nvSpPr>
+        <p:spPr>
+          <a:xfrm>
+            <a:off x="822960" y="4361688"/>
+            <a:ext cx="10515600" cy="15240"/>
+          </a:xfrm>
+          <a:prstGeom prst="rect">
+            <a:avLst/>
+          </a:prstGeom>
+          <a:solidFill>
+            <a:srgbClr val="223047"/>
+          </a:solidFill>
+          <a:ln>
+            <a:noFill/>
+          </a:ln>
+          <a:effectLst/>
+        </p:spPr>
+        <p:style>
+          <a:lnRef idx="1">
+            <a:schemeClr val="accent1"/>
+          </a:lnRef>
+          <a:fillRef idx="3">
+            <a:schemeClr val="accent1"/>
+          </a:fillRef>
+          <a:effectRef idx="2">
+            <a:schemeClr val="accent1"/>
+          </a:effectRef>
+          <a:fontRef idx="minor">
+            <a:schemeClr val="lt1"/>
+          </a:fontRef>
+        </p:style>
+        <p:txBody>
+          <a:bodyPr rtlCol="0" anchor="ctr" wrap="square"/>
+          <a:lstStyle/>
+          <a:p>
+            <a:pPr algn="ctr"/>
+          </a:p>
+        </p:txBody>
+      </p:sp>
+      <p:sp>
+        <p:nvSpPr>
+          <p:cNvPr id="14" name="Oval 13"/>
+          <p:cNvSpPr/>
+          <p:nvPr/>
+        </p:nvSpPr>
+        <p:spPr>
+          <a:xfrm>
+            <a:off x="868680" y="4581144"/>
+            <a:ext cx="165100" cy="165100"/>
+          </a:xfrm>
+          <a:prstGeom prst="ellipse">
+            <a:avLst/>
+          </a:prstGeom>
+          <a:solidFill>
+            <a:srgbClr val="7FC8A9"/>
+          </a:solidFill>
+          <a:ln>
+            <a:noFill/>
+          </a:ln>
+          <a:effectLst/>
+        </p:spPr>
+        <p:style>
+          <a:lnRef idx="1">
+            <a:schemeClr val="accent1"/>
+          </a:lnRef>
+          <a:fillRef idx="3">
+            <a:schemeClr val="accent1"/>
+          </a:fillRef>
+          <a:effectRef idx="2">
+            <a:schemeClr val="accent1"/>
+          </a:effectRef>
+          <a:fontRef idx="minor">
+            <a:schemeClr val="lt1"/>
+          </a:fontRef>
+        </p:style>
+        <p:txBody>
+          <a:bodyPr rtlCol="0" anchor="ctr" wrap="square"/>
+          <a:lstStyle/>
+          <a:p>
+            <a:pPr algn="ctr"/>
+          </a:p>
+        </p:txBody>
+      </p:sp>
+      <p:sp>
+        <p:nvSpPr>
+          <p:cNvPr id="15" name="TextBox 14"/>
+          <p:cNvSpPr txBox="1"/>
+          <p:nvPr/>
+        </p:nvSpPr>
+        <p:spPr>
+          <a:xfrm>
+            <a:off x="1234440" y="4425696"/>
+            <a:ext cx="10012680" cy="822960"/>
+          </a:xfrm>
+          <a:prstGeom prst="rect">
+            <a:avLst/>
+          </a:prstGeom>
+          <a:noFill/>
+          <a:effectLst/>
+        </p:spPr>
+        <p:txBody>
+          <a:bodyPr wrap="square" lIns="50800" rIns="50800">
+            <a:spAutoFit/>
+          </a:bodyPr>
+          <a:lstStyle/>
+          <a:p>
+            <a:pPr algn="l"/>
+            <a:r>
+              <a:rPr sz="1650" b="0">
+                <a:solidFill>
+                  <a:srgbClr val="E8ECF2"/>
+                </a:solidFill>
+                <a:latin typeface="Segoe UI"/>
+                <a:ea typeface="Microsoft YaHei"/>
+              </a:rPr>
+              <a:t>Maya 单仓 25+ 域技能包、198 个结构化操作</a:t>
+            </a:r>
+          </a:p>
+        </p:txBody>
+      </p:sp>
+      <p:sp>
+        <p:nvSpPr>
+          <p:cNvPr id="16" name="TextBox 15"/>
+          <p:cNvSpPr txBox="1"/>
+          <p:nvPr/>
+        </p:nvSpPr>
+        <p:spPr>
+          <a:xfrm>
+            <a:off x="822960" y="6473952"/>
+            <a:ext cx="7315200" cy="274320"/>
+          </a:xfrm>
+          <a:prstGeom prst="rect">
+            <a:avLst/>
+          </a:prstGeom>
+          <a:noFill/>
+          <a:effectLst/>
+        </p:spPr>
+        <p:txBody>
+          <a:bodyPr wrap="square" lIns="50800" rIns="50800">
+            <a:spAutoFit/>
+          </a:bodyPr>
+          <a:lstStyle/>
+          <a:p>
+            <a:pPr algn="l"/>
+            <a:r>
+              <a:rPr sz="1000" b="0">
+                <a:solidFill>
+                  <a:srgbClr val="9AA7BC"/>
+                </a:solidFill>
+                <a:latin typeface="Segoe UI"/>
+                <a:ea typeface="Microsoft YaHei"/>
+              </a:rPr>
+              <a:t>DCC-MCP 框架介绍</a:t>
+            </a:r>
+          </a:p>
+        </p:txBody>
+      </p:sp>
+      <p:sp>
+        <p:nvSpPr>
+          <p:cNvPr id="17" name="TextBox 16"/>
           <p:cNvSpPr txBox="1"/>
           <p:nvPr/>
         </p:nvSpPr>
@@ -7214,8 +8886,8 @@
         </p:nvSpPr>
         <p:spPr>
           <a:xfrm>
-            <a:off x="822960" y="457200"/>
-            <a:ext cx="10515600" cy="731520"/>
+            <a:off x="822960" y="502920"/>
+            <a:ext cx="10515600" cy="685800"/>
           </a:xfrm>
           <a:prstGeom prst="rect">
             <a:avLst/>
@@ -7231,7 +8903,7 @@
           <a:p>
             <a:pPr algn="l"/>
             <a:r>
-              <a:rPr sz="3000" b="1">
+              <a:rPr sz="2800" b="1">
                 <a:solidFill>
                   <a:srgbClr val="E8ECF2"/>
                 </a:solidFill>
@@ -7245,18 +8917,62 @@
       </p:sp>
       <p:sp>
         <p:nvSpPr>
-          <p:cNvPr id="4" name="Rounded Rectangle 3"/>
+          <p:cNvPr id="4" name="Rectangle 3"/>
           <p:cNvSpPr/>
           <p:nvPr/>
         </p:nvSpPr>
         <p:spPr>
           <a:xfrm>
-            <a:off x="822960" y="1371600"/>
-            <a:ext cx="3291840" cy="1737360"/>
+            <a:off x="822960" y="1298448"/>
+            <a:ext cx="822960" cy="44450"/>
+          </a:xfrm>
+          <a:prstGeom prst="rect">
+            <a:avLst/>
+          </a:prstGeom>
+          <a:solidFill>
+            <a:srgbClr val="4D9DE0"/>
+          </a:solidFill>
+          <a:ln>
+            <a:noFill/>
+          </a:ln>
+          <a:effectLst/>
+        </p:spPr>
+        <p:style>
+          <a:lnRef idx="1">
+            <a:schemeClr val="accent1"/>
+          </a:lnRef>
+          <a:fillRef idx="3">
+            <a:schemeClr val="accent1"/>
+          </a:fillRef>
+          <a:effectRef idx="2">
+            <a:schemeClr val="accent1"/>
+          </a:effectRef>
+          <a:fontRef idx="minor">
+            <a:schemeClr val="lt1"/>
+          </a:fontRef>
+        </p:style>
+        <p:txBody>
+          <a:bodyPr rtlCol="0" anchor="ctr" wrap="square"/>
+          <a:lstStyle/>
+          <a:p>
+            <a:pPr algn="ctr"/>
+          </a:p>
+        </p:txBody>
+      </p:sp>
+      <p:sp>
+        <p:nvSpPr>
+          <p:cNvPr id="5" name="Rounded Rectangle 4"/>
+          <p:cNvSpPr/>
+          <p:nvPr/>
+        </p:nvSpPr>
+        <p:spPr>
+          <a:xfrm>
+            <a:off x="822960" y="1627632"/>
+            <a:ext cx="3291840" cy="1691640"/>
           </a:xfrm>
           <a:prstGeom prst="roundRect">
             <a:avLst>
-              <a:gd name="adj" fmla="val 8000"/>
+              <a:gd name="adj" fmla="val 7000"/>
             </a:avLst>
           </a:prstGeom>
           <a:solidFill>
@@ -7314,18 +9030,62 @@
       </p:sp>
       <p:sp>
         <p:nvSpPr>
-          <p:cNvPr id="5" name="Rounded Rectangle 4"/>
+          <p:cNvPr id="6" name="Rectangle 5"/>
           <p:cNvSpPr/>
           <p:nvPr/>
         </p:nvSpPr>
         <p:spPr>
           <a:xfrm>
-            <a:off x="4389120" y="1371600"/>
-            <a:ext cx="3291840" cy="1737360"/>
+            <a:off x="1188720" y="1627632"/>
+            <a:ext cx="502920" cy="50800"/>
+          </a:xfrm>
+          <a:prstGeom prst="rect">
+            <a:avLst/>
+          </a:prstGeom>
+          <a:solidFill>
+            <a:srgbClr val="7FC8A9"/>
+          </a:solidFill>
+          <a:ln>
+            <a:noFill/>
+          </a:ln>
+          <a:effectLst/>
+        </p:spPr>
+        <p:style>
+          <a:lnRef idx="1">
+            <a:schemeClr val="accent1"/>
+          </a:lnRef>
+          <a:fillRef idx="3">
+            <a:schemeClr val="accent1"/>
+          </a:fillRef>
+          <a:effectRef idx="2">
+            <a:schemeClr val="accent1"/>
+          </a:effectRef>
+          <a:fontRef idx="minor">
+            <a:schemeClr val="lt1"/>
+          </a:fontRef>
+        </p:style>
+        <p:txBody>
+          <a:bodyPr rtlCol="0" anchor="ctr" wrap="square"/>
+          <a:lstStyle/>
+          <a:p>
+            <a:pPr algn="ctr"/>
+          </a:p>
+        </p:txBody>
+      </p:sp>
+      <p:sp>
+        <p:nvSpPr>
+          <p:cNvPr id="7" name="Rounded Rectangle 6"/>
+          <p:cNvSpPr/>
+          <p:nvPr/>
+        </p:nvSpPr>
+        <p:spPr>
+          <a:xfrm>
+            <a:off x="4389120" y="1627632"/>
+            <a:ext cx="3291840" cy="1691640"/>
           </a:xfrm>
           <a:prstGeom prst="roundRect">
             <a:avLst>
-              <a:gd name="adj" fmla="val 8000"/>
+              <a:gd name="adj" fmla="val 7000"/>
             </a:avLst>
           </a:prstGeom>
           <a:solidFill>
@@ -7383,18 +9143,62 @@
       </p:sp>
       <p:sp>
         <p:nvSpPr>
-          <p:cNvPr id="6" name="Rounded Rectangle 5"/>
+          <p:cNvPr id="8" name="Rectangle 7"/>
           <p:cNvSpPr/>
           <p:nvPr/>
         </p:nvSpPr>
         <p:spPr>
           <a:xfrm>
-            <a:off x="7955279" y="1371600"/>
-            <a:ext cx="3291840" cy="1737360"/>
+            <a:off x="4754880" y="1627632"/>
+            <a:ext cx="502920" cy="50800"/>
+          </a:xfrm>
+          <a:prstGeom prst="rect">
+            <a:avLst/>
+          </a:prstGeom>
+          <a:solidFill>
+            <a:srgbClr val="7FC8A9"/>
+          </a:solidFill>
+          <a:ln>
+            <a:noFill/>
+          </a:ln>
+          <a:effectLst/>
+        </p:spPr>
+        <p:style>
+          <a:lnRef idx="1">
+            <a:schemeClr val="accent1"/>
+          </a:lnRef>
+          <a:fillRef idx="3">
+            <a:schemeClr val="accent1"/>
+          </a:fillRef>
+          <a:effectRef idx="2">
+            <a:schemeClr val="accent1"/>
+          </a:effectRef>
+          <a:fontRef idx="minor">
+            <a:schemeClr val="lt1"/>
+          </a:fontRef>
+        </p:style>
+        <p:txBody>
+          <a:bodyPr rtlCol="0" anchor="ctr" wrap="square"/>
+          <a:lstStyle/>
+          <a:p>
+            <a:pPr algn="ctr"/>
+          </a:p>
+        </p:txBody>
+      </p:sp>
+      <p:sp>
+        <p:nvSpPr>
+          <p:cNvPr id="9" name="Rounded Rectangle 8"/>
+          <p:cNvSpPr/>
+          <p:nvPr/>
+        </p:nvSpPr>
+        <p:spPr>
+          <a:xfrm>
+            <a:off x="7955279" y="1627632"/>
+            <a:ext cx="3291840" cy="1691640"/>
           </a:xfrm>
           <a:prstGeom prst="roundRect">
             <a:avLst>
-              <a:gd name="adj" fmla="val 8000"/>
+              <a:gd name="adj" fmla="val 7000"/>
             </a:avLst>
           </a:prstGeom>
           <a:solidFill>
@@ -7452,18 +9256,62 @@
       </p:sp>
       <p:sp>
         <p:nvSpPr>
-          <p:cNvPr id="7" name="Rounded Rectangle 6"/>
+          <p:cNvPr id="10" name="Rectangle 9"/>
           <p:cNvSpPr/>
           <p:nvPr/>
         </p:nvSpPr>
         <p:spPr>
           <a:xfrm>
-            <a:off x="822960" y="3337560"/>
-            <a:ext cx="3291840" cy="1737360"/>
+            <a:off x="8321039" y="1627632"/>
+            <a:ext cx="502920" cy="50800"/>
+          </a:xfrm>
+          <a:prstGeom prst="rect">
+            <a:avLst/>
+          </a:prstGeom>
+          <a:solidFill>
+            <a:srgbClr val="7FC8A9"/>
+          </a:solidFill>
+          <a:ln>
+            <a:noFill/>
+          </a:ln>
+          <a:effectLst/>
+        </p:spPr>
+        <p:style>
+          <a:lnRef idx="1">
+            <a:schemeClr val="accent1"/>
+          </a:lnRef>
+          <a:fillRef idx="3">
+            <a:schemeClr val="accent1"/>
+          </a:fillRef>
+          <a:effectRef idx="2">
+            <a:schemeClr val="accent1"/>
+          </a:effectRef>
+          <a:fontRef idx="minor">
+            <a:schemeClr val="lt1"/>
+          </a:fontRef>
+        </p:style>
+        <p:txBody>
+          <a:bodyPr rtlCol="0" anchor="ctr" wrap="square"/>
+          <a:lstStyle/>
+          <a:p>
+            <a:pPr algn="ctr"/>
+          </a:p>
+        </p:txBody>
+      </p:sp>
+      <p:sp>
+        <p:nvSpPr>
+          <p:cNvPr id="11" name="Rounded Rectangle 10"/>
+          <p:cNvSpPr/>
+          <p:nvPr/>
+        </p:nvSpPr>
+        <p:spPr>
+          <a:xfrm>
+            <a:off x="822960" y="3547872"/>
+            <a:ext cx="3291840" cy="1691640"/>
           </a:xfrm>
           <a:prstGeom prst="roundRect">
             <a:avLst>
-              <a:gd name="adj" fmla="val 8000"/>
+              <a:gd name="adj" fmla="val 7000"/>
             </a:avLst>
           </a:prstGeom>
           <a:solidFill>
@@ -7521,18 +9369,62 @@
       </p:sp>
       <p:sp>
         <p:nvSpPr>
-          <p:cNvPr id="8" name="Rounded Rectangle 7"/>
+          <p:cNvPr id="12" name="Rectangle 11"/>
           <p:cNvSpPr/>
           <p:nvPr/>
         </p:nvSpPr>
         <p:spPr>
           <a:xfrm>
-            <a:off x="4389120" y="3337560"/>
-            <a:ext cx="3291840" cy="1737360"/>
+            <a:off x="1188720" y="3547872"/>
+            <a:ext cx="502920" cy="50800"/>
+          </a:xfrm>
+          <a:prstGeom prst="rect">
+            <a:avLst/>
+          </a:prstGeom>
+          <a:solidFill>
+            <a:srgbClr val="7FC8A9"/>
+          </a:solidFill>
+          <a:ln>
+            <a:noFill/>
+          </a:ln>
+          <a:effectLst/>
+        </p:spPr>
+        <p:style>
+          <a:lnRef idx="1">
+            <a:schemeClr val="accent1"/>
+          </a:lnRef>
+          <a:fillRef idx="3">
+            <a:schemeClr val="accent1"/>
+          </a:fillRef>
+          <a:effectRef idx="2">
+            <a:schemeClr val="accent1"/>
+          </a:effectRef>
+          <a:fontRef idx="minor">
+            <a:schemeClr val="lt1"/>
+          </a:fontRef>
+        </p:style>
+        <p:txBody>
+          <a:bodyPr rtlCol="0" anchor="ctr" wrap="square"/>
+          <a:lstStyle/>
+          <a:p>
+            <a:pPr algn="ctr"/>
+          </a:p>
+        </p:txBody>
+      </p:sp>
+      <p:sp>
+        <p:nvSpPr>
+          <p:cNvPr id="13" name="Rounded Rectangle 12"/>
+          <p:cNvSpPr/>
+          <p:nvPr/>
+        </p:nvSpPr>
+        <p:spPr>
+          <a:xfrm>
+            <a:off x="4389120" y="3547872"/>
+            <a:ext cx="3291840" cy="1691640"/>
           </a:xfrm>
           <a:prstGeom prst="roundRect">
             <a:avLst>
-              <a:gd name="adj" fmla="val 8000"/>
+              <a:gd name="adj" fmla="val 7000"/>
             </a:avLst>
           </a:prstGeom>
           <a:solidFill>
@@ -7590,18 +9482,62 @@
       </p:sp>
       <p:sp>
         <p:nvSpPr>
-          <p:cNvPr id="9" name="Rounded Rectangle 8"/>
+          <p:cNvPr id="14" name="Rectangle 13"/>
           <p:cNvSpPr/>
           <p:nvPr/>
         </p:nvSpPr>
         <p:spPr>
           <a:xfrm>
-            <a:off x="7955279" y="3337560"/>
-            <a:ext cx="3291840" cy="1737360"/>
+            <a:off x="4754880" y="3547872"/>
+            <a:ext cx="502920" cy="50800"/>
+          </a:xfrm>
+          <a:prstGeom prst="rect">
+            <a:avLst/>
+          </a:prstGeom>
+          <a:solidFill>
+            <a:srgbClr val="7FC8A9"/>
+          </a:solidFill>
+          <a:ln>
+            <a:noFill/>
+          </a:ln>
+          <a:effectLst/>
+        </p:spPr>
+        <p:style>
+          <a:lnRef idx="1">
+            <a:schemeClr val="accent1"/>
+          </a:lnRef>
+          <a:fillRef idx="3">
+            <a:schemeClr val="accent1"/>
+          </a:fillRef>
+          <a:effectRef idx="2">
+            <a:schemeClr val="accent1"/>
+          </a:effectRef>
+          <a:fontRef idx="minor">
+            <a:schemeClr val="lt1"/>
+          </a:fontRef>
+        </p:style>
+        <p:txBody>
+          <a:bodyPr rtlCol="0" anchor="ctr" wrap="square"/>
+          <a:lstStyle/>
+          <a:p>
+            <a:pPr algn="ctr"/>
+          </a:p>
+        </p:txBody>
+      </p:sp>
+      <p:sp>
+        <p:nvSpPr>
+          <p:cNvPr id="15" name="Rounded Rectangle 14"/>
+          <p:cNvSpPr/>
+          <p:nvPr/>
+        </p:nvSpPr>
+        <p:spPr>
+          <a:xfrm>
+            <a:off x="7955279" y="3547872"/>
+            <a:ext cx="3291840" cy="1691640"/>
           </a:xfrm>
           <a:prstGeom prst="roundRect">
             <a:avLst>
-              <a:gd name="adj" fmla="val 8000"/>
+              <a:gd name="adj" fmla="val 7000"/>
             </a:avLst>
           </a:prstGeom>
           <a:solidFill>
@@ -7659,7 +9595,88 @@
       </p:sp>
       <p:sp>
         <p:nvSpPr>
-          <p:cNvPr id="10" name="TextBox 9"/>
+          <p:cNvPr id="16" name="Rectangle 15"/>
+          <p:cNvSpPr/>
+          <p:nvPr/>
+        </p:nvSpPr>
+        <p:spPr>
+          <a:xfrm>
+            <a:off x="8321039" y="3547872"/>
+            <a:ext cx="502920" cy="50800"/>
+          </a:xfrm>
+          <a:prstGeom prst="rect">
+            <a:avLst/>
+          </a:prstGeom>
+          <a:solidFill>
+            <a:srgbClr val="7FC8A9"/>
+          </a:solidFill>
+          <a:ln>
+            <a:noFill/>
+          </a:ln>
+          <a:effectLst/>
+        </p:spPr>
+        <p:style>
+          <a:lnRef idx="1">
+            <a:schemeClr val="accent1"/>
+          </a:lnRef>
+          <a:fillRef idx="3">
+            <a:schemeClr val="accent1"/>
+          </a:fillRef>
+          <a:effectRef idx="2">
+            <a:schemeClr val="accent1"/>
+          </a:effectRef>
+          <a:fontRef idx="minor">
+            <a:schemeClr val="lt1"/>
+          </a:fontRef>
+        </p:style>
+        <p:txBody>
+          <a:bodyPr rtlCol="0" anchor="ctr" wrap="square"/>
+          <a:lstStyle/>
+          <a:p>
+            <a:pPr algn="ctr"/>
+          </a:p>
+        </p:txBody>
+      </p:sp>
+      <p:sp>
+        <p:nvSpPr>
+          <p:cNvPr id="17" name="TextBox 16"/>
+          <p:cNvSpPr txBox="1"/>
+          <p:nvPr/>
+        </p:nvSpPr>
+        <p:spPr>
+          <a:xfrm>
+            <a:off x="822960" y="6473952"/>
+            <a:ext cx="7315200" cy="274320"/>
+          </a:xfrm>
+          <a:prstGeom prst="rect">
+            <a:avLst/>
+          </a:prstGeom>
+          <a:noFill/>
+          <a:effectLst/>
+        </p:spPr>
+        <p:txBody>
+          <a:bodyPr wrap="square" lIns="50800" rIns="50800">
+            <a:spAutoFit/>
+          </a:bodyPr>
+          <a:lstStyle/>
+          <a:p>
+            <a:pPr algn="l"/>
+            <a:r>
+              <a:rPr sz="1000" b="0">
+                <a:solidFill>
+                  <a:srgbClr val="9AA7BC"/>
+                </a:solidFill>
+                <a:latin typeface="Segoe UI"/>
+                <a:ea typeface="Microsoft YaHei"/>
+              </a:rPr>
+              <a:t>DCC-MCP 框架介绍</a:t>
+            </a:r>
+          </a:p>
+        </p:txBody>
+      </p:sp>
+      <p:sp>
+        <p:nvSpPr>
+          <p:cNvPr id="18" name="TextBox 17"/>
           <p:cNvSpPr txBox="1"/>
           <p:nvPr/>
         </p:nvSpPr>
@@ -7802,13 +9819,57 @@
       </p:sp>
       <p:sp>
         <p:nvSpPr>
-          <p:cNvPr id="4" name="TextBox 3"/>
+          <p:cNvPr id="4" name="Oval 3"/>
+          <p:cNvSpPr/>
+          <p:nvPr/>
+        </p:nvSpPr>
+        <p:spPr>
+          <a:xfrm>
+            <a:off x="9601200" y="320040"/>
+            <a:ext cx="2468880" cy="2468880"/>
+          </a:xfrm>
+          <a:prstGeom prst="ellipse">
+            <a:avLst/>
+          </a:prstGeom>
+          <a:solidFill>
+            <a:srgbClr val="223047"/>
+          </a:solidFill>
+          <a:ln>
+            <a:noFill/>
+          </a:ln>
+          <a:effectLst/>
+        </p:spPr>
+        <p:style>
+          <a:lnRef idx="1">
+            <a:schemeClr val="accent1"/>
+          </a:lnRef>
+          <a:fillRef idx="3">
+            <a:schemeClr val="accent1"/>
+          </a:fillRef>
+          <a:effectRef idx="2">
+            <a:schemeClr val="accent1"/>
+          </a:effectRef>
+          <a:fontRef idx="minor">
+            <a:schemeClr val="lt1"/>
+          </a:fontRef>
+        </p:style>
+        <p:txBody>
+          <a:bodyPr rtlCol="0" anchor="ctr"/>
+          <a:lstStyle/>
+          <a:p>
+            <a:pPr algn="ctr"/>
+          </a:p>
+        </p:txBody>
+      </p:sp>
+      <p:sp>
+        <p:nvSpPr>
+          <p:cNvPr id="5" name="TextBox 4"/>
           <p:cNvSpPr txBox="1"/>
           <p:nvPr/>
         </p:nvSpPr>
         <p:spPr>
           <a:xfrm>
-            <a:off x="640080" y="548640"/>
+            <a:off x="640080" y="640080"/>
             <a:ext cx="4572000" cy="3840480"/>
           </a:xfrm>
           <a:prstGeom prst="rect">
@@ -7839,13 +9900,13 @@
       </p:sp>
       <p:sp>
         <p:nvSpPr>
-          <p:cNvPr id="5" name="Rectangle 4"/>
+          <p:cNvPr id="6" name="Rectangle 5"/>
           <p:cNvSpPr/>
           <p:nvPr/>
         </p:nvSpPr>
         <p:spPr>
           <a:xfrm>
-            <a:off x="822960" y="2880360"/>
+            <a:off x="822960" y="2788920"/>
             <a:ext cx="164592" cy="1097280"/>
           </a:xfrm>
           <a:prstGeom prst="rect">
@@ -7883,13 +9944,13 @@
       </p:sp>
       <p:sp>
         <p:nvSpPr>
-          <p:cNvPr id="6" name="TextBox 5"/>
+          <p:cNvPr id="7" name="TextBox 6"/>
           <p:cNvSpPr txBox="1"/>
           <p:nvPr/>
         </p:nvSpPr>
         <p:spPr>
           <a:xfrm>
-            <a:off x="1188720" y="2834640"/>
+            <a:off x="1188720" y="2743200"/>
             <a:ext cx="10058400" cy="1280160"/>
           </a:xfrm>
           <a:prstGeom prst="rect">
@@ -7920,7 +9981,44 @@
       </p:sp>
       <p:sp>
         <p:nvSpPr>
-          <p:cNvPr id="7" name="TextBox 6"/>
+          <p:cNvPr id="8" name="TextBox 7"/>
+          <p:cNvSpPr txBox="1"/>
+          <p:nvPr/>
+        </p:nvSpPr>
+        <p:spPr>
+          <a:xfrm>
+            <a:off x="822960" y="6473952"/>
+            <a:ext cx="7315200" cy="274320"/>
+          </a:xfrm>
+          <a:prstGeom prst="rect">
+            <a:avLst/>
+          </a:prstGeom>
+          <a:noFill/>
+          <a:effectLst/>
+        </p:spPr>
+        <p:txBody>
+          <a:bodyPr wrap="square" lIns="50800" rIns="50800">
+            <a:spAutoFit/>
+          </a:bodyPr>
+          <a:lstStyle/>
+          <a:p>
+            <a:pPr algn="l"/>
+            <a:r>
+              <a:rPr sz="1000" b="0">
+                <a:solidFill>
+                  <a:srgbClr val="9AA7BC"/>
+                </a:solidFill>
+                <a:latin typeface="Segoe UI"/>
+                <a:ea typeface="Microsoft YaHei"/>
+              </a:rPr>
+              <a:t>DCC-MCP 框架介绍</a:t>
+            </a:r>
+          </a:p>
+        </p:txBody>
+      </p:sp>
+      <p:sp>
+        <p:nvSpPr>
+          <p:cNvPr id="9" name="TextBox 8"/>
           <p:cNvSpPr txBox="1"/>
           <p:nvPr/>
         </p:nvSpPr>
@@ -8025,8 +10123,8 @@
         </p:nvSpPr>
         <p:spPr>
           <a:xfrm>
-            <a:off x="822960" y="457200"/>
-            <a:ext cx="10515600" cy="731520"/>
+            <a:off x="822960" y="502920"/>
+            <a:ext cx="10515600" cy="685800"/>
           </a:xfrm>
           <a:prstGeom prst="rect">
             <a:avLst/>
@@ -8042,7 +10140,7 @@
           <a:p>
             <a:pPr algn="l"/>
             <a:r>
-              <a:rPr sz="3000" b="1">
+              <a:rPr sz="2800" b="1">
                 <a:solidFill>
                   <a:srgbClr val="E8ECF2"/>
                 </a:solidFill>
@@ -8062,8 +10160,8 @@
         </p:nvSpPr>
         <p:spPr>
           <a:xfrm>
-            <a:off x="822960" y="3291840"/>
-            <a:ext cx="10515600" cy="38100"/>
+            <a:off x="822960" y="1298448"/>
+            <a:ext cx="822960" cy="44450"/>
           </a:xfrm>
           <a:prstGeom prst="rect">
             <a:avLst/>
@@ -8100,20 +10198,20 @@
       </p:sp>
       <p:sp>
         <p:nvSpPr>
-          <p:cNvPr id="5" name="Oval 4"/>
+          <p:cNvPr id="5" name="Rectangle 4"/>
           <p:cNvSpPr/>
           <p:nvPr/>
         </p:nvSpPr>
         <p:spPr>
           <a:xfrm>
-            <a:off x="1760219" y="3241040"/>
-            <a:ext cx="228600" cy="228600"/>
-          </a:xfrm>
-          <a:prstGeom prst="ellipse">
+            <a:off x="822960" y="3246120"/>
+            <a:ext cx="10515600" cy="38100"/>
+          </a:xfrm>
+          <a:prstGeom prst="rect">
             <a:avLst/>
           </a:prstGeom>
           <a:solidFill>
-            <a:srgbClr val="7FC8A9"/>
+            <a:srgbClr val="4D9DE0"/>
           </a:solidFill>
           <a:ln>
             <a:noFill/>
@@ -8144,60 +10242,25 @@
       </p:sp>
       <p:sp>
         <p:nvSpPr>
-          <p:cNvPr id="6" name="TextBox 5"/>
-          <p:cNvSpPr txBox="1"/>
-          <p:nvPr/>
-        </p:nvSpPr>
-        <p:spPr>
-          <a:xfrm>
-            <a:off x="891539" y="3520440"/>
-            <a:ext cx="1965960" cy="1097280"/>
-          </a:xfrm>
-          <a:prstGeom prst="rect">
-            <a:avLst/>
-          </a:prstGeom>
-          <a:noFill/>
-          <a:effectLst/>
-        </p:spPr>
-        <p:txBody>
-          <a:bodyPr wrap="square" lIns="50800" rIns="50800">
-            <a:spAutoFit/>
-          </a:bodyPr>
-          <a:lstStyle/>
-          <a:p>
-            <a:pPr algn="ctr"/>
-            <a:r>
-              <a:rPr sz="1500" b="0">
-                <a:solidFill>
-                  <a:srgbClr val="E8ECF2"/>
-                </a:solidFill>
-                <a:latin typeface="Segoe UI"/>
-                <a:ea typeface="Microsoft YaHei"/>
-              </a:rPr>
-              <a:t>01  list / search — 渐进式能力发现</a:t>
-            </a:r>
-          </a:p>
-        </p:txBody>
-      </p:sp>
-      <p:sp>
-        <p:nvSpPr>
-          <p:cNvPr id="7" name="Oval 6"/>
+          <p:cNvPr id="6" name="Oval 5"/>
           <p:cNvSpPr/>
           <p:nvPr/>
         </p:nvSpPr>
         <p:spPr>
           <a:xfrm>
-            <a:off x="3863339" y="3241040"/>
-            <a:ext cx="228600" cy="228600"/>
+            <a:off x="1719071" y="3090672"/>
+            <a:ext cx="310896" cy="310896"/>
           </a:xfrm>
           <a:prstGeom prst="ellipse">
             <a:avLst/>
           </a:prstGeom>
           <a:solidFill>
-            <a:srgbClr val="7FC8A9"/>
+            <a:srgbClr val="0F141E"/>
           </a:solidFill>
-          <a:ln>
-            <a:noFill/>
+          <a:ln w="19050">
+            <a:solidFill>
+              <a:srgbClr val="7FC8A9"/>
+            </a:solidFill>
           </a:ln>
           <a:effectLst/>
         </p:spPr>
@@ -8216,23 +10279,33 @@
           </a:fontRef>
         </p:style>
         <p:txBody>
-          <a:bodyPr rtlCol="0" anchor="ctr" wrap="square"/>
+          <a:bodyPr rtlCol="0" anchor="ctr" wrap="square" lIns="101600" rIns="101600" tIns="76200" bIns="76200"/>
           <a:lstStyle/>
           <a:p>
             <a:pPr algn="ctr"/>
-          </a:p>
-        </p:txBody>
-      </p:sp>
-      <p:sp>
-        <p:nvSpPr>
-          <p:cNvPr id="8" name="TextBox 7"/>
+            <a:r>
+              <a:rPr sz="1200" b="1">
+                <a:solidFill>
+                  <a:srgbClr val="7FC8A9"/>
+                </a:solidFill>
+                <a:latin typeface="Segoe UI"/>
+                <a:ea typeface="Microsoft YaHei"/>
+              </a:rPr>
+              <a:t>1</a:t>
+            </a:r>
+          </a:p>
+        </p:txBody>
+      </p:sp>
+      <p:sp>
+        <p:nvSpPr>
+          <p:cNvPr id="7" name="TextBox 6"/>
           <p:cNvSpPr txBox="1"/>
           <p:nvPr/>
         </p:nvSpPr>
         <p:spPr>
           <a:xfrm>
-            <a:off x="2994659" y="3520440"/>
-            <a:ext cx="1965960" cy="1097280"/>
+            <a:off x="960120" y="2103120"/>
+            <a:ext cx="1828799" cy="960120"/>
           </a:xfrm>
           <a:prstGeom prst="rect">
             <a:avLst/>
@@ -8248,37 +10321,39 @@
           <a:p>
             <a:pPr algn="ctr"/>
             <a:r>
-              <a:rPr sz="1500" b="0">
+              <a:rPr sz="1350" b="0">
                 <a:solidFill>
                   <a:srgbClr val="E8ECF2"/>
                 </a:solidFill>
                 <a:latin typeface="Segoe UI"/>
                 <a:ea typeface="Microsoft YaHei"/>
               </a:rPr>
-              <a:t>02  load_skill / describe — 契约与确认级别</a:t>
-            </a:r>
-          </a:p>
-        </p:txBody>
-      </p:sp>
-      <p:sp>
-        <p:nvSpPr>
-          <p:cNvPr id="9" name="Oval 8"/>
+              <a:t>list / search — 渐进式能力发现</a:t>
+            </a:r>
+          </a:p>
+        </p:txBody>
+      </p:sp>
+      <p:sp>
+        <p:nvSpPr>
+          <p:cNvPr id="8" name="Oval 7"/>
           <p:cNvSpPr/>
           <p:nvPr/>
         </p:nvSpPr>
         <p:spPr>
           <a:xfrm>
-            <a:off x="5966460" y="3241040"/>
-            <a:ext cx="228600" cy="228600"/>
+            <a:off x="3822191" y="3090672"/>
+            <a:ext cx="310896" cy="310896"/>
           </a:xfrm>
           <a:prstGeom prst="ellipse">
             <a:avLst/>
           </a:prstGeom>
           <a:solidFill>
-            <a:srgbClr val="7FC8A9"/>
+            <a:srgbClr val="0F141E"/>
           </a:solidFill>
-          <a:ln>
-            <a:noFill/>
+          <a:ln w="19050">
+            <a:solidFill>
+              <a:srgbClr val="7FC8A9"/>
+            </a:solidFill>
           </a:ln>
           <a:effectLst/>
         </p:spPr>
@@ -8297,23 +10372,33 @@
           </a:fontRef>
         </p:style>
         <p:txBody>
-          <a:bodyPr rtlCol="0" anchor="ctr" wrap="square"/>
+          <a:bodyPr rtlCol="0" anchor="ctr" wrap="square" lIns="101600" rIns="101600" tIns="76200" bIns="76200"/>
           <a:lstStyle/>
           <a:p>
             <a:pPr algn="ctr"/>
-          </a:p>
-        </p:txBody>
-      </p:sp>
-      <p:sp>
-        <p:nvSpPr>
-          <p:cNvPr id="10" name="TextBox 9"/>
+            <a:r>
+              <a:rPr sz="1200" b="1">
+                <a:solidFill>
+                  <a:srgbClr val="7FC8A9"/>
+                </a:solidFill>
+                <a:latin typeface="Segoe UI"/>
+                <a:ea typeface="Microsoft YaHei"/>
+              </a:rPr>
+              <a:t>2</a:t>
+            </a:r>
+          </a:p>
+        </p:txBody>
+      </p:sp>
+      <p:sp>
+        <p:nvSpPr>
+          <p:cNvPr id="9" name="TextBox 8"/>
           <p:cNvSpPr txBox="1"/>
           <p:nvPr/>
         </p:nvSpPr>
         <p:spPr>
           <a:xfrm>
-            <a:off x="5097780" y="3520440"/>
-            <a:ext cx="1965960" cy="1097280"/>
+            <a:off x="3063240" y="3566160"/>
+            <a:ext cx="1828799" cy="960120"/>
           </a:xfrm>
           <a:prstGeom prst="rect">
             <a:avLst/>
@@ -8329,37 +10414,39 @@
           <a:p>
             <a:pPr algn="ctr"/>
             <a:r>
-              <a:rPr sz="1500" b="0">
+              <a:rPr sz="1350" b="0">
                 <a:solidFill>
                   <a:srgbClr val="E8ECF2"/>
                 </a:solidFill>
                 <a:latin typeface="Segoe UI"/>
                 <a:ea typeface="Microsoft YaHei"/>
               </a:rPr>
-              <a:t>03  call — 任务级 Capability</a:t>
-            </a:r>
-          </a:p>
-        </p:txBody>
-      </p:sp>
-      <p:sp>
-        <p:nvSpPr>
-          <p:cNvPr id="11" name="Oval 10"/>
+              <a:t>load_skill / describe — 契约与确认级别</a:t>
+            </a:r>
+          </a:p>
+        </p:txBody>
+      </p:sp>
+      <p:sp>
+        <p:nvSpPr>
+          <p:cNvPr id="10" name="Oval 9"/>
           <p:cNvSpPr/>
           <p:nvPr/>
         </p:nvSpPr>
         <p:spPr>
           <a:xfrm>
-            <a:off x="8069579" y="3241040"/>
-            <a:ext cx="228600" cy="228600"/>
+            <a:off x="5925312" y="3090672"/>
+            <a:ext cx="310896" cy="310896"/>
           </a:xfrm>
           <a:prstGeom prst="ellipse">
             <a:avLst/>
           </a:prstGeom>
           <a:solidFill>
-            <a:srgbClr val="7FC8A9"/>
+            <a:srgbClr val="0F141E"/>
           </a:solidFill>
-          <a:ln>
-            <a:noFill/>
+          <a:ln w="19050">
+            <a:solidFill>
+              <a:srgbClr val="7FC8A9"/>
+            </a:solidFill>
           </a:ln>
           <a:effectLst/>
         </p:spPr>
@@ -8378,23 +10465,33 @@
           </a:fontRef>
         </p:style>
         <p:txBody>
-          <a:bodyPr rtlCol="0" anchor="ctr" wrap="square"/>
+          <a:bodyPr rtlCol="0" anchor="ctr" wrap="square" lIns="101600" rIns="101600" tIns="76200" bIns="76200"/>
           <a:lstStyle/>
           <a:p>
             <a:pPr algn="ctr"/>
-          </a:p>
-        </p:txBody>
-      </p:sp>
-      <p:sp>
-        <p:nvSpPr>
-          <p:cNvPr id="12" name="TextBox 11"/>
+            <a:r>
+              <a:rPr sz="1200" b="1">
+                <a:solidFill>
+                  <a:srgbClr val="7FC8A9"/>
+                </a:solidFill>
+                <a:latin typeface="Segoe UI"/>
+                <a:ea typeface="Microsoft YaHei"/>
+              </a:rPr>
+              <a:t>3</a:t>
+            </a:r>
+          </a:p>
+        </p:txBody>
+      </p:sp>
+      <p:sp>
+        <p:nvSpPr>
+          <p:cNvPr id="11" name="TextBox 10"/>
           <p:cNvSpPr txBox="1"/>
           <p:nvPr/>
         </p:nvSpPr>
         <p:spPr>
           <a:xfrm>
-            <a:off x="7200899" y="3520440"/>
-            <a:ext cx="1965960" cy="1097280"/>
+            <a:off x="5166361" y="2103120"/>
+            <a:ext cx="1828799" cy="960120"/>
           </a:xfrm>
           <a:prstGeom prst="rect">
             <a:avLst/>
@@ -8410,37 +10507,39 @@
           <a:p>
             <a:pPr algn="ctr"/>
             <a:r>
-              <a:rPr sz="1500" b="0">
+              <a:rPr sz="1350" b="0">
                 <a:solidFill>
                   <a:srgbClr val="E8ECF2"/>
                 </a:solidFill>
                 <a:latin typeface="Segoe UI"/>
                 <a:ea typeface="Microsoft YaHei"/>
               </a:rPr>
-              <a:t>04  Job — 批处理永不占住连接</a:t>
-            </a:r>
-          </a:p>
-        </p:txBody>
-      </p:sp>
-      <p:sp>
-        <p:nvSpPr>
-          <p:cNvPr id="13" name="Oval 12"/>
+              <a:t>call — 任务级 Capability</a:t>
+            </a:r>
+          </a:p>
+        </p:txBody>
+      </p:sp>
+      <p:sp>
+        <p:nvSpPr>
+          <p:cNvPr id="12" name="Oval 11"/>
           <p:cNvSpPr/>
           <p:nvPr/>
         </p:nvSpPr>
         <p:spPr>
           <a:xfrm>
-            <a:off x="10172700" y="3241040"/>
-            <a:ext cx="228600" cy="228600"/>
+            <a:off x="8028431" y="3090672"/>
+            <a:ext cx="310896" cy="310896"/>
           </a:xfrm>
           <a:prstGeom prst="ellipse">
             <a:avLst/>
           </a:prstGeom>
           <a:solidFill>
-            <a:srgbClr val="7FC8A9"/>
+            <a:srgbClr val="0F141E"/>
           </a:solidFill>
-          <a:ln>
-            <a:noFill/>
+          <a:ln w="19050">
+            <a:solidFill>
+              <a:srgbClr val="7FC8A9"/>
+            </a:solidFill>
           </a:ln>
           <a:effectLst/>
         </p:spPr>
@@ -8459,23 +10558,33 @@
           </a:fontRef>
         </p:style>
         <p:txBody>
-          <a:bodyPr rtlCol="0" anchor="ctr" wrap="square"/>
+          <a:bodyPr rtlCol="0" anchor="ctr" wrap="square" lIns="101600" rIns="101600" tIns="76200" bIns="76200"/>
           <a:lstStyle/>
           <a:p>
             <a:pPr algn="ctr"/>
-          </a:p>
-        </p:txBody>
-      </p:sp>
-      <p:sp>
-        <p:nvSpPr>
-          <p:cNvPr id="14" name="TextBox 13"/>
+            <a:r>
+              <a:rPr sz="1200" b="1">
+                <a:solidFill>
+                  <a:srgbClr val="7FC8A9"/>
+                </a:solidFill>
+                <a:latin typeface="Segoe UI"/>
+                <a:ea typeface="Microsoft YaHei"/>
+              </a:rPr>
+              <a:t>4</a:t>
+            </a:r>
+          </a:p>
+        </p:txBody>
+      </p:sp>
+      <p:sp>
+        <p:nvSpPr>
+          <p:cNvPr id="13" name="TextBox 12"/>
           <p:cNvSpPr txBox="1"/>
           <p:nvPr/>
         </p:nvSpPr>
         <p:spPr>
           <a:xfrm>
-            <a:off x="9304020" y="3520440"/>
-            <a:ext cx="1965960" cy="1097280"/>
+            <a:off x="7269480" y="3566160"/>
+            <a:ext cx="1828799" cy="960120"/>
           </a:xfrm>
           <a:prstGeom prst="rect">
             <a:avLst/>
@@ -8491,14 +10600,70 @@
           <a:p>
             <a:pPr algn="ctr"/>
             <a:r>
-              <a:rPr sz="1500" b="0">
+              <a:rPr sz="1350" b="0">
                 <a:solidFill>
                   <a:srgbClr val="E8ECF2"/>
                 </a:solidFill>
                 <a:latin typeface="Segoe UI"/>
                 <a:ea typeface="Microsoft YaHei"/>
               </a:rPr>
-              <a:t>05  Artifact — 结果、预览、审计可追踪</a:t>
+              <a:t>Job — 批处理永不占住连接</a:t>
+            </a:r>
+          </a:p>
+        </p:txBody>
+      </p:sp>
+      <p:sp>
+        <p:nvSpPr>
+          <p:cNvPr id="14" name="Oval 13"/>
+          <p:cNvSpPr/>
+          <p:nvPr/>
+        </p:nvSpPr>
+        <p:spPr>
+          <a:xfrm>
+            <a:off x="10131552" y="3090672"/>
+            <a:ext cx="310896" cy="310896"/>
+          </a:xfrm>
+          <a:prstGeom prst="ellipse">
+            <a:avLst/>
+          </a:prstGeom>
+          <a:solidFill>
+            <a:srgbClr val="0F141E"/>
+          </a:solidFill>
+          <a:ln w="19050">
+            <a:solidFill>
+              <a:srgbClr val="7FC8A9"/>
+            </a:solidFill>
+          </a:ln>
+          <a:effectLst/>
+        </p:spPr>
+        <p:style>
+          <a:lnRef idx="1">
+            <a:schemeClr val="accent1"/>
+          </a:lnRef>
+          <a:fillRef idx="3">
+            <a:schemeClr val="accent1"/>
+          </a:fillRef>
+          <a:effectRef idx="2">
+            <a:schemeClr val="accent1"/>
+          </a:effectRef>
+          <a:fontRef idx="minor">
+            <a:schemeClr val="lt1"/>
+          </a:fontRef>
+        </p:style>
+        <p:txBody>
+          <a:bodyPr rtlCol="0" anchor="ctr" wrap="square" lIns="101600" rIns="101600" tIns="76200" bIns="76200"/>
+          <a:lstStyle/>
+          <a:p>
+            <a:pPr algn="ctr"/>
+            <a:r>
+              <a:rPr sz="1200" b="1">
+                <a:solidFill>
+                  <a:srgbClr val="7FC8A9"/>
+                </a:solidFill>
+                <a:latin typeface="Segoe UI"/>
+                <a:ea typeface="Microsoft YaHei"/>
+              </a:rPr>
+              <a:t>5</a:t>
             </a:r>
           </a:p>
         </p:txBody>
@@ -8506,6 +10671,80 @@
       <p:sp>
         <p:nvSpPr>
           <p:cNvPr id="15" name="TextBox 14"/>
+          <p:cNvSpPr txBox="1"/>
+          <p:nvPr/>
+        </p:nvSpPr>
+        <p:spPr>
+          <a:xfrm>
+            <a:off x="9372601" y="2103120"/>
+            <a:ext cx="1828799" cy="960120"/>
+          </a:xfrm>
+          <a:prstGeom prst="rect">
+            <a:avLst/>
+          </a:prstGeom>
+          <a:noFill/>
+          <a:effectLst/>
+        </p:spPr>
+        <p:txBody>
+          <a:bodyPr wrap="square" lIns="50800" rIns="50800">
+            <a:spAutoFit/>
+          </a:bodyPr>
+          <a:lstStyle/>
+          <a:p>
+            <a:pPr algn="ctr"/>
+            <a:r>
+              <a:rPr sz="1350" b="0">
+                <a:solidFill>
+                  <a:srgbClr val="E8ECF2"/>
+                </a:solidFill>
+                <a:latin typeface="Segoe UI"/>
+                <a:ea typeface="Microsoft YaHei"/>
+              </a:rPr>
+              <a:t>Artifact — 结果、预览、审计可追踪</a:t>
+            </a:r>
+          </a:p>
+        </p:txBody>
+      </p:sp>
+      <p:sp>
+        <p:nvSpPr>
+          <p:cNvPr id="16" name="TextBox 15"/>
+          <p:cNvSpPr txBox="1"/>
+          <p:nvPr/>
+        </p:nvSpPr>
+        <p:spPr>
+          <a:xfrm>
+            <a:off x="822960" y="6473952"/>
+            <a:ext cx="7315200" cy="274320"/>
+          </a:xfrm>
+          <a:prstGeom prst="rect">
+            <a:avLst/>
+          </a:prstGeom>
+          <a:noFill/>
+          <a:effectLst/>
+        </p:spPr>
+        <p:txBody>
+          <a:bodyPr wrap="square" lIns="50800" rIns="50800">
+            <a:spAutoFit/>
+          </a:bodyPr>
+          <a:lstStyle/>
+          <a:p>
+            <a:pPr algn="l"/>
+            <a:r>
+              <a:rPr sz="1000" b="0">
+                <a:solidFill>
+                  <a:srgbClr val="9AA7BC"/>
+                </a:solidFill>
+                <a:latin typeface="Segoe UI"/>
+                <a:ea typeface="Microsoft YaHei"/>
+              </a:rPr>
+              <a:t>DCC-MCP 框架介绍</a:t>
+            </a:r>
+          </a:p>
+        </p:txBody>
+      </p:sp>
+      <p:sp>
+        <p:nvSpPr>
+          <p:cNvPr id="17" name="TextBox 16"/>
           <p:cNvSpPr txBox="1"/>
           <p:nvPr/>
         </p:nvSpPr>
@@ -8648,13 +10887,57 @@
       </p:sp>
       <p:sp>
         <p:nvSpPr>
-          <p:cNvPr id="4" name="TextBox 3"/>
+          <p:cNvPr id="4" name="Oval 3"/>
+          <p:cNvSpPr/>
+          <p:nvPr/>
+        </p:nvSpPr>
+        <p:spPr>
+          <a:xfrm>
+            <a:off x="9601200" y="320040"/>
+            <a:ext cx="2468880" cy="2468880"/>
+          </a:xfrm>
+          <a:prstGeom prst="ellipse">
+            <a:avLst/>
+          </a:prstGeom>
+          <a:solidFill>
+            <a:srgbClr val="223047"/>
+          </a:solidFill>
+          <a:ln>
+            <a:noFill/>
+          </a:ln>
+          <a:effectLst/>
+        </p:spPr>
+        <p:style>
+          <a:lnRef idx="1">
+            <a:schemeClr val="accent1"/>
+          </a:lnRef>
+          <a:fillRef idx="3">
+            <a:schemeClr val="accent1"/>
+          </a:fillRef>
+          <a:effectRef idx="2">
+            <a:schemeClr val="accent1"/>
+          </a:effectRef>
+          <a:fontRef idx="minor">
+            <a:schemeClr val="lt1"/>
+          </a:fontRef>
+        </p:style>
+        <p:txBody>
+          <a:bodyPr rtlCol="0" anchor="ctr"/>
+          <a:lstStyle/>
+          <a:p>
+            <a:pPr algn="ctr"/>
+          </a:p>
+        </p:txBody>
+      </p:sp>
+      <p:sp>
+        <p:nvSpPr>
+          <p:cNvPr id="5" name="TextBox 4"/>
           <p:cNvSpPr txBox="1"/>
           <p:nvPr/>
         </p:nvSpPr>
         <p:spPr>
           <a:xfrm>
-            <a:off x="640080" y="548640"/>
+            <a:off x="640080" y="640080"/>
             <a:ext cx="4572000" cy="3840480"/>
           </a:xfrm>
           <a:prstGeom prst="rect">
@@ -8685,13 +10968,13 @@
       </p:sp>
       <p:sp>
         <p:nvSpPr>
-          <p:cNvPr id="5" name="Rectangle 4"/>
+          <p:cNvPr id="6" name="Rectangle 5"/>
           <p:cNvSpPr/>
           <p:nvPr/>
         </p:nvSpPr>
         <p:spPr>
           <a:xfrm>
-            <a:off x="822960" y="2880360"/>
+            <a:off x="822960" y="2788920"/>
             <a:ext cx="164592" cy="1097280"/>
           </a:xfrm>
           <a:prstGeom prst="rect">
@@ -8729,13 +11012,13 @@
       </p:sp>
       <p:sp>
         <p:nvSpPr>
-          <p:cNvPr id="6" name="TextBox 5"/>
+          <p:cNvPr id="7" name="TextBox 6"/>
           <p:cNvSpPr txBox="1"/>
           <p:nvPr/>
         </p:nvSpPr>
         <p:spPr>
           <a:xfrm>
-            <a:off x="1188720" y="2834640"/>
+            <a:off x="1188720" y="2743200"/>
             <a:ext cx="10058400" cy="1280160"/>
           </a:xfrm>
           <a:prstGeom prst="rect">
@@ -8766,7 +11049,44 @@
       </p:sp>
       <p:sp>
         <p:nvSpPr>
-          <p:cNvPr id="7" name="TextBox 6"/>
+          <p:cNvPr id="8" name="TextBox 7"/>
+          <p:cNvSpPr txBox="1"/>
+          <p:nvPr/>
+        </p:nvSpPr>
+        <p:spPr>
+          <a:xfrm>
+            <a:off x="822960" y="6473952"/>
+            <a:ext cx="7315200" cy="274320"/>
+          </a:xfrm>
+          <a:prstGeom prst="rect">
+            <a:avLst/>
+          </a:prstGeom>
+          <a:noFill/>
+          <a:effectLst/>
+        </p:spPr>
+        <p:txBody>
+          <a:bodyPr wrap="square" lIns="50800" rIns="50800">
+            <a:spAutoFit/>
+          </a:bodyPr>
+          <a:lstStyle/>
+          <a:p>
+            <a:pPr algn="l"/>
+            <a:r>
+              <a:rPr sz="1000" b="0">
+                <a:solidFill>
+                  <a:srgbClr val="9AA7BC"/>
+                </a:solidFill>
+                <a:latin typeface="Segoe UI"/>
+                <a:ea typeface="Microsoft YaHei"/>
+              </a:rPr>
+              <a:t>DCC-MCP 框架介绍</a:t>
+            </a:r>
+          </a:p>
+        </p:txBody>
+      </p:sp>
+      <p:sp>
+        <p:nvSpPr>
+          <p:cNvPr id="9" name="TextBox 8"/>
           <p:cNvSpPr txBox="1"/>
           <p:nvPr/>
         </p:nvSpPr>

</xml_diff>

<commit_message>
feat: 16-slide showcase deck + standalone packaging verified end-to-end
- deck: add project pipeline + quality/distribution slides (14 -> 16);
  regenerated pptx/pdf/16 previews
- runtime purity: __init__ no longer imports analyze at package import
  (python-pptx is dev-only); subprocess guard test asserts no dev deps
- build_binary: publish the host as a single-file exe
  (PublishSingleFile) so FileManifest.add_path bundles one binary;
  locate the install dir via the exe glob (debug profile nesting)
- packaging CI: pyoxidizer build + smoke (version/compile/inspect) +
  artifact upload, triggered on packaging-relevant paths
- verified locally: standalone exe compiles the 16-slide deck via the
  bundled host, PowerPoint opens the output
</commit_message>
<xml_diff>
--- a/examples/output/draft-dcc-mcp-framework-intro.pptx
+++ b/examples/output/draft-dcc-mcp-framework-intro.pptx
@@ -19,6 +19,8 @@
     <p:sldId id="267" r:id="rId19"/>
     <p:sldId id="268" r:id="rId20"/>
     <p:sldId id="269" r:id="rId21"/>
+    <p:sldId id="270" r:id="rId22"/>
+    <p:sldId id="271" r:id="rId23"/>
   </p:sldIdLst>
   <p:sldSz cx="12191695" cy="6858000" type="screen4x3"/>
   <p:notesSz cx="6858000" cy="9144000"/>
@@ -585,7 +587,7 @@
           <a:lstStyle/>
           <a:p>
             <a:r>
-              <a:t>五步：发现 → 加载 → 调用 → 作业 → 产物。</a:t>
+              <a:t>质量门禁与零依赖分发是项目的两条硬约束。</a:t>
             </a:r>
           </a:p>
         </p:txBody>
@@ -655,7 +657,7 @@
           <a:lstStyle/>
           <a:p>
             <a:r>
-              <a:t>第三部分：Office 域如何复用同一套控制面，形成双后端执行模型。</a:t>
+              <a:t>第二部分：一次调用如何走完发现、执行、批处理与产物闭环。</a:t>
             </a:r>
           </a:p>
         </p:txBody>
@@ -725,7 +727,7 @@
           <a:lstStyle/>
           <a:p>
             <a:r>
-              <a:t>本 PPT 即由该流程生成：Deck IR → Open XML 编译 → COM 渲染。</a:t>
+              <a:t>五步：发现 → 加载 → 调用 → 作业 → 产物。</a:t>
             </a:r>
           </a:p>
         </p:txBody>
@@ -795,7 +797,7 @@
           <a:lstStyle/>
           <a:p>
             <a:r>
-              <a:t>两条主线：执行路径有明确优先级，能力面保持任务级抽象。</a:t>
+              <a:t>第三部分：Office 域如何复用同一套控制面，形成双后端执行模型。</a:t>
             </a:r>
           </a:p>
         </p:txBody>
@@ -865,6 +867,146 @@
           <a:lstStyle/>
           <a:p>
             <a:r>
+              <a:t>本 PPT 即由该流程生成：Deck IR → Open XML 编译 → COM 渲染。</a:t>
+            </a:r>
+          </a:p>
+        </p:txBody>
+      </p:sp>
+      <p:sp>
+        <p:nvSpPr>
+          <p:cNvPr id="4" name="Slide Number Placeholder 3"/>
+          <p:cNvSpPr>
+            <a:spLocks noGrp="1"/>
+          </p:cNvSpPr>
+          <p:nvPr>
+            <p:ph type="sldNum" idx="5" sz="quarter"/>
+          </p:nvPr>
+        </p:nvSpPr>
+        <p:spPr/>
+      </p:sp>
+    </p:spTree>
+  </p:cSld>
+  <p:clrMapOvr>
+    <a:masterClrMapping/>
+  </p:clrMapOvr>
+</p:notes>
+</file>
+
+<file path=ppt/notesSlides/notesSlide15.xml><?xml version="1.0" encoding="utf-8"?>
+<p:notes xmlns:a="http://schemas.openxmlformats.org/drawingml/2006/main" xmlns:p="http://schemas.openxmlformats.org/presentationml/2006/main" xmlns:r="http://schemas.openxmlformats.org/officeDocument/2006/relationships">
+  <p:cSld>
+    <p:spTree>
+      <p:nvGrpSpPr>
+        <p:cNvPr id="1" name=""/>
+        <p:cNvGrpSpPr/>
+        <p:nvPr/>
+      </p:nvGrpSpPr>
+      <p:grpSpPr>
+        <a:xfrm>
+          <a:off x="0" y="0"/>
+          <a:ext cx="0" cy="0"/>
+          <a:chOff x="0" y="0"/>
+          <a:chExt cx="0" cy="0"/>
+        </a:xfrm>
+      </p:grpSpPr>
+      <p:sp>
+        <p:nvSpPr>
+          <p:cNvPr id="2" name="Slide Image Placeholder 1"/>
+          <p:cNvSpPr>
+            <a:spLocks noGrp="1"/>
+          </p:cNvSpPr>
+          <p:nvPr>
+            <p:ph type="sldImg" idx="2"/>
+          </p:nvPr>
+        </p:nvSpPr>
+        <p:spPr/>
+      </p:sp>
+      <p:sp>
+        <p:nvSpPr>
+          <p:cNvPr id="3" name="Notes Placeholder 2"/>
+          <p:cNvSpPr>
+            <a:spLocks noGrp="1"/>
+          </p:cNvSpPr>
+          <p:nvPr>
+            <p:ph type="body" idx="3" sz="quarter"/>
+          </p:nvPr>
+        </p:nvSpPr>
+        <p:spPr/>
+        <p:txBody>
+          <a:bodyPr/>
+          <a:lstStyle/>
+          <a:p>
+            <a:r>
+              <a:t>两条主线：执行路径有明确优先级，能力面保持任务级抽象。</a:t>
+            </a:r>
+          </a:p>
+        </p:txBody>
+      </p:sp>
+      <p:sp>
+        <p:nvSpPr>
+          <p:cNvPr id="4" name="Slide Number Placeholder 3"/>
+          <p:cNvSpPr>
+            <a:spLocks noGrp="1"/>
+          </p:cNvSpPr>
+          <p:nvPr>
+            <p:ph type="sldNum" idx="5" sz="quarter"/>
+          </p:nvPr>
+        </p:nvSpPr>
+        <p:spPr/>
+      </p:sp>
+    </p:spTree>
+  </p:cSld>
+  <p:clrMapOvr>
+    <a:masterClrMapping/>
+  </p:clrMapOvr>
+</p:notes>
+</file>
+
+<file path=ppt/notesSlides/notesSlide16.xml><?xml version="1.0" encoding="utf-8"?>
+<p:notes xmlns:a="http://schemas.openxmlformats.org/drawingml/2006/main" xmlns:p="http://schemas.openxmlformats.org/presentationml/2006/main" xmlns:r="http://schemas.openxmlformats.org/officeDocument/2006/relationships">
+  <p:cSld>
+    <p:spTree>
+      <p:nvGrpSpPr>
+        <p:cNvPr id="1" name=""/>
+        <p:cNvGrpSpPr/>
+        <p:nvPr/>
+      </p:nvGrpSpPr>
+      <p:grpSpPr>
+        <a:xfrm>
+          <a:off x="0" y="0"/>
+          <a:ext cx="0" cy="0"/>
+          <a:chOff x="0" y="0"/>
+          <a:chExt cx="0" cy="0"/>
+        </a:xfrm>
+      </p:grpSpPr>
+      <p:sp>
+        <p:nvSpPr>
+          <p:cNvPr id="2" name="Slide Image Placeholder 1"/>
+          <p:cNvSpPr>
+            <a:spLocks noGrp="1"/>
+          </p:cNvSpPr>
+          <p:nvPr>
+            <p:ph type="sldImg" idx="2"/>
+          </p:nvPr>
+        </p:nvSpPr>
+        <p:spPr/>
+      </p:sp>
+      <p:sp>
+        <p:nvSpPr>
+          <p:cNvPr id="3" name="Notes Placeholder 2"/>
+          <p:cNvSpPr>
+            <a:spLocks noGrp="1"/>
+          </p:cNvSpPr>
+          <p:nvPr>
+            <p:ph type="body" idx="3" sz="quarter"/>
+          </p:nvPr>
+        </p:nvSpPr>
+        <p:spPr/>
+        <p:txBody>
+          <a:bodyPr/>
+          <a:lstStyle/>
+          <a:p>
+            <a:r>
               <a:t>收尾：欢迎共建适配器与技能包。</a:t>
             </a:r>
           </a:p>
@@ -1425,7 +1567,7 @@
           <a:lstStyle/>
           <a:p>
             <a:r>
-              <a:t>第二部分：一次调用如何走完发现、执行、批处理与产物闭环。</a:t>
+              <a:t>本 Deck 即由这条管线生成：IR → C# 宿主 → COM 渲染。</a:t>
             </a:r>
           </a:p>
         </p:txBody>
@@ -4619,6 +4761,7 @@
                 </a:solidFill>
                 <a:latin typeface="Segoe UI"/>
                 <a:ea typeface="Microsoft YaHei"/>
+                <a:cs typeface="Segoe UI"/>
               </a:rPr>
               <a:t>DCC-MCP</a:t>
             </a:r>
@@ -4700,6 +4843,7 @@
                 </a:solidFill>
                 <a:latin typeface="Segoe UI"/>
                 <a:ea typeface="Microsoft YaHei"/>
+                <a:cs typeface="Segoe UI"/>
               </a:rPr>
               <a:t>多 DCC 统一智能体网关框架</a:t>
             </a:r>
@@ -4713,6 +4857,7 @@
                 </a:solidFill>
                 <a:latin typeface="Segoe UI"/>
                 <a:ea typeface="Microsoft YaHei"/>
+                <a:cs typeface="Segoe UI"/>
               </a:rPr>
               <a:t>让 AI 进入每一个创作工具 · Maya / Blender / Houdini / Photoshop / Unity / Office</a:t>
             </a:r>
@@ -4750,6 +4895,7 @@
                 </a:solidFill>
                 <a:latin typeface="Segoe UI"/>
                 <a:ea typeface="Microsoft YaHei"/>
+                <a:cs typeface="Segoe UI"/>
               </a:rPr>
               <a:t>DCC-MCP 框架介绍 · draft:dcc-mcp-framework-intro</a:t>
             </a:r>
@@ -4787,6 +4933,7 @@
                 </a:solidFill>
                 <a:latin typeface="Segoe UI"/>
                 <a:ea typeface="Microsoft YaHei"/>
+                <a:cs typeface="Segoe UI"/>
               </a:rPr>
               <a:t>DCC-MCP 框架介绍</a:t>
             </a:r>
@@ -4824,8 +4971,9 @@
                 </a:solidFill>
                 <a:latin typeface="Segoe UI"/>
                 <a:ea typeface="Microsoft YaHei"/>
+                <a:cs typeface="Segoe UI"/>
               </a:rPr>
-              <a:t>01 / 14</a:t>
+              <a:t>01 / 16</a:t>
             </a:r>
           </a:p>
         </p:txBody>
@@ -4923,8 +5071,9 @@
                 </a:solidFill>
                 <a:latin typeface="Segoe UI"/>
                 <a:ea typeface="Microsoft YaHei"/>
+                <a:cs typeface="Segoe UI"/>
               </a:rPr>
-              <a:t>一次调用的旅程</a:t>
+              <a:t>质量与分发</a:t>
             </a:r>
           </a:p>
         </p:txBody>
@@ -4975,20 +5124,20 @@
       </p:sp>
       <p:sp>
         <p:nvSpPr>
-          <p:cNvPr id="5" name="Rectangle 4"/>
+          <p:cNvPr id="5" name="Oval 4"/>
           <p:cNvSpPr/>
           <p:nvPr/>
         </p:nvSpPr>
         <p:spPr>
           <a:xfrm>
-            <a:off x="822960" y="3246120"/>
-            <a:ext cx="10515600" cy="38100"/>
-          </a:xfrm>
-          <a:prstGeom prst="rect">
+            <a:off x="868680" y="1783080"/>
+            <a:ext cx="165100" cy="165100"/>
+          </a:xfrm>
+          <a:prstGeom prst="ellipse">
             <a:avLst/>
           </a:prstGeom>
           <a:solidFill>
-            <a:srgbClr val="4D9DE0"/>
+            <a:srgbClr val="7FC8A9"/>
           </a:solidFill>
           <a:ln>
             <a:noFill/>
@@ -5019,25 +5168,61 @@
       </p:sp>
       <p:sp>
         <p:nvSpPr>
-          <p:cNvPr id="6" name="Oval 5"/>
+          <p:cNvPr id="6" name="TextBox 5"/>
+          <p:cNvSpPr txBox="1"/>
+          <p:nvPr/>
+        </p:nvSpPr>
+        <p:spPr>
+          <a:xfrm>
+            <a:off x="1234440" y="1627632"/>
+            <a:ext cx="10012680" cy="822960"/>
+          </a:xfrm>
+          <a:prstGeom prst="rect">
+            <a:avLst/>
+          </a:prstGeom>
+          <a:noFill/>
+          <a:effectLst/>
+        </p:spPr>
+        <p:txBody>
+          <a:bodyPr wrap="square" lIns="50800" rIns="50800">
+            <a:spAutoFit/>
+          </a:bodyPr>
+          <a:lstStyle/>
+          <a:p>
+            <a:pPr algn="l"/>
+            <a:r>
+              <a:rPr sz="1650" b="0">
+                <a:solidFill>
+                  <a:srgbClr val="E8ECF2"/>
+                </a:solidFill>
+                <a:latin typeface="Segoe UI"/>
+                <a:ea typeface="Microsoft YaHei"/>
+                <a:cs typeface="Segoe UI"/>
+              </a:rPr>
+              <a:t>官方 dcc-mcp-cli lint：4 个技能包 0 错误 0 警告</a:t>
+            </a:r>
+          </a:p>
+        </p:txBody>
+      </p:sp>
+      <p:sp>
+        <p:nvSpPr>
+          <p:cNvPr id="7" name="Rectangle 6"/>
           <p:cNvSpPr/>
           <p:nvPr/>
         </p:nvSpPr>
         <p:spPr>
           <a:xfrm>
-            <a:off x="1719071" y="3090672"/>
-            <a:ext cx="310896" cy="310896"/>
-          </a:xfrm>
-          <a:prstGeom prst="ellipse">
+            <a:off x="822960" y="2496312"/>
+            <a:ext cx="10515600" cy="15240"/>
+          </a:xfrm>
+          <a:prstGeom prst="rect">
             <a:avLst/>
           </a:prstGeom>
           <a:solidFill>
-            <a:srgbClr val="0F141E"/>
+            <a:srgbClr val="223047"/>
           </a:solidFill>
-          <a:ln w="19050">
-            <a:solidFill>
-              <a:srgbClr val="7FC8A9"/>
-            </a:solidFill>
+          <a:ln>
+            <a:noFill/>
           </a:ln>
           <a:effectLst/>
         </p:spPr>
@@ -5056,57 +5241,10 @@
           </a:fontRef>
         </p:style>
         <p:txBody>
-          <a:bodyPr rtlCol="0" anchor="ctr" wrap="square" lIns="101600" rIns="101600" tIns="76200" bIns="76200"/>
-          <a:lstStyle/>
-          <a:p>
-            <a:pPr algn="ctr"/>
-            <a:r>
-              <a:rPr sz="1200" b="1">
-                <a:solidFill>
-                  <a:srgbClr val="7FC8A9"/>
-                </a:solidFill>
-                <a:latin typeface="Segoe UI"/>
-                <a:ea typeface="Microsoft YaHei"/>
-              </a:rPr>
-              <a:t>1</a:t>
-            </a:r>
-          </a:p>
-        </p:txBody>
-      </p:sp>
-      <p:sp>
-        <p:nvSpPr>
-          <p:cNvPr id="7" name="TextBox 6"/>
-          <p:cNvSpPr txBox="1"/>
-          <p:nvPr/>
-        </p:nvSpPr>
-        <p:spPr>
-          <a:xfrm>
-            <a:off x="960120" y="2103120"/>
-            <a:ext cx="1828799" cy="960120"/>
-          </a:xfrm>
-          <a:prstGeom prst="rect">
-            <a:avLst/>
-          </a:prstGeom>
-          <a:noFill/>
-          <a:effectLst/>
-        </p:spPr>
-        <p:txBody>
-          <a:bodyPr wrap="square" lIns="50800" rIns="50800">
-            <a:spAutoFit/>
-          </a:bodyPr>
-          <a:lstStyle/>
-          <a:p>
-            <a:pPr algn="ctr"/>
-            <a:r>
-              <a:rPr sz="1350" b="0">
-                <a:solidFill>
-                  <a:srgbClr val="E8ECF2"/>
-                </a:solidFill>
-                <a:latin typeface="Segoe UI"/>
-                <a:ea typeface="Microsoft YaHei"/>
-              </a:rPr>
-              <a:t>list / search — 渐进式能力发现</a:t>
-            </a:r>
+          <a:bodyPr rtlCol="0" anchor="ctr" wrap="square"/>
+          <a:lstStyle/>
+          <a:p>
+            <a:pPr algn="ctr"/>
           </a:p>
         </p:txBody>
       </p:sp>
@@ -5118,19 +5256,17 @@
         </p:nvSpPr>
         <p:spPr>
           <a:xfrm>
-            <a:off x="3822191" y="3090672"/>
-            <a:ext cx="310896" cy="310896"/>
+            <a:off x="868680" y="2715768"/>
+            <a:ext cx="165100" cy="165100"/>
           </a:xfrm>
           <a:prstGeom prst="ellipse">
             <a:avLst/>
           </a:prstGeom>
           <a:solidFill>
-            <a:srgbClr val="0F141E"/>
+            <a:srgbClr val="7FC8A9"/>
           </a:solidFill>
-          <a:ln w="19050">
-            <a:solidFill>
-              <a:srgbClr val="7FC8A9"/>
-            </a:solidFill>
+          <a:ln>
+            <a:noFill/>
           </a:ln>
           <a:effectLst/>
         </p:spPr>
@@ -5149,20 +5285,10 @@
           </a:fontRef>
         </p:style>
         <p:txBody>
-          <a:bodyPr rtlCol="0" anchor="ctr" wrap="square" lIns="101600" rIns="101600" tIns="76200" bIns="76200"/>
-          <a:lstStyle/>
-          <a:p>
-            <a:pPr algn="ctr"/>
-            <a:r>
-              <a:rPr sz="1200" b="1">
-                <a:solidFill>
-                  <a:srgbClr val="7FC8A9"/>
-                </a:solidFill>
-                <a:latin typeface="Segoe UI"/>
-                <a:ea typeface="Microsoft YaHei"/>
-              </a:rPr>
-              <a:t>2</a:t>
-            </a:r>
+          <a:bodyPr rtlCol="0" anchor="ctr" wrap="square"/>
+          <a:lstStyle/>
+          <a:p>
+            <a:pPr algn="ctr"/>
           </a:p>
         </p:txBody>
       </p:sp>
@@ -5174,8 +5300,8 @@
         </p:nvSpPr>
         <p:spPr>
           <a:xfrm>
-            <a:off x="3063240" y="3566160"/>
-            <a:ext cx="1828799" cy="960120"/>
+            <a:off x="1234440" y="2560320"/>
+            <a:ext cx="10012680" cy="822960"/>
           </a:xfrm>
           <a:prstGeom prst="rect">
             <a:avLst/>
@@ -5189,41 +5315,40 @@
           </a:bodyPr>
           <a:lstStyle/>
           <a:p>
-            <a:pPr algn="ctr"/>
-            <a:r>
-              <a:rPr sz="1350" b="0">
+            <a:pPr algn="l"/>
+            <a:r>
+              <a:rPr sz="1650" b="0">
                 <a:solidFill>
                   <a:srgbClr val="E8ECF2"/>
                 </a:solidFill>
                 <a:latin typeface="Segoe UI"/>
                 <a:ea typeface="Microsoft YaHei"/>
+                <a:cs typeface="Segoe UI"/>
               </a:rPr>
-              <a:t>load_skill / describe — 契约与确认级别</a:t>
-            </a:r>
-          </a:p>
-        </p:txBody>
-      </p:sp>
-      <p:sp>
-        <p:nvSpPr>
-          <p:cNvPr id="10" name="Oval 9"/>
+              <a:t>pytest 35 用例 · ruff 0 错误 · CI 全绿后 squash 合并</a:t>
+            </a:r>
+          </a:p>
+        </p:txBody>
+      </p:sp>
+      <p:sp>
+        <p:nvSpPr>
+          <p:cNvPr id="10" name="Rectangle 9"/>
           <p:cNvSpPr/>
           <p:nvPr/>
         </p:nvSpPr>
         <p:spPr>
           <a:xfrm>
-            <a:off x="5925312" y="3090672"/>
-            <a:ext cx="310896" cy="310896"/>
-          </a:xfrm>
-          <a:prstGeom prst="ellipse">
+            <a:off x="822960" y="3429000"/>
+            <a:ext cx="10515600" cy="15240"/>
+          </a:xfrm>
+          <a:prstGeom prst="rect">
             <a:avLst/>
           </a:prstGeom>
           <a:solidFill>
-            <a:srgbClr val="0F141E"/>
+            <a:srgbClr val="223047"/>
           </a:solidFill>
-          <a:ln w="19050">
-            <a:solidFill>
-              <a:srgbClr val="7FC8A9"/>
-            </a:solidFill>
+          <a:ln>
+            <a:noFill/>
           </a:ln>
           <a:effectLst/>
         </p:spPr>
@@ -5242,81 +5367,32 @@
           </a:fontRef>
         </p:style>
         <p:txBody>
-          <a:bodyPr rtlCol="0" anchor="ctr" wrap="square" lIns="101600" rIns="101600" tIns="76200" bIns="76200"/>
-          <a:lstStyle/>
-          <a:p>
-            <a:pPr algn="ctr"/>
-            <a:r>
-              <a:rPr sz="1200" b="1">
-                <a:solidFill>
-                  <a:srgbClr val="7FC8A9"/>
-                </a:solidFill>
-                <a:latin typeface="Segoe UI"/>
-                <a:ea typeface="Microsoft YaHei"/>
-              </a:rPr>
-              <a:t>3</a:t>
-            </a:r>
-          </a:p>
-        </p:txBody>
-      </p:sp>
-      <p:sp>
-        <p:nvSpPr>
-          <p:cNvPr id="11" name="TextBox 10"/>
-          <p:cNvSpPr txBox="1"/>
-          <p:nvPr/>
-        </p:nvSpPr>
-        <p:spPr>
-          <a:xfrm>
-            <a:off x="5166361" y="2103120"/>
-            <a:ext cx="1828799" cy="960120"/>
-          </a:xfrm>
-          <a:prstGeom prst="rect">
-            <a:avLst/>
-          </a:prstGeom>
-          <a:noFill/>
-          <a:effectLst/>
-        </p:spPr>
-        <p:txBody>
-          <a:bodyPr wrap="square" lIns="50800" rIns="50800">
-            <a:spAutoFit/>
-          </a:bodyPr>
-          <a:lstStyle/>
-          <a:p>
-            <a:pPr algn="ctr"/>
-            <a:r>
-              <a:rPr sz="1350" b="0">
-                <a:solidFill>
-                  <a:srgbClr val="E8ECF2"/>
-                </a:solidFill>
-                <a:latin typeface="Segoe UI"/>
-                <a:ea typeface="Microsoft YaHei"/>
-              </a:rPr>
-              <a:t>call — 任务级 Capability</a:t>
-            </a:r>
-          </a:p>
-        </p:txBody>
-      </p:sp>
-      <p:sp>
-        <p:nvSpPr>
-          <p:cNvPr id="12" name="Oval 11"/>
+          <a:bodyPr rtlCol="0" anchor="ctr" wrap="square"/>
+          <a:lstStyle/>
+          <a:p>
+            <a:pPr algn="ctr"/>
+          </a:p>
+        </p:txBody>
+      </p:sp>
+      <p:sp>
+        <p:nvSpPr>
+          <p:cNvPr id="11" name="Oval 10"/>
           <p:cNvSpPr/>
           <p:nvPr/>
         </p:nvSpPr>
         <p:spPr>
           <a:xfrm>
-            <a:off x="8028431" y="3090672"/>
-            <a:ext cx="310896" cy="310896"/>
+            <a:off x="868680" y="3648456"/>
+            <a:ext cx="165100" cy="165100"/>
           </a:xfrm>
           <a:prstGeom prst="ellipse">
             <a:avLst/>
           </a:prstGeom>
           <a:solidFill>
-            <a:srgbClr val="0F141E"/>
+            <a:srgbClr val="7FC8A9"/>
           </a:solidFill>
-          <a:ln w="19050">
-            <a:solidFill>
-              <a:srgbClr val="7FC8A9"/>
-            </a:solidFill>
+          <a:ln>
+            <a:noFill/>
           </a:ln>
           <a:effectLst/>
         </p:spPr>
@@ -5335,33 +5411,23 @@
           </a:fontRef>
         </p:style>
         <p:txBody>
-          <a:bodyPr rtlCol="0" anchor="ctr" wrap="square" lIns="101600" rIns="101600" tIns="76200" bIns="76200"/>
-          <a:lstStyle/>
-          <a:p>
-            <a:pPr algn="ctr"/>
-            <a:r>
-              <a:rPr sz="1200" b="1">
-                <a:solidFill>
-                  <a:srgbClr val="7FC8A9"/>
-                </a:solidFill>
-                <a:latin typeface="Segoe UI"/>
-                <a:ea typeface="Microsoft YaHei"/>
-              </a:rPr>
-              <a:t>4</a:t>
-            </a:r>
-          </a:p>
-        </p:txBody>
-      </p:sp>
-      <p:sp>
-        <p:nvSpPr>
-          <p:cNvPr id="13" name="TextBox 12"/>
+          <a:bodyPr rtlCol="0" anchor="ctr" wrap="square"/>
+          <a:lstStyle/>
+          <a:p>
+            <a:pPr algn="ctr"/>
+          </a:p>
+        </p:txBody>
+      </p:sp>
+      <p:sp>
+        <p:nvSpPr>
+          <p:cNvPr id="12" name="TextBox 11"/>
           <p:cNvSpPr txBox="1"/>
           <p:nvPr/>
         </p:nvSpPr>
         <p:spPr>
           <a:xfrm>
-            <a:off x="7269480" y="3566160"/>
-            <a:ext cx="1828799" cy="960120"/>
+            <a:off x="1234440" y="3493008"/>
+            <a:ext cx="10012680" cy="822960"/>
           </a:xfrm>
           <a:prstGeom prst="rect">
             <a:avLst/>
@@ -5375,41 +5441,40 @@
           </a:bodyPr>
           <a:lstStyle/>
           <a:p>
-            <a:pPr algn="ctr"/>
-            <a:r>
-              <a:rPr sz="1350" b="0">
+            <a:pPr algn="l"/>
+            <a:r>
+              <a:rPr sz="1650" b="0">
                 <a:solidFill>
                   <a:srgbClr val="E8ECF2"/>
                 </a:solidFill>
                 <a:latin typeface="Segoe UI"/>
                 <a:ea typeface="Microsoft YaHei"/>
+                <a:cs typeface="Segoe UI"/>
               </a:rPr>
-              <a:t>Job — 批处理永不占住连接</a:t>
-            </a:r>
-          </a:p>
-        </p:txBody>
-      </p:sp>
-      <p:sp>
-        <p:nvSpPr>
-          <p:cNvPr id="14" name="Oval 13"/>
+              <a:t>运行时零第三方依赖：Python 只用 stdlib，重型接口走 C# 宿主</a:t>
+            </a:r>
+          </a:p>
+        </p:txBody>
+      </p:sp>
+      <p:sp>
+        <p:nvSpPr>
+          <p:cNvPr id="13" name="Rectangle 12"/>
           <p:cNvSpPr/>
           <p:nvPr/>
         </p:nvSpPr>
         <p:spPr>
           <a:xfrm>
-            <a:off x="10131552" y="3090672"/>
-            <a:ext cx="310896" cy="310896"/>
-          </a:xfrm>
-          <a:prstGeom prst="ellipse">
+            <a:off x="822960" y="4361688"/>
+            <a:ext cx="10515600" cy="15240"/>
+          </a:xfrm>
+          <a:prstGeom prst="rect">
             <a:avLst/>
           </a:prstGeom>
           <a:solidFill>
-            <a:srgbClr val="0F141E"/>
+            <a:srgbClr val="223047"/>
           </a:solidFill>
-          <a:ln w="19050">
-            <a:solidFill>
-              <a:srgbClr val="7FC8A9"/>
-            </a:solidFill>
+          <a:ln>
+            <a:noFill/>
           </a:ln>
           <a:effectLst/>
         </p:spPr>
@@ -5428,20 +5493,54 @@
           </a:fontRef>
         </p:style>
         <p:txBody>
-          <a:bodyPr rtlCol="0" anchor="ctr" wrap="square" lIns="101600" rIns="101600" tIns="76200" bIns="76200"/>
-          <a:lstStyle/>
-          <a:p>
-            <a:pPr algn="ctr"/>
-            <a:r>
-              <a:rPr sz="1200" b="1">
-                <a:solidFill>
-                  <a:srgbClr val="7FC8A9"/>
-                </a:solidFill>
-                <a:latin typeface="Segoe UI"/>
-                <a:ea typeface="Microsoft YaHei"/>
-              </a:rPr>
-              <a:t>5</a:t>
-            </a:r>
+          <a:bodyPr rtlCol="0" anchor="ctr" wrap="square"/>
+          <a:lstStyle/>
+          <a:p>
+            <a:pPr algn="ctr"/>
+          </a:p>
+        </p:txBody>
+      </p:sp>
+      <p:sp>
+        <p:nvSpPr>
+          <p:cNvPr id="14" name="Oval 13"/>
+          <p:cNvSpPr/>
+          <p:nvPr/>
+        </p:nvSpPr>
+        <p:spPr>
+          <a:xfrm>
+            <a:off x="868680" y="4581144"/>
+            <a:ext cx="165100" cy="165100"/>
+          </a:xfrm>
+          <a:prstGeom prst="ellipse">
+            <a:avLst/>
+          </a:prstGeom>
+          <a:solidFill>
+            <a:srgbClr val="7FC8A9"/>
+          </a:solidFill>
+          <a:ln>
+            <a:noFill/>
+          </a:ln>
+          <a:effectLst/>
+        </p:spPr>
+        <p:style>
+          <a:lnRef idx="1">
+            <a:schemeClr val="accent1"/>
+          </a:lnRef>
+          <a:fillRef idx="3">
+            <a:schemeClr val="accent1"/>
+          </a:fillRef>
+          <a:effectRef idx="2">
+            <a:schemeClr val="accent1"/>
+          </a:effectRef>
+          <a:fontRef idx="minor">
+            <a:schemeClr val="lt1"/>
+          </a:fontRef>
+        </p:style>
+        <p:txBody>
+          <a:bodyPr rtlCol="0" anchor="ctr" wrap="square"/>
+          <a:lstStyle/>
+          <a:p>
+            <a:pPr algn="ctr"/>
           </a:p>
         </p:txBody>
       </p:sp>
@@ -5453,8 +5552,8 @@
         </p:nvSpPr>
         <p:spPr>
           <a:xfrm>
-            <a:off x="9372601" y="2103120"/>
-            <a:ext cx="1828799" cy="960120"/>
+            <a:off x="1234440" y="4425696"/>
+            <a:ext cx="10012680" cy="822960"/>
           </a:xfrm>
           <a:prstGeom prst="rect">
             <a:avLst/>
@@ -5468,16 +5567,17 @@
           </a:bodyPr>
           <a:lstStyle/>
           <a:p>
-            <a:pPr algn="ctr"/>
-            <a:r>
-              <a:rPr sz="1350" b="0">
+            <a:pPr algn="l"/>
+            <a:r>
+              <a:rPr sz="1650" b="0">
                 <a:solidFill>
                   <a:srgbClr val="E8ECF2"/>
                 </a:solidFill>
                 <a:latin typeface="Segoe UI"/>
                 <a:ea typeface="Microsoft YaHei"/>
+                <a:cs typeface="Segoe UI"/>
               </a:rPr>
-              <a:t>Artifact — 结果、预览、审计可追踪</a:t>
+              <a:t>PyOxidizer 独立可执行文件分发（photoshop 同款模式）</a:t>
             </a:r>
           </a:p>
         </p:txBody>
@@ -5513,6 +5613,7 @@
                 </a:solidFill>
                 <a:latin typeface="Segoe UI"/>
                 <a:ea typeface="Microsoft YaHei"/>
+                <a:cs typeface="Segoe UI"/>
               </a:rPr>
               <a:t>DCC-MCP 框架介绍</a:t>
             </a:r>
@@ -5550,8 +5651,9 @@
                 </a:solidFill>
                 <a:latin typeface="Segoe UI"/>
                 <a:ea typeface="Microsoft YaHei"/>
+                <a:cs typeface="Segoe UI"/>
               </a:rPr>
-              <a:t>10 / 14</a:t>
+              <a:t>10 / 16</a:t>
             </a:r>
           </a:p>
         </p:txBody>
@@ -5737,8 +5839,9 @@
                 </a:solidFill>
                 <a:latin typeface="Segoe UI"/>
                 <a:ea typeface="Microsoft YaHei"/>
+                <a:cs typeface="Segoe UI"/>
               </a:rPr>
-              <a:t>03</a:t>
+              <a:t>02</a:t>
             </a:r>
           </a:p>
         </p:txBody>
@@ -5818,8 +5921,9 @@
                 </a:solidFill>
                 <a:latin typeface="Segoe UI"/>
                 <a:ea typeface="Microsoft YaHei"/>
+                <a:cs typeface="Segoe UI"/>
               </a:rPr>
-              <a:t>Office 自动化平台</a:t>
+              <a:t>执行模型</a:t>
             </a:r>
           </a:p>
         </p:txBody>
@@ -5855,6 +5959,7 @@
                 </a:solidFill>
                 <a:latin typeface="Segoe UI"/>
                 <a:ea typeface="Microsoft YaHei"/>
+                <a:cs typeface="Segoe UI"/>
               </a:rPr>
               <a:t>DCC-MCP 框架介绍</a:t>
             </a:r>
@@ -5892,8 +5997,9 @@
                 </a:solidFill>
                 <a:latin typeface="Segoe UI"/>
                 <a:ea typeface="Microsoft YaHei"/>
+                <a:cs typeface="Segoe UI"/>
               </a:rPr>
-              <a:t>11 / 14</a:t>
+              <a:t>11 / 16</a:t>
             </a:r>
           </a:p>
         </p:txBody>
@@ -5991,8 +6097,9 @@
                 </a:solidFill>
                 <a:latin typeface="Segoe UI"/>
                 <a:ea typeface="Microsoft YaHei"/>
+                <a:cs typeface="Segoe UI"/>
               </a:rPr>
-              <a:t>Office 双后端</a:t>
+              <a:t>一次调用的旅程</a:t>
             </a:r>
           </a:p>
         </p:txBody>
@@ -6043,25 +6150,23 @@
       </p:sp>
       <p:sp>
         <p:nvSpPr>
-          <p:cNvPr id="5" name="Oval 4"/>
+          <p:cNvPr id="5" name="Rectangle 4"/>
           <p:cNvSpPr/>
           <p:nvPr/>
         </p:nvSpPr>
         <p:spPr>
           <a:xfrm>
-            <a:off x="2148840" y="1819656"/>
-            <a:ext cx="384048" cy="384048"/>
-          </a:xfrm>
-          <a:prstGeom prst="ellipse">
+            <a:off x="822960" y="3246120"/>
+            <a:ext cx="10515600" cy="38100"/>
+          </a:xfrm>
+          <a:prstGeom prst="rect">
             <a:avLst/>
           </a:prstGeom>
           <a:solidFill>
-            <a:srgbClr val="171F2E"/>
+            <a:srgbClr val="4D9DE0"/>
           </a:solidFill>
-          <a:ln w="15240">
-            <a:solidFill>
-              <a:srgbClr val="4D9DE0"/>
-            </a:solidFill>
+          <a:ln>
+            <a:noFill/>
           </a:ln>
           <a:effectLst/>
         </p:spPr>
@@ -6080,44 +6185,34 @@
           </a:fontRef>
         </p:style>
         <p:txBody>
-          <a:bodyPr rtlCol="0" anchor="ctr" wrap="square" lIns="101600" rIns="101600" tIns="76200" bIns="76200"/>
-          <a:lstStyle/>
-          <a:p>
-            <a:pPr algn="ctr"/>
-            <a:r>
-              <a:rPr sz="1200" b="1">
-                <a:solidFill>
-                  <a:srgbClr val="4D9DE0"/>
-                </a:solidFill>
-                <a:latin typeface="Segoe UI"/>
-                <a:ea typeface="Microsoft YaHei"/>
-              </a:rPr>
-              <a:t>1</a:t>
-            </a:r>
-          </a:p>
-        </p:txBody>
-      </p:sp>
-      <p:sp>
-        <p:nvSpPr>
-          <p:cNvPr id="6" name="Rounded Rectangle 5"/>
+          <a:bodyPr rtlCol="0" anchor="ctr" wrap="square"/>
+          <a:lstStyle/>
+          <a:p>
+            <a:pPr algn="ctr"/>
+          </a:p>
+        </p:txBody>
+      </p:sp>
+      <p:sp>
+        <p:nvSpPr>
+          <p:cNvPr id="6" name="Oval 5"/>
           <p:cNvSpPr/>
           <p:nvPr/>
         </p:nvSpPr>
         <p:spPr>
           <a:xfrm>
-            <a:off x="2788920" y="1673352"/>
-            <a:ext cx="8412480" cy="713232"/>
-          </a:xfrm>
-          <a:prstGeom prst="roundRect">
-            <a:avLst>
-              <a:gd name="adj" fmla="val 10000"/>
-            </a:avLst>
+            <a:off x="1719071" y="3090672"/>
+            <a:ext cx="310896" cy="310896"/>
+          </a:xfrm>
+          <a:prstGeom prst="ellipse">
+            <a:avLst/>
           </a:prstGeom>
           <a:solidFill>
-            <a:srgbClr val="1E2A3D"/>
+            <a:srgbClr val="0F141E"/>
           </a:solidFill>
-          <a:ln>
-            <a:noFill/>
+          <a:ln w="19050">
+            <a:solidFill>
+              <a:srgbClr val="7FC8A9"/>
+            </a:solidFill>
           </a:ln>
           <a:effectLst/>
         </p:spPr>
@@ -6141,38 +6236,77 @@
           <a:p>
             <a:pPr algn="ctr"/>
             <a:r>
-              <a:rPr sz="1450" b="0">
-                <a:solidFill>
-                  <a:srgbClr val="E8ECF2"/>
+              <a:rPr sz="1200" b="1">
+                <a:solidFill>
+                  <a:srgbClr val="7FC8A9"/>
                 </a:solidFill>
                 <a:latin typeface="Segoe UI"/>
                 <a:ea typeface="Microsoft YaHei"/>
+                <a:cs typeface="Segoe UI"/>
               </a:rPr>
-              <a:t>Rust Gateway（dcc-mcp-core）：控制面 · Job · Artifact · 安全策略</a:t>
-            </a:r>
-          </a:p>
-        </p:txBody>
-      </p:sp>
-      <p:sp>
-        <p:nvSpPr>
-          <p:cNvPr id="7" name="Oval 6"/>
+              <a:t>1</a:t>
+            </a:r>
+          </a:p>
+        </p:txBody>
+      </p:sp>
+      <p:sp>
+        <p:nvSpPr>
+          <p:cNvPr id="7" name="TextBox 6"/>
+          <p:cNvSpPr txBox="1"/>
+          <p:nvPr/>
+        </p:nvSpPr>
+        <p:spPr>
+          <a:xfrm>
+            <a:off x="960120" y="2103120"/>
+            <a:ext cx="1828799" cy="960120"/>
+          </a:xfrm>
+          <a:prstGeom prst="rect">
+            <a:avLst/>
+          </a:prstGeom>
+          <a:noFill/>
+          <a:effectLst/>
+        </p:spPr>
+        <p:txBody>
+          <a:bodyPr wrap="square" lIns="50800" rIns="50800">
+            <a:spAutoFit/>
+          </a:bodyPr>
+          <a:lstStyle/>
+          <a:p>
+            <a:pPr algn="ctr"/>
+            <a:r>
+              <a:rPr sz="1350" b="0">
+                <a:solidFill>
+                  <a:srgbClr val="E8ECF2"/>
+                </a:solidFill>
+                <a:latin typeface="Segoe UI"/>
+                <a:ea typeface="Microsoft YaHei"/>
+                <a:cs typeface="Segoe UI"/>
+              </a:rPr>
+              <a:t>list / search — 渐进式能力发现</a:t>
+            </a:r>
+          </a:p>
+        </p:txBody>
+      </p:sp>
+      <p:sp>
+        <p:nvSpPr>
+          <p:cNvPr id="8" name="Oval 7"/>
           <p:cNvSpPr/>
           <p:nvPr/>
         </p:nvSpPr>
         <p:spPr>
           <a:xfrm>
-            <a:off x="2148840" y="2688336"/>
-            <a:ext cx="384048" cy="384048"/>
+            <a:off x="3822191" y="3090672"/>
+            <a:ext cx="310896" cy="310896"/>
           </a:xfrm>
           <a:prstGeom prst="ellipse">
             <a:avLst/>
           </a:prstGeom>
           <a:solidFill>
-            <a:srgbClr val="171F2E"/>
+            <a:srgbClr val="0F141E"/>
           </a:solidFill>
-          <a:ln w="15240">
+          <a:ln w="19050">
             <a:solidFill>
-              <a:srgbClr val="4D9DE0"/>
+              <a:srgbClr val="7FC8A9"/>
             </a:solidFill>
           </a:ln>
           <a:effectLst/>
@@ -6199,10 +6333,11 @@
             <a:r>
               <a:rPr sz="1200" b="1">
                 <a:solidFill>
-                  <a:srgbClr val="4D9DE0"/>
+                  <a:srgbClr val="7FC8A9"/>
                 </a:solidFill>
                 <a:latin typeface="Segoe UI"/>
                 <a:ea typeface="Microsoft YaHei"/>
+                <a:cs typeface="Segoe UI"/>
               </a:rPr>
               <a:t>2</a:t>
             </a:r>
@@ -6211,25 +6346,63 @@
       </p:sp>
       <p:sp>
         <p:nvSpPr>
-          <p:cNvPr id="8" name="Rounded Rectangle 7"/>
+          <p:cNvPr id="9" name="TextBox 8"/>
+          <p:cNvSpPr txBox="1"/>
+          <p:nvPr/>
+        </p:nvSpPr>
+        <p:spPr>
+          <a:xfrm>
+            <a:off x="3063240" y="3566160"/>
+            <a:ext cx="1828799" cy="960120"/>
+          </a:xfrm>
+          <a:prstGeom prst="rect">
+            <a:avLst/>
+          </a:prstGeom>
+          <a:noFill/>
+          <a:effectLst/>
+        </p:spPr>
+        <p:txBody>
+          <a:bodyPr wrap="square" lIns="50800" rIns="50800">
+            <a:spAutoFit/>
+          </a:bodyPr>
+          <a:lstStyle/>
+          <a:p>
+            <a:pPr algn="ctr"/>
+            <a:r>
+              <a:rPr sz="1350" b="0">
+                <a:solidFill>
+                  <a:srgbClr val="E8ECF2"/>
+                </a:solidFill>
+                <a:latin typeface="Segoe UI"/>
+                <a:ea typeface="Microsoft YaHei"/>
+                <a:cs typeface="Segoe UI"/>
+              </a:rPr>
+              <a:t>load_skill / describe — 契约与确认级别</a:t>
+            </a:r>
+          </a:p>
+        </p:txBody>
+      </p:sp>
+      <p:sp>
+        <p:nvSpPr>
+          <p:cNvPr id="10" name="Oval 9"/>
           <p:cNvSpPr/>
           <p:nvPr/>
         </p:nvSpPr>
         <p:spPr>
           <a:xfrm>
-            <a:off x="2788920" y="2542032"/>
-            <a:ext cx="8412480" cy="713232"/>
-          </a:xfrm>
-          <a:prstGeom prst="roundRect">
-            <a:avLst>
-              <a:gd name="adj" fmla="val 10000"/>
-            </a:avLst>
+            <a:off x="5925312" y="3090672"/>
+            <a:ext cx="310896" cy="310896"/>
+          </a:xfrm>
+          <a:prstGeom prst="ellipse">
+            <a:avLst/>
           </a:prstGeom>
           <a:solidFill>
-            <a:srgbClr val="1E2A3D"/>
+            <a:srgbClr val="0F141E"/>
           </a:solidFill>
-          <a:ln>
-            <a:noFill/>
+          <a:ln w="19050">
+            <a:solidFill>
+              <a:srgbClr val="7FC8A9"/>
+            </a:solidFill>
           </a:ln>
           <a:effectLst/>
         </p:spPr>
@@ -6253,38 +6426,77 @@
           <a:p>
             <a:pPr algn="ctr"/>
             <a:r>
-              <a:rPr sz="1450" b="0">
-                <a:solidFill>
-                  <a:srgbClr val="E8ECF2"/>
+              <a:rPr sz="1200" b="1">
+                <a:solidFill>
+                  <a:srgbClr val="7FC8A9"/>
                 </a:solidFill>
                 <a:latin typeface="Segoe UI"/>
                 <a:ea typeface="Microsoft YaHei"/>
+                <a:cs typeface="Segoe UI"/>
               </a:rPr>
-              <a:t>office-host.exe（C#）：每应用独立 Sidecar · 单 STA 队列</a:t>
-            </a:r>
-          </a:p>
-        </p:txBody>
-      </p:sp>
-      <p:sp>
-        <p:nvSpPr>
-          <p:cNvPr id="9" name="Oval 8"/>
+              <a:t>3</a:t>
+            </a:r>
+          </a:p>
+        </p:txBody>
+      </p:sp>
+      <p:sp>
+        <p:nvSpPr>
+          <p:cNvPr id="11" name="TextBox 10"/>
+          <p:cNvSpPr txBox="1"/>
+          <p:nvPr/>
+        </p:nvSpPr>
+        <p:spPr>
+          <a:xfrm>
+            <a:off x="5166361" y="2103120"/>
+            <a:ext cx="1828799" cy="960120"/>
+          </a:xfrm>
+          <a:prstGeom prst="rect">
+            <a:avLst/>
+          </a:prstGeom>
+          <a:noFill/>
+          <a:effectLst/>
+        </p:spPr>
+        <p:txBody>
+          <a:bodyPr wrap="square" lIns="50800" rIns="50800">
+            <a:spAutoFit/>
+          </a:bodyPr>
+          <a:lstStyle/>
+          <a:p>
+            <a:pPr algn="ctr"/>
+            <a:r>
+              <a:rPr sz="1350" b="0">
+                <a:solidFill>
+                  <a:srgbClr val="E8ECF2"/>
+                </a:solidFill>
+                <a:latin typeface="Segoe UI"/>
+                <a:ea typeface="Microsoft YaHei"/>
+                <a:cs typeface="Segoe UI"/>
+              </a:rPr>
+              <a:t>call — 任务级 Capability</a:t>
+            </a:r>
+          </a:p>
+        </p:txBody>
+      </p:sp>
+      <p:sp>
+        <p:nvSpPr>
+          <p:cNvPr id="12" name="Oval 11"/>
           <p:cNvSpPr/>
           <p:nvPr/>
         </p:nvSpPr>
         <p:spPr>
           <a:xfrm>
-            <a:off x="2148840" y="3557016"/>
-            <a:ext cx="384048" cy="384048"/>
+            <a:off x="8028431" y="3090672"/>
+            <a:ext cx="310896" cy="310896"/>
           </a:xfrm>
           <a:prstGeom prst="ellipse">
             <a:avLst/>
           </a:prstGeom>
           <a:solidFill>
-            <a:srgbClr val="171F2E"/>
+            <a:srgbClr val="0F141E"/>
           </a:solidFill>
-          <a:ln w="15240">
+          <a:ln w="19050">
             <a:solidFill>
-              <a:srgbClr val="4D9DE0"/>
+              <a:srgbClr val="7FC8A9"/>
             </a:solidFill>
           </a:ln>
           <a:effectLst/>
@@ -6311,37 +6523,76 @@
             <a:r>
               <a:rPr sz="1200" b="1">
                 <a:solidFill>
-                  <a:srgbClr val="4D9DE0"/>
+                  <a:srgbClr val="7FC8A9"/>
                 </a:solidFill>
                 <a:latin typeface="Segoe UI"/>
                 <a:ea typeface="Microsoft YaHei"/>
+                <a:cs typeface="Segoe UI"/>
               </a:rPr>
-              <a:t>3</a:t>
-            </a:r>
-          </a:p>
-        </p:txBody>
-      </p:sp>
-      <p:sp>
-        <p:nvSpPr>
-          <p:cNvPr id="10" name="Rounded Rectangle 9"/>
+              <a:t>4</a:t>
+            </a:r>
+          </a:p>
+        </p:txBody>
+      </p:sp>
+      <p:sp>
+        <p:nvSpPr>
+          <p:cNvPr id="13" name="TextBox 12"/>
+          <p:cNvSpPr txBox="1"/>
+          <p:nvPr/>
+        </p:nvSpPr>
+        <p:spPr>
+          <a:xfrm>
+            <a:off x="7269480" y="3566160"/>
+            <a:ext cx="1828799" cy="960120"/>
+          </a:xfrm>
+          <a:prstGeom prst="rect">
+            <a:avLst/>
+          </a:prstGeom>
+          <a:noFill/>
+          <a:effectLst/>
+        </p:spPr>
+        <p:txBody>
+          <a:bodyPr wrap="square" lIns="50800" rIns="50800">
+            <a:spAutoFit/>
+          </a:bodyPr>
+          <a:lstStyle/>
+          <a:p>
+            <a:pPr algn="ctr"/>
+            <a:r>
+              <a:rPr sz="1350" b="0">
+                <a:solidFill>
+                  <a:srgbClr val="E8ECF2"/>
+                </a:solidFill>
+                <a:latin typeface="Segoe UI"/>
+                <a:ea typeface="Microsoft YaHei"/>
+                <a:cs typeface="Segoe UI"/>
+              </a:rPr>
+              <a:t>Job — 批处理永不占住连接</a:t>
+            </a:r>
+          </a:p>
+        </p:txBody>
+      </p:sp>
+      <p:sp>
+        <p:nvSpPr>
+          <p:cNvPr id="14" name="Oval 13"/>
           <p:cNvSpPr/>
           <p:nvPr/>
         </p:nvSpPr>
         <p:spPr>
           <a:xfrm>
-            <a:off x="2788920" y="3410712"/>
-            <a:ext cx="8412480" cy="713232"/>
-          </a:xfrm>
-          <a:prstGeom prst="roundRect">
-            <a:avLst>
-              <a:gd name="adj" fmla="val 10000"/>
-            </a:avLst>
+            <a:off x="10131552" y="3090672"/>
+            <a:ext cx="310896" cy="310896"/>
+          </a:xfrm>
+          <a:prstGeom prst="ellipse">
+            <a:avLst/>
           </a:prstGeom>
           <a:solidFill>
-            <a:srgbClr val="1E2A3D"/>
+            <a:srgbClr val="0F141E"/>
           </a:solidFill>
-          <a:ln>
-            <a:noFill/>
+          <a:ln w="19050">
+            <a:solidFill>
+              <a:srgbClr val="7FC8A9"/>
+            </a:solidFill>
           </a:ln>
           <a:effectLst/>
         </p:spPr>
@@ -6365,180 +6616,13 @@
           <a:p>
             <a:pPr algn="ctr"/>
             <a:r>
-              <a:rPr sz="1450" b="0">
-                <a:solidFill>
-                  <a:srgbClr val="E8ECF2"/>
+              <a:rPr sz="1200" b="1">
+                <a:solidFill>
+                  <a:srgbClr val="7FC8A9"/>
                 </a:solidFill>
                 <a:latin typeface="Segoe UI"/>
                 <a:ea typeface="Microsoft YaHei"/>
-              </a:rPr>
-              <a:t>POWERPNT / WINWORD / EXCEL（COM 数据面）</a:t>
-            </a:r>
-          </a:p>
-        </p:txBody>
-      </p:sp>
-      <p:sp>
-        <p:nvSpPr>
-          <p:cNvPr id="11" name="Oval 10"/>
-          <p:cNvSpPr/>
-          <p:nvPr/>
-        </p:nvSpPr>
-        <p:spPr>
-          <a:xfrm>
-            <a:off x="2148840" y="4425696"/>
-            <a:ext cx="384048" cy="384048"/>
-          </a:xfrm>
-          <a:prstGeom prst="ellipse">
-            <a:avLst/>
-          </a:prstGeom>
-          <a:solidFill>
-            <a:srgbClr val="171F2E"/>
-          </a:solidFill>
-          <a:ln w="15240">
-            <a:solidFill>
-              <a:srgbClr val="4D9DE0"/>
-            </a:solidFill>
-          </a:ln>
-          <a:effectLst/>
-        </p:spPr>
-        <p:style>
-          <a:lnRef idx="1">
-            <a:schemeClr val="accent1"/>
-          </a:lnRef>
-          <a:fillRef idx="3">
-            <a:schemeClr val="accent1"/>
-          </a:fillRef>
-          <a:effectRef idx="2">
-            <a:schemeClr val="accent1"/>
-          </a:effectRef>
-          <a:fontRef idx="minor">
-            <a:schemeClr val="lt1"/>
-          </a:fontRef>
-        </p:style>
-        <p:txBody>
-          <a:bodyPr rtlCol="0" anchor="ctr" wrap="square" lIns="101600" rIns="101600" tIns="76200" bIns="76200"/>
-          <a:lstStyle/>
-          <a:p>
-            <a:pPr algn="ctr"/>
-            <a:r>
-              <a:rPr sz="1200" b="1">
-                <a:solidFill>
-                  <a:srgbClr val="4D9DE0"/>
-                </a:solidFill>
-                <a:latin typeface="Segoe UI"/>
-                <a:ea typeface="Microsoft YaHei"/>
-              </a:rPr>
-              <a:t>4</a:t>
-            </a:r>
-          </a:p>
-        </p:txBody>
-      </p:sp>
-      <p:sp>
-        <p:nvSpPr>
-          <p:cNvPr id="12" name="Rounded Rectangle 11"/>
-          <p:cNvSpPr/>
-          <p:nvPr/>
-        </p:nvSpPr>
-        <p:spPr>
-          <a:xfrm>
-            <a:off x="2788920" y="4279392"/>
-            <a:ext cx="8412480" cy="713232"/>
-          </a:xfrm>
-          <a:prstGeom prst="roundRect">
-            <a:avLst>
-              <a:gd name="adj" fmla="val 10000"/>
-            </a:avLst>
-          </a:prstGeom>
-          <a:solidFill>
-            <a:srgbClr val="1E2A3D"/>
-          </a:solidFill>
-          <a:ln>
-            <a:noFill/>
-          </a:ln>
-          <a:effectLst/>
-        </p:spPr>
-        <p:style>
-          <a:lnRef idx="1">
-            <a:schemeClr val="accent1"/>
-          </a:lnRef>
-          <a:fillRef idx="3">
-            <a:schemeClr val="accent1"/>
-          </a:fillRef>
-          <a:effectRef idx="2">
-            <a:schemeClr val="accent1"/>
-          </a:effectRef>
-          <a:fontRef idx="minor">
-            <a:schemeClr val="lt1"/>
-          </a:fontRef>
-        </p:style>
-        <p:txBody>
-          <a:bodyPr rtlCol="0" anchor="ctr" wrap="square" lIns="101600" rIns="101600" tIns="76200" bIns="76200"/>
-          <a:lstStyle/>
-          <a:p>
-            <a:pPr algn="ctr"/>
-            <a:r>
-              <a:rPr sz="1450" b="0">
-                <a:solidFill>
-                  <a:srgbClr val="E8ECF2"/>
-                </a:solidFill>
-                <a:latin typeface="Segoe UI"/>
-                <a:ea typeface="Microsoft YaHei"/>
-              </a:rPr>
-              <a:t>Open XML Worker：批量结构处理（编译器，非渲染器）</a:t>
-            </a:r>
-          </a:p>
-        </p:txBody>
-      </p:sp>
-      <p:sp>
-        <p:nvSpPr>
-          <p:cNvPr id="13" name="Oval 12"/>
-          <p:cNvSpPr/>
-          <p:nvPr/>
-        </p:nvSpPr>
-        <p:spPr>
-          <a:xfrm>
-            <a:off x="2148840" y="5294376"/>
-            <a:ext cx="384048" cy="384048"/>
-          </a:xfrm>
-          <a:prstGeom prst="ellipse">
-            <a:avLst/>
-          </a:prstGeom>
-          <a:solidFill>
-            <a:srgbClr val="171F2E"/>
-          </a:solidFill>
-          <a:ln w="15240">
-            <a:solidFill>
-              <a:srgbClr val="4D9DE0"/>
-            </a:solidFill>
-          </a:ln>
-          <a:effectLst/>
-        </p:spPr>
-        <p:style>
-          <a:lnRef idx="1">
-            <a:schemeClr val="accent1"/>
-          </a:lnRef>
-          <a:fillRef idx="3">
-            <a:schemeClr val="accent1"/>
-          </a:fillRef>
-          <a:effectRef idx="2">
-            <a:schemeClr val="accent1"/>
-          </a:effectRef>
-          <a:fontRef idx="minor">
-            <a:schemeClr val="lt1"/>
-          </a:fontRef>
-        </p:style>
-        <p:txBody>
-          <a:bodyPr rtlCol="0" anchor="ctr" wrap="square" lIns="101600" rIns="101600" tIns="76200" bIns="76200"/>
-          <a:lstStyle/>
-          <a:p>
-            <a:pPr algn="ctr"/>
-            <a:r>
-              <a:rPr sz="1200" b="1">
-                <a:solidFill>
-                  <a:srgbClr val="4D9DE0"/>
-                </a:solidFill>
-                <a:latin typeface="Segoe UI"/>
-                <a:ea typeface="Microsoft YaHei"/>
+                <a:cs typeface="Segoe UI"/>
               </a:rPr>
               <a:t>5</a:t>
             </a:r>
@@ -6547,106 +6631,14 @@
       </p:sp>
       <p:sp>
         <p:nvSpPr>
-          <p:cNvPr id="14" name="Rounded Rectangle 13"/>
-          <p:cNvSpPr/>
-          <p:nvPr/>
-        </p:nvSpPr>
-        <p:spPr>
-          <a:xfrm>
-            <a:off x="2788920" y="5148072"/>
-            <a:ext cx="8412480" cy="713232"/>
-          </a:xfrm>
-          <a:prstGeom prst="roundRect">
-            <a:avLst>
-              <a:gd name="adj" fmla="val 10000"/>
-            </a:avLst>
-          </a:prstGeom>
-          <a:solidFill>
-            <a:srgbClr val="1E2A3D"/>
-          </a:solidFill>
-          <a:ln>
-            <a:noFill/>
-          </a:ln>
-          <a:effectLst/>
-        </p:spPr>
-        <p:style>
-          <a:lnRef idx="1">
-            <a:schemeClr val="accent1"/>
-          </a:lnRef>
-          <a:fillRef idx="3">
-            <a:schemeClr val="accent1"/>
-          </a:fillRef>
-          <a:effectRef idx="2">
-            <a:schemeClr val="accent1"/>
-          </a:effectRef>
-          <a:fontRef idx="minor">
-            <a:schemeClr val="lt1"/>
-          </a:fontRef>
-        </p:style>
-        <p:txBody>
-          <a:bodyPr rtlCol="0" anchor="ctr" wrap="square" lIns="101600" rIns="101600" tIns="76200" bIns="76200"/>
-          <a:lstStyle/>
-          <a:p>
-            <a:pPr algn="ctr"/>
-            <a:r>
-              <a:rPr sz="1450" b="0">
-                <a:solidFill>
-                  <a:srgbClr val="E8ECF2"/>
-                </a:solidFill>
-                <a:latin typeface="Segoe UI"/>
-                <a:ea typeface="Microsoft YaHei"/>
-              </a:rPr>
-              <a:t>Microsoft Graph / Office.js / UIA-CUA：云与兜底路径</a:t>
-            </a:r>
-          </a:p>
-        </p:txBody>
-      </p:sp>
-      <p:cxnSp>
-        <p:nvCxnSpPr>
-          <p:cNvPr id="15" name="Connector 14"/>
-          <p:cNvCxnSpPr/>
-          <p:nvPr/>
-        </p:nvCxnSpPr>
-        <p:spPr>
-          <a:xfrm>
-            <a:off x="2340864" y="2194560"/>
-            <a:ext cx="0" cy="3474719"/>
-          </a:xfrm>
-          <a:prstGeom prst="line">
-            <a:avLst/>
-          </a:prstGeom>
-          <a:ln>
-            <a:solidFill>
-              <a:srgbClr val="4D9DE0"/>
-            </a:solidFill>
-          </a:ln>
-          <a:effectLst/>
-        </p:spPr>
-        <p:style>
-          <a:lnRef idx="2">
-            <a:schemeClr val="accent1"/>
-          </a:lnRef>
-          <a:fillRef idx="0">
-            <a:schemeClr val="accent1"/>
-          </a:fillRef>
-          <a:effectRef idx="1">
-            <a:schemeClr val="accent1"/>
-          </a:effectRef>
-          <a:fontRef idx="minor">
-            <a:schemeClr val="tx1"/>
-          </a:fontRef>
-        </p:style>
-      </p:cxnSp>
-      <p:sp>
-        <p:nvSpPr>
-          <p:cNvPr id="16" name="TextBox 15"/>
+          <p:cNvPr id="15" name="TextBox 14"/>
           <p:cNvSpPr txBox="1"/>
           <p:nvPr/>
         </p:nvSpPr>
         <p:spPr>
           <a:xfrm>
-            <a:off x="822960" y="6473952"/>
-            <a:ext cx="7315200" cy="274320"/>
+            <a:off x="9372601" y="2103120"/>
+            <a:ext cx="1828799" cy="960120"/>
           </a:xfrm>
           <a:prstGeom prst="rect">
             <a:avLst/>
@@ -6660,14 +6652,53 @@
           </a:bodyPr>
           <a:lstStyle/>
           <a:p>
-            <a:pPr algn="l"/>
-            <a:r>
-              <a:rPr sz="1000" b="0">
-                <a:solidFill>
-                  <a:srgbClr val="9AA7BC"/>
+            <a:pPr algn="ctr"/>
+            <a:r>
+              <a:rPr sz="1350" b="0">
+                <a:solidFill>
+                  <a:srgbClr val="E8ECF2"/>
                 </a:solidFill>
                 <a:latin typeface="Segoe UI"/>
                 <a:ea typeface="Microsoft YaHei"/>
+                <a:cs typeface="Segoe UI"/>
+              </a:rPr>
+              <a:t>Artifact — 结果、预览、审计可追踪</a:t>
+            </a:r>
+          </a:p>
+        </p:txBody>
+      </p:sp>
+      <p:sp>
+        <p:nvSpPr>
+          <p:cNvPr id="16" name="TextBox 15"/>
+          <p:cNvSpPr txBox="1"/>
+          <p:nvPr/>
+        </p:nvSpPr>
+        <p:spPr>
+          <a:xfrm>
+            <a:off x="822960" y="6473952"/>
+            <a:ext cx="7315200" cy="274320"/>
+          </a:xfrm>
+          <a:prstGeom prst="rect">
+            <a:avLst/>
+          </a:prstGeom>
+          <a:noFill/>
+          <a:effectLst/>
+        </p:spPr>
+        <p:txBody>
+          <a:bodyPr wrap="square" lIns="50800" rIns="50800">
+            <a:spAutoFit/>
+          </a:bodyPr>
+          <a:lstStyle/>
+          <a:p>
+            <a:pPr algn="l"/>
+            <a:r>
+              <a:rPr sz="1000" b="0">
+                <a:solidFill>
+                  <a:srgbClr val="9AA7BC"/>
+                </a:solidFill>
+                <a:latin typeface="Segoe UI"/>
+                <a:ea typeface="Microsoft YaHei"/>
+                <a:cs typeface="Segoe UI"/>
               </a:rPr>
               <a:t>DCC-MCP 框架介绍</a:t>
             </a:r>
@@ -6705,8 +6736,9 @@
                 </a:solidFill>
                 <a:latin typeface="Segoe UI"/>
                 <a:ea typeface="Microsoft YaHei"/>
+                <a:cs typeface="Segoe UI"/>
               </a:rPr>
-              <a:t>12 / 14</a:t>
+              <a:t>12 / 16</a:t>
             </a:r>
           </a:p>
         </p:txBody>
@@ -6775,57 +6807,20 @@
       </p:sp>
       <p:sp>
         <p:nvSpPr>
-          <p:cNvPr id="3" name="TextBox 2"/>
-          <p:cNvSpPr txBox="1"/>
-          <p:nvPr/>
-        </p:nvSpPr>
-        <p:spPr>
-          <a:xfrm>
-            <a:off x="822960" y="502920"/>
-            <a:ext cx="10515600" cy="685800"/>
-          </a:xfrm>
-          <a:prstGeom prst="rect">
-            <a:avLst/>
-          </a:prstGeom>
-          <a:noFill/>
-          <a:effectLst/>
-        </p:spPr>
-        <p:txBody>
-          <a:bodyPr wrap="square" lIns="50800" rIns="50800">
-            <a:spAutoFit/>
-          </a:bodyPr>
-          <a:lstStyle/>
-          <a:p>
-            <a:pPr algn="l"/>
-            <a:r>
-              <a:rPr sz="2800" b="1">
-                <a:solidFill>
-                  <a:srgbClr val="E8ECF2"/>
-                </a:solidFill>
-                <a:latin typeface="Segoe UI"/>
-                <a:ea typeface="Microsoft YaHei"/>
-              </a:rPr>
-              <a:t>设计取舍</a:t>
-            </a:r>
-          </a:p>
-        </p:txBody>
-      </p:sp>
-      <p:sp>
-        <p:nvSpPr>
-          <p:cNvPr id="4" name="Rectangle 3"/>
+          <p:cNvPr id="3" name="Rectangle 2"/>
           <p:cNvSpPr/>
           <p:nvPr/>
         </p:nvSpPr>
         <p:spPr>
           <a:xfrm>
-            <a:off x="822960" y="1298448"/>
-            <a:ext cx="822960" cy="44450"/>
+            <a:off x="0" y="0"/>
+            <a:ext cx="12191695" cy="6858000"/>
           </a:xfrm>
           <a:prstGeom prst="rect">
             <a:avLst/>
           </a:prstGeom>
           <a:solidFill>
-            <a:srgbClr val="4D9DE0"/>
+            <a:srgbClr val="171F2E"/>
           </a:solidFill>
           <a:ln>
             <a:noFill/>
@@ -6847,31 +6842,29 @@
           </a:fontRef>
         </p:style>
         <p:txBody>
-          <a:bodyPr rtlCol="0" anchor="ctr" wrap="square"/>
-          <a:lstStyle/>
-          <a:p>
-            <a:pPr algn="ctr"/>
-          </a:p>
-        </p:txBody>
-      </p:sp>
-      <p:sp>
-        <p:nvSpPr>
-          <p:cNvPr id="5" name="Rounded Rectangle 4"/>
+          <a:bodyPr rtlCol="0" anchor="ctr"/>
+          <a:lstStyle/>
+          <a:p>
+            <a:pPr algn="ctr"/>
+          </a:p>
+        </p:txBody>
+      </p:sp>
+      <p:sp>
+        <p:nvSpPr>
+          <p:cNvPr id="4" name="Oval 3"/>
           <p:cNvSpPr/>
           <p:nvPr/>
         </p:nvSpPr>
         <p:spPr>
           <a:xfrm>
-            <a:off x="822960" y="1627632"/>
-            <a:ext cx="5120640" cy="566928"/>
-          </a:xfrm>
-          <a:prstGeom prst="roundRect">
-            <a:avLst>
-              <a:gd name="adj" fmla="val 16000"/>
-            </a:avLst>
+            <a:off x="9601200" y="320040"/>
+            <a:ext cx="2468880" cy="2468880"/>
+          </a:xfrm>
+          <a:prstGeom prst="ellipse">
+            <a:avLst/>
           </a:prstGeom>
           <a:solidFill>
-            <a:srgbClr val="4D9DE0"/>
+            <a:srgbClr val="223047"/>
           </a:solidFill>
           <a:ln>
             <a:noFill/>
@@ -6893,120 +6886,64 @@
           </a:fontRef>
         </p:style>
         <p:txBody>
-          <a:bodyPr rtlCol="0" anchor="ctr" wrap="square" lIns="101600" rIns="101600" tIns="76200" bIns="76200"/>
-          <a:lstStyle/>
-          <a:p>
-            <a:pPr algn="ctr"/>
-            <a:r>
-              <a:rPr sz="1600" b="1">
-                <a:solidFill>
-                  <a:srgbClr val="E8ECF2"/>
+          <a:bodyPr rtlCol="0" anchor="ctr"/>
+          <a:lstStyle/>
+          <a:p>
+            <a:pPr algn="ctr"/>
+          </a:p>
+        </p:txBody>
+      </p:sp>
+      <p:sp>
+        <p:nvSpPr>
+          <p:cNvPr id="5" name="TextBox 4"/>
+          <p:cNvSpPr txBox="1"/>
+          <p:nvPr/>
+        </p:nvSpPr>
+        <p:spPr>
+          <a:xfrm>
+            <a:off x="640080" y="640080"/>
+            <a:ext cx="4572000" cy="3840480"/>
+          </a:xfrm>
+          <a:prstGeom prst="rect">
+            <a:avLst/>
+          </a:prstGeom>
+          <a:noFill/>
+          <a:effectLst/>
+        </p:spPr>
+        <p:txBody>
+          <a:bodyPr wrap="square" lIns="50800" rIns="50800">
+            <a:spAutoFit/>
+          </a:bodyPr>
+          <a:lstStyle/>
+          <a:p>
+            <a:pPr algn="l"/>
+            <a:r>
+              <a:rPr sz="20000" b="1">
+                <a:solidFill>
+                  <a:srgbClr val="223047"/>
                 </a:solidFill>
                 <a:latin typeface="Segoe UI"/>
                 <a:ea typeface="Microsoft YaHei"/>
+                <a:cs typeface="Segoe UI"/>
               </a:rPr>
-              <a:t>结构化 API 优先</a:t>
-            </a:r>
-          </a:p>
-        </p:txBody>
-      </p:sp>
-      <p:sp>
-        <p:nvSpPr>
-          <p:cNvPr id="6" name="Rounded Rectangle 5"/>
+              <a:t>03</a:t>
+            </a:r>
+          </a:p>
+        </p:txBody>
+      </p:sp>
+      <p:sp>
+        <p:nvSpPr>
+          <p:cNvPr id="6" name="Rectangle 5"/>
           <p:cNvSpPr/>
           <p:nvPr/>
         </p:nvSpPr>
         <p:spPr>
           <a:xfrm>
-            <a:off x="822960" y="2304288"/>
-            <a:ext cx="5120640" cy="3749039"/>
-          </a:xfrm>
-          <a:prstGeom prst="roundRect">
-            <a:avLst>
-              <a:gd name="adj" fmla="val 5000"/>
-            </a:avLst>
-          </a:prstGeom>
-          <a:solidFill>
-            <a:srgbClr val="1E2A3D"/>
-          </a:solidFill>
-          <a:ln>
-            <a:noFill/>
-          </a:ln>
-          <a:effectLst/>
-        </p:spPr>
-        <p:style>
-          <a:lnRef idx="1">
-            <a:schemeClr val="accent1"/>
-          </a:lnRef>
-          <a:fillRef idx="3">
-            <a:schemeClr val="accent1"/>
-          </a:fillRef>
-          <a:effectRef idx="2">
-            <a:schemeClr val="accent1"/>
-          </a:effectRef>
-          <a:fontRef idx="minor">
-            <a:schemeClr val="lt1"/>
-          </a:fontRef>
-        </p:style>
-        <p:txBody>
-          <a:bodyPr rtlCol="0" anchor="ctr" wrap="square" lIns="101600" rIns="101600" tIns="76200" bIns="76200"/>
-          <a:lstStyle/>
-          <a:p>
-            <a:pPr algn="l"/>
-            <a:r>
-              <a:rPr sz="1450" b="0">
-                <a:solidFill>
-                  <a:srgbClr val="E8ECF2"/>
-                </a:solidFill>
-                <a:latin typeface="Segoe UI"/>
-                <a:ea typeface="Microsoft YaHei"/>
-              </a:rPr>
-              <a:t>✓  确定性、可验证、可审计</a:t>
-            </a:r>
-          </a:p>
-          <a:p>
-            <a:pPr algn="l"/>
-            <a:r>
-              <a:rPr sz="1450" b="0">
-                <a:solidFill>
-                  <a:srgbClr val="E8ECF2"/>
-                </a:solidFill>
-                <a:latin typeface="Segoe UI"/>
-                <a:ea typeface="Microsoft YaHei"/>
-              </a:rPr>
-              <a:t>✓  UIA/CUA 只做最后兜底</a:t>
-            </a:r>
-          </a:p>
-          <a:p>
-            <a:pPr algn="l"/>
-            <a:r>
-              <a:rPr sz="1450" b="0">
-                <a:solidFill>
-                  <a:srgbClr val="E8ECF2"/>
-                </a:solidFill>
-                <a:latin typeface="Segoe UI"/>
-                <a:ea typeface="Microsoft YaHei"/>
-              </a:rPr>
-              <a:t>✓  写操作不得静默降级</a:t>
-            </a:r>
-          </a:p>
-        </p:txBody>
-      </p:sp>
-      <p:sp>
-        <p:nvSpPr>
-          <p:cNvPr id="7" name="Rounded Rectangle 6"/>
-          <p:cNvSpPr/>
-          <p:nvPr/>
-        </p:nvSpPr>
-        <p:spPr>
-          <a:xfrm>
-            <a:off x="6309360" y="1627632"/>
-            <a:ext cx="5120640" cy="566928"/>
-          </a:xfrm>
-          <a:prstGeom prst="roundRect">
-            <a:avLst>
-              <a:gd name="adj" fmla="val 16000"/>
-            </a:avLst>
+            <a:off x="822960" y="2788920"/>
+            <a:ext cx="164592" cy="1097280"/>
+          </a:xfrm>
+          <a:prstGeom prst="rect">
+            <a:avLst/>
           </a:prstGeom>
           <a:solidFill>
             <a:srgbClr val="7FC8A9"/>
@@ -7031,115 +6968,23 @@
           </a:fontRef>
         </p:style>
         <p:txBody>
-          <a:bodyPr rtlCol="0" anchor="ctr" wrap="square" lIns="101600" rIns="101600" tIns="76200" bIns="76200"/>
-          <a:lstStyle/>
-          <a:p>
-            <a:pPr algn="ctr"/>
-            <a:r>
-              <a:rPr sz="1600" b="1">
-                <a:solidFill>
-                  <a:srgbClr val="E8ECF2"/>
-                </a:solidFill>
-                <a:latin typeface="Segoe UI"/>
-                <a:ea typeface="Microsoft YaHei"/>
-              </a:rPr>
-              <a:t>任务级能力</a:t>
-            </a:r>
-          </a:p>
-        </p:txBody>
-      </p:sp>
-      <p:sp>
-        <p:nvSpPr>
-          <p:cNvPr id="8" name="Rounded Rectangle 7"/>
-          <p:cNvSpPr/>
-          <p:nvPr/>
-        </p:nvSpPr>
-        <p:spPr>
-          <a:xfrm>
-            <a:off x="6309360" y="2304288"/>
-            <a:ext cx="5120640" cy="3749039"/>
-          </a:xfrm>
-          <a:prstGeom prst="roundRect">
-            <a:avLst>
-              <a:gd name="adj" fmla="val 5000"/>
-            </a:avLst>
-          </a:prstGeom>
-          <a:solidFill>
-            <a:srgbClr val="1E2A3D"/>
-          </a:solidFill>
-          <a:ln>
-            <a:noFill/>
-          </a:ln>
-          <a:effectLst/>
-        </p:spPr>
-        <p:style>
-          <a:lnRef idx="1">
-            <a:schemeClr val="accent1"/>
-          </a:lnRef>
-          <a:fillRef idx="3">
-            <a:schemeClr val="accent1"/>
-          </a:fillRef>
-          <a:effectRef idx="2">
-            <a:schemeClr val="accent1"/>
-          </a:effectRef>
-          <a:fontRef idx="minor">
-            <a:schemeClr val="lt1"/>
-          </a:fontRef>
-        </p:style>
-        <p:txBody>
-          <a:bodyPr rtlCol="0" anchor="ctr" wrap="square" lIns="101600" rIns="101600" tIns="76200" bIns="76200"/>
-          <a:lstStyle/>
-          <a:p>
-            <a:pPr algn="l"/>
-            <a:r>
-              <a:rPr sz="1450" b="0">
-                <a:solidFill>
-                  <a:srgbClr val="E8ECF2"/>
-                </a:solidFill>
-                <a:latin typeface="Segoe UI"/>
-                <a:ea typeface="Microsoft YaHei"/>
-              </a:rPr>
-              <a:t>✓  不暴露原始 COM 成员</a:t>
-            </a:r>
-          </a:p>
-          <a:p>
-            <a:pPr algn="l"/>
-            <a:r>
-              <a:rPr sz="1450" b="0">
-                <a:solidFill>
-                  <a:srgbClr val="E8ECF2"/>
-                </a:solidFill>
-                <a:latin typeface="Segoe UI"/>
-                <a:ea typeface="Microsoft YaHei"/>
-              </a:rPr>
-              <a:t>✓  模板优先于自由坐标</a:t>
-            </a:r>
-          </a:p>
-          <a:p>
-            <a:pPr algn="l"/>
-            <a:r>
-              <a:rPr sz="1450" b="0">
-                <a:solidFill>
-                  <a:srgbClr val="E8ECF2"/>
-                </a:solidFill>
-                <a:latin typeface="Segoe UI"/>
-                <a:ea typeface="Microsoft YaHei"/>
-              </a:rPr>
-              <a:t>✓  检查点 + 预览 + 可追踪结果</a:t>
-            </a:r>
-          </a:p>
-        </p:txBody>
-      </p:sp>
-      <p:sp>
-        <p:nvSpPr>
-          <p:cNvPr id="9" name="TextBox 8"/>
+          <a:bodyPr rtlCol="0" anchor="ctr" wrap="square"/>
+          <a:lstStyle/>
+          <a:p>
+            <a:pPr algn="ctr"/>
+          </a:p>
+        </p:txBody>
+      </p:sp>
+      <p:sp>
+        <p:nvSpPr>
+          <p:cNvPr id="7" name="TextBox 6"/>
           <p:cNvSpPr txBox="1"/>
           <p:nvPr/>
         </p:nvSpPr>
         <p:spPr>
           <a:xfrm>
-            <a:off x="822960" y="6473952"/>
-            <a:ext cx="7315200" cy="274320"/>
+            <a:off x="1188720" y="2743200"/>
+            <a:ext cx="10058400" cy="1280160"/>
           </a:xfrm>
           <a:prstGeom prst="rect">
             <a:avLst/>
@@ -7155,12 +7000,51 @@
           <a:p>
             <a:pPr algn="l"/>
             <a:r>
-              <a:rPr sz="1000" b="0">
-                <a:solidFill>
-                  <a:srgbClr val="9AA7BC"/>
+              <a:rPr sz="4400" b="1">
+                <a:solidFill>
+                  <a:srgbClr val="E8ECF2"/>
                 </a:solidFill>
                 <a:latin typeface="Segoe UI"/>
                 <a:ea typeface="Microsoft YaHei"/>
+                <a:cs typeface="Segoe UI"/>
+              </a:rPr>
+              <a:t>Office 自动化平台</a:t>
+            </a:r>
+          </a:p>
+        </p:txBody>
+      </p:sp>
+      <p:sp>
+        <p:nvSpPr>
+          <p:cNvPr id="8" name="TextBox 7"/>
+          <p:cNvSpPr txBox="1"/>
+          <p:nvPr/>
+        </p:nvSpPr>
+        <p:spPr>
+          <a:xfrm>
+            <a:off x="822960" y="6473952"/>
+            <a:ext cx="7315200" cy="274320"/>
+          </a:xfrm>
+          <a:prstGeom prst="rect">
+            <a:avLst/>
+          </a:prstGeom>
+          <a:noFill/>
+          <a:effectLst/>
+        </p:spPr>
+        <p:txBody>
+          <a:bodyPr wrap="square" lIns="50800" rIns="50800">
+            <a:spAutoFit/>
+          </a:bodyPr>
+          <a:lstStyle/>
+          <a:p>
+            <a:pPr algn="l"/>
+            <a:r>
+              <a:rPr sz="1000" b="0">
+                <a:solidFill>
+                  <a:srgbClr val="9AA7BC"/>
+                </a:solidFill>
+                <a:latin typeface="Segoe UI"/>
+                <a:ea typeface="Microsoft YaHei"/>
+                <a:cs typeface="Segoe UI"/>
               </a:rPr>
               <a:t>DCC-MCP 框架介绍</a:t>
             </a:r>
@@ -7169,7 +7053,7 @@
       </p:sp>
       <p:sp>
         <p:nvSpPr>
-          <p:cNvPr id="10" name="TextBox 9"/>
+          <p:cNvPr id="9" name="TextBox 8"/>
           <p:cNvSpPr txBox="1"/>
           <p:nvPr/>
         </p:nvSpPr>
@@ -7198,8 +7082,9 @@
                 </a:solidFill>
                 <a:latin typeface="Segoe UI"/>
                 <a:ea typeface="Microsoft YaHei"/>
+                <a:cs typeface="Segoe UI"/>
               </a:rPr>
-              <a:t>13 / 14</a:t>
+              <a:t>13 / 16</a:t>
             </a:r>
           </a:p>
         </p:txBody>
@@ -7268,6 +7153,1336 @@
       </p:sp>
       <p:sp>
         <p:nvSpPr>
+          <p:cNvPr id="3" name="TextBox 2"/>
+          <p:cNvSpPr txBox="1"/>
+          <p:nvPr/>
+        </p:nvSpPr>
+        <p:spPr>
+          <a:xfrm>
+            <a:off x="822960" y="502920"/>
+            <a:ext cx="10515600" cy="685800"/>
+          </a:xfrm>
+          <a:prstGeom prst="rect">
+            <a:avLst/>
+          </a:prstGeom>
+          <a:noFill/>
+          <a:effectLst/>
+        </p:spPr>
+        <p:txBody>
+          <a:bodyPr wrap="square" lIns="50800" rIns="50800">
+            <a:spAutoFit/>
+          </a:bodyPr>
+          <a:lstStyle/>
+          <a:p>
+            <a:pPr algn="l"/>
+            <a:r>
+              <a:rPr sz="2800" b="1">
+                <a:solidFill>
+                  <a:srgbClr val="E8ECF2"/>
+                </a:solidFill>
+                <a:latin typeface="Segoe UI"/>
+                <a:ea typeface="Microsoft YaHei"/>
+                <a:cs typeface="Segoe UI"/>
+              </a:rPr>
+              <a:t>Office 双后端</a:t>
+            </a:r>
+          </a:p>
+        </p:txBody>
+      </p:sp>
+      <p:sp>
+        <p:nvSpPr>
+          <p:cNvPr id="4" name="Rectangle 3"/>
+          <p:cNvSpPr/>
+          <p:nvPr/>
+        </p:nvSpPr>
+        <p:spPr>
+          <a:xfrm>
+            <a:off x="822960" y="1298448"/>
+            <a:ext cx="822960" cy="44450"/>
+          </a:xfrm>
+          <a:prstGeom prst="rect">
+            <a:avLst/>
+          </a:prstGeom>
+          <a:solidFill>
+            <a:srgbClr val="4D9DE0"/>
+          </a:solidFill>
+          <a:ln>
+            <a:noFill/>
+          </a:ln>
+          <a:effectLst/>
+        </p:spPr>
+        <p:style>
+          <a:lnRef idx="1">
+            <a:schemeClr val="accent1"/>
+          </a:lnRef>
+          <a:fillRef idx="3">
+            <a:schemeClr val="accent1"/>
+          </a:fillRef>
+          <a:effectRef idx="2">
+            <a:schemeClr val="accent1"/>
+          </a:effectRef>
+          <a:fontRef idx="minor">
+            <a:schemeClr val="lt1"/>
+          </a:fontRef>
+        </p:style>
+        <p:txBody>
+          <a:bodyPr rtlCol="0" anchor="ctr" wrap="square"/>
+          <a:lstStyle/>
+          <a:p>
+            <a:pPr algn="ctr"/>
+          </a:p>
+        </p:txBody>
+      </p:sp>
+      <p:sp>
+        <p:nvSpPr>
+          <p:cNvPr id="5" name="Oval 4"/>
+          <p:cNvSpPr/>
+          <p:nvPr/>
+        </p:nvSpPr>
+        <p:spPr>
+          <a:xfrm>
+            <a:off x="2148840" y="1819656"/>
+            <a:ext cx="384048" cy="384048"/>
+          </a:xfrm>
+          <a:prstGeom prst="ellipse">
+            <a:avLst/>
+          </a:prstGeom>
+          <a:solidFill>
+            <a:srgbClr val="171F2E"/>
+          </a:solidFill>
+          <a:ln w="15240">
+            <a:solidFill>
+              <a:srgbClr val="4D9DE0"/>
+            </a:solidFill>
+          </a:ln>
+          <a:effectLst/>
+        </p:spPr>
+        <p:style>
+          <a:lnRef idx="1">
+            <a:schemeClr val="accent1"/>
+          </a:lnRef>
+          <a:fillRef idx="3">
+            <a:schemeClr val="accent1"/>
+          </a:fillRef>
+          <a:effectRef idx="2">
+            <a:schemeClr val="accent1"/>
+          </a:effectRef>
+          <a:fontRef idx="minor">
+            <a:schemeClr val="lt1"/>
+          </a:fontRef>
+        </p:style>
+        <p:txBody>
+          <a:bodyPr rtlCol="0" anchor="ctr" wrap="square" lIns="101600" rIns="101600" tIns="76200" bIns="76200"/>
+          <a:lstStyle/>
+          <a:p>
+            <a:pPr algn="ctr"/>
+            <a:r>
+              <a:rPr sz="1200" b="1">
+                <a:solidFill>
+                  <a:srgbClr val="4D9DE0"/>
+                </a:solidFill>
+                <a:latin typeface="Segoe UI"/>
+                <a:ea typeface="Microsoft YaHei"/>
+                <a:cs typeface="Segoe UI"/>
+              </a:rPr>
+              <a:t>1</a:t>
+            </a:r>
+          </a:p>
+        </p:txBody>
+      </p:sp>
+      <p:sp>
+        <p:nvSpPr>
+          <p:cNvPr id="6" name="Rounded Rectangle 5"/>
+          <p:cNvSpPr/>
+          <p:nvPr/>
+        </p:nvSpPr>
+        <p:spPr>
+          <a:xfrm>
+            <a:off x="2788920" y="1673352"/>
+            <a:ext cx="8412480" cy="713232"/>
+          </a:xfrm>
+          <a:prstGeom prst="roundRect">
+            <a:avLst>
+              <a:gd name="adj" fmla="val 10000"/>
+            </a:avLst>
+          </a:prstGeom>
+          <a:solidFill>
+            <a:srgbClr val="1E2A3D"/>
+          </a:solidFill>
+          <a:ln>
+            <a:noFill/>
+          </a:ln>
+          <a:effectLst/>
+        </p:spPr>
+        <p:style>
+          <a:lnRef idx="1">
+            <a:schemeClr val="accent1"/>
+          </a:lnRef>
+          <a:fillRef idx="3">
+            <a:schemeClr val="accent1"/>
+          </a:fillRef>
+          <a:effectRef idx="2">
+            <a:schemeClr val="accent1"/>
+          </a:effectRef>
+          <a:fontRef idx="minor">
+            <a:schemeClr val="lt1"/>
+          </a:fontRef>
+        </p:style>
+        <p:txBody>
+          <a:bodyPr rtlCol="0" anchor="ctr" wrap="square" lIns="101600" rIns="101600" tIns="76200" bIns="76200"/>
+          <a:lstStyle/>
+          <a:p>
+            <a:pPr algn="ctr"/>
+            <a:r>
+              <a:rPr sz="1450" b="0">
+                <a:solidFill>
+                  <a:srgbClr val="E8ECF2"/>
+                </a:solidFill>
+                <a:latin typeface="Segoe UI"/>
+                <a:ea typeface="Microsoft YaHei"/>
+                <a:cs typeface="Segoe UI"/>
+              </a:rPr>
+              <a:t>Rust Gateway（dcc-mcp-core）：控制面 · Job · Artifact · 安全策略</a:t>
+            </a:r>
+          </a:p>
+        </p:txBody>
+      </p:sp>
+      <p:sp>
+        <p:nvSpPr>
+          <p:cNvPr id="7" name="Oval 6"/>
+          <p:cNvSpPr/>
+          <p:nvPr/>
+        </p:nvSpPr>
+        <p:spPr>
+          <a:xfrm>
+            <a:off x="2148840" y="2688336"/>
+            <a:ext cx="384048" cy="384048"/>
+          </a:xfrm>
+          <a:prstGeom prst="ellipse">
+            <a:avLst/>
+          </a:prstGeom>
+          <a:solidFill>
+            <a:srgbClr val="171F2E"/>
+          </a:solidFill>
+          <a:ln w="15240">
+            <a:solidFill>
+              <a:srgbClr val="4D9DE0"/>
+            </a:solidFill>
+          </a:ln>
+          <a:effectLst/>
+        </p:spPr>
+        <p:style>
+          <a:lnRef idx="1">
+            <a:schemeClr val="accent1"/>
+          </a:lnRef>
+          <a:fillRef idx="3">
+            <a:schemeClr val="accent1"/>
+          </a:fillRef>
+          <a:effectRef idx="2">
+            <a:schemeClr val="accent1"/>
+          </a:effectRef>
+          <a:fontRef idx="minor">
+            <a:schemeClr val="lt1"/>
+          </a:fontRef>
+        </p:style>
+        <p:txBody>
+          <a:bodyPr rtlCol="0" anchor="ctr" wrap="square" lIns="101600" rIns="101600" tIns="76200" bIns="76200"/>
+          <a:lstStyle/>
+          <a:p>
+            <a:pPr algn="ctr"/>
+            <a:r>
+              <a:rPr sz="1200" b="1">
+                <a:solidFill>
+                  <a:srgbClr val="4D9DE0"/>
+                </a:solidFill>
+                <a:latin typeface="Segoe UI"/>
+                <a:ea typeface="Microsoft YaHei"/>
+                <a:cs typeface="Segoe UI"/>
+              </a:rPr>
+              <a:t>2</a:t>
+            </a:r>
+          </a:p>
+        </p:txBody>
+      </p:sp>
+      <p:sp>
+        <p:nvSpPr>
+          <p:cNvPr id="8" name="Rounded Rectangle 7"/>
+          <p:cNvSpPr/>
+          <p:nvPr/>
+        </p:nvSpPr>
+        <p:spPr>
+          <a:xfrm>
+            <a:off x="2788920" y="2542032"/>
+            <a:ext cx="8412480" cy="713232"/>
+          </a:xfrm>
+          <a:prstGeom prst="roundRect">
+            <a:avLst>
+              <a:gd name="adj" fmla="val 10000"/>
+            </a:avLst>
+          </a:prstGeom>
+          <a:solidFill>
+            <a:srgbClr val="1E2A3D"/>
+          </a:solidFill>
+          <a:ln>
+            <a:noFill/>
+          </a:ln>
+          <a:effectLst/>
+        </p:spPr>
+        <p:style>
+          <a:lnRef idx="1">
+            <a:schemeClr val="accent1"/>
+          </a:lnRef>
+          <a:fillRef idx="3">
+            <a:schemeClr val="accent1"/>
+          </a:fillRef>
+          <a:effectRef idx="2">
+            <a:schemeClr val="accent1"/>
+          </a:effectRef>
+          <a:fontRef idx="minor">
+            <a:schemeClr val="lt1"/>
+          </a:fontRef>
+        </p:style>
+        <p:txBody>
+          <a:bodyPr rtlCol="0" anchor="ctr" wrap="square" lIns="101600" rIns="101600" tIns="76200" bIns="76200"/>
+          <a:lstStyle/>
+          <a:p>
+            <a:pPr algn="ctr"/>
+            <a:r>
+              <a:rPr sz="1450" b="0">
+                <a:solidFill>
+                  <a:srgbClr val="E8ECF2"/>
+                </a:solidFill>
+                <a:latin typeface="Segoe UI"/>
+                <a:ea typeface="Microsoft YaHei"/>
+                <a:cs typeface="Segoe UI"/>
+              </a:rPr>
+              <a:t>office-host.exe（C#）：每应用独立 Sidecar · 单 STA 队列</a:t>
+            </a:r>
+          </a:p>
+        </p:txBody>
+      </p:sp>
+      <p:sp>
+        <p:nvSpPr>
+          <p:cNvPr id="9" name="Oval 8"/>
+          <p:cNvSpPr/>
+          <p:nvPr/>
+        </p:nvSpPr>
+        <p:spPr>
+          <a:xfrm>
+            <a:off x="2148840" y="3557016"/>
+            <a:ext cx="384048" cy="384048"/>
+          </a:xfrm>
+          <a:prstGeom prst="ellipse">
+            <a:avLst/>
+          </a:prstGeom>
+          <a:solidFill>
+            <a:srgbClr val="171F2E"/>
+          </a:solidFill>
+          <a:ln w="15240">
+            <a:solidFill>
+              <a:srgbClr val="4D9DE0"/>
+            </a:solidFill>
+          </a:ln>
+          <a:effectLst/>
+        </p:spPr>
+        <p:style>
+          <a:lnRef idx="1">
+            <a:schemeClr val="accent1"/>
+          </a:lnRef>
+          <a:fillRef idx="3">
+            <a:schemeClr val="accent1"/>
+          </a:fillRef>
+          <a:effectRef idx="2">
+            <a:schemeClr val="accent1"/>
+          </a:effectRef>
+          <a:fontRef idx="minor">
+            <a:schemeClr val="lt1"/>
+          </a:fontRef>
+        </p:style>
+        <p:txBody>
+          <a:bodyPr rtlCol="0" anchor="ctr" wrap="square" lIns="101600" rIns="101600" tIns="76200" bIns="76200"/>
+          <a:lstStyle/>
+          <a:p>
+            <a:pPr algn="ctr"/>
+            <a:r>
+              <a:rPr sz="1200" b="1">
+                <a:solidFill>
+                  <a:srgbClr val="4D9DE0"/>
+                </a:solidFill>
+                <a:latin typeface="Segoe UI"/>
+                <a:ea typeface="Microsoft YaHei"/>
+                <a:cs typeface="Segoe UI"/>
+              </a:rPr>
+              <a:t>3</a:t>
+            </a:r>
+          </a:p>
+        </p:txBody>
+      </p:sp>
+      <p:sp>
+        <p:nvSpPr>
+          <p:cNvPr id="10" name="Rounded Rectangle 9"/>
+          <p:cNvSpPr/>
+          <p:nvPr/>
+        </p:nvSpPr>
+        <p:spPr>
+          <a:xfrm>
+            <a:off x="2788920" y="3410712"/>
+            <a:ext cx="8412480" cy="713232"/>
+          </a:xfrm>
+          <a:prstGeom prst="roundRect">
+            <a:avLst>
+              <a:gd name="adj" fmla="val 10000"/>
+            </a:avLst>
+          </a:prstGeom>
+          <a:solidFill>
+            <a:srgbClr val="1E2A3D"/>
+          </a:solidFill>
+          <a:ln>
+            <a:noFill/>
+          </a:ln>
+          <a:effectLst/>
+        </p:spPr>
+        <p:style>
+          <a:lnRef idx="1">
+            <a:schemeClr val="accent1"/>
+          </a:lnRef>
+          <a:fillRef idx="3">
+            <a:schemeClr val="accent1"/>
+          </a:fillRef>
+          <a:effectRef idx="2">
+            <a:schemeClr val="accent1"/>
+          </a:effectRef>
+          <a:fontRef idx="minor">
+            <a:schemeClr val="lt1"/>
+          </a:fontRef>
+        </p:style>
+        <p:txBody>
+          <a:bodyPr rtlCol="0" anchor="ctr" wrap="square" lIns="101600" rIns="101600" tIns="76200" bIns="76200"/>
+          <a:lstStyle/>
+          <a:p>
+            <a:pPr algn="ctr"/>
+            <a:r>
+              <a:rPr sz="1450" b="0">
+                <a:solidFill>
+                  <a:srgbClr val="E8ECF2"/>
+                </a:solidFill>
+                <a:latin typeface="Segoe UI"/>
+                <a:ea typeface="Microsoft YaHei"/>
+                <a:cs typeface="Segoe UI"/>
+              </a:rPr>
+              <a:t>POWERPNT / WINWORD / EXCEL（COM 数据面）</a:t>
+            </a:r>
+          </a:p>
+        </p:txBody>
+      </p:sp>
+      <p:sp>
+        <p:nvSpPr>
+          <p:cNvPr id="11" name="Oval 10"/>
+          <p:cNvSpPr/>
+          <p:nvPr/>
+        </p:nvSpPr>
+        <p:spPr>
+          <a:xfrm>
+            <a:off x="2148840" y="4425696"/>
+            <a:ext cx="384048" cy="384048"/>
+          </a:xfrm>
+          <a:prstGeom prst="ellipse">
+            <a:avLst/>
+          </a:prstGeom>
+          <a:solidFill>
+            <a:srgbClr val="171F2E"/>
+          </a:solidFill>
+          <a:ln w="15240">
+            <a:solidFill>
+              <a:srgbClr val="4D9DE0"/>
+            </a:solidFill>
+          </a:ln>
+          <a:effectLst/>
+        </p:spPr>
+        <p:style>
+          <a:lnRef idx="1">
+            <a:schemeClr val="accent1"/>
+          </a:lnRef>
+          <a:fillRef idx="3">
+            <a:schemeClr val="accent1"/>
+          </a:fillRef>
+          <a:effectRef idx="2">
+            <a:schemeClr val="accent1"/>
+          </a:effectRef>
+          <a:fontRef idx="minor">
+            <a:schemeClr val="lt1"/>
+          </a:fontRef>
+        </p:style>
+        <p:txBody>
+          <a:bodyPr rtlCol="0" anchor="ctr" wrap="square" lIns="101600" rIns="101600" tIns="76200" bIns="76200"/>
+          <a:lstStyle/>
+          <a:p>
+            <a:pPr algn="ctr"/>
+            <a:r>
+              <a:rPr sz="1200" b="1">
+                <a:solidFill>
+                  <a:srgbClr val="4D9DE0"/>
+                </a:solidFill>
+                <a:latin typeface="Segoe UI"/>
+                <a:ea typeface="Microsoft YaHei"/>
+                <a:cs typeface="Segoe UI"/>
+              </a:rPr>
+              <a:t>4</a:t>
+            </a:r>
+          </a:p>
+        </p:txBody>
+      </p:sp>
+      <p:sp>
+        <p:nvSpPr>
+          <p:cNvPr id="12" name="Rounded Rectangle 11"/>
+          <p:cNvSpPr/>
+          <p:nvPr/>
+        </p:nvSpPr>
+        <p:spPr>
+          <a:xfrm>
+            <a:off x="2788920" y="4279392"/>
+            <a:ext cx="8412480" cy="713232"/>
+          </a:xfrm>
+          <a:prstGeom prst="roundRect">
+            <a:avLst>
+              <a:gd name="adj" fmla="val 10000"/>
+            </a:avLst>
+          </a:prstGeom>
+          <a:solidFill>
+            <a:srgbClr val="1E2A3D"/>
+          </a:solidFill>
+          <a:ln>
+            <a:noFill/>
+          </a:ln>
+          <a:effectLst/>
+        </p:spPr>
+        <p:style>
+          <a:lnRef idx="1">
+            <a:schemeClr val="accent1"/>
+          </a:lnRef>
+          <a:fillRef idx="3">
+            <a:schemeClr val="accent1"/>
+          </a:fillRef>
+          <a:effectRef idx="2">
+            <a:schemeClr val="accent1"/>
+          </a:effectRef>
+          <a:fontRef idx="minor">
+            <a:schemeClr val="lt1"/>
+          </a:fontRef>
+        </p:style>
+        <p:txBody>
+          <a:bodyPr rtlCol="0" anchor="ctr" wrap="square" lIns="101600" rIns="101600" tIns="76200" bIns="76200"/>
+          <a:lstStyle/>
+          <a:p>
+            <a:pPr algn="ctr"/>
+            <a:r>
+              <a:rPr sz="1450" b="0">
+                <a:solidFill>
+                  <a:srgbClr val="E8ECF2"/>
+                </a:solidFill>
+                <a:latin typeface="Segoe UI"/>
+                <a:ea typeface="Microsoft YaHei"/>
+                <a:cs typeface="Segoe UI"/>
+              </a:rPr>
+              <a:t>Open XML Worker：批量结构处理（编译器，非渲染器）</a:t>
+            </a:r>
+          </a:p>
+        </p:txBody>
+      </p:sp>
+      <p:sp>
+        <p:nvSpPr>
+          <p:cNvPr id="13" name="Oval 12"/>
+          <p:cNvSpPr/>
+          <p:nvPr/>
+        </p:nvSpPr>
+        <p:spPr>
+          <a:xfrm>
+            <a:off x="2148840" y="5294376"/>
+            <a:ext cx="384048" cy="384048"/>
+          </a:xfrm>
+          <a:prstGeom prst="ellipse">
+            <a:avLst/>
+          </a:prstGeom>
+          <a:solidFill>
+            <a:srgbClr val="171F2E"/>
+          </a:solidFill>
+          <a:ln w="15240">
+            <a:solidFill>
+              <a:srgbClr val="4D9DE0"/>
+            </a:solidFill>
+          </a:ln>
+          <a:effectLst/>
+        </p:spPr>
+        <p:style>
+          <a:lnRef idx="1">
+            <a:schemeClr val="accent1"/>
+          </a:lnRef>
+          <a:fillRef idx="3">
+            <a:schemeClr val="accent1"/>
+          </a:fillRef>
+          <a:effectRef idx="2">
+            <a:schemeClr val="accent1"/>
+          </a:effectRef>
+          <a:fontRef idx="minor">
+            <a:schemeClr val="lt1"/>
+          </a:fontRef>
+        </p:style>
+        <p:txBody>
+          <a:bodyPr rtlCol="0" anchor="ctr" wrap="square" lIns="101600" rIns="101600" tIns="76200" bIns="76200"/>
+          <a:lstStyle/>
+          <a:p>
+            <a:pPr algn="ctr"/>
+            <a:r>
+              <a:rPr sz="1200" b="1">
+                <a:solidFill>
+                  <a:srgbClr val="4D9DE0"/>
+                </a:solidFill>
+                <a:latin typeface="Segoe UI"/>
+                <a:ea typeface="Microsoft YaHei"/>
+                <a:cs typeface="Segoe UI"/>
+              </a:rPr>
+              <a:t>5</a:t>
+            </a:r>
+          </a:p>
+        </p:txBody>
+      </p:sp>
+      <p:sp>
+        <p:nvSpPr>
+          <p:cNvPr id="14" name="Rounded Rectangle 13"/>
+          <p:cNvSpPr/>
+          <p:nvPr/>
+        </p:nvSpPr>
+        <p:spPr>
+          <a:xfrm>
+            <a:off x="2788920" y="5148072"/>
+            <a:ext cx="8412480" cy="713232"/>
+          </a:xfrm>
+          <a:prstGeom prst="roundRect">
+            <a:avLst>
+              <a:gd name="adj" fmla="val 10000"/>
+            </a:avLst>
+          </a:prstGeom>
+          <a:solidFill>
+            <a:srgbClr val="1E2A3D"/>
+          </a:solidFill>
+          <a:ln>
+            <a:noFill/>
+          </a:ln>
+          <a:effectLst/>
+        </p:spPr>
+        <p:style>
+          <a:lnRef idx="1">
+            <a:schemeClr val="accent1"/>
+          </a:lnRef>
+          <a:fillRef idx="3">
+            <a:schemeClr val="accent1"/>
+          </a:fillRef>
+          <a:effectRef idx="2">
+            <a:schemeClr val="accent1"/>
+          </a:effectRef>
+          <a:fontRef idx="minor">
+            <a:schemeClr val="lt1"/>
+          </a:fontRef>
+        </p:style>
+        <p:txBody>
+          <a:bodyPr rtlCol="0" anchor="ctr" wrap="square" lIns="101600" rIns="101600" tIns="76200" bIns="76200"/>
+          <a:lstStyle/>
+          <a:p>
+            <a:pPr algn="ctr"/>
+            <a:r>
+              <a:rPr sz="1450" b="0">
+                <a:solidFill>
+                  <a:srgbClr val="E8ECF2"/>
+                </a:solidFill>
+                <a:latin typeface="Segoe UI"/>
+                <a:ea typeface="Microsoft YaHei"/>
+                <a:cs typeface="Segoe UI"/>
+              </a:rPr>
+              <a:t>Microsoft Graph / Office.js / UIA-CUA：云与兜底路径</a:t>
+            </a:r>
+          </a:p>
+        </p:txBody>
+      </p:sp>
+      <p:cxnSp>
+        <p:nvCxnSpPr>
+          <p:cNvPr id="15" name="Connector 14"/>
+          <p:cNvCxnSpPr/>
+          <p:nvPr/>
+        </p:nvCxnSpPr>
+        <p:spPr>
+          <a:xfrm>
+            <a:off x="2340864" y="2194560"/>
+            <a:ext cx="0" cy="3474719"/>
+          </a:xfrm>
+          <a:prstGeom prst="line">
+            <a:avLst/>
+          </a:prstGeom>
+          <a:ln>
+            <a:solidFill>
+              <a:srgbClr val="4D9DE0"/>
+            </a:solidFill>
+          </a:ln>
+          <a:effectLst/>
+        </p:spPr>
+        <p:style>
+          <a:lnRef idx="2">
+            <a:schemeClr val="accent1"/>
+          </a:lnRef>
+          <a:fillRef idx="0">
+            <a:schemeClr val="accent1"/>
+          </a:fillRef>
+          <a:effectRef idx="1">
+            <a:schemeClr val="accent1"/>
+          </a:effectRef>
+          <a:fontRef idx="minor">
+            <a:schemeClr val="tx1"/>
+          </a:fontRef>
+        </p:style>
+      </p:cxnSp>
+      <p:sp>
+        <p:nvSpPr>
+          <p:cNvPr id="16" name="TextBox 15"/>
+          <p:cNvSpPr txBox="1"/>
+          <p:nvPr/>
+        </p:nvSpPr>
+        <p:spPr>
+          <a:xfrm>
+            <a:off x="822960" y="6473952"/>
+            <a:ext cx="7315200" cy="274320"/>
+          </a:xfrm>
+          <a:prstGeom prst="rect">
+            <a:avLst/>
+          </a:prstGeom>
+          <a:noFill/>
+          <a:effectLst/>
+        </p:spPr>
+        <p:txBody>
+          <a:bodyPr wrap="square" lIns="50800" rIns="50800">
+            <a:spAutoFit/>
+          </a:bodyPr>
+          <a:lstStyle/>
+          <a:p>
+            <a:pPr algn="l"/>
+            <a:r>
+              <a:rPr sz="1000" b="0">
+                <a:solidFill>
+                  <a:srgbClr val="9AA7BC"/>
+                </a:solidFill>
+                <a:latin typeface="Segoe UI"/>
+                <a:ea typeface="Microsoft YaHei"/>
+                <a:cs typeface="Segoe UI"/>
+              </a:rPr>
+              <a:t>DCC-MCP 框架介绍</a:t>
+            </a:r>
+          </a:p>
+        </p:txBody>
+      </p:sp>
+      <p:sp>
+        <p:nvSpPr>
+          <p:cNvPr id="17" name="TextBox 16"/>
+          <p:cNvSpPr txBox="1"/>
+          <p:nvPr/>
+        </p:nvSpPr>
+        <p:spPr>
+          <a:xfrm>
+            <a:off x="10728655" y="6400800"/>
+            <a:ext cx="1097280" cy="320040"/>
+          </a:xfrm>
+          <a:prstGeom prst="rect">
+            <a:avLst/>
+          </a:prstGeom>
+          <a:noFill/>
+          <a:effectLst/>
+        </p:spPr>
+        <p:txBody>
+          <a:bodyPr wrap="none">
+            <a:spAutoFit/>
+          </a:bodyPr>
+          <a:lstStyle/>
+          <a:p>
+            <a:pPr algn="r"/>
+            <a:r>
+              <a:rPr sz="1000" b="0">
+                <a:solidFill>
+                  <a:srgbClr val="9AA7BC"/>
+                </a:solidFill>
+                <a:latin typeface="Segoe UI"/>
+                <a:ea typeface="Microsoft YaHei"/>
+                <a:cs typeface="Segoe UI"/>
+              </a:rPr>
+              <a:t>14 / 16</a:t>
+            </a:r>
+          </a:p>
+        </p:txBody>
+      </p:sp>
+    </p:spTree>
+  </p:cSld>
+  <p:clrMapOvr>
+    <a:masterClrMapping/>
+  </p:clrMapOvr>
+</p:sld>
+</file>
+
+<file path=ppt/slides/slide15.xml><?xml version="1.0" encoding="utf-8"?>
+<p:sld xmlns:a="http://schemas.openxmlformats.org/drawingml/2006/main" xmlns:p="http://schemas.openxmlformats.org/presentationml/2006/main" xmlns:r="http://schemas.openxmlformats.org/officeDocument/2006/relationships">
+  <p:cSld>
+    <p:spTree>
+      <p:nvGrpSpPr>
+        <p:cNvPr id="1" name=""/>
+        <p:cNvGrpSpPr/>
+        <p:nvPr/>
+      </p:nvGrpSpPr>
+      <p:grpSpPr/>
+      <p:sp>
+        <p:nvSpPr>
+          <p:cNvPr id="2" name="Rectangle 1"/>
+          <p:cNvSpPr/>
+          <p:nvPr/>
+        </p:nvSpPr>
+        <p:spPr>
+          <a:xfrm>
+            <a:off x="0" y="0"/>
+            <a:ext cx="12191695" cy="6858000"/>
+          </a:xfrm>
+          <a:prstGeom prst="rect">
+            <a:avLst/>
+          </a:prstGeom>
+          <a:solidFill>
+            <a:srgbClr val="0F141E"/>
+          </a:solidFill>
+          <a:ln>
+            <a:noFill/>
+          </a:ln>
+          <a:effectLst/>
+        </p:spPr>
+        <p:style>
+          <a:lnRef idx="1">
+            <a:schemeClr val="accent1"/>
+          </a:lnRef>
+          <a:fillRef idx="3">
+            <a:schemeClr val="accent1"/>
+          </a:fillRef>
+          <a:effectRef idx="2">
+            <a:schemeClr val="accent1"/>
+          </a:effectRef>
+          <a:fontRef idx="minor">
+            <a:schemeClr val="lt1"/>
+          </a:fontRef>
+        </p:style>
+        <p:txBody>
+          <a:bodyPr rtlCol="0" anchor="ctr"/>
+          <a:lstStyle/>
+          <a:p>
+            <a:pPr algn="ctr"/>
+          </a:p>
+        </p:txBody>
+      </p:sp>
+      <p:sp>
+        <p:nvSpPr>
+          <p:cNvPr id="3" name="TextBox 2"/>
+          <p:cNvSpPr txBox="1"/>
+          <p:nvPr/>
+        </p:nvSpPr>
+        <p:spPr>
+          <a:xfrm>
+            <a:off x="822960" y="502920"/>
+            <a:ext cx="10515600" cy="685800"/>
+          </a:xfrm>
+          <a:prstGeom prst="rect">
+            <a:avLst/>
+          </a:prstGeom>
+          <a:noFill/>
+          <a:effectLst/>
+        </p:spPr>
+        <p:txBody>
+          <a:bodyPr wrap="square" lIns="50800" rIns="50800">
+            <a:spAutoFit/>
+          </a:bodyPr>
+          <a:lstStyle/>
+          <a:p>
+            <a:pPr algn="l"/>
+            <a:r>
+              <a:rPr sz="2800" b="1">
+                <a:solidFill>
+                  <a:srgbClr val="E8ECF2"/>
+                </a:solidFill>
+                <a:latin typeface="Segoe UI"/>
+                <a:ea typeface="Microsoft YaHei"/>
+                <a:cs typeface="Segoe UI"/>
+              </a:rPr>
+              <a:t>设计取舍</a:t>
+            </a:r>
+          </a:p>
+        </p:txBody>
+      </p:sp>
+      <p:sp>
+        <p:nvSpPr>
+          <p:cNvPr id="4" name="Rectangle 3"/>
+          <p:cNvSpPr/>
+          <p:nvPr/>
+        </p:nvSpPr>
+        <p:spPr>
+          <a:xfrm>
+            <a:off x="822960" y="1298448"/>
+            <a:ext cx="822960" cy="44450"/>
+          </a:xfrm>
+          <a:prstGeom prst="rect">
+            <a:avLst/>
+          </a:prstGeom>
+          <a:solidFill>
+            <a:srgbClr val="4D9DE0"/>
+          </a:solidFill>
+          <a:ln>
+            <a:noFill/>
+          </a:ln>
+          <a:effectLst/>
+        </p:spPr>
+        <p:style>
+          <a:lnRef idx="1">
+            <a:schemeClr val="accent1"/>
+          </a:lnRef>
+          <a:fillRef idx="3">
+            <a:schemeClr val="accent1"/>
+          </a:fillRef>
+          <a:effectRef idx="2">
+            <a:schemeClr val="accent1"/>
+          </a:effectRef>
+          <a:fontRef idx="minor">
+            <a:schemeClr val="lt1"/>
+          </a:fontRef>
+        </p:style>
+        <p:txBody>
+          <a:bodyPr rtlCol="0" anchor="ctr" wrap="square"/>
+          <a:lstStyle/>
+          <a:p>
+            <a:pPr algn="ctr"/>
+          </a:p>
+        </p:txBody>
+      </p:sp>
+      <p:sp>
+        <p:nvSpPr>
+          <p:cNvPr id="5" name="Rounded Rectangle 4"/>
+          <p:cNvSpPr/>
+          <p:nvPr/>
+        </p:nvSpPr>
+        <p:spPr>
+          <a:xfrm>
+            <a:off x="822960" y="1627632"/>
+            <a:ext cx="5120640" cy="566928"/>
+          </a:xfrm>
+          <a:prstGeom prst="roundRect">
+            <a:avLst>
+              <a:gd name="adj" fmla="val 16000"/>
+            </a:avLst>
+          </a:prstGeom>
+          <a:solidFill>
+            <a:srgbClr val="4D9DE0"/>
+          </a:solidFill>
+          <a:ln>
+            <a:noFill/>
+          </a:ln>
+          <a:effectLst/>
+        </p:spPr>
+        <p:style>
+          <a:lnRef idx="1">
+            <a:schemeClr val="accent1"/>
+          </a:lnRef>
+          <a:fillRef idx="3">
+            <a:schemeClr val="accent1"/>
+          </a:fillRef>
+          <a:effectRef idx="2">
+            <a:schemeClr val="accent1"/>
+          </a:effectRef>
+          <a:fontRef idx="minor">
+            <a:schemeClr val="lt1"/>
+          </a:fontRef>
+        </p:style>
+        <p:txBody>
+          <a:bodyPr rtlCol="0" anchor="ctr" wrap="square" lIns="101600" rIns="101600" tIns="76200" bIns="76200"/>
+          <a:lstStyle/>
+          <a:p>
+            <a:pPr algn="ctr"/>
+            <a:r>
+              <a:rPr sz="1600" b="1">
+                <a:solidFill>
+                  <a:srgbClr val="E8ECF2"/>
+                </a:solidFill>
+                <a:latin typeface="Segoe UI"/>
+                <a:ea typeface="Microsoft YaHei"/>
+                <a:cs typeface="Segoe UI"/>
+              </a:rPr>
+              <a:t>结构化 API 优先</a:t>
+            </a:r>
+          </a:p>
+        </p:txBody>
+      </p:sp>
+      <p:sp>
+        <p:nvSpPr>
+          <p:cNvPr id="6" name="Rounded Rectangle 5"/>
+          <p:cNvSpPr/>
+          <p:nvPr/>
+        </p:nvSpPr>
+        <p:spPr>
+          <a:xfrm>
+            <a:off x="822960" y="2304288"/>
+            <a:ext cx="5120640" cy="3749039"/>
+          </a:xfrm>
+          <a:prstGeom prst="roundRect">
+            <a:avLst>
+              <a:gd name="adj" fmla="val 5000"/>
+            </a:avLst>
+          </a:prstGeom>
+          <a:solidFill>
+            <a:srgbClr val="1E2A3D"/>
+          </a:solidFill>
+          <a:ln>
+            <a:noFill/>
+          </a:ln>
+          <a:effectLst/>
+        </p:spPr>
+        <p:style>
+          <a:lnRef idx="1">
+            <a:schemeClr val="accent1"/>
+          </a:lnRef>
+          <a:fillRef idx="3">
+            <a:schemeClr val="accent1"/>
+          </a:fillRef>
+          <a:effectRef idx="2">
+            <a:schemeClr val="accent1"/>
+          </a:effectRef>
+          <a:fontRef idx="minor">
+            <a:schemeClr val="lt1"/>
+          </a:fontRef>
+        </p:style>
+        <p:txBody>
+          <a:bodyPr rtlCol="0" anchor="ctr" wrap="square" lIns="101600" rIns="101600" tIns="76200" bIns="76200"/>
+          <a:lstStyle/>
+          <a:p>
+            <a:pPr algn="l"/>
+            <a:r>
+              <a:rPr sz="1450" b="0">
+                <a:solidFill>
+                  <a:srgbClr val="E8ECF2"/>
+                </a:solidFill>
+                <a:latin typeface="Segoe UI"/>
+                <a:ea typeface="Microsoft YaHei"/>
+                <a:cs typeface="Segoe UI"/>
+              </a:rPr>
+              <a:t>✓  确定性、可验证、可审计</a:t>
+            </a:r>
+          </a:p>
+          <a:p>
+            <a:pPr algn="l"/>
+            <a:r>
+              <a:rPr sz="1450" b="0">
+                <a:solidFill>
+                  <a:srgbClr val="E8ECF2"/>
+                </a:solidFill>
+                <a:latin typeface="Segoe UI"/>
+                <a:ea typeface="Microsoft YaHei"/>
+                <a:cs typeface="Segoe UI"/>
+              </a:rPr>
+              <a:t>✓  UIA/CUA 只做最后兜底</a:t>
+            </a:r>
+          </a:p>
+          <a:p>
+            <a:pPr algn="l"/>
+            <a:r>
+              <a:rPr sz="1450" b="0">
+                <a:solidFill>
+                  <a:srgbClr val="E8ECF2"/>
+                </a:solidFill>
+                <a:latin typeface="Segoe UI"/>
+                <a:ea typeface="Microsoft YaHei"/>
+                <a:cs typeface="Segoe UI"/>
+              </a:rPr>
+              <a:t>✓  写操作不得静默降级</a:t>
+            </a:r>
+          </a:p>
+        </p:txBody>
+      </p:sp>
+      <p:sp>
+        <p:nvSpPr>
+          <p:cNvPr id="7" name="Rounded Rectangle 6"/>
+          <p:cNvSpPr/>
+          <p:nvPr/>
+        </p:nvSpPr>
+        <p:spPr>
+          <a:xfrm>
+            <a:off x="6309360" y="1627632"/>
+            <a:ext cx="5120640" cy="566928"/>
+          </a:xfrm>
+          <a:prstGeom prst="roundRect">
+            <a:avLst>
+              <a:gd name="adj" fmla="val 16000"/>
+            </a:avLst>
+          </a:prstGeom>
+          <a:solidFill>
+            <a:srgbClr val="7FC8A9"/>
+          </a:solidFill>
+          <a:ln>
+            <a:noFill/>
+          </a:ln>
+          <a:effectLst/>
+        </p:spPr>
+        <p:style>
+          <a:lnRef idx="1">
+            <a:schemeClr val="accent1"/>
+          </a:lnRef>
+          <a:fillRef idx="3">
+            <a:schemeClr val="accent1"/>
+          </a:fillRef>
+          <a:effectRef idx="2">
+            <a:schemeClr val="accent1"/>
+          </a:effectRef>
+          <a:fontRef idx="minor">
+            <a:schemeClr val="lt1"/>
+          </a:fontRef>
+        </p:style>
+        <p:txBody>
+          <a:bodyPr rtlCol="0" anchor="ctr" wrap="square" lIns="101600" rIns="101600" tIns="76200" bIns="76200"/>
+          <a:lstStyle/>
+          <a:p>
+            <a:pPr algn="ctr"/>
+            <a:r>
+              <a:rPr sz="1600" b="1">
+                <a:solidFill>
+                  <a:srgbClr val="E8ECF2"/>
+                </a:solidFill>
+                <a:latin typeface="Segoe UI"/>
+                <a:ea typeface="Microsoft YaHei"/>
+                <a:cs typeface="Segoe UI"/>
+              </a:rPr>
+              <a:t>任务级能力</a:t>
+            </a:r>
+          </a:p>
+        </p:txBody>
+      </p:sp>
+      <p:sp>
+        <p:nvSpPr>
+          <p:cNvPr id="8" name="Rounded Rectangle 7"/>
+          <p:cNvSpPr/>
+          <p:nvPr/>
+        </p:nvSpPr>
+        <p:spPr>
+          <a:xfrm>
+            <a:off x="6309360" y="2304288"/>
+            <a:ext cx="5120640" cy="3749039"/>
+          </a:xfrm>
+          <a:prstGeom prst="roundRect">
+            <a:avLst>
+              <a:gd name="adj" fmla="val 5000"/>
+            </a:avLst>
+          </a:prstGeom>
+          <a:solidFill>
+            <a:srgbClr val="1E2A3D"/>
+          </a:solidFill>
+          <a:ln>
+            <a:noFill/>
+          </a:ln>
+          <a:effectLst/>
+        </p:spPr>
+        <p:style>
+          <a:lnRef idx="1">
+            <a:schemeClr val="accent1"/>
+          </a:lnRef>
+          <a:fillRef idx="3">
+            <a:schemeClr val="accent1"/>
+          </a:fillRef>
+          <a:effectRef idx="2">
+            <a:schemeClr val="accent1"/>
+          </a:effectRef>
+          <a:fontRef idx="minor">
+            <a:schemeClr val="lt1"/>
+          </a:fontRef>
+        </p:style>
+        <p:txBody>
+          <a:bodyPr rtlCol="0" anchor="ctr" wrap="square" lIns="101600" rIns="101600" tIns="76200" bIns="76200"/>
+          <a:lstStyle/>
+          <a:p>
+            <a:pPr algn="l"/>
+            <a:r>
+              <a:rPr sz="1450" b="0">
+                <a:solidFill>
+                  <a:srgbClr val="E8ECF2"/>
+                </a:solidFill>
+                <a:latin typeface="Segoe UI"/>
+                <a:ea typeface="Microsoft YaHei"/>
+                <a:cs typeface="Segoe UI"/>
+              </a:rPr>
+              <a:t>✓  不暴露原始 COM 成员</a:t>
+            </a:r>
+          </a:p>
+          <a:p>
+            <a:pPr algn="l"/>
+            <a:r>
+              <a:rPr sz="1450" b="0">
+                <a:solidFill>
+                  <a:srgbClr val="E8ECF2"/>
+                </a:solidFill>
+                <a:latin typeface="Segoe UI"/>
+                <a:ea typeface="Microsoft YaHei"/>
+                <a:cs typeface="Segoe UI"/>
+              </a:rPr>
+              <a:t>✓  模板优先于自由坐标</a:t>
+            </a:r>
+          </a:p>
+          <a:p>
+            <a:pPr algn="l"/>
+            <a:r>
+              <a:rPr sz="1450" b="0">
+                <a:solidFill>
+                  <a:srgbClr val="E8ECF2"/>
+                </a:solidFill>
+                <a:latin typeface="Segoe UI"/>
+                <a:ea typeface="Microsoft YaHei"/>
+                <a:cs typeface="Segoe UI"/>
+              </a:rPr>
+              <a:t>✓  检查点 + 预览 + 可追踪结果</a:t>
+            </a:r>
+          </a:p>
+        </p:txBody>
+      </p:sp>
+      <p:sp>
+        <p:nvSpPr>
+          <p:cNvPr id="9" name="TextBox 8"/>
+          <p:cNvSpPr txBox="1"/>
+          <p:nvPr/>
+        </p:nvSpPr>
+        <p:spPr>
+          <a:xfrm>
+            <a:off x="822960" y="6473952"/>
+            <a:ext cx="7315200" cy="274320"/>
+          </a:xfrm>
+          <a:prstGeom prst="rect">
+            <a:avLst/>
+          </a:prstGeom>
+          <a:noFill/>
+          <a:effectLst/>
+        </p:spPr>
+        <p:txBody>
+          <a:bodyPr wrap="square" lIns="50800" rIns="50800">
+            <a:spAutoFit/>
+          </a:bodyPr>
+          <a:lstStyle/>
+          <a:p>
+            <a:pPr algn="l"/>
+            <a:r>
+              <a:rPr sz="1000" b="0">
+                <a:solidFill>
+                  <a:srgbClr val="9AA7BC"/>
+                </a:solidFill>
+                <a:latin typeface="Segoe UI"/>
+                <a:ea typeface="Microsoft YaHei"/>
+                <a:cs typeface="Segoe UI"/>
+              </a:rPr>
+              <a:t>DCC-MCP 框架介绍</a:t>
+            </a:r>
+          </a:p>
+        </p:txBody>
+      </p:sp>
+      <p:sp>
+        <p:nvSpPr>
+          <p:cNvPr id="10" name="TextBox 9"/>
+          <p:cNvSpPr txBox="1"/>
+          <p:nvPr/>
+        </p:nvSpPr>
+        <p:spPr>
+          <a:xfrm>
+            <a:off x="10728655" y="6400800"/>
+            <a:ext cx="1097280" cy="320040"/>
+          </a:xfrm>
+          <a:prstGeom prst="rect">
+            <a:avLst/>
+          </a:prstGeom>
+          <a:noFill/>
+          <a:effectLst/>
+        </p:spPr>
+        <p:txBody>
+          <a:bodyPr wrap="none">
+            <a:spAutoFit/>
+          </a:bodyPr>
+          <a:lstStyle/>
+          <a:p>
+            <a:pPr algn="r"/>
+            <a:r>
+              <a:rPr sz="1000" b="0">
+                <a:solidFill>
+                  <a:srgbClr val="9AA7BC"/>
+                </a:solidFill>
+                <a:latin typeface="Segoe UI"/>
+                <a:ea typeface="Microsoft YaHei"/>
+                <a:cs typeface="Segoe UI"/>
+              </a:rPr>
+              <a:t>15 / 16</a:t>
+            </a:r>
+          </a:p>
+        </p:txBody>
+      </p:sp>
+    </p:spTree>
+  </p:cSld>
+  <p:clrMapOvr>
+    <a:masterClrMapping/>
+  </p:clrMapOvr>
+</p:sld>
+</file>
+
+<file path=ppt/slides/slide16.xml><?xml version="1.0" encoding="utf-8"?>
+<p:sld xmlns:a="http://schemas.openxmlformats.org/drawingml/2006/main" xmlns:p="http://schemas.openxmlformats.org/presentationml/2006/main" xmlns:r="http://schemas.openxmlformats.org/officeDocument/2006/relationships">
+  <p:cSld>
+    <p:spTree>
+      <p:nvGrpSpPr>
+        <p:cNvPr id="1" name=""/>
+        <p:cNvGrpSpPr/>
+        <p:nvPr/>
+      </p:nvGrpSpPr>
+      <p:grpSpPr/>
+      <p:sp>
+        <p:nvSpPr>
+          <p:cNvPr id="2" name="Rectangle 1"/>
+          <p:cNvSpPr/>
+          <p:nvPr/>
+        </p:nvSpPr>
+        <p:spPr>
+          <a:xfrm>
+            <a:off x="0" y="0"/>
+            <a:ext cx="12191695" cy="6858000"/>
+          </a:xfrm>
+          <a:prstGeom prst="rect">
+            <a:avLst/>
+          </a:prstGeom>
+          <a:solidFill>
+            <a:srgbClr val="0F141E"/>
+          </a:solidFill>
+          <a:ln>
+            <a:noFill/>
+          </a:ln>
+          <a:effectLst/>
+        </p:spPr>
+        <p:style>
+          <a:lnRef idx="1">
+            <a:schemeClr val="accent1"/>
+          </a:lnRef>
+          <a:fillRef idx="3">
+            <a:schemeClr val="accent1"/>
+          </a:fillRef>
+          <a:effectRef idx="2">
+            <a:schemeClr val="accent1"/>
+          </a:effectRef>
+          <a:fontRef idx="minor">
+            <a:schemeClr val="lt1"/>
+          </a:fontRef>
+        </p:style>
+        <p:txBody>
+          <a:bodyPr rtlCol="0" anchor="ctr"/>
+          <a:lstStyle/>
+          <a:p>
+            <a:pPr algn="ctr"/>
+          </a:p>
+        </p:txBody>
+      </p:sp>
+      <p:sp>
+        <p:nvSpPr>
           <p:cNvPr id="3" name="Rectangle 2"/>
           <p:cNvSpPr/>
           <p:nvPr/>
@@ -7410,6 +8625,7 @@
                 </a:solidFill>
                 <a:latin typeface="Segoe UI"/>
                 <a:ea typeface="Microsoft YaHei"/>
+                <a:cs typeface="Segoe UI"/>
               </a:rPr>
               <a:t>Thanks</a:t>
             </a:r>
@@ -7447,6 +8663,7 @@
                 </a:solidFill>
                 <a:latin typeface="Segoe UI"/>
                 <a:ea typeface="Microsoft YaHei"/>
+                <a:cs typeface="Segoe UI"/>
               </a:rPr>
               <a:t>dcc-mcp · 让 AI 进入每一个创作工具</a:t>
             </a:r>
@@ -7484,6 +8701,7 @@
                 </a:solidFill>
                 <a:latin typeface="Segoe UI"/>
                 <a:ea typeface="Microsoft YaHei"/>
+                <a:cs typeface="Segoe UI"/>
               </a:rPr>
               <a:t>DCC-MCP 框架介绍</a:t>
             </a:r>
@@ -7521,8 +8739,9 @@
                 </a:solidFill>
                 <a:latin typeface="Segoe UI"/>
                 <a:ea typeface="Microsoft YaHei"/>
+                <a:cs typeface="Segoe UI"/>
               </a:rPr>
-              <a:t>14 / 14</a:t>
+              <a:t>16 / 16</a:t>
             </a:r>
           </a:p>
         </p:txBody>
@@ -7708,6 +8927,7 @@
                 </a:solidFill>
                 <a:latin typeface="Segoe UI"/>
                 <a:ea typeface="Microsoft YaHei"/>
+                <a:cs typeface="Segoe UI"/>
               </a:rPr>
               <a:t>01</a:t>
             </a:r>
@@ -7789,6 +9009,7 @@
                 </a:solidFill>
                 <a:latin typeface="Segoe UI"/>
                 <a:ea typeface="Microsoft YaHei"/>
+                <a:cs typeface="Segoe UI"/>
               </a:rPr>
               <a:t>框架总览</a:t>
             </a:r>
@@ -7826,6 +9047,7 @@
                 </a:solidFill>
                 <a:latin typeface="Segoe UI"/>
                 <a:ea typeface="Microsoft YaHei"/>
+                <a:cs typeface="Segoe UI"/>
               </a:rPr>
               <a:t>DCC-MCP 框架介绍</a:t>
             </a:r>
@@ -7863,8 +9085,9 @@
                 </a:solidFill>
                 <a:latin typeface="Segoe UI"/>
                 <a:ea typeface="Microsoft YaHei"/>
+                <a:cs typeface="Segoe UI"/>
               </a:rPr>
-              <a:t>02 / 14</a:t>
+              <a:t>02 / 16</a:t>
             </a:r>
           </a:p>
         </p:txBody>
@@ -7962,6 +9185,7 @@
                 </a:solidFill>
                 <a:latin typeface="Segoe UI"/>
                 <a:ea typeface="Microsoft YaHei"/>
+                <a:cs typeface="Segoe UI"/>
               </a:rPr>
               <a:t>什么是 DCC-MCP</a:t>
             </a:r>
@@ -8087,6 +9311,7 @@
                 </a:solidFill>
                 <a:latin typeface="Segoe UI"/>
                 <a:ea typeface="Microsoft YaHei"/>
+                <a:cs typeface="Segoe UI"/>
               </a:rPr>
               <a:t>面向数字内容创作（DCC）工具的统一 MCP 网关生态</a:t>
             </a:r>
@@ -8212,6 +9437,7 @@
                 </a:solidFill>
                 <a:latin typeface="Segoe UI"/>
                 <a:ea typeface="Microsoft YaHei"/>
+                <a:cs typeface="Segoe UI"/>
               </a:rPr>
               <a:t>一个 DCC 一个适配器仓库：Maya、Blender、Houdini、Photoshop、Unity、Office…</a:t>
             </a:r>
@@ -8337,6 +9563,7 @@
                 </a:solidFill>
                 <a:latin typeface="Segoe UI"/>
                 <a:ea typeface="Microsoft YaHei"/>
+                <a:cs typeface="Segoe UI"/>
               </a:rPr>
               <a:t>统一的能力发现机制：list → search → load_skill → call</a:t>
             </a:r>
@@ -8462,6 +9689,7 @@
                 </a:solidFill>
                 <a:latin typeface="Segoe UI"/>
                 <a:ea typeface="Microsoft YaHei"/>
+                <a:cs typeface="Segoe UI"/>
               </a:rPr>
               <a:t>Skills 机制：把稳定流程固化为可复用的技能包</a:t>
             </a:r>
@@ -8499,6 +9727,7 @@
                 </a:solidFill>
                 <a:latin typeface="Segoe UI"/>
                 <a:ea typeface="Microsoft YaHei"/>
+                <a:cs typeface="Segoe UI"/>
               </a:rPr>
               <a:t>DCC-MCP 框架介绍</a:t>
             </a:r>
@@ -8536,8 +9765,9 @@
                 </a:solidFill>
                 <a:latin typeface="Segoe UI"/>
                 <a:ea typeface="Microsoft YaHei"/>
+                <a:cs typeface="Segoe UI"/>
               </a:rPr>
-              <a:t>03 / 14</a:t>
+              <a:t>03 / 16</a:t>
             </a:r>
           </a:p>
         </p:txBody>
@@ -8635,6 +9865,7 @@
                 </a:solidFill>
                 <a:latin typeface="Segoe UI"/>
                 <a:ea typeface="Microsoft YaHei"/>
+                <a:cs typeface="Segoe UI"/>
               </a:rPr>
               <a:t>总体架构</a:t>
             </a:r>
@@ -8735,6 +9966,7 @@
                 </a:solidFill>
                 <a:latin typeface="Segoe UI"/>
                 <a:ea typeface="Microsoft YaHei"/>
+                <a:cs typeface="Segoe UI"/>
               </a:rPr>
               <a:t>1</a:t>
             </a:r>
@@ -8791,6 +10023,7 @@
                 </a:solidFill>
                 <a:latin typeface="Segoe UI"/>
                 <a:ea typeface="Microsoft YaHei"/>
+                <a:cs typeface="Segoe UI"/>
               </a:rPr>
               <a:t>Agent / MCP Client / IDE / CI</a:t>
             </a:r>
@@ -8847,6 +10080,7 @@
                 </a:solidFill>
                 <a:latin typeface="Segoe UI"/>
                 <a:ea typeface="Microsoft YaHei"/>
+                <a:cs typeface="Segoe UI"/>
               </a:rPr>
               <a:t>2</a:t>
             </a:r>
@@ -8903,6 +10137,7 @@
                 </a:solidFill>
                 <a:latin typeface="Segoe UI"/>
                 <a:ea typeface="Microsoft YaHei"/>
+                <a:cs typeface="Segoe UI"/>
               </a:rPr>
               <a:t>dcc-mcp-gateway（Rust）：路由 · 能力索引 · Job · Artifact · 策略</a:t>
             </a:r>
@@ -8959,6 +10194,7 @@
                 </a:solidFill>
                 <a:latin typeface="Segoe UI"/>
                 <a:ea typeface="Microsoft YaHei"/>
+                <a:cs typeface="Segoe UI"/>
               </a:rPr>
               <a:t>3</a:t>
             </a:r>
@@ -9015,6 +10251,7 @@
                 </a:solidFill>
                 <a:latin typeface="Segoe UI"/>
                 <a:ea typeface="Microsoft YaHei"/>
+                <a:cs typeface="Segoe UI"/>
               </a:rPr>
               <a:t>Sidecar（RFC #998）：进程生命周期 · PPID 守护 · HostRpcClient</a:t>
             </a:r>
@@ -9071,6 +10308,7 @@
                 </a:solidFill>
                 <a:latin typeface="Segoe UI"/>
                 <a:ea typeface="Microsoft YaHei"/>
+                <a:cs typeface="Segoe UI"/>
               </a:rPr>
               <a:t>4</a:t>
             </a:r>
@@ -9127,6 +10365,7 @@
                 </a:solidFill>
                 <a:latin typeface="Segoe UI"/>
                 <a:ea typeface="Microsoft YaHei"/>
+                <a:cs typeface="Segoe UI"/>
               </a:rPr>
               <a:t>各 DCC 适配器：Maya commandPort · Blender HTTP · Houdini hrpyc · …</a:t>
             </a:r>
@@ -9183,6 +10422,7 @@
                 </a:solidFill>
                 <a:latin typeface="Segoe UI"/>
                 <a:ea typeface="Microsoft YaHei"/>
+                <a:cs typeface="Segoe UI"/>
               </a:rPr>
               <a:t>5</a:t>
             </a:r>
@@ -9239,6 +10479,7 @@
                 </a:solidFill>
                 <a:latin typeface="Segoe UI"/>
                 <a:ea typeface="Microsoft YaHei"/>
+                <a:cs typeface="Segoe UI"/>
               </a:rPr>
               <a:t>DCC 应用：Maya / Blender / Houdini / Photoshop / Unity / Office</a:t>
             </a:r>
@@ -9312,6 +10553,7 @@
                 </a:solidFill>
                 <a:latin typeface="Segoe UI"/>
                 <a:ea typeface="Microsoft YaHei"/>
+                <a:cs typeface="Segoe UI"/>
               </a:rPr>
               <a:t>DCC-MCP 框架介绍</a:t>
             </a:r>
@@ -9349,8 +10591,9 @@
                 </a:solidFill>
                 <a:latin typeface="Segoe UI"/>
                 <a:ea typeface="Microsoft YaHei"/>
+                <a:cs typeface="Segoe UI"/>
               </a:rPr>
-              <a:t>04 / 14</a:t>
+              <a:t>04 / 16</a:t>
             </a:r>
           </a:p>
         </p:txBody>
@@ -9448,6 +10691,7 @@
                 </a:solidFill>
                 <a:latin typeface="Segoe UI"/>
                 <a:ea typeface="Microsoft YaHei"/>
+                <a:cs typeface="Segoe UI"/>
               </a:rPr>
               <a:t>能力与 Skills</a:t>
             </a:r>
@@ -9573,6 +10817,7 @@
                 </a:solidFill>
                 <a:latin typeface="Segoe UI"/>
                 <a:ea typeface="Microsoft YaHei"/>
+                <a:cs typeface="Segoe UI"/>
               </a:rPr>
               <a:t>任务级 Capability，不暴露原始对象模型</a:t>
             </a:r>
@@ -9698,6 +10943,7 @@
                 </a:solidFill>
                 <a:latin typeface="Segoe UI"/>
                 <a:ea typeface="Microsoft YaHei"/>
+                <a:cs typeface="Segoe UI"/>
               </a:rPr>
               <a:t>渐进式发现：初始上下文不塞满数百个工具</a:t>
             </a:r>
@@ -9823,6 +11069,7 @@
                 </a:solidFill>
                 <a:latin typeface="Segoe UI"/>
                 <a:ea typeface="Microsoft YaHei"/>
+                <a:cs typeface="Segoe UI"/>
               </a:rPr>
               <a:t>契约化技能包：SKILL.md + tools.yaml + scripts/&lt;name&gt;.py</a:t>
             </a:r>
@@ -9948,6 +11195,7 @@
                 </a:solidFill>
                 <a:latin typeface="Segoe UI"/>
                 <a:ea typeface="Microsoft YaHei"/>
+                <a:cs typeface="Segoe UI"/>
               </a:rPr>
               <a:t>Maya 单仓 25+ 域技能包、198 个结构化操作</a:t>
             </a:r>
@@ -9985,6 +11233,7 @@
                 </a:solidFill>
                 <a:latin typeface="Segoe UI"/>
                 <a:ea typeface="Microsoft YaHei"/>
+                <a:cs typeface="Segoe UI"/>
               </a:rPr>
               <a:t>DCC-MCP 框架介绍</a:t>
             </a:r>
@@ -10022,8 +11271,9 @@
                 </a:solidFill>
                 <a:latin typeface="Segoe UI"/>
                 <a:ea typeface="Microsoft YaHei"/>
+                <a:cs typeface="Segoe UI"/>
               </a:rPr>
-              <a:t>05 / 14</a:t>
+              <a:t>05 / 16</a:t>
             </a:r>
           </a:p>
         </p:txBody>
@@ -10121,6 +11371,7 @@
                 </a:solidFill>
                 <a:latin typeface="Segoe UI"/>
                 <a:ea typeface="Microsoft YaHei"/>
+                <a:cs typeface="Segoe UI"/>
               </a:rPr>
               <a:t>生态现状</a:t>
             </a:r>
@@ -10221,6 +11472,7 @@
                 </a:solidFill>
                 <a:latin typeface="Segoe UI"/>
                 <a:ea typeface="Microsoft YaHei"/>
+                <a:cs typeface="Segoe UI"/>
               </a:rPr>
               <a:t>30+</a:t>
             </a:r>
@@ -10234,6 +11486,7 @@
                 </a:solidFill>
                 <a:latin typeface="Segoe UI"/>
                 <a:ea typeface="Microsoft YaHei"/>
+                <a:cs typeface="Segoe UI"/>
               </a:rPr>
               <a:t>DCC 适配器仓库</a:t>
             </a:r>
@@ -10334,6 +11587,7 @@
                 </a:solidFill>
                 <a:latin typeface="Segoe UI"/>
                 <a:ea typeface="Microsoft YaHei"/>
+                <a:cs typeface="Segoe UI"/>
               </a:rPr>
               <a:t>198</a:t>
             </a:r>
@@ -10347,6 +11601,7 @@
                 </a:solidFill>
                 <a:latin typeface="Segoe UI"/>
                 <a:ea typeface="Microsoft YaHei"/>
+                <a:cs typeface="Segoe UI"/>
               </a:rPr>
               <a:t>Maya 结构化操作</a:t>
             </a:r>
@@ -10447,6 +11702,7 @@
                 </a:solidFill>
                 <a:latin typeface="Segoe UI"/>
                 <a:ea typeface="Microsoft YaHei"/>
+                <a:cs typeface="Segoe UI"/>
               </a:rPr>
               <a:t>25+</a:t>
             </a:r>
@@ -10460,6 +11716,7 @@
                 </a:solidFill>
                 <a:latin typeface="Segoe UI"/>
                 <a:ea typeface="Microsoft YaHei"/>
+                <a:cs typeface="Segoe UI"/>
               </a:rPr>
               <a:t>Maya 域技能包</a:t>
             </a:r>
@@ -10560,6 +11817,7 @@
                 </a:solidFill>
                 <a:latin typeface="Segoe UI"/>
                 <a:ea typeface="Microsoft YaHei"/>
+                <a:cs typeface="Segoe UI"/>
               </a:rPr>
               <a:t>5</a:t>
             </a:r>
@@ -10573,6 +11831,7 @@
                 </a:solidFill>
                 <a:latin typeface="Segoe UI"/>
                 <a:ea typeface="Microsoft YaHei"/>
+                <a:cs typeface="Segoe UI"/>
               </a:rPr>
               <a:t>Office 新域仓库（office / PPT / Word / Excel / Outlook）</a:t>
             </a:r>
@@ -10673,6 +11932,7 @@
                 </a:solidFill>
                 <a:latin typeface="Segoe UI"/>
                 <a:ea typeface="Microsoft YaHei"/>
+                <a:cs typeface="Segoe UI"/>
               </a:rPr>
               <a:t>6</a:t>
             </a:r>
@@ -10686,6 +11946,7 @@
                 </a:solidFill>
                 <a:latin typeface="Segoe UI"/>
                 <a:ea typeface="Microsoft YaHei"/>
+                <a:cs typeface="Segoe UI"/>
               </a:rPr>
               <a:t>执行后端路径（OpenXML / COM / Graph / Office.js / UIA / CUA）</a:t>
             </a:r>
@@ -10786,6 +12047,7 @@
                 </a:solidFill>
                 <a:latin typeface="Segoe UI"/>
                 <a:ea typeface="Microsoft YaHei"/>
+                <a:cs typeface="Segoe UI"/>
               </a:rPr>
               <a:t>12</a:t>
             </a:r>
@@ -10799,6 +12061,7 @@
                 </a:solidFill>
                 <a:latin typeface="Segoe UI"/>
                 <a:ea typeface="Microsoft YaHei"/>
+                <a:cs typeface="Segoe UI"/>
               </a:rPr>
               <a:t>Office MVP 验收标准</a:t>
             </a:r>
@@ -10880,6 +12143,7 @@
                 </a:solidFill>
                 <a:latin typeface="Segoe UI"/>
                 <a:ea typeface="Microsoft YaHei"/>
+                <a:cs typeface="Segoe UI"/>
               </a:rPr>
               <a:t>DCC-MCP 框架介绍</a:t>
             </a:r>
@@ -10917,8 +12181,9 @@
                 </a:solidFill>
                 <a:latin typeface="Segoe UI"/>
                 <a:ea typeface="Microsoft YaHei"/>
+                <a:cs typeface="Segoe UI"/>
               </a:rPr>
-              <a:t>06 / 14</a:t>
+              <a:t>06 / 16</a:t>
             </a:r>
           </a:p>
         </p:txBody>
@@ -11016,6 +12281,7 @@
                 </a:solidFill>
                 <a:latin typeface="Segoe UI"/>
                 <a:ea typeface="Microsoft YaHei"/>
+                <a:cs typeface="Segoe UI"/>
               </a:rPr>
               <a:t>覆盖的 DCC 工具</a:t>
             </a:r>
@@ -11168,6 +12434,7 @@
                 </a:solidFill>
                 <a:latin typeface="Segoe UI"/>
                 <a:ea typeface="Microsoft YaHei"/>
+                <a:cs typeface="Segoe UI"/>
               </a:rPr>
               <a:t>Maya</a:t>
             </a:r>
@@ -11276,6 +12543,7 @@
                 </a:solidFill>
                 <a:latin typeface="Segoe UI"/>
                 <a:ea typeface="Microsoft YaHei"/>
+                <a:cs typeface="Segoe UI"/>
               </a:rPr>
               <a:t>Blender</a:t>
             </a:r>
@@ -11384,6 +12652,7 @@
                 </a:solidFill>
                 <a:latin typeface="Segoe UI"/>
                 <a:ea typeface="Microsoft YaHei"/>
+                <a:cs typeface="Segoe UI"/>
               </a:rPr>
               <a:t>Houdini</a:t>
             </a:r>
@@ -11492,6 +12761,7 @@
                 </a:solidFill>
                 <a:latin typeface="Segoe UI"/>
                 <a:ea typeface="Microsoft YaHei"/>
+                <a:cs typeface="Segoe UI"/>
               </a:rPr>
               <a:t>Photoshop</a:t>
             </a:r>
@@ -11600,6 +12870,7 @@
                 </a:solidFill>
                 <a:latin typeface="Segoe UI"/>
                 <a:ea typeface="Microsoft YaHei"/>
+                <a:cs typeface="Segoe UI"/>
               </a:rPr>
               <a:t>Unity</a:t>
             </a:r>
@@ -11708,6 +12979,7 @@
                 </a:solidFill>
                 <a:latin typeface="Segoe UI"/>
                 <a:ea typeface="Microsoft YaHei"/>
+                <a:cs typeface="Segoe UI"/>
               </a:rPr>
               <a:t>Unreal</a:t>
             </a:r>
@@ -11816,6 +13088,7 @@
                 </a:solidFill>
                 <a:latin typeface="Segoe UI"/>
                 <a:ea typeface="Microsoft YaHei"/>
+                <a:cs typeface="Segoe UI"/>
               </a:rPr>
               <a:t>Nuke</a:t>
             </a:r>
@@ -11924,6 +13197,7 @@
                 </a:solidFill>
                 <a:latin typeface="Segoe UI"/>
                 <a:ea typeface="Microsoft YaHei"/>
+                <a:cs typeface="Segoe UI"/>
               </a:rPr>
               <a:t>3ds Max</a:t>
             </a:r>
@@ -12032,6 +13306,7 @@
                 </a:solidFill>
                 <a:latin typeface="Segoe UI"/>
                 <a:ea typeface="Microsoft YaHei"/>
+                <a:cs typeface="Segoe UI"/>
               </a:rPr>
               <a:t>Cinema 4D</a:t>
             </a:r>
@@ -12140,6 +13415,7 @@
                 </a:solidFill>
                 <a:latin typeface="Segoe UI"/>
                 <a:ea typeface="Microsoft YaHei"/>
+                <a:cs typeface="Segoe UI"/>
               </a:rPr>
               <a:t>Katana</a:t>
             </a:r>
@@ -12248,6 +13524,7 @@
                 </a:solidFill>
                 <a:latin typeface="Segoe UI"/>
                 <a:ea typeface="Microsoft YaHei"/>
+                <a:cs typeface="Segoe UI"/>
               </a:rPr>
               <a:t>Marmoset</a:t>
             </a:r>
@@ -12356,6 +13633,7 @@
                 </a:solidFill>
                 <a:latin typeface="Segoe UI"/>
                 <a:ea typeface="Microsoft YaHei"/>
+                <a:cs typeface="Segoe UI"/>
               </a:rPr>
               <a:t>Substance</a:t>
             </a:r>
@@ -12393,6 +13671,7 @@
                 </a:solidFill>
                 <a:latin typeface="Segoe UI"/>
                 <a:ea typeface="Microsoft YaHei"/>
+                <a:cs typeface="Segoe UI"/>
               </a:rPr>
               <a:t>DCC-MCP 框架介绍</a:t>
             </a:r>
@@ -12430,8 +13709,9 @@
                 </a:solidFill>
                 <a:latin typeface="Segoe UI"/>
                 <a:ea typeface="Microsoft YaHei"/>
+                <a:cs typeface="Segoe UI"/>
               </a:rPr>
-              <a:t>07 / 14</a:t>
+              <a:t>07 / 16</a:t>
             </a:r>
           </a:p>
         </p:txBody>
@@ -12529,6 +13809,7 @@
                 </a:solidFill>
                 <a:latin typeface="Segoe UI"/>
                 <a:ea typeface="Microsoft YaHei"/>
+                <a:cs typeface="Segoe UI"/>
               </a:rPr>
               <a:t>真实案例</a:t>
             </a:r>
@@ -12681,6 +13962,7 @@
                 </a:solidFill>
                 <a:latin typeface="Segoe UI"/>
                 <a:ea typeface="Microsoft YaHei"/>
+                <a:cs typeface="Segoe UI"/>
               </a:rPr>
               <a:t>Blender 螺旋星系</a:t>
             </a:r>
@@ -12789,6 +14071,7 @@
                 </a:solidFill>
                 <a:latin typeface="Segoe UI"/>
                 <a:ea typeface="Microsoft YaHei"/>
+                <a:cs typeface="Segoe UI"/>
               </a:rPr>
               <a:t>Marmoset PBR 材质</a:t>
             </a:r>
@@ -12897,6 +14180,7 @@
                 </a:solidFill>
                 <a:latin typeface="Segoe UI"/>
                 <a:ea typeface="Microsoft YaHei"/>
+                <a:cs typeface="Segoe UI"/>
               </a:rPr>
               <a:t>Hunyuan 3D 生成</a:t>
             </a:r>
@@ -13005,6 +14289,7 @@
                 </a:solidFill>
                 <a:latin typeface="Segoe UI"/>
                 <a:ea typeface="Microsoft YaHei"/>
+                <a:cs typeface="Segoe UI"/>
               </a:rPr>
               <a:t>ZBrush 重拓扑</a:t>
             </a:r>
@@ -13042,6 +14327,7 @@
                 </a:solidFill>
                 <a:latin typeface="Segoe UI"/>
                 <a:ea typeface="Microsoft YaHei"/>
+                <a:cs typeface="Segoe UI"/>
               </a:rPr>
               <a:t>DCC-MCP 框架介绍</a:t>
             </a:r>
@@ -13079,8 +14365,9 @@
                 </a:solidFill>
                 <a:latin typeface="Segoe UI"/>
                 <a:ea typeface="Microsoft YaHei"/>
+                <a:cs typeface="Segoe UI"/>
               </a:rPr>
-              <a:t>08 / 14</a:t>
+              <a:t>08 / 16</a:t>
             </a:r>
           </a:p>
         </p:txBody>
@@ -13149,20 +14436,58 @@
       </p:sp>
       <p:sp>
         <p:nvSpPr>
-          <p:cNvPr id="3" name="Rectangle 2"/>
+          <p:cNvPr id="3" name="TextBox 2"/>
+          <p:cNvSpPr txBox="1"/>
+          <p:nvPr/>
+        </p:nvSpPr>
+        <p:spPr>
+          <a:xfrm>
+            <a:off x="822960" y="502920"/>
+            <a:ext cx="10515600" cy="685800"/>
+          </a:xfrm>
+          <a:prstGeom prst="rect">
+            <a:avLst/>
+          </a:prstGeom>
+          <a:noFill/>
+          <a:effectLst/>
+        </p:spPr>
+        <p:txBody>
+          <a:bodyPr wrap="square" lIns="50800" rIns="50800">
+            <a:spAutoFit/>
+          </a:bodyPr>
+          <a:lstStyle/>
+          <a:p>
+            <a:pPr algn="l"/>
+            <a:r>
+              <a:rPr sz="2800" b="1">
+                <a:solidFill>
+                  <a:srgbClr val="E8ECF2"/>
+                </a:solidFill>
+                <a:latin typeface="Segoe UI"/>
+                <a:ea typeface="Microsoft YaHei"/>
+                <a:cs typeface="Segoe UI"/>
+              </a:rPr>
+              <a:t>本项目：dcc-mcp-PowerPoint 管线</a:t>
+            </a:r>
+          </a:p>
+        </p:txBody>
+      </p:sp>
+      <p:sp>
+        <p:nvSpPr>
+          <p:cNvPr id="4" name="Rectangle 3"/>
           <p:cNvSpPr/>
           <p:nvPr/>
         </p:nvSpPr>
         <p:spPr>
           <a:xfrm>
-            <a:off x="0" y="0"/>
-            <a:ext cx="12191695" cy="6858000"/>
+            <a:off x="822960" y="1298448"/>
+            <a:ext cx="822960" cy="44450"/>
           </a:xfrm>
           <a:prstGeom prst="rect">
             <a:avLst/>
           </a:prstGeom>
           <a:solidFill>
-            <a:srgbClr val="171F2E"/>
+            <a:srgbClr val="4D9DE0"/>
           </a:solidFill>
           <a:ln>
             <a:noFill/>
@@ -13184,32 +14509,34 @@
           </a:fontRef>
         </p:style>
         <p:txBody>
-          <a:bodyPr rtlCol="0" anchor="ctr"/>
-          <a:lstStyle/>
-          <a:p>
-            <a:pPr algn="ctr"/>
-          </a:p>
-        </p:txBody>
-      </p:sp>
-      <p:sp>
-        <p:nvSpPr>
-          <p:cNvPr id="4" name="Oval 3"/>
+          <a:bodyPr rtlCol="0" anchor="ctr" wrap="square"/>
+          <a:lstStyle/>
+          <a:p>
+            <a:pPr algn="ctr"/>
+          </a:p>
+        </p:txBody>
+      </p:sp>
+      <p:sp>
+        <p:nvSpPr>
+          <p:cNvPr id="5" name="Oval 4"/>
           <p:cNvSpPr/>
           <p:nvPr/>
         </p:nvSpPr>
         <p:spPr>
           <a:xfrm>
-            <a:off x="9601200" y="320040"/>
-            <a:ext cx="2468880" cy="2468880"/>
+            <a:off x="2148840" y="1819656"/>
+            <a:ext cx="384048" cy="384048"/>
           </a:xfrm>
           <a:prstGeom prst="ellipse">
             <a:avLst/>
           </a:prstGeom>
           <a:solidFill>
-            <a:srgbClr val="223047"/>
+            <a:srgbClr val="171F2E"/>
           </a:solidFill>
-          <a:ln>
-            <a:noFill/>
+          <a:ln w="15240">
+            <a:solidFill>
+              <a:srgbClr val="4D9DE0"/>
+            </a:solidFill>
           </a:ln>
           <a:effectLst/>
         </p:spPr>
@@ -13228,66 +14555,42 @@
           </a:fontRef>
         </p:style>
         <p:txBody>
-          <a:bodyPr rtlCol="0" anchor="ctr"/>
-          <a:lstStyle/>
-          <a:p>
-            <a:pPr algn="ctr"/>
-          </a:p>
-        </p:txBody>
-      </p:sp>
-      <p:sp>
-        <p:nvSpPr>
-          <p:cNvPr id="5" name="TextBox 4"/>
-          <p:cNvSpPr txBox="1"/>
-          <p:nvPr/>
-        </p:nvSpPr>
-        <p:spPr>
-          <a:xfrm>
-            <a:off x="640080" y="640080"/>
-            <a:ext cx="4572000" cy="3840480"/>
-          </a:xfrm>
-          <a:prstGeom prst="rect">
-            <a:avLst/>
-          </a:prstGeom>
-          <a:noFill/>
-          <a:effectLst/>
-        </p:spPr>
-        <p:txBody>
-          <a:bodyPr wrap="square" lIns="50800" rIns="50800">
-            <a:spAutoFit/>
-          </a:bodyPr>
-          <a:lstStyle/>
-          <a:p>
-            <a:pPr algn="l"/>
-            <a:r>
-              <a:rPr sz="20000" b="1">
-                <a:solidFill>
-                  <a:srgbClr val="223047"/>
+          <a:bodyPr rtlCol="0" anchor="ctr" wrap="square" lIns="101600" rIns="101600" tIns="76200" bIns="76200"/>
+          <a:lstStyle/>
+          <a:p>
+            <a:pPr algn="ctr"/>
+            <a:r>
+              <a:rPr sz="1200" b="1">
+                <a:solidFill>
+                  <a:srgbClr val="4D9DE0"/>
                 </a:solidFill>
                 <a:latin typeface="Segoe UI"/>
                 <a:ea typeface="Microsoft YaHei"/>
+                <a:cs typeface="Segoe UI"/>
               </a:rPr>
-              <a:t>02</a:t>
-            </a:r>
-          </a:p>
-        </p:txBody>
-      </p:sp>
-      <p:sp>
-        <p:nvSpPr>
-          <p:cNvPr id="6" name="Rectangle 5"/>
+              <a:t>1</a:t>
+            </a:r>
+          </a:p>
+        </p:txBody>
+      </p:sp>
+      <p:sp>
+        <p:nvSpPr>
+          <p:cNvPr id="6" name="Rounded Rectangle 5"/>
           <p:cNvSpPr/>
           <p:nvPr/>
         </p:nvSpPr>
         <p:spPr>
           <a:xfrm>
-            <a:off x="822960" y="2788920"/>
-            <a:ext cx="164592" cy="1097280"/>
-          </a:xfrm>
-          <a:prstGeom prst="rect">
-            <a:avLst/>
+            <a:off x="2788920" y="1673352"/>
+            <a:ext cx="8412480" cy="713232"/>
+          </a:xfrm>
+          <a:prstGeom prst="roundRect">
+            <a:avLst>
+              <a:gd name="adj" fmla="val 10000"/>
+            </a:avLst>
           </a:prstGeom>
           <a:solidFill>
-            <a:srgbClr val="7FC8A9"/>
+            <a:srgbClr val="1E2A3D"/>
           </a:solidFill>
           <a:ln>
             <a:noFill/>
@@ -13309,23 +14612,526 @@
           </a:fontRef>
         </p:style>
         <p:txBody>
-          <a:bodyPr rtlCol="0" anchor="ctr" wrap="square"/>
-          <a:lstStyle/>
-          <a:p>
-            <a:pPr algn="ctr"/>
-          </a:p>
-        </p:txBody>
-      </p:sp>
-      <p:sp>
-        <p:nvSpPr>
-          <p:cNvPr id="7" name="TextBox 6"/>
+          <a:bodyPr rtlCol="0" anchor="ctr" wrap="square" lIns="101600" rIns="101600" tIns="76200" bIns="76200"/>
+          <a:lstStyle/>
+          <a:p>
+            <a:pPr algn="ctr"/>
+            <a:r>
+              <a:rPr sz="1450" b="0">
+                <a:solidFill>
+                  <a:srgbClr val="E8ECF2"/>
+                </a:solidFill>
+                <a:latin typeface="Segoe UI"/>
+                <a:ea typeface="Microsoft YaHei"/>
+                <a:cs typeface="Segoe UI"/>
+              </a:rPr>
+              <a:t>Deck IR 契约（office-ir/1.0，镜像 dcc-mcp-office-ir）</a:t>
+            </a:r>
+          </a:p>
+        </p:txBody>
+      </p:sp>
+      <p:sp>
+        <p:nvSpPr>
+          <p:cNvPr id="7" name="Oval 6"/>
+          <p:cNvSpPr/>
+          <p:nvPr/>
+        </p:nvSpPr>
+        <p:spPr>
+          <a:xfrm>
+            <a:off x="2148840" y="2688336"/>
+            <a:ext cx="384048" cy="384048"/>
+          </a:xfrm>
+          <a:prstGeom prst="ellipse">
+            <a:avLst/>
+          </a:prstGeom>
+          <a:solidFill>
+            <a:srgbClr val="171F2E"/>
+          </a:solidFill>
+          <a:ln w="15240">
+            <a:solidFill>
+              <a:srgbClr val="4D9DE0"/>
+            </a:solidFill>
+          </a:ln>
+          <a:effectLst/>
+        </p:spPr>
+        <p:style>
+          <a:lnRef idx="1">
+            <a:schemeClr val="accent1"/>
+          </a:lnRef>
+          <a:fillRef idx="3">
+            <a:schemeClr val="accent1"/>
+          </a:fillRef>
+          <a:effectRef idx="2">
+            <a:schemeClr val="accent1"/>
+          </a:effectRef>
+          <a:fontRef idx="minor">
+            <a:schemeClr val="lt1"/>
+          </a:fontRef>
+        </p:style>
+        <p:txBody>
+          <a:bodyPr rtlCol="0" anchor="ctr" wrap="square" lIns="101600" rIns="101600" tIns="76200" bIns="76200"/>
+          <a:lstStyle/>
+          <a:p>
+            <a:pPr algn="ctr"/>
+            <a:r>
+              <a:rPr sz="1200" b="1">
+                <a:solidFill>
+                  <a:srgbClr val="4D9DE0"/>
+                </a:solidFill>
+                <a:latin typeface="Segoe UI"/>
+                <a:ea typeface="Microsoft YaHei"/>
+                <a:cs typeface="Segoe UI"/>
+              </a:rPr>
+              <a:t>2</a:t>
+            </a:r>
+          </a:p>
+        </p:txBody>
+      </p:sp>
+      <p:sp>
+        <p:nvSpPr>
+          <p:cNvPr id="8" name="Rounded Rectangle 7"/>
+          <p:cNvSpPr/>
+          <p:nvPr/>
+        </p:nvSpPr>
+        <p:spPr>
+          <a:xfrm>
+            <a:off x="2788920" y="2542032"/>
+            <a:ext cx="8412480" cy="713232"/>
+          </a:xfrm>
+          <a:prstGeom prst="roundRect">
+            <a:avLst>
+              <a:gd name="adj" fmla="val 10000"/>
+            </a:avLst>
+          </a:prstGeom>
+          <a:solidFill>
+            <a:srgbClr val="1E2A3D"/>
+          </a:solidFill>
+          <a:ln>
+            <a:noFill/>
+          </a:ln>
+          <a:effectLst/>
+        </p:spPr>
+        <p:style>
+          <a:lnRef idx="1">
+            <a:schemeClr val="accent1"/>
+          </a:lnRef>
+          <a:fillRef idx="3">
+            <a:schemeClr val="accent1"/>
+          </a:fillRef>
+          <a:effectRef idx="2">
+            <a:schemeClr val="accent1"/>
+          </a:effectRef>
+          <a:fontRef idx="minor">
+            <a:schemeClr val="lt1"/>
+          </a:fontRef>
+        </p:style>
+        <p:txBody>
+          <a:bodyPr rtlCol="0" anchor="ctr" wrap="square" lIns="101600" rIns="101600" tIns="76200" bIns="76200"/>
+          <a:lstStyle/>
+          <a:p>
+            <a:pPr algn="ctr"/>
+            <a:r>
+              <a:rPr sz="1450" b="0">
+                <a:solidFill>
+                  <a:srgbClr val="E8ECF2"/>
+                </a:solidFill>
+                <a:latin typeface="Segoe UI"/>
+                <a:ea typeface="Microsoft YaHei"/>
+                <a:cs typeface="Segoe UI"/>
+              </a:rPr>
+              <a:t>dcc-office-host（C#，零 NuGet）：Open XML 编译 · 路径寻址检查</a:t>
+            </a:r>
+          </a:p>
+        </p:txBody>
+      </p:sp>
+      <p:sp>
+        <p:nvSpPr>
+          <p:cNvPr id="9" name="Oval 8"/>
+          <p:cNvSpPr/>
+          <p:nvPr/>
+        </p:nvSpPr>
+        <p:spPr>
+          <a:xfrm>
+            <a:off x="2148840" y="3557016"/>
+            <a:ext cx="384048" cy="384048"/>
+          </a:xfrm>
+          <a:prstGeom prst="ellipse">
+            <a:avLst/>
+          </a:prstGeom>
+          <a:solidFill>
+            <a:srgbClr val="171F2E"/>
+          </a:solidFill>
+          <a:ln w="15240">
+            <a:solidFill>
+              <a:srgbClr val="4D9DE0"/>
+            </a:solidFill>
+          </a:ln>
+          <a:effectLst/>
+        </p:spPr>
+        <p:style>
+          <a:lnRef idx="1">
+            <a:schemeClr val="accent1"/>
+          </a:lnRef>
+          <a:fillRef idx="3">
+            <a:schemeClr val="accent1"/>
+          </a:fillRef>
+          <a:effectRef idx="2">
+            <a:schemeClr val="accent1"/>
+          </a:effectRef>
+          <a:fontRef idx="minor">
+            <a:schemeClr val="lt1"/>
+          </a:fontRef>
+        </p:style>
+        <p:txBody>
+          <a:bodyPr rtlCol="0" anchor="ctr" wrap="square" lIns="101600" rIns="101600" tIns="76200" bIns="76200"/>
+          <a:lstStyle/>
+          <a:p>
+            <a:pPr algn="ctr"/>
+            <a:r>
+              <a:rPr sz="1200" b="1">
+                <a:solidFill>
+                  <a:srgbClr val="4D9DE0"/>
+                </a:solidFill>
+                <a:latin typeface="Segoe UI"/>
+                <a:ea typeface="Microsoft YaHei"/>
+                <a:cs typeface="Segoe UI"/>
+              </a:rPr>
+              <a:t>3</a:t>
+            </a:r>
+          </a:p>
+        </p:txBody>
+      </p:sp>
+      <p:sp>
+        <p:nvSpPr>
+          <p:cNvPr id="10" name="Rounded Rectangle 9"/>
+          <p:cNvSpPr/>
+          <p:nvPr/>
+        </p:nvSpPr>
+        <p:spPr>
+          <a:xfrm>
+            <a:off x="2788920" y="3410712"/>
+            <a:ext cx="8412480" cy="713232"/>
+          </a:xfrm>
+          <a:prstGeom prst="roundRect">
+            <a:avLst>
+              <a:gd name="adj" fmla="val 10000"/>
+            </a:avLst>
+          </a:prstGeom>
+          <a:solidFill>
+            <a:srgbClr val="1E2A3D"/>
+          </a:solidFill>
+          <a:ln>
+            <a:noFill/>
+          </a:ln>
+          <a:effectLst/>
+        </p:spPr>
+        <p:style>
+          <a:lnRef idx="1">
+            <a:schemeClr val="accent1"/>
+          </a:lnRef>
+          <a:fillRef idx="3">
+            <a:schemeClr val="accent1"/>
+          </a:fillRef>
+          <a:effectRef idx="2">
+            <a:schemeClr val="accent1"/>
+          </a:effectRef>
+          <a:fontRef idx="minor">
+            <a:schemeClr val="lt1"/>
+          </a:fontRef>
+        </p:style>
+        <p:txBody>
+          <a:bodyPr rtlCol="0" anchor="ctr" wrap="square" lIns="101600" rIns="101600" tIns="76200" bIns="76200"/>
+          <a:lstStyle/>
+          <a:p>
+            <a:pPr algn="ctr"/>
+            <a:r>
+              <a:rPr sz="1450" b="0">
+                <a:solidFill>
+                  <a:srgbClr val="E8ECF2"/>
+                </a:solidFill>
+                <a:latin typeface="Segoe UI"/>
+                <a:ea typeface="Microsoft YaHei"/>
+                <a:cs typeface="Segoe UI"/>
+              </a:rPr>
+              <a:t>桌面 COM 渲染：PDF + 逐页 PNG（DispatchEx 专用实例）</a:t>
+            </a:r>
+          </a:p>
+        </p:txBody>
+      </p:sp>
+      <p:sp>
+        <p:nvSpPr>
+          <p:cNvPr id="11" name="Oval 10"/>
+          <p:cNvSpPr/>
+          <p:nvPr/>
+        </p:nvSpPr>
+        <p:spPr>
+          <a:xfrm>
+            <a:off x="2148840" y="4425696"/>
+            <a:ext cx="384048" cy="384048"/>
+          </a:xfrm>
+          <a:prstGeom prst="ellipse">
+            <a:avLst/>
+          </a:prstGeom>
+          <a:solidFill>
+            <a:srgbClr val="171F2E"/>
+          </a:solidFill>
+          <a:ln w="15240">
+            <a:solidFill>
+              <a:srgbClr val="4D9DE0"/>
+            </a:solidFill>
+          </a:ln>
+          <a:effectLst/>
+        </p:spPr>
+        <p:style>
+          <a:lnRef idx="1">
+            <a:schemeClr val="accent1"/>
+          </a:lnRef>
+          <a:fillRef idx="3">
+            <a:schemeClr val="accent1"/>
+          </a:fillRef>
+          <a:effectRef idx="2">
+            <a:schemeClr val="accent1"/>
+          </a:effectRef>
+          <a:fontRef idx="minor">
+            <a:schemeClr val="lt1"/>
+          </a:fontRef>
+        </p:style>
+        <p:txBody>
+          <a:bodyPr rtlCol="0" anchor="ctr" wrap="square" lIns="101600" rIns="101600" tIns="76200" bIns="76200"/>
+          <a:lstStyle/>
+          <a:p>
+            <a:pPr algn="ctr"/>
+            <a:r>
+              <a:rPr sz="1200" b="1">
+                <a:solidFill>
+                  <a:srgbClr val="4D9DE0"/>
+                </a:solidFill>
+                <a:latin typeface="Segoe UI"/>
+                <a:ea typeface="Microsoft YaHei"/>
+                <a:cs typeface="Segoe UI"/>
+              </a:rPr>
+              <a:t>4</a:t>
+            </a:r>
+          </a:p>
+        </p:txBody>
+      </p:sp>
+      <p:sp>
+        <p:nvSpPr>
+          <p:cNvPr id="12" name="Rounded Rectangle 11"/>
+          <p:cNvSpPr/>
+          <p:nvPr/>
+        </p:nvSpPr>
+        <p:spPr>
+          <a:xfrm>
+            <a:off x="2788920" y="4279392"/>
+            <a:ext cx="8412480" cy="713232"/>
+          </a:xfrm>
+          <a:prstGeom prst="roundRect">
+            <a:avLst>
+              <a:gd name="adj" fmla="val 10000"/>
+            </a:avLst>
+          </a:prstGeom>
+          <a:solidFill>
+            <a:srgbClr val="1E2A3D"/>
+          </a:solidFill>
+          <a:ln>
+            <a:noFill/>
+          </a:ln>
+          <a:effectLst/>
+        </p:spPr>
+        <p:style>
+          <a:lnRef idx="1">
+            <a:schemeClr val="accent1"/>
+          </a:lnRef>
+          <a:fillRef idx="3">
+            <a:schemeClr val="accent1"/>
+          </a:fillRef>
+          <a:effectRef idx="2">
+            <a:schemeClr val="accent1"/>
+          </a:effectRef>
+          <a:fontRef idx="minor">
+            <a:schemeClr val="lt1"/>
+          </a:fontRef>
+        </p:style>
+        <p:txBody>
+          <a:bodyPr rtlCol="0" anchor="ctr" wrap="square" lIns="101600" rIns="101600" tIns="76200" bIns="76200"/>
+          <a:lstStyle/>
+          <a:p>
+            <a:pPr algn="ctr"/>
+            <a:r>
+              <a:rPr sz="1450" b="0">
+                <a:solidFill>
+                  <a:srgbClr val="E8ECF2"/>
+                </a:solidFill>
+                <a:latin typeface="Segoe UI"/>
+                <a:ea typeface="Microsoft YaHei"/>
+                <a:cs typeface="Segoe UI"/>
+              </a:rPr>
+              <a:t>自研 issues 分析器：真实字体度量溢出 + WCAG 对比度</a:t>
+            </a:r>
+          </a:p>
+        </p:txBody>
+      </p:sp>
+      <p:sp>
+        <p:nvSpPr>
+          <p:cNvPr id="13" name="Oval 12"/>
+          <p:cNvSpPr/>
+          <p:nvPr/>
+        </p:nvSpPr>
+        <p:spPr>
+          <a:xfrm>
+            <a:off x="2148840" y="5294376"/>
+            <a:ext cx="384048" cy="384048"/>
+          </a:xfrm>
+          <a:prstGeom prst="ellipse">
+            <a:avLst/>
+          </a:prstGeom>
+          <a:solidFill>
+            <a:srgbClr val="171F2E"/>
+          </a:solidFill>
+          <a:ln w="15240">
+            <a:solidFill>
+              <a:srgbClr val="4D9DE0"/>
+            </a:solidFill>
+          </a:ln>
+          <a:effectLst/>
+        </p:spPr>
+        <p:style>
+          <a:lnRef idx="1">
+            <a:schemeClr val="accent1"/>
+          </a:lnRef>
+          <a:fillRef idx="3">
+            <a:schemeClr val="accent1"/>
+          </a:fillRef>
+          <a:effectRef idx="2">
+            <a:schemeClr val="accent1"/>
+          </a:effectRef>
+          <a:fontRef idx="minor">
+            <a:schemeClr val="lt1"/>
+          </a:fontRef>
+        </p:style>
+        <p:txBody>
+          <a:bodyPr rtlCol="0" anchor="ctr" wrap="square" lIns="101600" rIns="101600" tIns="76200" bIns="76200"/>
+          <a:lstStyle/>
+          <a:p>
+            <a:pPr algn="ctr"/>
+            <a:r>
+              <a:rPr sz="1200" b="1">
+                <a:solidFill>
+                  <a:srgbClr val="4D9DE0"/>
+                </a:solidFill>
+                <a:latin typeface="Segoe UI"/>
+                <a:ea typeface="Microsoft YaHei"/>
+                <a:cs typeface="Segoe UI"/>
+              </a:rPr>
+              <a:t>5</a:t>
+            </a:r>
+          </a:p>
+        </p:txBody>
+      </p:sp>
+      <p:sp>
+        <p:nvSpPr>
+          <p:cNvPr id="14" name="Rounded Rectangle 13"/>
+          <p:cNvSpPr/>
+          <p:nvPr/>
+        </p:nvSpPr>
+        <p:spPr>
+          <a:xfrm>
+            <a:off x="2788920" y="5148072"/>
+            <a:ext cx="8412480" cy="713232"/>
+          </a:xfrm>
+          <a:prstGeom prst="roundRect">
+            <a:avLst>
+              <a:gd name="adj" fmla="val 10000"/>
+            </a:avLst>
+          </a:prstGeom>
+          <a:solidFill>
+            <a:srgbClr val="1E2A3D"/>
+          </a:solidFill>
+          <a:ln>
+            <a:noFill/>
+          </a:ln>
+          <a:effectLst/>
+        </p:spPr>
+        <p:style>
+          <a:lnRef idx="1">
+            <a:schemeClr val="accent1"/>
+          </a:lnRef>
+          <a:fillRef idx="3">
+            <a:schemeClr val="accent1"/>
+          </a:fillRef>
+          <a:effectRef idx="2">
+            <a:schemeClr val="accent1"/>
+          </a:effectRef>
+          <a:fontRef idx="minor">
+            <a:schemeClr val="lt1"/>
+          </a:fontRef>
+        </p:style>
+        <p:txBody>
+          <a:bodyPr rtlCol="0" anchor="ctr" wrap="square" lIns="101600" rIns="101600" tIns="76200" bIns="76200"/>
+          <a:lstStyle/>
+          <a:p>
+            <a:pPr algn="ctr"/>
+            <a:r>
+              <a:rPr sz="1450" b="0">
+                <a:solidFill>
+                  <a:srgbClr val="E8ECF2"/>
+                </a:solidFill>
+                <a:latin typeface="Segoe UI"/>
+                <a:ea typeface="Microsoft YaHei"/>
+                <a:cs typeface="Segoe UI"/>
+              </a:rPr>
+              <a:t>像素级视觉 QA：覆盖率 + 边缘出血（背景自适应）</a:t>
+            </a:r>
+          </a:p>
+        </p:txBody>
+      </p:sp>
+      <p:cxnSp>
+        <p:nvCxnSpPr>
+          <p:cNvPr id="15" name="Connector 14"/>
+          <p:cNvCxnSpPr/>
+          <p:nvPr/>
+        </p:nvCxnSpPr>
+        <p:spPr>
+          <a:xfrm>
+            <a:off x="2340864" y="2194560"/>
+            <a:ext cx="0" cy="3474719"/>
+          </a:xfrm>
+          <a:prstGeom prst="line">
+            <a:avLst/>
+          </a:prstGeom>
+          <a:ln>
+            <a:solidFill>
+              <a:srgbClr val="4D9DE0"/>
+            </a:solidFill>
+          </a:ln>
+          <a:effectLst/>
+        </p:spPr>
+        <p:style>
+          <a:lnRef idx="2">
+            <a:schemeClr val="accent1"/>
+          </a:lnRef>
+          <a:fillRef idx="0">
+            <a:schemeClr val="accent1"/>
+          </a:fillRef>
+          <a:effectRef idx="1">
+            <a:schemeClr val="accent1"/>
+          </a:effectRef>
+          <a:fontRef idx="minor">
+            <a:schemeClr val="tx1"/>
+          </a:fontRef>
+        </p:style>
+      </p:cxnSp>
+      <p:sp>
+        <p:nvSpPr>
+          <p:cNvPr id="16" name="TextBox 15"/>
           <p:cNvSpPr txBox="1"/>
           <p:nvPr/>
         </p:nvSpPr>
         <p:spPr>
           <a:xfrm>
-            <a:off x="1188720" y="2743200"/>
-            <a:ext cx="10058400" cy="1280160"/>
+            <a:off x="822960" y="6473952"/>
+            <a:ext cx="7315200" cy="274320"/>
           </a:xfrm>
           <a:prstGeom prst="rect">
             <a:avLst/>
@@ -13341,49 +15147,13 @@
           <a:p>
             <a:pPr algn="l"/>
             <a:r>
-              <a:rPr sz="4400" b="1">
-                <a:solidFill>
-                  <a:srgbClr val="E8ECF2"/>
+              <a:rPr sz="1000" b="0">
+                <a:solidFill>
+                  <a:srgbClr val="9AA7BC"/>
                 </a:solidFill>
                 <a:latin typeface="Segoe UI"/>
                 <a:ea typeface="Microsoft YaHei"/>
-              </a:rPr>
-              <a:t>执行模型</a:t>
-            </a:r>
-          </a:p>
-        </p:txBody>
-      </p:sp>
-      <p:sp>
-        <p:nvSpPr>
-          <p:cNvPr id="8" name="TextBox 7"/>
-          <p:cNvSpPr txBox="1"/>
-          <p:nvPr/>
-        </p:nvSpPr>
-        <p:spPr>
-          <a:xfrm>
-            <a:off x="822960" y="6473952"/>
-            <a:ext cx="7315200" cy="274320"/>
-          </a:xfrm>
-          <a:prstGeom prst="rect">
-            <a:avLst/>
-          </a:prstGeom>
-          <a:noFill/>
-          <a:effectLst/>
-        </p:spPr>
-        <p:txBody>
-          <a:bodyPr wrap="square" lIns="50800" rIns="50800">
-            <a:spAutoFit/>
-          </a:bodyPr>
-          <a:lstStyle/>
-          <a:p>
-            <a:pPr algn="l"/>
-            <a:r>
-              <a:rPr sz="1000" b="0">
-                <a:solidFill>
-                  <a:srgbClr val="9AA7BC"/>
-                </a:solidFill>
-                <a:latin typeface="Segoe UI"/>
-                <a:ea typeface="Microsoft YaHei"/>
+                <a:cs typeface="Segoe UI"/>
               </a:rPr>
               <a:t>DCC-MCP 框架介绍</a:t>
             </a:r>
@@ -13392,7 +15162,7 @@
       </p:sp>
       <p:sp>
         <p:nvSpPr>
-          <p:cNvPr id="9" name="TextBox 8"/>
+          <p:cNvPr id="17" name="TextBox 16"/>
           <p:cNvSpPr txBox="1"/>
           <p:nvPr/>
         </p:nvSpPr>
@@ -13421,8 +15191,9 @@
                 </a:solidFill>
                 <a:latin typeface="Segoe UI"/>
                 <a:ea typeface="Microsoft YaHei"/>
+                <a:cs typeface="Segoe UI"/>
               </a:rPr>
-              <a:t>09 / 14</a:t>
+              <a:t>09 / 16</a:t>
             </a:r>
           </a:p>
         </p:txBody>

</xml_diff>

<commit_message>
feat: 16-slide showcase deck + verified standalone packaging (#11)
* feat: 16-slide showcase deck + standalone packaging verified end-to-end

- deck: add project pipeline + quality/distribution slides (14 -> 16);
  regenerated pptx/pdf/16 previews
- runtime purity: __init__ no longer imports analyze at package import
  (python-pptx is dev-only); subprocess guard test asserts no dev deps
- build_binary: publish the host as a single-file exe
  (PublishSingleFile) so FileManifest.add_path bundles one binary;
  locate the install dir via the exe glob (debug profile nesting)
- packaging CI: pyoxidizer build + smoke (version/compile/inspect) +
  artifact upload, triggered on packaging-relevant paths
- verified locally: standalone exe compiles the 16-slide deck via the
  bundled host, PowerPoint opens the output

* ci: robust standalone smoke step (absolute exe path + dir listing)
</commit_message>
<xml_diff>
--- a/examples/output/draft-dcc-mcp-framework-intro.pptx
+++ b/examples/output/draft-dcc-mcp-framework-intro.pptx
@@ -19,6 +19,8 @@
     <p:sldId id="267" r:id="rId19"/>
     <p:sldId id="268" r:id="rId20"/>
     <p:sldId id="269" r:id="rId21"/>
+    <p:sldId id="270" r:id="rId22"/>
+    <p:sldId id="271" r:id="rId23"/>
   </p:sldIdLst>
   <p:sldSz cx="12191695" cy="6858000" type="screen4x3"/>
   <p:notesSz cx="6858000" cy="9144000"/>
@@ -585,7 +587,7 @@
           <a:lstStyle/>
           <a:p>
             <a:r>
-              <a:t>五步：发现 → 加载 → 调用 → 作业 → 产物。</a:t>
+              <a:t>质量门禁与零依赖分发是项目的两条硬约束。</a:t>
             </a:r>
           </a:p>
         </p:txBody>
@@ -655,7 +657,7 @@
           <a:lstStyle/>
           <a:p>
             <a:r>
-              <a:t>第三部分：Office 域如何复用同一套控制面，形成双后端执行模型。</a:t>
+              <a:t>第二部分：一次调用如何走完发现、执行、批处理与产物闭环。</a:t>
             </a:r>
           </a:p>
         </p:txBody>
@@ -725,7 +727,7 @@
           <a:lstStyle/>
           <a:p>
             <a:r>
-              <a:t>本 PPT 即由该流程生成：Deck IR → Open XML 编译 → COM 渲染。</a:t>
+              <a:t>五步：发现 → 加载 → 调用 → 作业 → 产物。</a:t>
             </a:r>
           </a:p>
         </p:txBody>
@@ -795,7 +797,7 @@
           <a:lstStyle/>
           <a:p>
             <a:r>
-              <a:t>两条主线：执行路径有明确优先级，能力面保持任务级抽象。</a:t>
+              <a:t>第三部分：Office 域如何复用同一套控制面，形成双后端执行模型。</a:t>
             </a:r>
           </a:p>
         </p:txBody>
@@ -865,6 +867,146 @@
           <a:lstStyle/>
           <a:p>
             <a:r>
+              <a:t>本 PPT 即由该流程生成：Deck IR → Open XML 编译 → COM 渲染。</a:t>
+            </a:r>
+          </a:p>
+        </p:txBody>
+      </p:sp>
+      <p:sp>
+        <p:nvSpPr>
+          <p:cNvPr id="4" name="Slide Number Placeholder 3"/>
+          <p:cNvSpPr>
+            <a:spLocks noGrp="1"/>
+          </p:cNvSpPr>
+          <p:nvPr>
+            <p:ph type="sldNum" idx="5" sz="quarter"/>
+          </p:nvPr>
+        </p:nvSpPr>
+        <p:spPr/>
+      </p:sp>
+    </p:spTree>
+  </p:cSld>
+  <p:clrMapOvr>
+    <a:masterClrMapping/>
+  </p:clrMapOvr>
+</p:notes>
+</file>
+
+<file path=ppt/notesSlides/notesSlide15.xml><?xml version="1.0" encoding="utf-8"?>
+<p:notes xmlns:a="http://schemas.openxmlformats.org/drawingml/2006/main" xmlns:p="http://schemas.openxmlformats.org/presentationml/2006/main" xmlns:r="http://schemas.openxmlformats.org/officeDocument/2006/relationships">
+  <p:cSld>
+    <p:spTree>
+      <p:nvGrpSpPr>
+        <p:cNvPr id="1" name=""/>
+        <p:cNvGrpSpPr/>
+        <p:nvPr/>
+      </p:nvGrpSpPr>
+      <p:grpSpPr>
+        <a:xfrm>
+          <a:off x="0" y="0"/>
+          <a:ext cx="0" cy="0"/>
+          <a:chOff x="0" y="0"/>
+          <a:chExt cx="0" cy="0"/>
+        </a:xfrm>
+      </p:grpSpPr>
+      <p:sp>
+        <p:nvSpPr>
+          <p:cNvPr id="2" name="Slide Image Placeholder 1"/>
+          <p:cNvSpPr>
+            <a:spLocks noGrp="1"/>
+          </p:cNvSpPr>
+          <p:nvPr>
+            <p:ph type="sldImg" idx="2"/>
+          </p:nvPr>
+        </p:nvSpPr>
+        <p:spPr/>
+      </p:sp>
+      <p:sp>
+        <p:nvSpPr>
+          <p:cNvPr id="3" name="Notes Placeholder 2"/>
+          <p:cNvSpPr>
+            <a:spLocks noGrp="1"/>
+          </p:cNvSpPr>
+          <p:nvPr>
+            <p:ph type="body" idx="3" sz="quarter"/>
+          </p:nvPr>
+        </p:nvSpPr>
+        <p:spPr/>
+        <p:txBody>
+          <a:bodyPr/>
+          <a:lstStyle/>
+          <a:p>
+            <a:r>
+              <a:t>两条主线：执行路径有明确优先级，能力面保持任务级抽象。</a:t>
+            </a:r>
+          </a:p>
+        </p:txBody>
+      </p:sp>
+      <p:sp>
+        <p:nvSpPr>
+          <p:cNvPr id="4" name="Slide Number Placeholder 3"/>
+          <p:cNvSpPr>
+            <a:spLocks noGrp="1"/>
+          </p:cNvSpPr>
+          <p:nvPr>
+            <p:ph type="sldNum" idx="5" sz="quarter"/>
+          </p:nvPr>
+        </p:nvSpPr>
+        <p:spPr/>
+      </p:sp>
+    </p:spTree>
+  </p:cSld>
+  <p:clrMapOvr>
+    <a:masterClrMapping/>
+  </p:clrMapOvr>
+</p:notes>
+</file>
+
+<file path=ppt/notesSlides/notesSlide16.xml><?xml version="1.0" encoding="utf-8"?>
+<p:notes xmlns:a="http://schemas.openxmlformats.org/drawingml/2006/main" xmlns:p="http://schemas.openxmlformats.org/presentationml/2006/main" xmlns:r="http://schemas.openxmlformats.org/officeDocument/2006/relationships">
+  <p:cSld>
+    <p:spTree>
+      <p:nvGrpSpPr>
+        <p:cNvPr id="1" name=""/>
+        <p:cNvGrpSpPr/>
+        <p:nvPr/>
+      </p:nvGrpSpPr>
+      <p:grpSpPr>
+        <a:xfrm>
+          <a:off x="0" y="0"/>
+          <a:ext cx="0" cy="0"/>
+          <a:chOff x="0" y="0"/>
+          <a:chExt cx="0" cy="0"/>
+        </a:xfrm>
+      </p:grpSpPr>
+      <p:sp>
+        <p:nvSpPr>
+          <p:cNvPr id="2" name="Slide Image Placeholder 1"/>
+          <p:cNvSpPr>
+            <a:spLocks noGrp="1"/>
+          </p:cNvSpPr>
+          <p:nvPr>
+            <p:ph type="sldImg" idx="2"/>
+          </p:nvPr>
+        </p:nvSpPr>
+        <p:spPr/>
+      </p:sp>
+      <p:sp>
+        <p:nvSpPr>
+          <p:cNvPr id="3" name="Notes Placeholder 2"/>
+          <p:cNvSpPr>
+            <a:spLocks noGrp="1"/>
+          </p:cNvSpPr>
+          <p:nvPr>
+            <p:ph type="body" idx="3" sz="quarter"/>
+          </p:nvPr>
+        </p:nvSpPr>
+        <p:spPr/>
+        <p:txBody>
+          <a:bodyPr/>
+          <a:lstStyle/>
+          <a:p>
+            <a:r>
               <a:t>收尾：欢迎共建适配器与技能包。</a:t>
             </a:r>
           </a:p>
@@ -1425,7 +1567,7 @@
           <a:lstStyle/>
           <a:p>
             <a:r>
-              <a:t>第二部分：一次调用如何走完发现、执行、批处理与产物闭环。</a:t>
+              <a:t>本 Deck 即由这条管线生成：IR → C# 宿主 → COM 渲染。</a:t>
             </a:r>
           </a:p>
         </p:txBody>
@@ -4619,6 +4761,7 @@
                 </a:solidFill>
                 <a:latin typeface="Segoe UI"/>
                 <a:ea typeface="Microsoft YaHei"/>
+                <a:cs typeface="Segoe UI"/>
               </a:rPr>
               <a:t>DCC-MCP</a:t>
             </a:r>
@@ -4700,6 +4843,7 @@
                 </a:solidFill>
                 <a:latin typeface="Segoe UI"/>
                 <a:ea typeface="Microsoft YaHei"/>
+                <a:cs typeface="Segoe UI"/>
               </a:rPr>
               <a:t>多 DCC 统一智能体网关框架</a:t>
             </a:r>
@@ -4713,6 +4857,7 @@
                 </a:solidFill>
                 <a:latin typeface="Segoe UI"/>
                 <a:ea typeface="Microsoft YaHei"/>
+                <a:cs typeface="Segoe UI"/>
               </a:rPr>
               <a:t>让 AI 进入每一个创作工具 · Maya / Blender / Houdini / Photoshop / Unity / Office</a:t>
             </a:r>
@@ -4750,6 +4895,7 @@
                 </a:solidFill>
                 <a:latin typeface="Segoe UI"/>
                 <a:ea typeface="Microsoft YaHei"/>
+                <a:cs typeface="Segoe UI"/>
               </a:rPr>
               <a:t>DCC-MCP 框架介绍 · draft:dcc-mcp-framework-intro</a:t>
             </a:r>
@@ -4787,6 +4933,7 @@
                 </a:solidFill>
                 <a:latin typeface="Segoe UI"/>
                 <a:ea typeface="Microsoft YaHei"/>
+                <a:cs typeface="Segoe UI"/>
               </a:rPr>
               <a:t>DCC-MCP 框架介绍</a:t>
             </a:r>
@@ -4824,8 +4971,9 @@
                 </a:solidFill>
                 <a:latin typeface="Segoe UI"/>
                 <a:ea typeface="Microsoft YaHei"/>
+                <a:cs typeface="Segoe UI"/>
               </a:rPr>
-              <a:t>01 / 14</a:t>
+              <a:t>01 / 16</a:t>
             </a:r>
           </a:p>
         </p:txBody>
@@ -4923,8 +5071,9 @@
                 </a:solidFill>
                 <a:latin typeface="Segoe UI"/>
                 <a:ea typeface="Microsoft YaHei"/>
+                <a:cs typeface="Segoe UI"/>
               </a:rPr>
-              <a:t>一次调用的旅程</a:t>
+              <a:t>质量与分发</a:t>
             </a:r>
           </a:p>
         </p:txBody>
@@ -4975,20 +5124,20 @@
       </p:sp>
       <p:sp>
         <p:nvSpPr>
-          <p:cNvPr id="5" name="Rectangle 4"/>
+          <p:cNvPr id="5" name="Oval 4"/>
           <p:cNvSpPr/>
           <p:nvPr/>
         </p:nvSpPr>
         <p:spPr>
           <a:xfrm>
-            <a:off x="822960" y="3246120"/>
-            <a:ext cx="10515600" cy="38100"/>
-          </a:xfrm>
-          <a:prstGeom prst="rect">
+            <a:off x="868680" y="1783080"/>
+            <a:ext cx="165100" cy="165100"/>
+          </a:xfrm>
+          <a:prstGeom prst="ellipse">
             <a:avLst/>
           </a:prstGeom>
           <a:solidFill>
-            <a:srgbClr val="4D9DE0"/>
+            <a:srgbClr val="7FC8A9"/>
           </a:solidFill>
           <a:ln>
             <a:noFill/>
@@ -5019,25 +5168,61 @@
       </p:sp>
       <p:sp>
         <p:nvSpPr>
-          <p:cNvPr id="6" name="Oval 5"/>
+          <p:cNvPr id="6" name="TextBox 5"/>
+          <p:cNvSpPr txBox="1"/>
+          <p:nvPr/>
+        </p:nvSpPr>
+        <p:spPr>
+          <a:xfrm>
+            <a:off x="1234440" y="1627632"/>
+            <a:ext cx="10012680" cy="822960"/>
+          </a:xfrm>
+          <a:prstGeom prst="rect">
+            <a:avLst/>
+          </a:prstGeom>
+          <a:noFill/>
+          <a:effectLst/>
+        </p:spPr>
+        <p:txBody>
+          <a:bodyPr wrap="square" lIns="50800" rIns="50800">
+            <a:spAutoFit/>
+          </a:bodyPr>
+          <a:lstStyle/>
+          <a:p>
+            <a:pPr algn="l"/>
+            <a:r>
+              <a:rPr sz="1650" b="0">
+                <a:solidFill>
+                  <a:srgbClr val="E8ECF2"/>
+                </a:solidFill>
+                <a:latin typeface="Segoe UI"/>
+                <a:ea typeface="Microsoft YaHei"/>
+                <a:cs typeface="Segoe UI"/>
+              </a:rPr>
+              <a:t>官方 dcc-mcp-cli lint：4 个技能包 0 错误 0 警告</a:t>
+            </a:r>
+          </a:p>
+        </p:txBody>
+      </p:sp>
+      <p:sp>
+        <p:nvSpPr>
+          <p:cNvPr id="7" name="Rectangle 6"/>
           <p:cNvSpPr/>
           <p:nvPr/>
         </p:nvSpPr>
         <p:spPr>
           <a:xfrm>
-            <a:off x="1719071" y="3090672"/>
-            <a:ext cx="310896" cy="310896"/>
-          </a:xfrm>
-          <a:prstGeom prst="ellipse">
+            <a:off x="822960" y="2496312"/>
+            <a:ext cx="10515600" cy="15240"/>
+          </a:xfrm>
+          <a:prstGeom prst="rect">
             <a:avLst/>
           </a:prstGeom>
           <a:solidFill>
-            <a:srgbClr val="0F141E"/>
+            <a:srgbClr val="223047"/>
           </a:solidFill>
-          <a:ln w="19050">
-            <a:solidFill>
-              <a:srgbClr val="7FC8A9"/>
-            </a:solidFill>
+          <a:ln>
+            <a:noFill/>
           </a:ln>
           <a:effectLst/>
         </p:spPr>
@@ -5056,57 +5241,10 @@
           </a:fontRef>
         </p:style>
         <p:txBody>
-          <a:bodyPr rtlCol="0" anchor="ctr" wrap="square" lIns="101600" rIns="101600" tIns="76200" bIns="76200"/>
-          <a:lstStyle/>
-          <a:p>
-            <a:pPr algn="ctr"/>
-            <a:r>
-              <a:rPr sz="1200" b="1">
-                <a:solidFill>
-                  <a:srgbClr val="7FC8A9"/>
-                </a:solidFill>
-                <a:latin typeface="Segoe UI"/>
-                <a:ea typeface="Microsoft YaHei"/>
-              </a:rPr>
-              <a:t>1</a:t>
-            </a:r>
-          </a:p>
-        </p:txBody>
-      </p:sp>
-      <p:sp>
-        <p:nvSpPr>
-          <p:cNvPr id="7" name="TextBox 6"/>
-          <p:cNvSpPr txBox="1"/>
-          <p:nvPr/>
-        </p:nvSpPr>
-        <p:spPr>
-          <a:xfrm>
-            <a:off x="960120" y="2103120"/>
-            <a:ext cx="1828799" cy="960120"/>
-          </a:xfrm>
-          <a:prstGeom prst="rect">
-            <a:avLst/>
-          </a:prstGeom>
-          <a:noFill/>
-          <a:effectLst/>
-        </p:spPr>
-        <p:txBody>
-          <a:bodyPr wrap="square" lIns="50800" rIns="50800">
-            <a:spAutoFit/>
-          </a:bodyPr>
-          <a:lstStyle/>
-          <a:p>
-            <a:pPr algn="ctr"/>
-            <a:r>
-              <a:rPr sz="1350" b="0">
-                <a:solidFill>
-                  <a:srgbClr val="E8ECF2"/>
-                </a:solidFill>
-                <a:latin typeface="Segoe UI"/>
-                <a:ea typeface="Microsoft YaHei"/>
-              </a:rPr>
-              <a:t>list / search — 渐进式能力发现</a:t>
-            </a:r>
+          <a:bodyPr rtlCol="0" anchor="ctr" wrap="square"/>
+          <a:lstStyle/>
+          <a:p>
+            <a:pPr algn="ctr"/>
           </a:p>
         </p:txBody>
       </p:sp>
@@ -5118,19 +5256,17 @@
         </p:nvSpPr>
         <p:spPr>
           <a:xfrm>
-            <a:off x="3822191" y="3090672"/>
-            <a:ext cx="310896" cy="310896"/>
+            <a:off x="868680" y="2715768"/>
+            <a:ext cx="165100" cy="165100"/>
           </a:xfrm>
           <a:prstGeom prst="ellipse">
             <a:avLst/>
           </a:prstGeom>
           <a:solidFill>
-            <a:srgbClr val="0F141E"/>
+            <a:srgbClr val="7FC8A9"/>
           </a:solidFill>
-          <a:ln w="19050">
-            <a:solidFill>
-              <a:srgbClr val="7FC8A9"/>
-            </a:solidFill>
+          <a:ln>
+            <a:noFill/>
           </a:ln>
           <a:effectLst/>
         </p:spPr>
@@ -5149,20 +5285,10 @@
           </a:fontRef>
         </p:style>
         <p:txBody>
-          <a:bodyPr rtlCol="0" anchor="ctr" wrap="square" lIns="101600" rIns="101600" tIns="76200" bIns="76200"/>
-          <a:lstStyle/>
-          <a:p>
-            <a:pPr algn="ctr"/>
-            <a:r>
-              <a:rPr sz="1200" b="1">
-                <a:solidFill>
-                  <a:srgbClr val="7FC8A9"/>
-                </a:solidFill>
-                <a:latin typeface="Segoe UI"/>
-                <a:ea typeface="Microsoft YaHei"/>
-              </a:rPr>
-              <a:t>2</a:t>
-            </a:r>
+          <a:bodyPr rtlCol="0" anchor="ctr" wrap="square"/>
+          <a:lstStyle/>
+          <a:p>
+            <a:pPr algn="ctr"/>
           </a:p>
         </p:txBody>
       </p:sp>
@@ -5174,8 +5300,8 @@
         </p:nvSpPr>
         <p:spPr>
           <a:xfrm>
-            <a:off x="3063240" y="3566160"/>
-            <a:ext cx="1828799" cy="960120"/>
+            <a:off x="1234440" y="2560320"/>
+            <a:ext cx="10012680" cy="822960"/>
           </a:xfrm>
           <a:prstGeom prst="rect">
             <a:avLst/>
@@ -5189,41 +5315,40 @@
           </a:bodyPr>
           <a:lstStyle/>
           <a:p>
-            <a:pPr algn="ctr"/>
-            <a:r>
-              <a:rPr sz="1350" b="0">
+            <a:pPr algn="l"/>
+            <a:r>
+              <a:rPr sz="1650" b="0">
                 <a:solidFill>
                   <a:srgbClr val="E8ECF2"/>
                 </a:solidFill>
                 <a:latin typeface="Segoe UI"/>
                 <a:ea typeface="Microsoft YaHei"/>
+                <a:cs typeface="Segoe UI"/>
               </a:rPr>
-              <a:t>load_skill / describe — 契约与确认级别</a:t>
-            </a:r>
-          </a:p>
-        </p:txBody>
-      </p:sp>
-      <p:sp>
-        <p:nvSpPr>
-          <p:cNvPr id="10" name="Oval 9"/>
+              <a:t>pytest 35 用例 · ruff 0 错误 · CI 全绿后 squash 合并</a:t>
+            </a:r>
+          </a:p>
+        </p:txBody>
+      </p:sp>
+      <p:sp>
+        <p:nvSpPr>
+          <p:cNvPr id="10" name="Rectangle 9"/>
           <p:cNvSpPr/>
           <p:nvPr/>
         </p:nvSpPr>
         <p:spPr>
           <a:xfrm>
-            <a:off x="5925312" y="3090672"/>
-            <a:ext cx="310896" cy="310896"/>
-          </a:xfrm>
-          <a:prstGeom prst="ellipse">
+            <a:off x="822960" y="3429000"/>
+            <a:ext cx="10515600" cy="15240"/>
+          </a:xfrm>
+          <a:prstGeom prst="rect">
             <a:avLst/>
           </a:prstGeom>
           <a:solidFill>
-            <a:srgbClr val="0F141E"/>
+            <a:srgbClr val="223047"/>
           </a:solidFill>
-          <a:ln w="19050">
-            <a:solidFill>
-              <a:srgbClr val="7FC8A9"/>
-            </a:solidFill>
+          <a:ln>
+            <a:noFill/>
           </a:ln>
           <a:effectLst/>
         </p:spPr>
@@ -5242,81 +5367,32 @@
           </a:fontRef>
         </p:style>
         <p:txBody>
-          <a:bodyPr rtlCol="0" anchor="ctr" wrap="square" lIns="101600" rIns="101600" tIns="76200" bIns="76200"/>
-          <a:lstStyle/>
-          <a:p>
-            <a:pPr algn="ctr"/>
-            <a:r>
-              <a:rPr sz="1200" b="1">
-                <a:solidFill>
-                  <a:srgbClr val="7FC8A9"/>
-                </a:solidFill>
-                <a:latin typeface="Segoe UI"/>
-                <a:ea typeface="Microsoft YaHei"/>
-              </a:rPr>
-              <a:t>3</a:t>
-            </a:r>
-          </a:p>
-        </p:txBody>
-      </p:sp>
-      <p:sp>
-        <p:nvSpPr>
-          <p:cNvPr id="11" name="TextBox 10"/>
-          <p:cNvSpPr txBox="1"/>
-          <p:nvPr/>
-        </p:nvSpPr>
-        <p:spPr>
-          <a:xfrm>
-            <a:off x="5166361" y="2103120"/>
-            <a:ext cx="1828799" cy="960120"/>
-          </a:xfrm>
-          <a:prstGeom prst="rect">
-            <a:avLst/>
-          </a:prstGeom>
-          <a:noFill/>
-          <a:effectLst/>
-        </p:spPr>
-        <p:txBody>
-          <a:bodyPr wrap="square" lIns="50800" rIns="50800">
-            <a:spAutoFit/>
-          </a:bodyPr>
-          <a:lstStyle/>
-          <a:p>
-            <a:pPr algn="ctr"/>
-            <a:r>
-              <a:rPr sz="1350" b="0">
-                <a:solidFill>
-                  <a:srgbClr val="E8ECF2"/>
-                </a:solidFill>
-                <a:latin typeface="Segoe UI"/>
-                <a:ea typeface="Microsoft YaHei"/>
-              </a:rPr>
-              <a:t>call — 任务级 Capability</a:t>
-            </a:r>
-          </a:p>
-        </p:txBody>
-      </p:sp>
-      <p:sp>
-        <p:nvSpPr>
-          <p:cNvPr id="12" name="Oval 11"/>
+          <a:bodyPr rtlCol="0" anchor="ctr" wrap="square"/>
+          <a:lstStyle/>
+          <a:p>
+            <a:pPr algn="ctr"/>
+          </a:p>
+        </p:txBody>
+      </p:sp>
+      <p:sp>
+        <p:nvSpPr>
+          <p:cNvPr id="11" name="Oval 10"/>
           <p:cNvSpPr/>
           <p:nvPr/>
         </p:nvSpPr>
         <p:spPr>
           <a:xfrm>
-            <a:off x="8028431" y="3090672"/>
-            <a:ext cx="310896" cy="310896"/>
+            <a:off x="868680" y="3648456"/>
+            <a:ext cx="165100" cy="165100"/>
           </a:xfrm>
           <a:prstGeom prst="ellipse">
             <a:avLst/>
           </a:prstGeom>
           <a:solidFill>
-            <a:srgbClr val="0F141E"/>
+            <a:srgbClr val="7FC8A9"/>
           </a:solidFill>
-          <a:ln w="19050">
-            <a:solidFill>
-              <a:srgbClr val="7FC8A9"/>
-            </a:solidFill>
+          <a:ln>
+            <a:noFill/>
           </a:ln>
           <a:effectLst/>
         </p:spPr>
@@ -5335,33 +5411,23 @@
           </a:fontRef>
         </p:style>
         <p:txBody>
-          <a:bodyPr rtlCol="0" anchor="ctr" wrap="square" lIns="101600" rIns="101600" tIns="76200" bIns="76200"/>
-          <a:lstStyle/>
-          <a:p>
-            <a:pPr algn="ctr"/>
-            <a:r>
-              <a:rPr sz="1200" b="1">
-                <a:solidFill>
-                  <a:srgbClr val="7FC8A9"/>
-                </a:solidFill>
-                <a:latin typeface="Segoe UI"/>
-                <a:ea typeface="Microsoft YaHei"/>
-              </a:rPr>
-              <a:t>4</a:t>
-            </a:r>
-          </a:p>
-        </p:txBody>
-      </p:sp>
-      <p:sp>
-        <p:nvSpPr>
-          <p:cNvPr id="13" name="TextBox 12"/>
+          <a:bodyPr rtlCol="0" anchor="ctr" wrap="square"/>
+          <a:lstStyle/>
+          <a:p>
+            <a:pPr algn="ctr"/>
+          </a:p>
+        </p:txBody>
+      </p:sp>
+      <p:sp>
+        <p:nvSpPr>
+          <p:cNvPr id="12" name="TextBox 11"/>
           <p:cNvSpPr txBox="1"/>
           <p:nvPr/>
         </p:nvSpPr>
         <p:spPr>
           <a:xfrm>
-            <a:off x="7269480" y="3566160"/>
-            <a:ext cx="1828799" cy="960120"/>
+            <a:off x="1234440" y="3493008"/>
+            <a:ext cx="10012680" cy="822960"/>
           </a:xfrm>
           <a:prstGeom prst="rect">
             <a:avLst/>
@@ -5375,41 +5441,40 @@
           </a:bodyPr>
           <a:lstStyle/>
           <a:p>
-            <a:pPr algn="ctr"/>
-            <a:r>
-              <a:rPr sz="1350" b="0">
+            <a:pPr algn="l"/>
+            <a:r>
+              <a:rPr sz="1650" b="0">
                 <a:solidFill>
                   <a:srgbClr val="E8ECF2"/>
                 </a:solidFill>
                 <a:latin typeface="Segoe UI"/>
                 <a:ea typeface="Microsoft YaHei"/>
+                <a:cs typeface="Segoe UI"/>
               </a:rPr>
-              <a:t>Job — 批处理永不占住连接</a:t>
-            </a:r>
-          </a:p>
-        </p:txBody>
-      </p:sp>
-      <p:sp>
-        <p:nvSpPr>
-          <p:cNvPr id="14" name="Oval 13"/>
+              <a:t>运行时零第三方依赖：Python 只用 stdlib，重型接口走 C# 宿主</a:t>
+            </a:r>
+          </a:p>
+        </p:txBody>
+      </p:sp>
+      <p:sp>
+        <p:nvSpPr>
+          <p:cNvPr id="13" name="Rectangle 12"/>
           <p:cNvSpPr/>
           <p:nvPr/>
         </p:nvSpPr>
         <p:spPr>
           <a:xfrm>
-            <a:off x="10131552" y="3090672"/>
-            <a:ext cx="310896" cy="310896"/>
-          </a:xfrm>
-          <a:prstGeom prst="ellipse">
+            <a:off x="822960" y="4361688"/>
+            <a:ext cx="10515600" cy="15240"/>
+          </a:xfrm>
+          <a:prstGeom prst="rect">
             <a:avLst/>
           </a:prstGeom>
           <a:solidFill>
-            <a:srgbClr val="0F141E"/>
+            <a:srgbClr val="223047"/>
           </a:solidFill>
-          <a:ln w="19050">
-            <a:solidFill>
-              <a:srgbClr val="7FC8A9"/>
-            </a:solidFill>
+          <a:ln>
+            <a:noFill/>
           </a:ln>
           <a:effectLst/>
         </p:spPr>
@@ -5428,20 +5493,54 @@
           </a:fontRef>
         </p:style>
         <p:txBody>
-          <a:bodyPr rtlCol="0" anchor="ctr" wrap="square" lIns="101600" rIns="101600" tIns="76200" bIns="76200"/>
-          <a:lstStyle/>
-          <a:p>
-            <a:pPr algn="ctr"/>
-            <a:r>
-              <a:rPr sz="1200" b="1">
-                <a:solidFill>
-                  <a:srgbClr val="7FC8A9"/>
-                </a:solidFill>
-                <a:latin typeface="Segoe UI"/>
-                <a:ea typeface="Microsoft YaHei"/>
-              </a:rPr>
-              <a:t>5</a:t>
-            </a:r>
+          <a:bodyPr rtlCol="0" anchor="ctr" wrap="square"/>
+          <a:lstStyle/>
+          <a:p>
+            <a:pPr algn="ctr"/>
+          </a:p>
+        </p:txBody>
+      </p:sp>
+      <p:sp>
+        <p:nvSpPr>
+          <p:cNvPr id="14" name="Oval 13"/>
+          <p:cNvSpPr/>
+          <p:nvPr/>
+        </p:nvSpPr>
+        <p:spPr>
+          <a:xfrm>
+            <a:off x="868680" y="4581144"/>
+            <a:ext cx="165100" cy="165100"/>
+          </a:xfrm>
+          <a:prstGeom prst="ellipse">
+            <a:avLst/>
+          </a:prstGeom>
+          <a:solidFill>
+            <a:srgbClr val="7FC8A9"/>
+          </a:solidFill>
+          <a:ln>
+            <a:noFill/>
+          </a:ln>
+          <a:effectLst/>
+        </p:spPr>
+        <p:style>
+          <a:lnRef idx="1">
+            <a:schemeClr val="accent1"/>
+          </a:lnRef>
+          <a:fillRef idx="3">
+            <a:schemeClr val="accent1"/>
+          </a:fillRef>
+          <a:effectRef idx="2">
+            <a:schemeClr val="accent1"/>
+          </a:effectRef>
+          <a:fontRef idx="minor">
+            <a:schemeClr val="lt1"/>
+          </a:fontRef>
+        </p:style>
+        <p:txBody>
+          <a:bodyPr rtlCol="0" anchor="ctr" wrap="square"/>
+          <a:lstStyle/>
+          <a:p>
+            <a:pPr algn="ctr"/>
           </a:p>
         </p:txBody>
       </p:sp>
@@ -5453,8 +5552,8 @@
         </p:nvSpPr>
         <p:spPr>
           <a:xfrm>
-            <a:off x="9372601" y="2103120"/>
-            <a:ext cx="1828799" cy="960120"/>
+            <a:off x="1234440" y="4425696"/>
+            <a:ext cx="10012680" cy="822960"/>
           </a:xfrm>
           <a:prstGeom prst="rect">
             <a:avLst/>
@@ -5468,16 +5567,17 @@
           </a:bodyPr>
           <a:lstStyle/>
           <a:p>
-            <a:pPr algn="ctr"/>
-            <a:r>
-              <a:rPr sz="1350" b="0">
+            <a:pPr algn="l"/>
+            <a:r>
+              <a:rPr sz="1650" b="0">
                 <a:solidFill>
                   <a:srgbClr val="E8ECF2"/>
                 </a:solidFill>
                 <a:latin typeface="Segoe UI"/>
                 <a:ea typeface="Microsoft YaHei"/>
+                <a:cs typeface="Segoe UI"/>
               </a:rPr>
-              <a:t>Artifact — 结果、预览、审计可追踪</a:t>
+              <a:t>PyOxidizer 独立可执行文件分发（photoshop 同款模式）</a:t>
             </a:r>
           </a:p>
         </p:txBody>
@@ -5513,6 +5613,7 @@
                 </a:solidFill>
                 <a:latin typeface="Segoe UI"/>
                 <a:ea typeface="Microsoft YaHei"/>
+                <a:cs typeface="Segoe UI"/>
               </a:rPr>
               <a:t>DCC-MCP 框架介绍</a:t>
             </a:r>
@@ -5550,8 +5651,9 @@
                 </a:solidFill>
                 <a:latin typeface="Segoe UI"/>
                 <a:ea typeface="Microsoft YaHei"/>
+                <a:cs typeface="Segoe UI"/>
               </a:rPr>
-              <a:t>10 / 14</a:t>
+              <a:t>10 / 16</a:t>
             </a:r>
           </a:p>
         </p:txBody>
@@ -5737,8 +5839,9 @@
                 </a:solidFill>
                 <a:latin typeface="Segoe UI"/>
                 <a:ea typeface="Microsoft YaHei"/>
+                <a:cs typeface="Segoe UI"/>
               </a:rPr>
-              <a:t>03</a:t>
+              <a:t>02</a:t>
             </a:r>
           </a:p>
         </p:txBody>
@@ -5818,8 +5921,9 @@
                 </a:solidFill>
                 <a:latin typeface="Segoe UI"/>
                 <a:ea typeface="Microsoft YaHei"/>
+                <a:cs typeface="Segoe UI"/>
               </a:rPr>
-              <a:t>Office 自动化平台</a:t>
+              <a:t>执行模型</a:t>
             </a:r>
           </a:p>
         </p:txBody>
@@ -5855,6 +5959,7 @@
                 </a:solidFill>
                 <a:latin typeface="Segoe UI"/>
                 <a:ea typeface="Microsoft YaHei"/>
+                <a:cs typeface="Segoe UI"/>
               </a:rPr>
               <a:t>DCC-MCP 框架介绍</a:t>
             </a:r>
@@ -5892,8 +5997,9 @@
                 </a:solidFill>
                 <a:latin typeface="Segoe UI"/>
                 <a:ea typeface="Microsoft YaHei"/>
+                <a:cs typeface="Segoe UI"/>
               </a:rPr>
-              <a:t>11 / 14</a:t>
+              <a:t>11 / 16</a:t>
             </a:r>
           </a:p>
         </p:txBody>
@@ -5991,8 +6097,9 @@
                 </a:solidFill>
                 <a:latin typeface="Segoe UI"/>
                 <a:ea typeface="Microsoft YaHei"/>
+                <a:cs typeface="Segoe UI"/>
               </a:rPr>
-              <a:t>Office 双后端</a:t>
+              <a:t>一次调用的旅程</a:t>
             </a:r>
           </a:p>
         </p:txBody>
@@ -6043,25 +6150,23 @@
       </p:sp>
       <p:sp>
         <p:nvSpPr>
-          <p:cNvPr id="5" name="Oval 4"/>
+          <p:cNvPr id="5" name="Rectangle 4"/>
           <p:cNvSpPr/>
           <p:nvPr/>
         </p:nvSpPr>
         <p:spPr>
           <a:xfrm>
-            <a:off x="2148840" y="1819656"/>
-            <a:ext cx="384048" cy="384048"/>
-          </a:xfrm>
-          <a:prstGeom prst="ellipse">
+            <a:off x="822960" y="3246120"/>
+            <a:ext cx="10515600" cy="38100"/>
+          </a:xfrm>
+          <a:prstGeom prst="rect">
             <a:avLst/>
           </a:prstGeom>
           <a:solidFill>
-            <a:srgbClr val="171F2E"/>
+            <a:srgbClr val="4D9DE0"/>
           </a:solidFill>
-          <a:ln w="15240">
-            <a:solidFill>
-              <a:srgbClr val="4D9DE0"/>
-            </a:solidFill>
+          <a:ln>
+            <a:noFill/>
           </a:ln>
           <a:effectLst/>
         </p:spPr>
@@ -6080,44 +6185,34 @@
           </a:fontRef>
         </p:style>
         <p:txBody>
-          <a:bodyPr rtlCol="0" anchor="ctr" wrap="square" lIns="101600" rIns="101600" tIns="76200" bIns="76200"/>
-          <a:lstStyle/>
-          <a:p>
-            <a:pPr algn="ctr"/>
-            <a:r>
-              <a:rPr sz="1200" b="1">
-                <a:solidFill>
-                  <a:srgbClr val="4D9DE0"/>
-                </a:solidFill>
-                <a:latin typeface="Segoe UI"/>
-                <a:ea typeface="Microsoft YaHei"/>
-              </a:rPr>
-              <a:t>1</a:t>
-            </a:r>
-          </a:p>
-        </p:txBody>
-      </p:sp>
-      <p:sp>
-        <p:nvSpPr>
-          <p:cNvPr id="6" name="Rounded Rectangle 5"/>
+          <a:bodyPr rtlCol="0" anchor="ctr" wrap="square"/>
+          <a:lstStyle/>
+          <a:p>
+            <a:pPr algn="ctr"/>
+          </a:p>
+        </p:txBody>
+      </p:sp>
+      <p:sp>
+        <p:nvSpPr>
+          <p:cNvPr id="6" name="Oval 5"/>
           <p:cNvSpPr/>
           <p:nvPr/>
         </p:nvSpPr>
         <p:spPr>
           <a:xfrm>
-            <a:off x="2788920" y="1673352"/>
-            <a:ext cx="8412480" cy="713232"/>
-          </a:xfrm>
-          <a:prstGeom prst="roundRect">
-            <a:avLst>
-              <a:gd name="adj" fmla="val 10000"/>
-            </a:avLst>
+            <a:off x="1719071" y="3090672"/>
+            <a:ext cx="310896" cy="310896"/>
+          </a:xfrm>
+          <a:prstGeom prst="ellipse">
+            <a:avLst/>
           </a:prstGeom>
           <a:solidFill>
-            <a:srgbClr val="1E2A3D"/>
+            <a:srgbClr val="0F141E"/>
           </a:solidFill>
-          <a:ln>
-            <a:noFill/>
+          <a:ln w="19050">
+            <a:solidFill>
+              <a:srgbClr val="7FC8A9"/>
+            </a:solidFill>
           </a:ln>
           <a:effectLst/>
         </p:spPr>
@@ -6141,38 +6236,77 @@
           <a:p>
             <a:pPr algn="ctr"/>
             <a:r>
-              <a:rPr sz="1450" b="0">
-                <a:solidFill>
-                  <a:srgbClr val="E8ECF2"/>
+              <a:rPr sz="1200" b="1">
+                <a:solidFill>
+                  <a:srgbClr val="7FC8A9"/>
                 </a:solidFill>
                 <a:latin typeface="Segoe UI"/>
                 <a:ea typeface="Microsoft YaHei"/>
+                <a:cs typeface="Segoe UI"/>
               </a:rPr>
-              <a:t>Rust Gateway（dcc-mcp-core）：控制面 · Job · Artifact · 安全策略</a:t>
-            </a:r>
-          </a:p>
-        </p:txBody>
-      </p:sp>
-      <p:sp>
-        <p:nvSpPr>
-          <p:cNvPr id="7" name="Oval 6"/>
+              <a:t>1</a:t>
+            </a:r>
+          </a:p>
+        </p:txBody>
+      </p:sp>
+      <p:sp>
+        <p:nvSpPr>
+          <p:cNvPr id="7" name="TextBox 6"/>
+          <p:cNvSpPr txBox="1"/>
+          <p:nvPr/>
+        </p:nvSpPr>
+        <p:spPr>
+          <a:xfrm>
+            <a:off x="960120" y="2103120"/>
+            <a:ext cx="1828799" cy="960120"/>
+          </a:xfrm>
+          <a:prstGeom prst="rect">
+            <a:avLst/>
+          </a:prstGeom>
+          <a:noFill/>
+          <a:effectLst/>
+        </p:spPr>
+        <p:txBody>
+          <a:bodyPr wrap="square" lIns="50800" rIns="50800">
+            <a:spAutoFit/>
+          </a:bodyPr>
+          <a:lstStyle/>
+          <a:p>
+            <a:pPr algn="ctr"/>
+            <a:r>
+              <a:rPr sz="1350" b="0">
+                <a:solidFill>
+                  <a:srgbClr val="E8ECF2"/>
+                </a:solidFill>
+                <a:latin typeface="Segoe UI"/>
+                <a:ea typeface="Microsoft YaHei"/>
+                <a:cs typeface="Segoe UI"/>
+              </a:rPr>
+              <a:t>list / search — 渐进式能力发现</a:t>
+            </a:r>
+          </a:p>
+        </p:txBody>
+      </p:sp>
+      <p:sp>
+        <p:nvSpPr>
+          <p:cNvPr id="8" name="Oval 7"/>
           <p:cNvSpPr/>
           <p:nvPr/>
         </p:nvSpPr>
         <p:spPr>
           <a:xfrm>
-            <a:off x="2148840" y="2688336"/>
-            <a:ext cx="384048" cy="384048"/>
+            <a:off x="3822191" y="3090672"/>
+            <a:ext cx="310896" cy="310896"/>
           </a:xfrm>
           <a:prstGeom prst="ellipse">
             <a:avLst/>
           </a:prstGeom>
           <a:solidFill>
-            <a:srgbClr val="171F2E"/>
+            <a:srgbClr val="0F141E"/>
           </a:solidFill>
-          <a:ln w="15240">
+          <a:ln w="19050">
             <a:solidFill>
-              <a:srgbClr val="4D9DE0"/>
+              <a:srgbClr val="7FC8A9"/>
             </a:solidFill>
           </a:ln>
           <a:effectLst/>
@@ -6199,10 +6333,11 @@
             <a:r>
               <a:rPr sz="1200" b="1">
                 <a:solidFill>
-                  <a:srgbClr val="4D9DE0"/>
+                  <a:srgbClr val="7FC8A9"/>
                 </a:solidFill>
                 <a:latin typeface="Segoe UI"/>
                 <a:ea typeface="Microsoft YaHei"/>
+                <a:cs typeface="Segoe UI"/>
               </a:rPr>
               <a:t>2</a:t>
             </a:r>
@@ -6211,25 +6346,63 @@
       </p:sp>
       <p:sp>
         <p:nvSpPr>
-          <p:cNvPr id="8" name="Rounded Rectangle 7"/>
+          <p:cNvPr id="9" name="TextBox 8"/>
+          <p:cNvSpPr txBox="1"/>
+          <p:nvPr/>
+        </p:nvSpPr>
+        <p:spPr>
+          <a:xfrm>
+            <a:off x="3063240" y="3566160"/>
+            <a:ext cx="1828799" cy="960120"/>
+          </a:xfrm>
+          <a:prstGeom prst="rect">
+            <a:avLst/>
+          </a:prstGeom>
+          <a:noFill/>
+          <a:effectLst/>
+        </p:spPr>
+        <p:txBody>
+          <a:bodyPr wrap="square" lIns="50800" rIns="50800">
+            <a:spAutoFit/>
+          </a:bodyPr>
+          <a:lstStyle/>
+          <a:p>
+            <a:pPr algn="ctr"/>
+            <a:r>
+              <a:rPr sz="1350" b="0">
+                <a:solidFill>
+                  <a:srgbClr val="E8ECF2"/>
+                </a:solidFill>
+                <a:latin typeface="Segoe UI"/>
+                <a:ea typeface="Microsoft YaHei"/>
+                <a:cs typeface="Segoe UI"/>
+              </a:rPr>
+              <a:t>load_skill / describe — 契约与确认级别</a:t>
+            </a:r>
+          </a:p>
+        </p:txBody>
+      </p:sp>
+      <p:sp>
+        <p:nvSpPr>
+          <p:cNvPr id="10" name="Oval 9"/>
           <p:cNvSpPr/>
           <p:nvPr/>
         </p:nvSpPr>
         <p:spPr>
           <a:xfrm>
-            <a:off x="2788920" y="2542032"/>
-            <a:ext cx="8412480" cy="713232"/>
-          </a:xfrm>
-          <a:prstGeom prst="roundRect">
-            <a:avLst>
-              <a:gd name="adj" fmla="val 10000"/>
-            </a:avLst>
+            <a:off x="5925312" y="3090672"/>
+            <a:ext cx="310896" cy="310896"/>
+          </a:xfrm>
+          <a:prstGeom prst="ellipse">
+            <a:avLst/>
           </a:prstGeom>
           <a:solidFill>
-            <a:srgbClr val="1E2A3D"/>
+            <a:srgbClr val="0F141E"/>
           </a:solidFill>
-          <a:ln>
-            <a:noFill/>
+          <a:ln w="19050">
+            <a:solidFill>
+              <a:srgbClr val="7FC8A9"/>
+            </a:solidFill>
           </a:ln>
           <a:effectLst/>
         </p:spPr>
@@ -6253,38 +6426,77 @@
           <a:p>
             <a:pPr algn="ctr"/>
             <a:r>
-              <a:rPr sz="1450" b="0">
-                <a:solidFill>
-                  <a:srgbClr val="E8ECF2"/>
+              <a:rPr sz="1200" b="1">
+                <a:solidFill>
+                  <a:srgbClr val="7FC8A9"/>
                 </a:solidFill>
                 <a:latin typeface="Segoe UI"/>
                 <a:ea typeface="Microsoft YaHei"/>
+                <a:cs typeface="Segoe UI"/>
               </a:rPr>
-              <a:t>office-host.exe（C#）：每应用独立 Sidecar · 单 STA 队列</a:t>
-            </a:r>
-          </a:p>
-        </p:txBody>
-      </p:sp>
-      <p:sp>
-        <p:nvSpPr>
-          <p:cNvPr id="9" name="Oval 8"/>
+              <a:t>3</a:t>
+            </a:r>
+          </a:p>
+        </p:txBody>
+      </p:sp>
+      <p:sp>
+        <p:nvSpPr>
+          <p:cNvPr id="11" name="TextBox 10"/>
+          <p:cNvSpPr txBox="1"/>
+          <p:nvPr/>
+        </p:nvSpPr>
+        <p:spPr>
+          <a:xfrm>
+            <a:off x="5166361" y="2103120"/>
+            <a:ext cx="1828799" cy="960120"/>
+          </a:xfrm>
+          <a:prstGeom prst="rect">
+            <a:avLst/>
+          </a:prstGeom>
+          <a:noFill/>
+          <a:effectLst/>
+        </p:spPr>
+        <p:txBody>
+          <a:bodyPr wrap="square" lIns="50800" rIns="50800">
+            <a:spAutoFit/>
+          </a:bodyPr>
+          <a:lstStyle/>
+          <a:p>
+            <a:pPr algn="ctr"/>
+            <a:r>
+              <a:rPr sz="1350" b="0">
+                <a:solidFill>
+                  <a:srgbClr val="E8ECF2"/>
+                </a:solidFill>
+                <a:latin typeface="Segoe UI"/>
+                <a:ea typeface="Microsoft YaHei"/>
+                <a:cs typeface="Segoe UI"/>
+              </a:rPr>
+              <a:t>call — 任务级 Capability</a:t>
+            </a:r>
+          </a:p>
+        </p:txBody>
+      </p:sp>
+      <p:sp>
+        <p:nvSpPr>
+          <p:cNvPr id="12" name="Oval 11"/>
           <p:cNvSpPr/>
           <p:nvPr/>
         </p:nvSpPr>
         <p:spPr>
           <a:xfrm>
-            <a:off x="2148840" y="3557016"/>
-            <a:ext cx="384048" cy="384048"/>
+            <a:off x="8028431" y="3090672"/>
+            <a:ext cx="310896" cy="310896"/>
           </a:xfrm>
           <a:prstGeom prst="ellipse">
             <a:avLst/>
           </a:prstGeom>
           <a:solidFill>
-            <a:srgbClr val="171F2E"/>
+            <a:srgbClr val="0F141E"/>
           </a:solidFill>
-          <a:ln w="15240">
+          <a:ln w="19050">
             <a:solidFill>
-              <a:srgbClr val="4D9DE0"/>
+              <a:srgbClr val="7FC8A9"/>
             </a:solidFill>
           </a:ln>
           <a:effectLst/>
@@ -6311,37 +6523,76 @@
             <a:r>
               <a:rPr sz="1200" b="1">
                 <a:solidFill>
-                  <a:srgbClr val="4D9DE0"/>
+                  <a:srgbClr val="7FC8A9"/>
                 </a:solidFill>
                 <a:latin typeface="Segoe UI"/>
                 <a:ea typeface="Microsoft YaHei"/>
+                <a:cs typeface="Segoe UI"/>
               </a:rPr>
-              <a:t>3</a:t>
-            </a:r>
-          </a:p>
-        </p:txBody>
-      </p:sp>
-      <p:sp>
-        <p:nvSpPr>
-          <p:cNvPr id="10" name="Rounded Rectangle 9"/>
+              <a:t>4</a:t>
+            </a:r>
+          </a:p>
+        </p:txBody>
+      </p:sp>
+      <p:sp>
+        <p:nvSpPr>
+          <p:cNvPr id="13" name="TextBox 12"/>
+          <p:cNvSpPr txBox="1"/>
+          <p:nvPr/>
+        </p:nvSpPr>
+        <p:spPr>
+          <a:xfrm>
+            <a:off x="7269480" y="3566160"/>
+            <a:ext cx="1828799" cy="960120"/>
+          </a:xfrm>
+          <a:prstGeom prst="rect">
+            <a:avLst/>
+          </a:prstGeom>
+          <a:noFill/>
+          <a:effectLst/>
+        </p:spPr>
+        <p:txBody>
+          <a:bodyPr wrap="square" lIns="50800" rIns="50800">
+            <a:spAutoFit/>
+          </a:bodyPr>
+          <a:lstStyle/>
+          <a:p>
+            <a:pPr algn="ctr"/>
+            <a:r>
+              <a:rPr sz="1350" b="0">
+                <a:solidFill>
+                  <a:srgbClr val="E8ECF2"/>
+                </a:solidFill>
+                <a:latin typeface="Segoe UI"/>
+                <a:ea typeface="Microsoft YaHei"/>
+                <a:cs typeface="Segoe UI"/>
+              </a:rPr>
+              <a:t>Job — 批处理永不占住连接</a:t>
+            </a:r>
+          </a:p>
+        </p:txBody>
+      </p:sp>
+      <p:sp>
+        <p:nvSpPr>
+          <p:cNvPr id="14" name="Oval 13"/>
           <p:cNvSpPr/>
           <p:nvPr/>
         </p:nvSpPr>
         <p:spPr>
           <a:xfrm>
-            <a:off x="2788920" y="3410712"/>
-            <a:ext cx="8412480" cy="713232"/>
-          </a:xfrm>
-          <a:prstGeom prst="roundRect">
-            <a:avLst>
-              <a:gd name="adj" fmla="val 10000"/>
-            </a:avLst>
+            <a:off x="10131552" y="3090672"/>
+            <a:ext cx="310896" cy="310896"/>
+          </a:xfrm>
+          <a:prstGeom prst="ellipse">
+            <a:avLst/>
           </a:prstGeom>
           <a:solidFill>
-            <a:srgbClr val="1E2A3D"/>
+            <a:srgbClr val="0F141E"/>
           </a:solidFill>
-          <a:ln>
-            <a:noFill/>
+          <a:ln w="19050">
+            <a:solidFill>
+              <a:srgbClr val="7FC8A9"/>
+            </a:solidFill>
           </a:ln>
           <a:effectLst/>
         </p:spPr>
@@ -6365,180 +6616,13 @@
           <a:p>
             <a:pPr algn="ctr"/>
             <a:r>
-              <a:rPr sz="1450" b="0">
-                <a:solidFill>
-                  <a:srgbClr val="E8ECF2"/>
+              <a:rPr sz="1200" b="1">
+                <a:solidFill>
+                  <a:srgbClr val="7FC8A9"/>
                 </a:solidFill>
                 <a:latin typeface="Segoe UI"/>
                 <a:ea typeface="Microsoft YaHei"/>
-              </a:rPr>
-              <a:t>POWERPNT / WINWORD / EXCEL（COM 数据面）</a:t>
-            </a:r>
-          </a:p>
-        </p:txBody>
-      </p:sp>
-      <p:sp>
-        <p:nvSpPr>
-          <p:cNvPr id="11" name="Oval 10"/>
-          <p:cNvSpPr/>
-          <p:nvPr/>
-        </p:nvSpPr>
-        <p:spPr>
-          <a:xfrm>
-            <a:off x="2148840" y="4425696"/>
-            <a:ext cx="384048" cy="384048"/>
-          </a:xfrm>
-          <a:prstGeom prst="ellipse">
-            <a:avLst/>
-          </a:prstGeom>
-          <a:solidFill>
-            <a:srgbClr val="171F2E"/>
-          </a:solidFill>
-          <a:ln w="15240">
-            <a:solidFill>
-              <a:srgbClr val="4D9DE0"/>
-            </a:solidFill>
-          </a:ln>
-          <a:effectLst/>
-        </p:spPr>
-        <p:style>
-          <a:lnRef idx="1">
-            <a:schemeClr val="accent1"/>
-          </a:lnRef>
-          <a:fillRef idx="3">
-            <a:schemeClr val="accent1"/>
-          </a:fillRef>
-          <a:effectRef idx="2">
-            <a:schemeClr val="accent1"/>
-          </a:effectRef>
-          <a:fontRef idx="minor">
-            <a:schemeClr val="lt1"/>
-          </a:fontRef>
-        </p:style>
-        <p:txBody>
-          <a:bodyPr rtlCol="0" anchor="ctr" wrap="square" lIns="101600" rIns="101600" tIns="76200" bIns="76200"/>
-          <a:lstStyle/>
-          <a:p>
-            <a:pPr algn="ctr"/>
-            <a:r>
-              <a:rPr sz="1200" b="1">
-                <a:solidFill>
-                  <a:srgbClr val="4D9DE0"/>
-                </a:solidFill>
-                <a:latin typeface="Segoe UI"/>
-                <a:ea typeface="Microsoft YaHei"/>
-              </a:rPr>
-              <a:t>4</a:t>
-            </a:r>
-          </a:p>
-        </p:txBody>
-      </p:sp>
-      <p:sp>
-        <p:nvSpPr>
-          <p:cNvPr id="12" name="Rounded Rectangle 11"/>
-          <p:cNvSpPr/>
-          <p:nvPr/>
-        </p:nvSpPr>
-        <p:spPr>
-          <a:xfrm>
-            <a:off x="2788920" y="4279392"/>
-            <a:ext cx="8412480" cy="713232"/>
-          </a:xfrm>
-          <a:prstGeom prst="roundRect">
-            <a:avLst>
-              <a:gd name="adj" fmla="val 10000"/>
-            </a:avLst>
-          </a:prstGeom>
-          <a:solidFill>
-            <a:srgbClr val="1E2A3D"/>
-          </a:solidFill>
-          <a:ln>
-            <a:noFill/>
-          </a:ln>
-          <a:effectLst/>
-        </p:spPr>
-        <p:style>
-          <a:lnRef idx="1">
-            <a:schemeClr val="accent1"/>
-          </a:lnRef>
-          <a:fillRef idx="3">
-            <a:schemeClr val="accent1"/>
-          </a:fillRef>
-          <a:effectRef idx="2">
-            <a:schemeClr val="accent1"/>
-          </a:effectRef>
-          <a:fontRef idx="minor">
-            <a:schemeClr val="lt1"/>
-          </a:fontRef>
-        </p:style>
-        <p:txBody>
-          <a:bodyPr rtlCol="0" anchor="ctr" wrap="square" lIns="101600" rIns="101600" tIns="76200" bIns="76200"/>
-          <a:lstStyle/>
-          <a:p>
-            <a:pPr algn="ctr"/>
-            <a:r>
-              <a:rPr sz="1450" b="0">
-                <a:solidFill>
-                  <a:srgbClr val="E8ECF2"/>
-                </a:solidFill>
-                <a:latin typeface="Segoe UI"/>
-                <a:ea typeface="Microsoft YaHei"/>
-              </a:rPr>
-              <a:t>Open XML Worker：批量结构处理（编译器，非渲染器）</a:t>
-            </a:r>
-          </a:p>
-        </p:txBody>
-      </p:sp>
-      <p:sp>
-        <p:nvSpPr>
-          <p:cNvPr id="13" name="Oval 12"/>
-          <p:cNvSpPr/>
-          <p:nvPr/>
-        </p:nvSpPr>
-        <p:spPr>
-          <a:xfrm>
-            <a:off x="2148840" y="5294376"/>
-            <a:ext cx="384048" cy="384048"/>
-          </a:xfrm>
-          <a:prstGeom prst="ellipse">
-            <a:avLst/>
-          </a:prstGeom>
-          <a:solidFill>
-            <a:srgbClr val="171F2E"/>
-          </a:solidFill>
-          <a:ln w="15240">
-            <a:solidFill>
-              <a:srgbClr val="4D9DE0"/>
-            </a:solidFill>
-          </a:ln>
-          <a:effectLst/>
-        </p:spPr>
-        <p:style>
-          <a:lnRef idx="1">
-            <a:schemeClr val="accent1"/>
-          </a:lnRef>
-          <a:fillRef idx="3">
-            <a:schemeClr val="accent1"/>
-          </a:fillRef>
-          <a:effectRef idx="2">
-            <a:schemeClr val="accent1"/>
-          </a:effectRef>
-          <a:fontRef idx="minor">
-            <a:schemeClr val="lt1"/>
-          </a:fontRef>
-        </p:style>
-        <p:txBody>
-          <a:bodyPr rtlCol="0" anchor="ctr" wrap="square" lIns="101600" rIns="101600" tIns="76200" bIns="76200"/>
-          <a:lstStyle/>
-          <a:p>
-            <a:pPr algn="ctr"/>
-            <a:r>
-              <a:rPr sz="1200" b="1">
-                <a:solidFill>
-                  <a:srgbClr val="4D9DE0"/>
-                </a:solidFill>
-                <a:latin typeface="Segoe UI"/>
-                <a:ea typeface="Microsoft YaHei"/>
+                <a:cs typeface="Segoe UI"/>
               </a:rPr>
               <a:t>5</a:t>
             </a:r>
@@ -6547,106 +6631,14 @@
       </p:sp>
       <p:sp>
         <p:nvSpPr>
-          <p:cNvPr id="14" name="Rounded Rectangle 13"/>
-          <p:cNvSpPr/>
-          <p:nvPr/>
-        </p:nvSpPr>
-        <p:spPr>
-          <a:xfrm>
-            <a:off x="2788920" y="5148072"/>
-            <a:ext cx="8412480" cy="713232"/>
-          </a:xfrm>
-          <a:prstGeom prst="roundRect">
-            <a:avLst>
-              <a:gd name="adj" fmla="val 10000"/>
-            </a:avLst>
-          </a:prstGeom>
-          <a:solidFill>
-            <a:srgbClr val="1E2A3D"/>
-          </a:solidFill>
-          <a:ln>
-            <a:noFill/>
-          </a:ln>
-          <a:effectLst/>
-        </p:spPr>
-        <p:style>
-          <a:lnRef idx="1">
-            <a:schemeClr val="accent1"/>
-          </a:lnRef>
-          <a:fillRef idx="3">
-            <a:schemeClr val="accent1"/>
-          </a:fillRef>
-          <a:effectRef idx="2">
-            <a:schemeClr val="accent1"/>
-          </a:effectRef>
-          <a:fontRef idx="minor">
-            <a:schemeClr val="lt1"/>
-          </a:fontRef>
-        </p:style>
-        <p:txBody>
-          <a:bodyPr rtlCol="0" anchor="ctr" wrap="square" lIns="101600" rIns="101600" tIns="76200" bIns="76200"/>
-          <a:lstStyle/>
-          <a:p>
-            <a:pPr algn="ctr"/>
-            <a:r>
-              <a:rPr sz="1450" b="0">
-                <a:solidFill>
-                  <a:srgbClr val="E8ECF2"/>
-                </a:solidFill>
-                <a:latin typeface="Segoe UI"/>
-                <a:ea typeface="Microsoft YaHei"/>
-              </a:rPr>
-              <a:t>Microsoft Graph / Office.js / UIA-CUA：云与兜底路径</a:t>
-            </a:r>
-          </a:p>
-        </p:txBody>
-      </p:sp>
-      <p:cxnSp>
-        <p:nvCxnSpPr>
-          <p:cNvPr id="15" name="Connector 14"/>
-          <p:cNvCxnSpPr/>
-          <p:nvPr/>
-        </p:nvCxnSpPr>
-        <p:spPr>
-          <a:xfrm>
-            <a:off x="2340864" y="2194560"/>
-            <a:ext cx="0" cy="3474719"/>
-          </a:xfrm>
-          <a:prstGeom prst="line">
-            <a:avLst/>
-          </a:prstGeom>
-          <a:ln>
-            <a:solidFill>
-              <a:srgbClr val="4D9DE0"/>
-            </a:solidFill>
-          </a:ln>
-          <a:effectLst/>
-        </p:spPr>
-        <p:style>
-          <a:lnRef idx="2">
-            <a:schemeClr val="accent1"/>
-          </a:lnRef>
-          <a:fillRef idx="0">
-            <a:schemeClr val="accent1"/>
-          </a:fillRef>
-          <a:effectRef idx="1">
-            <a:schemeClr val="accent1"/>
-          </a:effectRef>
-          <a:fontRef idx="minor">
-            <a:schemeClr val="tx1"/>
-          </a:fontRef>
-        </p:style>
-      </p:cxnSp>
-      <p:sp>
-        <p:nvSpPr>
-          <p:cNvPr id="16" name="TextBox 15"/>
+          <p:cNvPr id="15" name="TextBox 14"/>
           <p:cNvSpPr txBox="1"/>
           <p:nvPr/>
         </p:nvSpPr>
         <p:spPr>
           <a:xfrm>
-            <a:off x="822960" y="6473952"/>
-            <a:ext cx="7315200" cy="274320"/>
+            <a:off x="9372601" y="2103120"/>
+            <a:ext cx="1828799" cy="960120"/>
           </a:xfrm>
           <a:prstGeom prst="rect">
             <a:avLst/>
@@ -6660,14 +6652,53 @@
           </a:bodyPr>
           <a:lstStyle/>
           <a:p>
-            <a:pPr algn="l"/>
-            <a:r>
-              <a:rPr sz="1000" b="0">
-                <a:solidFill>
-                  <a:srgbClr val="9AA7BC"/>
+            <a:pPr algn="ctr"/>
+            <a:r>
+              <a:rPr sz="1350" b="0">
+                <a:solidFill>
+                  <a:srgbClr val="E8ECF2"/>
                 </a:solidFill>
                 <a:latin typeface="Segoe UI"/>
                 <a:ea typeface="Microsoft YaHei"/>
+                <a:cs typeface="Segoe UI"/>
+              </a:rPr>
+              <a:t>Artifact — 结果、预览、审计可追踪</a:t>
+            </a:r>
+          </a:p>
+        </p:txBody>
+      </p:sp>
+      <p:sp>
+        <p:nvSpPr>
+          <p:cNvPr id="16" name="TextBox 15"/>
+          <p:cNvSpPr txBox="1"/>
+          <p:nvPr/>
+        </p:nvSpPr>
+        <p:spPr>
+          <a:xfrm>
+            <a:off x="822960" y="6473952"/>
+            <a:ext cx="7315200" cy="274320"/>
+          </a:xfrm>
+          <a:prstGeom prst="rect">
+            <a:avLst/>
+          </a:prstGeom>
+          <a:noFill/>
+          <a:effectLst/>
+        </p:spPr>
+        <p:txBody>
+          <a:bodyPr wrap="square" lIns="50800" rIns="50800">
+            <a:spAutoFit/>
+          </a:bodyPr>
+          <a:lstStyle/>
+          <a:p>
+            <a:pPr algn="l"/>
+            <a:r>
+              <a:rPr sz="1000" b="0">
+                <a:solidFill>
+                  <a:srgbClr val="9AA7BC"/>
+                </a:solidFill>
+                <a:latin typeface="Segoe UI"/>
+                <a:ea typeface="Microsoft YaHei"/>
+                <a:cs typeface="Segoe UI"/>
               </a:rPr>
               <a:t>DCC-MCP 框架介绍</a:t>
             </a:r>
@@ -6705,8 +6736,9 @@
                 </a:solidFill>
                 <a:latin typeface="Segoe UI"/>
                 <a:ea typeface="Microsoft YaHei"/>
+                <a:cs typeface="Segoe UI"/>
               </a:rPr>
-              <a:t>12 / 14</a:t>
+              <a:t>12 / 16</a:t>
             </a:r>
           </a:p>
         </p:txBody>
@@ -6775,57 +6807,20 @@
       </p:sp>
       <p:sp>
         <p:nvSpPr>
-          <p:cNvPr id="3" name="TextBox 2"/>
-          <p:cNvSpPr txBox="1"/>
-          <p:nvPr/>
-        </p:nvSpPr>
-        <p:spPr>
-          <a:xfrm>
-            <a:off x="822960" y="502920"/>
-            <a:ext cx="10515600" cy="685800"/>
-          </a:xfrm>
-          <a:prstGeom prst="rect">
-            <a:avLst/>
-          </a:prstGeom>
-          <a:noFill/>
-          <a:effectLst/>
-        </p:spPr>
-        <p:txBody>
-          <a:bodyPr wrap="square" lIns="50800" rIns="50800">
-            <a:spAutoFit/>
-          </a:bodyPr>
-          <a:lstStyle/>
-          <a:p>
-            <a:pPr algn="l"/>
-            <a:r>
-              <a:rPr sz="2800" b="1">
-                <a:solidFill>
-                  <a:srgbClr val="E8ECF2"/>
-                </a:solidFill>
-                <a:latin typeface="Segoe UI"/>
-                <a:ea typeface="Microsoft YaHei"/>
-              </a:rPr>
-              <a:t>设计取舍</a:t>
-            </a:r>
-          </a:p>
-        </p:txBody>
-      </p:sp>
-      <p:sp>
-        <p:nvSpPr>
-          <p:cNvPr id="4" name="Rectangle 3"/>
+          <p:cNvPr id="3" name="Rectangle 2"/>
           <p:cNvSpPr/>
           <p:nvPr/>
         </p:nvSpPr>
         <p:spPr>
           <a:xfrm>
-            <a:off x="822960" y="1298448"/>
-            <a:ext cx="822960" cy="44450"/>
+            <a:off x="0" y="0"/>
+            <a:ext cx="12191695" cy="6858000"/>
           </a:xfrm>
           <a:prstGeom prst="rect">
             <a:avLst/>
           </a:prstGeom>
           <a:solidFill>
-            <a:srgbClr val="4D9DE0"/>
+            <a:srgbClr val="171F2E"/>
           </a:solidFill>
           <a:ln>
             <a:noFill/>
@@ -6847,31 +6842,29 @@
           </a:fontRef>
         </p:style>
         <p:txBody>
-          <a:bodyPr rtlCol="0" anchor="ctr" wrap="square"/>
-          <a:lstStyle/>
-          <a:p>
-            <a:pPr algn="ctr"/>
-          </a:p>
-        </p:txBody>
-      </p:sp>
-      <p:sp>
-        <p:nvSpPr>
-          <p:cNvPr id="5" name="Rounded Rectangle 4"/>
+          <a:bodyPr rtlCol="0" anchor="ctr"/>
+          <a:lstStyle/>
+          <a:p>
+            <a:pPr algn="ctr"/>
+          </a:p>
+        </p:txBody>
+      </p:sp>
+      <p:sp>
+        <p:nvSpPr>
+          <p:cNvPr id="4" name="Oval 3"/>
           <p:cNvSpPr/>
           <p:nvPr/>
         </p:nvSpPr>
         <p:spPr>
           <a:xfrm>
-            <a:off x="822960" y="1627632"/>
-            <a:ext cx="5120640" cy="566928"/>
-          </a:xfrm>
-          <a:prstGeom prst="roundRect">
-            <a:avLst>
-              <a:gd name="adj" fmla="val 16000"/>
-            </a:avLst>
+            <a:off x="9601200" y="320040"/>
+            <a:ext cx="2468880" cy="2468880"/>
+          </a:xfrm>
+          <a:prstGeom prst="ellipse">
+            <a:avLst/>
           </a:prstGeom>
           <a:solidFill>
-            <a:srgbClr val="4D9DE0"/>
+            <a:srgbClr val="223047"/>
           </a:solidFill>
           <a:ln>
             <a:noFill/>
@@ -6893,120 +6886,64 @@
           </a:fontRef>
         </p:style>
         <p:txBody>
-          <a:bodyPr rtlCol="0" anchor="ctr" wrap="square" lIns="101600" rIns="101600" tIns="76200" bIns="76200"/>
-          <a:lstStyle/>
-          <a:p>
-            <a:pPr algn="ctr"/>
-            <a:r>
-              <a:rPr sz="1600" b="1">
-                <a:solidFill>
-                  <a:srgbClr val="E8ECF2"/>
+          <a:bodyPr rtlCol="0" anchor="ctr"/>
+          <a:lstStyle/>
+          <a:p>
+            <a:pPr algn="ctr"/>
+          </a:p>
+        </p:txBody>
+      </p:sp>
+      <p:sp>
+        <p:nvSpPr>
+          <p:cNvPr id="5" name="TextBox 4"/>
+          <p:cNvSpPr txBox="1"/>
+          <p:nvPr/>
+        </p:nvSpPr>
+        <p:spPr>
+          <a:xfrm>
+            <a:off x="640080" y="640080"/>
+            <a:ext cx="4572000" cy="3840480"/>
+          </a:xfrm>
+          <a:prstGeom prst="rect">
+            <a:avLst/>
+          </a:prstGeom>
+          <a:noFill/>
+          <a:effectLst/>
+        </p:spPr>
+        <p:txBody>
+          <a:bodyPr wrap="square" lIns="50800" rIns="50800">
+            <a:spAutoFit/>
+          </a:bodyPr>
+          <a:lstStyle/>
+          <a:p>
+            <a:pPr algn="l"/>
+            <a:r>
+              <a:rPr sz="20000" b="1">
+                <a:solidFill>
+                  <a:srgbClr val="223047"/>
                 </a:solidFill>
                 <a:latin typeface="Segoe UI"/>
                 <a:ea typeface="Microsoft YaHei"/>
+                <a:cs typeface="Segoe UI"/>
               </a:rPr>
-              <a:t>结构化 API 优先</a:t>
-            </a:r>
-          </a:p>
-        </p:txBody>
-      </p:sp>
-      <p:sp>
-        <p:nvSpPr>
-          <p:cNvPr id="6" name="Rounded Rectangle 5"/>
+              <a:t>03</a:t>
+            </a:r>
+          </a:p>
+        </p:txBody>
+      </p:sp>
+      <p:sp>
+        <p:nvSpPr>
+          <p:cNvPr id="6" name="Rectangle 5"/>
           <p:cNvSpPr/>
           <p:nvPr/>
         </p:nvSpPr>
         <p:spPr>
           <a:xfrm>
-            <a:off x="822960" y="2304288"/>
-            <a:ext cx="5120640" cy="3749039"/>
-          </a:xfrm>
-          <a:prstGeom prst="roundRect">
-            <a:avLst>
-              <a:gd name="adj" fmla="val 5000"/>
-            </a:avLst>
-          </a:prstGeom>
-          <a:solidFill>
-            <a:srgbClr val="1E2A3D"/>
-          </a:solidFill>
-          <a:ln>
-            <a:noFill/>
-          </a:ln>
-          <a:effectLst/>
-        </p:spPr>
-        <p:style>
-          <a:lnRef idx="1">
-            <a:schemeClr val="accent1"/>
-          </a:lnRef>
-          <a:fillRef idx="3">
-            <a:schemeClr val="accent1"/>
-          </a:fillRef>
-          <a:effectRef idx="2">
-            <a:schemeClr val="accent1"/>
-          </a:effectRef>
-          <a:fontRef idx="minor">
-            <a:schemeClr val="lt1"/>
-          </a:fontRef>
-        </p:style>
-        <p:txBody>
-          <a:bodyPr rtlCol="0" anchor="ctr" wrap="square" lIns="101600" rIns="101600" tIns="76200" bIns="76200"/>
-          <a:lstStyle/>
-          <a:p>
-            <a:pPr algn="l"/>
-            <a:r>
-              <a:rPr sz="1450" b="0">
-                <a:solidFill>
-                  <a:srgbClr val="E8ECF2"/>
-                </a:solidFill>
-                <a:latin typeface="Segoe UI"/>
-                <a:ea typeface="Microsoft YaHei"/>
-              </a:rPr>
-              <a:t>✓  确定性、可验证、可审计</a:t>
-            </a:r>
-          </a:p>
-          <a:p>
-            <a:pPr algn="l"/>
-            <a:r>
-              <a:rPr sz="1450" b="0">
-                <a:solidFill>
-                  <a:srgbClr val="E8ECF2"/>
-                </a:solidFill>
-                <a:latin typeface="Segoe UI"/>
-                <a:ea typeface="Microsoft YaHei"/>
-              </a:rPr>
-              <a:t>✓  UIA/CUA 只做最后兜底</a:t>
-            </a:r>
-          </a:p>
-          <a:p>
-            <a:pPr algn="l"/>
-            <a:r>
-              <a:rPr sz="1450" b="0">
-                <a:solidFill>
-                  <a:srgbClr val="E8ECF2"/>
-                </a:solidFill>
-                <a:latin typeface="Segoe UI"/>
-                <a:ea typeface="Microsoft YaHei"/>
-              </a:rPr>
-              <a:t>✓  写操作不得静默降级</a:t>
-            </a:r>
-          </a:p>
-        </p:txBody>
-      </p:sp>
-      <p:sp>
-        <p:nvSpPr>
-          <p:cNvPr id="7" name="Rounded Rectangle 6"/>
-          <p:cNvSpPr/>
-          <p:nvPr/>
-        </p:nvSpPr>
-        <p:spPr>
-          <a:xfrm>
-            <a:off x="6309360" y="1627632"/>
-            <a:ext cx="5120640" cy="566928"/>
-          </a:xfrm>
-          <a:prstGeom prst="roundRect">
-            <a:avLst>
-              <a:gd name="adj" fmla="val 16000"/>
-            </a:avLst>
+            <a:off x="822960" y="2788920"/>
+            <a:ext cx="164592" cy="1097280"/>
+          </a:xfrm>
+          <a:prstGeom prst="rect">
+            <a:avLst/>
           </a:prstGeom>
           <a:solidFill>
             <a:srgbClr val="7FC8A9"/>
@@ -7031,115 +6968,23 @@
           </a:fontRef>
         </p:style>
         <p:txBody>
-          <a:bodyPr rtlCol="0" anchor="ctr" wrap="square" lIns="101600" rIns="101600" tIns="76200" bIns="76200"/>
-          <a:lstStyle/>
-          <a:p>
-            <a:pPr algn="ctr"/>
-            <a:r>
-              <a:rPr sz="1600" b="1">
-                <a:solidFill>
-                  <a:srgbClr val="E8ECF2"/>
-                </a:solidFill>
-                <a:latin typeface="Segoe UI"/>
-                <a:ea typeface="Microsoft YaHei"/>
-              </a:rPr>
-              <a:t>任务级能力</a:t>
-            </a:r>
-          </a:p>
-        </p:txBody>
-      </p:sp>
-      <p:sp>
-        <p:nvSpPr>
-          <p:cNvPr id="8" name="Rounded Rectangle 7"/>
-          <p:cNvSpPr/>
-          <p:nvPr/>
-        </p:nvSpPr>
-        <p:spPr>
-          <a:xfrm>
-            <a:off x="6309360" y="2304288"/>
-            <a:ext cx="5120640" cy="3749039"/>
-          </a:xfrm>
-          <a:prstGeom prst="roundRect">
-            <a:avLst>
-              <a:gd name="adj" fmla="val 5000"/>
-            </a:avLst>
-          </a:prstGeom>
-          <a:solidFill>
-            <a:srgbClr val="1E2A3D"/>
-          </a:solidFill>
-          <a:ln>
-            <a:noFill/>
-          </a:ln>
-          <a:effectLst/>
-        </p:spPr>
-        <p:style>
-          <a:lnRef idx="1">
-            <a:schemeClr val="accent1"/>
-          </a:lnRef>
-          <a:fillRef idx="3">
-            <a:schemeClr val="accent1"/>
-          </a:fillRef>
-          <a:effectRef idx="2">
-            <a:schemeClr val="accent1"/>
-          </a:effectRef>
-          <a:fontRef idx="minor">
-            <a:schemeClr val="lt1"/>
-          </a:fontRef>
-        </p:style>
-        <p:txBody>
-          <a:bodyPr rtlCol="0" anchor="ctr" wrap="square" lIns="101600" rIns="101600" tIns="76200" bIns="76200"/>
-          <a:lstStyle/>
-          <a:p>
-            <a:pPr algn="l"/>
-            <a:r>
-              <a:rPr sz="1450" b="0">
-                <a:solidFill>
-                  <a:srgbClr val="E8ECF2"/>
-                </a:solidFill>
-                <a:latin typeface="Segoe UI"/>
-                <a:ea typeface="Microsoft YaHei"/>
-              </a:rPr>
-              <a:t>✓  不暴露原始 COM 成员</a:t>
-            </a:r>
-          </a:p>
-          <a:p>
-            <a:pPr algn="l"/>
-            <a:r>
-              <a:rPr sz="1450" b="0">
-                <a:solidFill>
-                  <a:srgbClr val="E8ECF2"/>
-                </a:solidFill>
-                <a:latin typeface="Segoe UI"/>
-                <a:ea typeface="Microsoft YaHei"/>
-              </a:rPr>
-              <a:t>✓  模板优先于自由坐标</a:t>
-            </a:r>
-          </a:p>
-          <a:p>
-            <a:pPr algn="l"/>
-            <a:r>
-              <a:rPr sz="1450" b="0">
-                <a:solidFill>
-                  <a:srgbClr val="E8ECF2"/>
-                </a:solidFill>
-                <a:latin typeface="Segoe UI"/>
-                <a:ea typeface="Microsoft YaHei"/>
-              </a:rPr>
-              <a:t>✓  检查点 + 预览 + 可追踪结果</a:t>
-            </a:r>
-          </a:p>
-        </p:txBody>
-      </p:sp>
-      <p:sp>
-        <p:nvSpPr>
-          <p:cNvPr id="9" name="TextBox 8"/>
+          <a:bodyPr rtlCol="0" anchor="ctr" wrap="square"/>
+          <a:lstStyle/>
+          <a:p>
+            <a:pPr algn="ctr"/>
+          </a:p>
+        </p:txBody>
+      </p:sp>
+      <p:sp>
+        <p:nvSpPr>
+          <p:cNvPr id="7" name="TextBox 6"/>
           <p:cNvSpPr txBox="1"/>
           <p:nvPr/>
         </p:nvSpPr>
         <p:spPr>
           <a:xfrm>
-            <a:off x="822960" y="6473952"/>
-            <a:ext cx="7315200" cy="274320"/>
+            <a:off x="1188720" y="2743200"/>
+            <a:ext cx="10058400" cy="1280160"/>
           </a:xfrm>
           <a:prstGeom prst="rect">
             <a:avLst/>
@@ -7155,12 +7000,51 @@
           <a:p>
             <a:pPr algn="l"/>
             <a:r>
-              <a:rPr sz="1000" b="0">
-                <a:solidFill>
-                  <a:srgbClr val="9AA7BC"/>
+              <a:rPr sz="4400" b="1">
+                <a:solidFill>
+                  <a:srgbClr val="E8ECF2"/>
                 </a:solidFill>
                 <a:latin typeface="Segoe UI"/>
                 <a:ea typeface="Microsoft YaHei"/>
+                <a:cs typeface="Segoe UI"/>
+              </a:rPr>
+              <a:t>Office 自动化平台</a:t>
+            </a:r>
+          </a:p>
+        </p:txBody>
+      </p:sp>
+      <p:sp>
+        <p:nvSpPr>
+          <p:cNvPr id="8" name="TextBox 7"/>
+          <p:cNvSpPr txBox="1"/>
+          <p:nvPr/>
+        </p:nvSpPr>
+        <p:spPr>
+          <a:xfrm>
+            <a:off x="822960" y="6473952"/>
+            <a:ext cx="7315200" cy="274320"/>
+          </a:xfrm>
+          <a:prstGeom prst="rect">
+            <a:avLst/>
+          </a:prstGeom>
+          <a:noFill/>
+          <a:effectLst/>
+        </p:spPr>
+        <p:txBody>
+          <a:bodyPr wrap="square" lIns="50800" rIns="50800">
+            <a:spAutoFit/>
+          </a:bodyPr>
+          <a:lstStyle/>
+          <a:p>
+            <a:pPr algn="l"/>
+            <a:r>
+              <a:rPr sz="1000" b="0">
+                <a:solidFill>
+                  <a:srgbClr val="9AA7BC"/>
+                </a:solidFill>
+                <a:latin typeface="Segoe UI"/>
+                <a:ea typeface="Microsoft YaHei"/>
+                <a:cs typeface="Segoe UI"/>
               </a:rPr>
               <a:t>DCC-MCP 框架介绍</a:t>
             </a:r>
@@ -7169,7 +7053,7 @@
       </p:sp>
       <p:sp>
         <p:nvSpPr>
-          <p:cNvPr id="10" name="TextBox 9"/>
+          <p:cNvPr id="9" name="TextBox 8"/>
           <p:cNvSpPr txBox="1"/>
           <p:nvPr/>
         </p:nvSpPr>
@@ -7198,8 +7082,9 @@
                 </a:solidFill>
                 <a:latin typeface="Segoe UI"/>
                 <a:ea typeface="Microsoft YaHei"/>
+                <a:cs typeface="Segoe UI"/>
               </a:rPr>
-              <a:t>13 / 14</a:t>
+              <a:t>13 / 16</a:t>
             </a:r>
           </a:p>
         </p:txBody>
@@ -7268,6 +7153,1336 @@
       </p:sp>
       <p:sp>
         <p:nvSpPr>
+          <p:cNvPr id="3" name="TextBox 2"/>
+          <p:cNvSpPr txBox="1"/>
+          <p:nvPr/>
+        </p:nvSpPr>
+        <p:spPr>
+          <a:xfrm>
+            <a:off x="822960" y="502920"/>
+            <a:ext cx="10515600" cy="685800"/>
+          </a:xfrm>
+          <a:prstGeom prst="rect">
+            <a:avLst/>
+          </a:prstGeom>
+          <a:noFill/>
+          <a:effectLst/>
+        </p:spPr>
+        <p:txBody>
+          <a:bodyPr wrap="square" lIns="50800" rIns="50800">
+            <a:spAutoFit/>
+          </a:bodyPr>
+          <a:lstStyle/>
+          <a:p>
+            <a:pPr algn="l"/>
+            <a:r>
+              <a:rPr sz="2800" b="1">
+                <a:solidFill>
+                  <a:srgbClr val="E8ECF2"/>
+                </a:solidFill>
+                <a:latin typeface="Segoe UI"/>
+                <a:ea typeface="Microsoft YaHei"/>
+                <a:cs typeface="Segoe UI"/>
+              </a:rPr>
+              <a:t>Office 双后端</a:t>
+            </a:r>
+          </a:p>
+        </p:txBody>
+      </p:sp>
+      <p:sp>
+        <p:nvSpPr>
+          <p:cNvPr id="4" name="Rectangle 3"/>
+          <p:cNvSpPr/>
+          <p:nvPr/>
+        </p:nvSpPr>
+        <p:spPr>
+          <a:xfrm>
+            <a:off x="822960" y="1298448"/>
+            <a:ext cx="822960" cy="44450"/>
+          </a:xfrm>
+          <a:prstGeom prst="rect">
+            <a:avLst/>
+          </a:prstGeom>
+          <a:solidFill>
+            <a:srgbClr val="4D9DE0"/>
+          </a:solidFill>
+          <a:ln>
+            <a:noFill/>
+          </a:ln>
+          <a:effectLst/>
+        </p:spPr>
+        <p:style>
+          <a:lnRef idx="1">
+            <a:schemeClr val="accent1"/>
+          </a:lnRef>
+          <a:fillRef idx="3">
+            <a:schemeClr val="accent1"/>
+          </a:fillRef>
+          <a:effectRef idx="2">
+            <a:schemeClr val="accent1"/>
+          </a:effectRef>
+          <a:fontRef idx="minor">
+            <a:schemeClr val="lt1"/>
+          </a:fontRef>
+        </p:style>
+        <p:txBody>
+          <a:bodyPr rtlCol="0" anchor="ctr" wrap="square"/>
+          <a:lstStyle/>
+          <a:p>
+            <a:pPr algn="ctr"/>
+          </a:p>
+        </p:txBody>
+      </p:sp>
+      <p:sp>
+        <p:nvSpPr>
+          <p:cNvPr id="5" name="Oval 4"/>
+          <p:cNvSpPr/>
+          <p:nvPr/>
+        </p:nvSpPr>
+        <p:spPr>
+          <a:xfrm>
+            <a:off x="2148840" y="1819656"/>
+            <a:ext cx="384048" cy="384048"/>
+          </a:xfrm>
+          <a:prstGeom prst="ellipse">
+            <a:avLst/>
+          </a:prstGeom>
+          <a:solidFill>
+            <a:srgbClr val="171F2E"/>
+          </a:solidFill>
+          <a:ln w="15240">
+            <a:solidFill>
+              <a:srgbClr val="4D9DE0"/>
+            </a:solidFill>
+          </a:ln>
+          <a:effectLst/>
+        </p:spPr>
+        <p:style>
+          <a:lnRef idx="1">
+            <a:schemeClr val="accent1"/>
+          </a:lnRef>
+          <a:fillRef idx="3">
+            <a:schemeClr val="accent1"/>
+          </a:fillRef>
+          <a:effectRef idx="2">
+            <a:schemeClr val="accent1"/>
+          </a:effectRef>
+          <a:fontRef idx="minor">
+            <a:schemeClr val="lt1"/>
+          </a:fontRef>
+        </p:style>
+        <p:txBody>
+          <a:bodyPr rtlCol="0" anchor="ctr" wrap="square" lIns="101600" rIns="101600" tIns="76200" bIns="76200"/>
+          <a:lstStyle/>
+          <a:p>
+            <a:pPr algn="ctr"/>
+            <a:r>
+              <a:rPr sz="1200" b="1">
+                <a:solidFill>
+                  <a:srgbClr val="4D9DE0"/>
+                </a:solidFill>
+                <a:latin typeface="Segoe UI"/>
+                <a:ea typeface="Microsoft YaHei"/>
+                <a:cs typeface="Segoe UI"/>
+              </a:rPr>
+              <a:t>1</a:t>
+            </a:r>
+          </a:p>
+        </p:txBody>
+      </p:sp>
+      <p:sp>
+        <p:nvSpPr>
+          <p:cNvPr id="6" name="Rounded Rectangle 5"/>
+          <p:cNvSpPr/>
+          <p:nvPr/>
+        </p:nvSpPr>
+        <p:spPr>
+          <a:xfrm>
+            <a:off x="2788920" y="1673352"/>
+            <a:ext cx="8412480" cy="713232"/>
+          </a:xfrm>
+          <a:prstGeom prst="roundRect">
+            <a:avLst>
+              <a:gd name="adj" fmla="val 10000"/>
+            </a:avLst>
+          </a:prstGeom>
+          <a:solidFill>
+            <a:srgbClr val="1E2A3D"/>
+          </a:solidFill>
+          <a:ln>
+            <a:noFill/>
+          </a:ln>
+          <a:effectLst/>
+        </p:spPr>
+        <p:style>
+          <a:lnRef idx="1">
+            <a:schemeClr val="accent1"/>
+          </a:lnRef>
+          <a:fillRef idx="3">
+            <a:schemeClr val="accent1"/>
+          </a:fillRef>
+          <a:effectRef idx="2">
+            <a:schemeClr val="accent1"/>
+          </a:effectRef>
+          <a:fontRef idx="minor">
+            <a:schemeClr val="lt1"/>
+          </a:fontRef>
+        </p:style>
+        <p:txBody>
+          <a:bodyPr rtlCol="0" anchor="ctr" wrap="square" lIns="101600" rIns="101600" tIns="76200" bIns="76200"/>
+          <a:lstStyle/>
+          <a:p>
+            <a:pPr algn="ctr"/>
+            <a:r>
+              <a:rPr sz="1450" b="0">
+                <a:solidFill>
+                  <a:srgbClr val="E8ECF2"/>
+                </a:solidFill>
+                <a:latin typeface="Segoe UI"/>
+                <a:ea typeface="Microsoft YaHei"/>
+                <a:cs typeface="Segoe UI"/>
+              </a:rPr>
+              <a:t>Rust Gateway（dcc-mcp-core）：控制面 · Job · Artifact · 安全策略</a:t>
+            </a:r>
+          </a:p>
+        </p:txBody>
+      </p:sp>
+      <p:sp>
+        <p:nvSpPr>
+          <p:cNvPr id="7" name="Oval 6"/>
+          <p:cNvSpPr/>
+          <p:nvPr/>
+        </p:nvSpPr>
+        <p:spPr>
+          <a:xfrm>
+            <a:off x="2148840" y="2688336"/>
+            <a:ext cx="384048" cy="384048"/>
+          </a:xfrm>
+          <a:prstGeom prst="ellipse">
+            <a:avLst/>
+          </a:prstGeom>
+          <a:solidFill>
+            <a:srgbClr val="171F2E"/>
+          </a:solidFill>
+          <a:ln w="15240">
+            <a:solidFill>
+              <a:srgbClr val="4D9DE0"/>
+            </a:solidFill>
+          </a:ln>
+          <a:effectLst/>
+        </p:spPr>
+        <p:style>
+          <a:lnRef idx="1">
+            <a:schemeClr val="accent1"/>
+          </a:lnRef>
+          <a:fillRef idx="3">
+            <a:schemeClr val="accent1"/>
+          </a:fillRef>
+          <a:effectRef idx="2">
+            <a:schemeClr val="accent1"/>
+          </a:effectRef>
+          <a:fontRef idx="minor">
+            <a:schemeClr val="lt1"/>
+          </a:fontRef>
+        </p:style>
+        <p:txBody>
+          <a:bodyPr rtlCol="0" anchor="ctr" wrap="square" lIns="101600" rIns="101600" tIns="76200" bIns="76200"/>
+          <a:lstStyle/>
+          <a:p>
+            <a:pPr algn="ctr"/>
+            <a:r>
+              <a:rPr sz="1200" b="1">
+                <a:solidFill>
+                  <a:srgbClr val="4D9DE0"/>
+                </a:solidFill>
+                <a:latin typeface="Segoe UI"/>
+                <a:ea typeface="Microsoft YaHei"/>
+                <a:cs typeface="Segoe UI"/>
+              </a:rPr>
+              <a:t>2</a:t>
+            </a:r>
+          </a:p>
+        </p:txBody>
+      </p:sp>
+      <p:sp>
+        <p:nvSpPr>
+          <p:cNvPr id="8" name="Rounded Rectangle 7"/>
+          <p:cNvSpPr/>
+          <p:nvPr/>
+        </p:nvSpPr>
+        <p:spPr>
+          <a:xfrm>
+            <a:off x="2788920" y="2542032"/>
+            <a:ext cx="8412480" cy="713232"/>
+          </a:xfrm>
+          <a:prstGeom prst="roundRect">
+            <a:avLst>
+              <a:gd name="adj" fmla="val 10000"/>
+            </a:avLst>
+          </a:prstGeom>
+          <a:solidFill>
+            <a:srgbClr val="1E2A3D"/>
+          </a:solidFill>
+          <a:ln>
+            <a:noFill/>
+          </a:ln>
+          <a:effectLst/>
+        </p:spPr>
+        <p:style>
+          <a:lnRef idx="1">
+            <a:schemeClr val="accent1"/>
+          </a:lnRef>
+          <a:fillRef idx="3">
+            <a:schemeClr val="accent1"/>
+          </a:fillRef>
+          <a:effectRef idx="2">
+            <a:schemeClr val="accent1"/>
+          </a:effectRef>
+          <a:fontRef idx="minor">
+            <a:schemeClr val="lt1"/>
+          </a:fontRef>
+        </p:style>
+        <p:txBody>
+          <a:bodyPr rtlCol="0" anchor="ctr" wrap="square" lIns="101600" rIns="101600" tIns="76200" bIns="76200"/>
+          <a:lstStyle/>
+          <a:p>
+            <a:pPr algn="ctr"/>
+            <a:r>
+              <a:rPr sz="1450" b="0">
+                <a:solidFill>
+                  <a:srgbClr val="E8ECF2"/>
+                </a:solidFill>
+                <a:latin typeface="Segoe UI"/>
+                <a:ea typeface="Microsoft YaHei"/>
+                <a:cs typeface="Segoe UI"/>
+              </a:rPr>
+              <a:t>office-host.exe（C#）：每应用独立 Sidecar · 单 STA 队列</a:t>
+            </a:r>
+          </a:p>
+        </p:txBody>
+      </p:sp>
+      <p:sp>
+        <p:nvSpPr>
+          <p:cNvPr id="9" name="Oval 8"/>
+          <p:cNvSpPr/>
+          <p:nvPr/>
+        </p:nvSpPr>
+        <p:spPr>
+          <a:xfrm>
+            <a:off x="2148840" y="3557016"/>
+            <a:ext cx="384048" cy="384048"/>
+          </a:xfrm>
+          <a:prstGeom prst="ellipse">
+            <a:avLst/>
+          </a:prstGeom>
+          <a:solidFill>
+            <a:srgbClr val="171F2E"/>
+          </a:solidFill>
+          <a:ln w="15240">
+            <a:solidFill>
+              <a:srgbClr val="4D9DE0"/>
+            </a:solidFill>
+          </a:ln>
+          <a:effectLst/>
+        </p:spPr>
+        <p:style>
+          <a:lnRef idx="1">
+            <a:schemeClr val="accent1"/>
+          </a:lnRef>
+          <a:fillRef idx="3">
+            <a:schemeClr val="accent1"/>
+          </a:fillRef>
+          <a:effectRef idx="2">
+            <a:schemeClr val="accent1"/>
+          </a:effectRef>
+          <a:fontRef idx="minor">
+            <a:schemeClr val="lt1"/>
+          </a:fontRef>
+        </p:style>
+        <p:txBody>
+          <a:bodyPr rtlCol="0" anchor="ctr" wrap="square" lIns="101600" rIns="101600" tIns="76200" bIns="76200"/>
+          <a:lstStyle/>
+          <a:p>
+            <a:pPr algn="ctr"/>
+            <a:r>
+              <a:rPr sz="1200" b="1">
+                <a:solidFill>
+                  <a:srgbClr val="4D9DE0"/>
+                </a:solidFill>
+                <a:latin typeface="Segoe UI"/>
+                <a:ea typeface="Microsoft YaHei"/>
+                <a:cs typeface="Segoe UI"/>
+              </a:rPr>
+              <a:t>3</a:t>
+            </a:r>
+          </a:p>
+        </p:txBody>
+      </p:sp>
+      <p:sp>
+        <p:nvSpPr>
+          <p:cNvPr id="10" name="Rounded Rectangle 9"/>
+          <p:cNvSpPr/>
+          <p:nvPr/>
+        </p:nvSpPr>
+        <p:spPr>
+          <a:xfrm>
+            <a:off x="2788920" y="3410712"/>
+            <a:ext cx="8412480" cy="713232"/>
+          </a:xfrm>
+          <a:prstGeom prst="roundRect">
+            <a:avLst>
+              <a:gd name="adj" fmla="val 10000"/>
+            </a:avLst>
+          </a:prstGeom>
+          <a:solidFill>
+            <a:srgbClr val="1E2A3D"/>
+          </a:solidFill>
+          <a:ln>
+            <a:noFill/>
+          </a:ln>
+          <a:effectLst/>
+        </p:spPr>
+        <p:style>
+          <a:lnRef idx="1">
+            <a:schemeClr val="accent1"/>
+          </a:lnRef>
+          <a:fillRef idx="3">
+            <a:schemeClr val="accent1"/>
+          </a:fillRef>
+          <a:effectRef idx="2">
+            <a:schemeClr val="accent1"/>
+          </a:effectRef>
+          <a:fontRef idx="minor">
+            <a:schemeClr val="lt1"/>
+          </a:fontRef>
+        </p:style>
+        <p:txBody>
+          <a:bodyPr rtlCol="0" anchor="ctr" wrap="square" lIns="101600" rIns="101600" tIns="76200" bIns="76200"/>
+          <a:lstStyle/>
+          <a:p>
+            <a:pPr algn="ctr"/>
+            <a:r>
+              <a:rPr sz="1450" b="0">
+                <a:solidFill>
+                  <a:srgbClr val="E8ECF2"/>
+                </a:solidFill>
+                <a:latin typeface="Segoe UI"/>
+                <a:ea typeface="Microsoft YaHei"/>
+                <a:cs typeface="Segoe UI"/>
+              </a:rPr>
+              <a:t>POWERPNT / WINWORD / EXCEL（COM 数据面）</a:t>
+            </a:r>
+          </a:p>
+        </p:txBody>
+      </p:sp>
+      <p:sp>
+        <p:nvSpPr>
+          <p:cNvPr id="11" name="Oval 10"/>
+          <p:cNvSpPr/>
+          <p:nvPr/>
+        </p:nvSpPr>
+        <p:spPr>
+          <a:xfrm>
+            <a:off x="2148840" y="4425696"/>
+            <a:ext cx="384048" cy="384048"/>
+          </a:xfrm>
+          <a:prstGeom prst="ellipse">
+            <a:avLst/>
+          </a:prstGeom>
+          <a:solidFill>
+            <a:srgbClr val="171F2E"/>
+          </a:solidFill>
+          <a:ln w="15240">
+            <a:solidFill>
+              <a:srgbClr val="4D9DE0"/>
+            </a:solidFill>
+          </a:ln>
+          <a:effectLst/>
+        </p:spPr>
+        <p:style>
+          <a:lnRef idx="1">
+            <a:schemeClr val="accent1"/>
+          </a:lnRef>
+          <a:fillRef idx="3">
+            <a:schemeClr val="accent1"/>
+          </a:fillRef>
+          <a:effectRef idx="2">
+            <a:schemeClr val="accent1"/>
+          </a:effectRef>
+          <a:fontRef idx="minor">
+            <a:schemeClr val="lt1"/>
+          </a:fontRef>
+        </p:style>
+        <p:txBody>
+          <a:bodyPr rtlCol="0" anchor="ctr" wrap="square" lIns="101600" rIns="101600" tIns="76200" bIns="76200"/>
+          <a:lstStyle/>
+          <a:p>
+            <a:pPr algn="ctr"/>
+            <a:r>
+              <a:rPr sz="1200" b="1">
+                <a:solidFill>
+                  <a:srgbClr val="4D9DE0"/>
+                </a:solidFill>
+                <a:latin typeface="Segoe UI"/>
+                <a:ea typeface="Microsoft YaHei"/>
+                <a:cs typeface="Segoe UI"/>
+              </a:rPr>
+              <a:t>4</a:t>
+            </a:r>
+          </a:p>
+        </p:txBody>
+      </p:sp>
+      <p:sp>
+        <p:nvSpPr>
+          <p:cNvPr id="12" name="Rounded Rectangle 11"/>
+          <p:cNvSpPr/>
+          <p:nvPr/>
+        </p:nvSpPr>
+        <p:spPr>
+          <a:xfrm>
+            <a:off x="2788920" y="4279392"/>
+            <a:ext cx="8412480" cy="713232"/>
+          </a:xfrm>
+          <a:prstGeom prst="roundRect">
+            <a:avLst>
+              <a:gd name="adj" fmla="val 10000"/>
+            </a:avLst>
+          </a:prstGeom>
+          <a:solidFill>
+            <a:srgbClr val="1E2A3D"/>
+          </a:solidFill>
+          <a:ln>
+            <a:noFill/>
+          </a:ln>
+          <a:effectLst/>
+        </p:spPr>
+        <p:style>
+          <a:lnRef idx="1">
+            <a:schemeClr val="accent1"/>
+          </a:lnRef>
+          <a:fillRef idx="3">
+            <a:schemeClr val="accent1"/>
+          </a:fillRef>
+          <a:effectRef idx="2">
+            <a:schemeClr val="accent1"/>
+          </a:effectRef>
+          <a:fontRef idx="minor">
+            <a:schemeClr val="lt1"/>
+          </a:fontRef>
+        </p:style>
+        <p:txBody>
+          <a:bodyPr rtlCol="0" anchor="ctr" wrap="square" lIns="101600" rIns="101600" tIns="76200" bIns="76200"/>
+          <a:lstStyle/>
+          <a:p>
+            <a:pPr algn="ctr"/>
+            <a:r>
+              <a:rPr sz="1450" b="0">
+                <a:solidFill>
+                  <a:srgbClr val="E8ECF2"/>
+                </a:solidFill>
+                <a:latin typeface="Segoe UI"/>
+                <a:ea typeface="Microsoft YaHei"/>
+                <a:cs typeface="Segoe UI"/>
+              </a:rPr>
+              <a:t>Open XML Worker：批量结构处理（编译器，非渲染器）</a:t>
+            </a:r>
+          </a:p>
+        </p:txBody>
+      </p:sp>
+      <p:sp>
+        <p:nvSpPr>
+          <p:cNvPr id="13" name="Oval 12"/>
+          <p:cNvSpPr/>
+          <p:nvPr/>
+        </p:nvSpPr>
+        <p:spPr>
+          <a:xfrm>
+            <a:off x="2148840" y="5294376"/>
+            <a:ext cx="384048" cy="384048"/>
+          </a:xfrm>
+          <a:prstGeom prst="ellipse">
+            <a:avLst/>
+          </a:prstGeom>
+          <a:solidFill>
+            <a:srgbClr val="171F2E"/>
+          </a:solidFill>
+          <a:ln w="15240">
+            <a:solidFill>
+              <a:srgbClr val="4D9DE0"/>
+            </a:solidFill>
+          </a:ln>
+          <a:effectLst/>
+        </p:spPr>
+        <p:style>
+          <a:lnRef idx="1">
+            <a:schemeClr val="accent1"/>
+          </a:lnRef>
+          <a:fillRef idx="3">
+            <a:schemeClr val="accent1"/>
+          </a:fillRef>
+          <a:effectRef idx="2">
+            <a:schemeClr val="accent1"/>
+          </a:effectRef>
+          <a:fontRef idx="minor">
+            <a:schemeClr val="lt1"/>
+          </a:fontRef>
+        </p:style>
+        <p:txBody>
+          <a:bodyPr rtlCol="0" anchor="ctr" wrap="square" lIns="101600" rIns="101600" tIns="76200" bIns="76200"/>
+          <a:lstStyle/>
+          <a:p>
+            <a:pPr algn="ctr"/>
+            <a:r>
+              <a:rPr sz="1200" b="1">
+                <a:solidFill>
+                  <a:srgbClr val="4D9DE0"/>
+                </a:solidFill>
+                <a:latin typeface="Segoe UI"/>
+                <a:ea typeface="Microsoft YaHei"/>
+                <a:cs typeface="Segoe UI"/>
+              </a:rPr>
+              <a:t>5</a:t>
+            </a:r>
+          </a:p>
+        </p:txBody>
+      </p:sp>
+      <p:sp>
+        <p:nvSpPr>
+          <p:cNvPr id="14" name="Rounded Rectangle 13"/>
+          <p:cNvSpPr/>
+          <p:nvPr/>
+        </p:nvSpPr>
+        <p:spPr>
+          <a:xfrm>
+            <a:off x="2788920" y="5148072"/>
+            <a:ext cx="8412480" cy="713232"/>
+          </a:xfrm>
+          <a:prstGeom prst="roundRect">
+            <a:avLst>
+              <a:gd name="adj" fmla="val 10000"/>
+            </a:avLst>
+          </a:prstGeom>
+          <a:solidFill>
+            <a:srgbClr val="1E2A3D"/>
+          </a:solidFill>
+          <a:ln>
+            <a:noFill/>
+          </a:ln>
+          <a:effectLst/>
+        </p:spPr>
+        <p:style>
+          <a:lnRef idx="1">
+            <a:schemeClr val="accent1"/>
+          </a:lnRef>
+          <a:fillRef idx="3">
+            <a:schemeClr val="accent1"/>
+          </a:fillRef>
+          <a:effectRef idx="2">
+            <a:schemeClr val="accent1"/>
+          </a:effectRef>
+          <a:fontRef idx="minor">
+            <a:schemeClr val="lt1"/>
+          </a:fontRef>
+        </p:style>
+        <p:txBody>
+          <a:bodyPr rtlCol="0" anchor="ctr" wrap="square" lIns="101600" rIns="101600" tIns="76200" bIns="76200"/>
+          <a:lstStyle/>
+          <a:p>
+            <a:pPr algn="ctr"/>
+            <a:r>
+              <a:rPr sz="1450" b="0">
+                <a:solidFill>
+                  <a:srgbClr val="E8ECF2"/>
+                </a:solidFill>
+                <a:latin typeface="Segoe UI"/>
+                <a:ea typeface="Microsoft YaHei"/>
+                <a:cs typeface="Segoe UI"/>
+              </a:rPr>
+              <a:t>Microsoft Graph / Office.js / UIA-CUA：云与兜底路径</a:t>
+            </a:r>
+          </a:p>
+        </p:txBody>
+      </p:sp>
+      <p:cxnSp>
+        <p:nvCxnSpPr>
+          <p:cNvPr id="15" name="Connector 14"/>
+          <p:cNvCxnSpPr/>
+          <p:nvPr/>
+        </p:nvCxnSpPr>
+        <p:spPr>
+          <a:xfrm>
+            <a:off x="2340864" y="2194560"/>
+            <a:ext cx="0" cy="3474719"/>
+          </a:xfrm>
+          <a:prstGeom prst="line">
+            <a:avLst/>
+          </a:prstGeom>
+          <a:ln>
+            <a:solidFill>
+              <a:srgbClr val="4D9DE0"/>
+            </a:solidFill>
+          </a:ln>
+          <a:effectLst/>
+        </p:spPr>
+        <p:style>
+          <a:lnRef idx="2">
+            <a:schemeClr val="accent1"/>
+          </a:lnRef>
+          <a:fillRef idx="0">
+            <a:schemeClr val="accent1"/>
+          </a:fillRef>
+          <a:effectRef idx="1">
+            <a:schemeClr val="accent1"/>
+          </a:effectRef>
+          <a:fontRef idx="minor">
+            <a:schemeClr val="tx1"/>
+          </a:fontRef>
+        </p:style>
+      </p:cxnSp>
+      <p:sp>
+        <p:nvSpPr>
+          <p:cNvPr id="16" name="TextBox 15"/>
+          <p:cNvSpPr txBox="1"/>
+          <p:nvPr/>
+        </p:nvSpPr>
+        <p:spPr>
+          <a:xfrm>
+            <a:off x="822960" y="6473952"/>
+            <a:ext cx="7315200" cy="274320"/>
+          </a:xfrm>
+          <a:prstGeom prst="rect">
+            <a:avLst/>
+          </a:prstGeom>
+          <a:noFill/>
+          <a:effectLst/>
+        </p:spPr>
+        <p:txBody>
+          <a:bodyPr wrap="square" lIns="50800" rIns="50800">
+            <a:spAutoFit/>
+          </a:bodyPr>
+          <a:lstStyle/>
+          <a:p>
+            <a:pPr algn="l"/>
+            <a:r>
+              <a:rPr sz="1000" b="0">
+                <a:solidFill>
+                  <a:srgbClr val="9AA7BC"/>
+                </a:solidFill>
+                <a:latin typeface="Segoe UI"/>
+                <a:ea typeface="Microsoft YaHei"/>
+                <a:cs typeface="Segoe UI"/>
+              </a:rPr>
+              <a:t>DCC-MCP 框架介绍</a:t>
+            </a:r>
+          </a:p>
+        </p:txBody>
+      </p:sp>
+      <p:sp>
+        <p:nvSpPr>
+          <p:cNvPr id="17" name="TextBox 16"/>
+          <p:cNvSpPr txBox="1"/>
+          <p:nvPr/>
+        </p:nvSpPr>
+        <p:spPr>
+          <a:xfrm>
+            <a:off x="10728655" y="6400800"/>
+            <a:ext cx="1097280" cy="320040"/>
+          </a:xfrm>
+          <a:prstGeom prst="rect">
+            <a:avLst/>
+          </a:prstGeom>
+          <a:noFill/>
+          <a:effectLst/>
+        </p:spPr>
+        <p:txBody>
+          <a:bodyPr wrap="none">
+            <a:spAutoFit/>
+          </a:bodyPr>
+          <a:lstStyle/>
+          <a:p>
+            <a:pPr algn="r"/>
+            <a:r>
+              <a:rPr sz="1000" b="0">
+                <a:solidFill>
+                  <a:srgbClr val="9AA7BC"/>
+                </a:solidFill>
+                <a:latin typeface="Segoe UI"/>
+                <a:ea typeface="Microsoft YaHei"/>
+                <a:cs typeface="Segoe UI"/>
+              </a:rPr>
+              <a:t>14 / 16</a:t>
+            </a:r>
+          </a:p>
+        </p:txBody>
+      </p:sp>
+    </p:spTree>
+  </p:cSld>
+  <p:clrMapOvr>
+    <a:masterClrMapping/>
+  </p:clrMapOvr>
+</p:sld>
+</file>
+
+<file path=ppt/slides/slide15.xml><?xml version="1.0" encoding="utf-8"?>
+<p:sld xmlns:a="http://schemas.openxmlformats.org/drawingml/2006/main" xmlns:p="http://schemas.openxmlformats.org/presentationml/2006/main" xmlns:r="http://schemas.openxmlformats.org/officeDocument/2006/relationships">
+  <p:cSld>
+    <p:spTree>
+      <p:nvGrpSpPr>
+        <p:cNvPr id="1" name=""/>
+        <p:cNvGrpSpPr/>
+        <p:nvPr/>
+      </p:nvGrpSpPr>
+      <p:grpSpPr/>
+      <p:sp>
+        <p:nvSpPr>
+          <p:cNvPr id="2" name="Rectangle 1"/>
+          <p:cNvSpPr/>
+          <p:nvPr/>
+        </p:nvSpPr>
+        <p:spPr>
+          <a:xfrm>
+            <a:off x="0" y="0"/>
+            <a:ext cx="12191695" cy="6858000"/>
+          </a:xfrm>
+          <a:prstGeom prst="rect">
+            <a:avLst/>
+          </a:prstGeom>
+          <a:solidFill>
+            <a:srgbClr val="0F141E"/>
+          </a:solidFill>
+          <a:ln>
+            <a:noFill/>
+          </a:ln>
+          <a:effectLst/>
+        </p:spPr>
+        <p:style>
+          <a:lnRef idx="1">
+            <a:schemeClr val="accent1"/>
+          </a:lnRef>
+          <a:fillRef idx="3">
+            <a:schemeClr val="accent1"/>
+          </a:fillRef>
+          <a:effectRef idx="2">
+            <a:schemeClr val="accent1"/>
+          </a:effectRef>
+          <a:fontRef idx="minor">
+            <a:schemeClr val="lt1"/>
+          </a:fontRef>
+        </p:style>
+        <p:txBody>
+          <a:bodyPr rtlCol="0" anchor="ctr"/>
+          <a:lstStyle/>
+          <a:p>
+            <a:pPr algn="ctr"/>
+          </a:p>
+        </p:txBody>
+      </p:sp>
+      <p:sp>
+        <p:nvSpPr>
+          <p:cNvPr id="3" name="TextBox 2"/>
+          <p:cNvSpPr txBox="1"/>
+          <p:nvPr/>
+        </p:nvSpPr>
+        <p:spPr>
+          <a:xfrm>
+            <a:off x="822960" y="502920"/>
+            <a:ext cx="10515600" cy="685800"/>
+          </a:xfrm>
+          <a:prstGeom prst="rect">
+            <a:avLst/>
+          </a:prstGeom>
+          <a:noFill/>
+          <a:effectLst/>
+        </p:spPr>
+        <p:txBody>
+          <a:bodyPr wrap="square" lIns="50800" rIns="50800">
+            <a:spAutoFit/>
+          </a:bodyPr>
+          <a:lstStyle/>
+          <a:p>
+            <a:pPr algn="l"/>
+            <a:r>
+              <a:rPr sz="2800" b="1">
+                <a:solidFill>
+                  <a:srgbClr val="E8ECF2"/>
+                </a:solidFill>
+                <a:latin typeface="Segoe UI"/>
+                <a:ea typeface="Microsoft YaHei"/>
+                <a:cs typeface="Segoe UI"/>
+              </a:rPr>
+              <a:t>设计取舍</a:t>
+            </a:r>
+          </a:p>
+        </p:txBody>
+      </p:sp>
+      <p:sp>
+        <p:nvSpPr>
+          <p:cNvPr id="4" name="Rectangle 3"/>
+          <p:cNvSpPr/>
+          <p:nvPr/>
+        </p:nvSpPr>
+        <p:spPr>
+          <a:xfrm>
+            <a:off x="822960" y="1298448"/>
+            <a:ext cx="822960" cy="44450"/>
+          </a:xfrm>
+          <a:prstGeom prst="rect">
+            <a:avLst/>
+          </a:prstGeom>
+          <a:solidFill>
+            <a:srgbClr val="4D9DE0"/>
+          </a:solidFill>
+          <a:ln>
+            <a:noFill/>
+          </a:ln>
+          <a:effectLst/>
+        </p:spPr>
+        <p:style>
+          <a:lnRef idx="1">
+            <a:schemeClr val="accent1"/>
+          </a:lnRef>
+          <a:fillRef idx="3">
+            <a:schemeClr val="accent1"/>
+          </a:fillRef>
+          <a:effectRef idx="2">
+            <a:schemeClr val="accent1"/>
+          </a:effectRef>
+          <a:fontRef idx="minor">
+            <a:schemeClr val="lt1"/>
+          </a:fontRef>
+        </p:style>
+        <p:txBody>
+          <a:bodyPr rtlCol="0" anchor="ctr" wrap="square"/>
+          <a:lstStyle/>
+          <a:p>
+            <a:pPr algn="ctr"/>
+          </a:p>
+        </p:txBody>
+      </p:sp>
+      <p:sp>
+        <p:nvSpPr>
+          <p:cNvPr id="5" name="Rounded Rectangle 4"/>
+          <p:cNvSpPr/>
+          <p:nvPr/>
+        </p:nvSpPr>
+        <p:spPr>
+          <a:xfrm>
+            <a:off x="822960" y="1627632"/>
+            <a:ext cx="5120640" cy="566928"/>
+          </a:xfrm>
+          <a:prstGeom prst="roundRect">
+            <a:avLst>
+              <a:gd name="adj" fmla="val 16000"/>
+            </a:avLst>
+          </a:prstGeom>
+          <a:solidFill>
+            <a:srgbClr val="4D9DE0"/>
+          </a:solidFill>
+          <a:ln>
+            <a:noFill/>
+          </a:ln>
+          <a:effectLst/>
+        </p:spPr>
+        <p:style>
+          <a:lnRef idx="1">
+            <a:schemeClr val="accent1"/>
+          </a:lnRef>
+          <a:fillRef idx="3">
+            <a:schemeClr val="accent1"/>
+          </a:fillRef>
+          <a:effectRef idx="2">
+            <a:schemeClr val="accent1"/>
+          </a:effectRef>
+          <a:fontRef idx="minor">
+            <a:schemeClr val="lt1"/>
+          </a:fontRef>
+        </p:style>
+        <p:txBody>
+          <a:bodyPr rtlCol="0" anchor="ctr" wrap="square" lIns="101600" rIns="101600" tIns="76200" bIns="76200"/>
+          <a:lstStyle/>
+          <a:p>
+            <a:pPr algn="ctr"/>
+            <a:r>
+              <a:rPr sz="1600" b="1">
+                <a:solidFill>
+                  <a:srgbClr val="E8ECF2"/>
+                </a:solidFill>
+                <a:latin typeface="Segoe UI"/>
+                <a:ea typeface="Microsoft YaHei"/>
+                <a:cs typeface="Segoe UI"/>
+              </a:rPr>
+              <a:t>结构化 API 优先</a:t>
+            </a:r>
+          </a:p>
+        </p:txBody>
+      </p:sp>
+      <p:sp>
+        <p:nvSpPr>
+          <p:cNvPr id="6" name="Rounded Rectangle 5"/>
+          <p:cNvSpPr/>
+          <p:nvPr/>
+        </p:nvSpPr>
+        <p:spPr>
+          <a:xfrm>
+            <a:off x="822960" y="2304288"/>
+            <a:ext cx="5120640" cy="3749039"/>
+          </a:xfrm>
+          <a:prstGeom prst="roundRect">
+            <a:avLst>
+              <a:gd name="adj" fmla="val 5000"/>
+            </a:avLst>
+          </a:prstGeom>
+          <a:solidFill>
+            <a:srgbClr val="1E2A3D"/>
+          </a:solidFill>
+          <a:ln>
+            <a:noFill/>
+          </a:ln>
+          <a:effectLst/>
+        </p:spPr>
+        <p:style>
+          <a:lnRef idx="1">
+            <a:schemeClr val="accent1"/>
+          </a:lnRef>
+          <a:fillRef idx="3">
+            <a:schemeClr val="accent1"/>
+          </a:fillRef>
+          <a:effectRef idx="2">
+            <a:schemeClr val="accent1"/>
+          </a:effectRef>
+          <a:fontRef idx="minor">
+            <a:schemeClr val="lt1"/>
+          </a:fontRef>
+        </p:style>
+        <p:txBody>
+          <a:bodyPr rtlCol="0" anchor="ctr" wrap="square" lIns="101600" rIns="101600" tIns="76200" bIns="76200"/>
+          <a:lstStyle/>
+          <a:p>
+            <a:pPr algn="l"/>
+            <a:r>
+              <a:rPr sz="1450" b="0">
+                <a:solidFill>
+                  <a:srgbClr val="E8ECF2"/>
+                </a:solidFill>
+                <a:latin typeface="Segoe UI"/>
+                <a:ea typeface="Microsoft YaHei"/>
+                <a:cs typeface="Segoe UI"/>
+              </a:rPr>
+              <a:t>✓  确定性、可验证、可审计</a:t>
+            </a:r>
+          </a:p>
+          <a:p>
+            <a:pPr algn="l"/>
+            <a:r>
+              <a:rPr sz="1450" b="0">
+                <a:solidFill>
+                  <a:srgbClr val="E8ECF2"/>
+                </a:solidFill>
+                <a:latin typeface="Segoe UI"/>
+                <a:ea typeface="Microsoft YaHei"/>
+                <a:cs typeface="Segoe UI"/>
+              </a:rPr>
+              <a:t>✓  UIA/CUA 只做最后兜底</a:t>
+            </a:r>
+          </a:p>
+          <a:p>
+            <a:pPr algn="l"/>
+            <a:r>
+              <a:rPr sz="1450" b="0">
+                <a:solidFill>
+                  <a:srgbClr val="E8ECF2"/>
+                </a:solidFill>
+                <a:latin typeface="Segoe UI"/>
+                <a:ea typeface="Microsoft YaHei"/>
+                <a:cs typeface="Segoe UI"/>
+              </a:rPr>
+              <a:t>✓  写操作不得静默降级</a:t>
+            </a:r>
+          </a:p>
+        </p:txBody>
+      </p:sp>
+      <p:sp>
+        <p:nvSpPr>
+          <p:cNvPr id="7" name="Rounded Rectangle 6"/>
+          <p:cNvSpPr/>
+          <p:nvPr/>
+        </p:nvSpPr>
+        <p:spPr>
+          <a:xfrm>
+            <a:off x="6309360" y="1627632"/>
+            <a:ext cx="5120640" cy="566928"/>
+          </a:xfrm>
+          <a:prstGeom prst="roundRect">
+            <a:avLst>
+              <a:gd name="adj" fmla="val 16000"/>
+            </a:avLst>
+          </a:prstGeom>
+          <a:solidFill>
+            <a:srgbClr val="7FC8A9"/>
+          </a:solidFill>
+          <a:ln>
+            <a:noFill/>
+          </a:ln>
+          <a:effectLst/>
+        </p:spPr>
+        <p:style>
+          <a:lnRef idx="1">
+            <a:schemeClr val="accent1"/>
+          </a:lnRef>
+          <a:fillRef idx="3">
+            <a:schemeClr val="accent1"/>
+          </a:fillRef>
+          <a:effectRef idx="2">
+            <a:schemeClr val="accent1"/>
+          </a:effectRef>
+          <a:fontRef idx="minor">
+            <a:schemeClr val="lt1"/>
+          </a:fontRef>
+        </p:style>
+        <p:txBody>
+          <a:bodyPr rtlCol="0" anchor="ctr" wrap="square" lIns="101600" rIns="101600" tIns="76200" bIns="76200"/>
+          <a:lstStyle/>
+          <a:p>
+            <a:pPr algn="ctr"/>
+            <a:r>
+              <a:rPr sz="1600" b="1">
+                <a:solidFill>
+                  <a:srgbClr val="E8ECF2"/>
+                </a:solidFill>
+                <a:latin typeface="Segoe UI"/>
+                <a:ea typeface="Microsoft YaHei"/>
+                <a:cs typeface="Segoe UI"/>
+              </a:rPr>
+              <a:t>任务级能力</a:t>
+            </a:r>
+          </a:p>
+        </p:txBody>
+      </p:sp>
+      <p:sp>
+        <p:nvSpPr>
+          <p:cNvPr id="8" name="Rounded Rectangle 7"/>
+          <p:cNvSpPr/>
+          <p:nvPr/>
+        </p:nvSpPr>
+        <p:spPr>
+          <a:xfrm>
+            <a:off x="6309360" y="2304288"/>
+            <a:ext cx="5120640" cy="3749039"/>
+          </a:xfrm>
+          <a:prstGeom prst="roundRect">
+            <a:avLst>
+              <a:gd name="adj" fmla="val 5000"/>
+            </a:avLst>
+          </a:prstGeom>
+          <a:solidFill>
+            <a:srgbClr val="1E2A3D"/>
+          </a:solidFill>
+          <a:ln>
+            <a:noFill/>
+          </a:ln>
+          <a:effectLst/>
+        </p:spPr>
+        <p:style>
+          <a:lnRef idx="1">
+            <a:schemeClr val="accent1"/>
+          </a:lnRef>
+          <a:fillRef idx="3">
+            <a:schemeClr val="accent1"/>
+          </a:fillRef>
+          <a:effectRef idx="2">
+            <a:schemeClr val="accent1"/>
+          </a:effectRef>
+          <a:fontRef idx="minor">
+            <a:schemeClr val="lt1"/>
+          </a:fontRef>
+        </p:style>
+        <p:txBody>
+          <a:bodyPr rtlCol="0" anchor="ctr" wrap="square" lIns="101600" rIns="101600" tIns="76200" bIns="76200"/>
+          <a:lstStyle/>
+          <a:p>
+            <a:pPr algn="l"/>
+            <a:r>
+              <a:rPr sz="1450" b="0">
+                <a:solidFill>
+                  <a:srgbClr val="E8ECF2"/>
+                </a:solidFill>
+                <a:latin typeface="Segoe UI"/>
+                <a:ea typeface="Microsoft YaHei"/>
+                <a:cs typeface="Segoe UI"/>
+              </a:rPr>
+              <a:t>✓  不暴露原始 COM 成员</a:t>
+            </a:r>
+          </a:p>
+          <a:p>
+            <a:pPr algn="l"/>
+            <a:r>
+              <a:rPr sz="1450" b="0">
+                <a:solidFill>
+                  <a:srgbClr val="E8ECF2"/>
+                </a:solidFill>
+                <a:latin typeface="Segoe UI"/>
+                <a:ea typeface="Microsoft YaHei"/>
+                <a:cs typeface="Segoe UI"/>
+              </a:rPr>
+              <a:t>✓  模板优先于自由坐标</a:t>
+            </a:r>
+          </a:p>
+          <a:p>
+            <a:pPr algn="l"/>
+            <a:r>
+              <a:rPr sz="1450" b="0">
+                <a:solidFill>
+                  <a:srgbClr val="E8ECF2"/>
+                </a:solidFill>
+                <a:latin typeface="Segoe UI"/>
+                <a:ea typeface="Microsoft YaHei"/>
+                <a:cs typeface="Segoe UI"/>
+              </a:rPr>
+              <a:t>✓  检查点 + 预览 + 可追踪结果</a:t>
+            </a:r>
+          </a:p>
+        </p:txBody>
+      </p:sp>
+      <p:sp>
+        <p:nvSpPr>
+          <p:cNvPr id="9" name="TextBox 8"/>
+          <p:cNvSpPr txBox="1"/>
+          <p:nvPr/>
+        </p:nvSpPr>
+        <p:spPr>
+          <a:xfrm>
+            <a:off x="822960" y="6473952"/>
+            <a:ext cx="7315200" cy="274320"/>
+          </a:xfrm>
+          <a:prstGeom prst="rect">
+            <a:avLst/>
+          </a:prstGeom>
+          <a:noFill/>
+          <a:effectLst/>
+        </p:spPr>
+        <p:txBody>
+          <a:bodyPr wrap="square" lIns="50800" rIns="50800">
+            <a:spAutoFit/>
+          </a:bodyPr>
+          <a:lstStyle/>
+          <a:p>
+            <a:pPr algn="l"/>
+            <a:r>
+              <a:rPr sz="1000" b="0">
+                <a:solidFill>
+                  <a:srgbClr val="9AA7BC"/>
+                </a:solidFill>
+                <a:latin typeface="Segoe UI"/>
+                <a:ea typeface="Microsoft YaHei"/>
+                <a:cs typeface="Segoe UI"/>
+              </a:rPr>
+              <a:t>DCC-MCP 框架介绍</a:t>
+            </a:r>
+          </a:p>
+        </p:txBody>
+      </p:sp>
+      <p:sp>
+        <p:nvSpPr>
+          <p:cNvPr id="10" name="TextBox 9"/>
+          <p:cNvSpPr txBox="1"/>
+          <p:nvPr/>
+        </p:nvSpPr>
+        <p:spPr>
+          <a:xfrm>
+            <a:off x="10728655" y="6400800"/>
+            <a:ext cx="1097280" cy="320040"/>
+          </a:xfrm>
+          <a:prstGeom prst="rect">
+            <a:avLst/>
+          </a:prstGeom>
+          <a:noFill/>
+          <a:effectLst/>
+        </p:spPr>
+        <p:txBody>
+          <a:bodyPr wrap="none">
+            <a:spAutoFit/>
+          </a:bodyPr>
+          <a:lstStyle/>
+          <a:p>
+            <a:pPr algn="r"/>
+            <a:r>
+              <a:rPr sz="1000" b="0">
+                <a:solidFill>
+                  <a:srgbClr val="9AA7BC"/>
+                </a:solidFill>
+                <a:latin typeface="Segoe UI"/>
+                <a:ea typeface="Microsoft YaHei"/>
+                <a:cs typeface="Segoe UI"/>
+              </a:rPr>
+              <a:t>15 / 16</a:t>
+            </a:r>
+          </a:p>
+        </p:txBody>
+      </p:sp>
+    </p:spTree>
+  </p:cSld>
+  <p:clrMapOvr>
+    <a:masterClrMapping/>
+  </p:clrMapOvr>
+</p:sld>
+</file>
+
+<file path=ppt/slides/slide16.xml><?xml version="1.0" encoding="utf-8"?>
+<p:sld xmlns:a="http://schemas.openxmlformats.org/drawingml/2006/main" xmlns:p="http://schemas.openxmlformats.org/presentationml/2006/main" xmlns:r="http://schemas.openxmlformats.org/officeDocument/2006/relationships">
+  <p:cSld>
+    <p:spTree>
+      <p:nvGrpSpPr>
+        <p:cNvPr id="1" name=""/>
+        <p:cNvGrpSpPr/>
+        <p:nvPr/>
+      </p:nvGrpSpPr>
+      <p:grpSpPr/>
+      <p:sp>
+        <p:nvSpPr>
+          <p:cNvPr id="2" name="Rectangle 1"/>
+          <p:cNvSpPr/>
+          <p:nvPr/>
+        </p:nvSpPr>
+        <p:spPr>
+          <a:xfrm>
+            <a:off x="0" y="0"/>
+            <a:ext cx="12191695" cy="6858000"/>
+          </a:xfrm>
+          <a:prstGeom prst="rect">
+            <a:avLst/>
+          </a:prstGeom>
+          <a:solidFill>
+            <a:srgbClr val="0F141E"/>
+          </a:solidFill>
+          <a:ln>
+            <a:noFill/>
+          </a:ln>
+          <a:effectLst/>
+        </p:spPr>
+        <p:style>
+          <a:lnRef idx="1">
+            <a:schemeClr val="accent1"/>
+          </a:lnRef>
+          <a:fillRef idx="3">
+            <a:schemeClr val="accent1"/>
+          </a:fillRef>
+          <a:effectRef idx="2">
+            <a:schemeClr val="accent1"/>
+          </a:effectRef>
+          <a:fontRef idx="minor">
+            <a:schemeClr val="lt1"/>
+          </a:fontRef>
+        </p:style>
+        <p:txBody>
+          <a:bodyPr rtlCol="0" anchor="ctr"/>
+          <a:lstStyle/>
+          <a:p>
+            <a:pPr algn="ctr"/>
+          </a:p>
+        </p:txBody>
+      </p:sp>
+      <p:sp>
+        <p:nvSpPr>
           <p:cNvPr id="3" name="Rectangle 2"/>
           <p:cNvSpPr/>
           <p:nvPr/>
@@ -7410,6 +8625,7 @@
                 </a:solidFill>
                 <a:latin typeface="Segoe UI"/>
                 <a:ea typeface="Microsoft YaHei"/>
+                <a:cs typeface="Segoe UI"/>
               </a:rPr>
               <a:t>Thanks</a:t>
             </a:r>
@@ -7447,6 +8663,7 @@
                 </a:solidFill>
                 <a:latin typeface="Segoe UI"/>
                 <a:ea typeface="Microsoft YaHei"/>
+                <a:cs typeface="Segoe UI"/>
               </a:rPr>
               <a:t>dcc-mcp · 让 AI 进入每一个创作工具</a:t>
             </a:r>
@@ -7484,6 +8701,7 @@
                 </a:solidFill>
                 <a:latin typeface="Segoe UI"/>
                 <a:ea typeface="Microsoft YaHei"/>
+                <a:cs typeface="Segoe UI"/>
               </a:rPr>
               <a:t>DCC-MCP 框架介绍</a:t>
             </a:r>
@@ -7521,8 +8739,9 @@
                 </a:solidFill>
                 <a:latin typeface="Segoe UI"/>
                 <a:ea typeface="Microsoft YaHei"/>
+                <a:cs typeface="Segoe UI"/>
               </a:rPr>
-              <a:t>14 / 14</a:t>
+              <a:t>16 / 16</a:t>
             </a:r>
           </a:p>
         </p:txBody>
@@ -7708,6 +8927,7 @@
                 </a:solidFill>
                 <a:latin typeface="Segoe UI"/>
                 <a:ea typeface="Microsoft YaHei"/>
+                <a:cs typeface="Segoe UI"/>
               </a:rPr>
               <a:t>01</a:t>
             </a:r>
@@ -7789,6 +9009,7 @@
                 </a:solidFill>
                 <a:latin typeface="Segoe UI"/>
                 <a:ea typeface="Microsoft YaHei"/>
+                <a:cs typeface="Segoe UI"/>
               </a:rPr>
               <a:t>框架总览</a:t>
             </a:r>
@@ -7826,6 +9047,7 @@
                 </a:solidFill>
                 <a:latin typeface="Segoe UI"/>
                 <a:ea typeface="Microsoft YaHei"/>
+                <a:cs typeface="Segoe UI"/>
               </a:rPr>
               <a:t>DCC-MCP 框架介绍</a:t>
             </a:r>
@@ -7863,8 +9085,9 @@
                 </a:solidFill>
                 <a:latin typeface="Segoe UI"/>
                 <a:ea typeface="Microsoft YaHei"/>
+                <a:cs typeface="Segoe UI"/>
               </a:rPr>
-              <a:t>02 / 14</a:t>
+              <a:t>02 / 16</a:t>
             </a:r>
           </a:p>
         </p:txBody>
@@ -7962,6 +9185,7 @@
                 </a:solidFill>
                 <a:latin typeface="Segoe UI"/>
                 <a:ea typeface="Microsoft YaHei"/>
+                <a:cs typeface="Segoe UI"/>
               </a:rPr>
               <a:t>什么是 DCC-MCP</a:t>
             </a:r>
@@ -8087,6 +9311,7 @@
                 </a:solidFill>
                 <a:latin typeface="Segoe UI"/>
                 <a:ea typeface="Microsoft YaHei"/>
+                <a:cs typeface="Segoe UI"/>
               </a:rPr>
               <a:t>面向数字内容创作（DCC）工具的统一 MCP 网关生态</a:t>
             </a:r>
@@ -8212,6 +9437,7 @@
                 </a:solidFill>
                 <a:latin typeface="Segoe UI"/>
                 <a:ea typeface="Microsoft YaHei"/>
+                <a:cs typeface="Segoe UI"/>
               </a:rPr>
               <a:t>一个 DCC 一个适配器仓库：Maya、Blender、Houdini、Photoshop、Unity、Office…</a:t>
             </a:r>
@@ -8337,6 +9563,7 @@
                 </a:solidFill>
                 <a:latin typeface="Segoe UI"/>
                 <a:ea typeface="Microsoft YaHei"/>
+                <a:cs typeface="Segoe UI"/>
               </a:rPr>
               <a:t>统一的能力发现机制：list → search → load_skill → call</a:t>
             </a:r>
@@ -8462,6 +9689,7 @@
                 </a:solidFill>
                 <a:latin typeface="Segoe UI"/>
                 <a:ea typeface="Microsoft YaHei"/>
+                <a:cs typeface="Segoe UI"/>
               </a:rPr>
               <a:t>Skills 机制：把稳定流程固化为可复用的技能包</a:t>
             </a:r>
@@ -8499,6 +9727,7 @@
                 </a:solidFill>
                 <a:latin typeface="Segoe UI"/>
                 <a:ea typeface="Microsoft YaHei"/>
+                <a:cs typeface="Segoe UI"/>
               </a:rPr>
               <a:t>DCC-MCP 框架介绍</a:t>
             </a:r>
@@ -8536,8 +9765,9 @@
                 </a:solidFill>
                 <a:latin typeface="Segoe UI"/>
                 <a:ea typeface="Microsoft YaHei"/>
+                <a:cs typeface="Segoe UI"/>
               </a:rPr>
-              <a:t>03 / 14</a:t>
+              <a:t>03 / 16</a:t>
             </a:r>
           </a:p>
         </p:txBody>
@@ -8635,6 +9865,7 @@
                 </a:solidFill>
                 <a:latin typeface="Segoe UI"/>
                 <a:ea typeface="Microsoft YaHei"/>
+                <a:cs typeface="Segoe UI"/>
               </a:rPr>
               <a:t>总体架构</a:t>
             </a:r>
@@ -8735,6 +9966,7 @@
                 </a:solidFill>
                 <a:latin typeface="Segoe UI"/>
                 <a:ea typeface="Microsoft YaHei"/>
+                <a:cs typeface="Segoe UI"/>
               </a:rPr>
               <a:t>1</a:t>
             </a:r>
@@ -8791,6 +10023,7 @@
                 </a:solidFill>
                 <a:latin typeface="Segoe UI"/>
                 <a:ea typeface="Microsoft YaHei"/>
+                <a:cs typeface="Segoe UI"/>
               </a:rPr>
               <a:t>Agent / MCP Client / IDE / CI</a:t>
             </a:r>
@@ -8847,6 +10080,7 @@
                 </a:solidFill>
                 <a:latin typeface="Segoe UI"/>
                 <a:ea typeface="Microsoft YaHei"/>
+                <a:cs typeface="Segoe UI"/>
               </a:rPr>
               <a:t>2</a:t>
             </a:r>
@@ -8903,6 +10137,7 @@
                 </a:solidFill>
                 <a:latin typeface="Segoe UI"/>
                 <a:ea typeface="Microsoft YaHei"/>
+                <a:cs typeface="Segoe UI"/>
               </a:rPr>
               <a:t>dcc-mcp-gateway（Rust）：路由 · 能力索引 · Job · Artifact · 策略</a:t>
             </a:r>
@@ -8959,6 +10194,7 @@
                 </a:solidFill>
                 <a:latin typeface="Segoe UI"/>
                 <a:ea typeface="Microsoft YaHei"/>
+                <a:cs typeface="Segoe UI"/>
               </a:rPr>
               <a:t>3</a:t>
             </a:r>
@@ -9015,6 +10251,7 @@
                 </a:solidFill>
                 <a:latin typeface="Segoe UI"/>
                 <a:ea typeface="Microsoft YaHei"/>
+                <a:cs typeface="Segoe UI"/>
               </a:rPr>
               <a:t>Sidecar（RFC #998）：进程生命周期 · PPID 守护 · HostRpcClient</a:t>
             </a:r>
@@ -9071,6 +10308,7 @@
                 </a:solidFill>
                 <a:latin typeface="Segoe UI"/>
                 <a:ea typeface="Microsoft YaHei"/>
+                <a:cs typeface="Segoe UI"/>
               </a:rPr>
               <a:t>4</a:t>
             </a:r>
@@ -9127,6 +10365,7 @@
                 </a:solidFill>
                 <a:latin typeface="Segoe UI"/>
                 <a:ea typeface="Microsoft YaHei"/>
+                <a:cs typeface="Segoe UI"/>
               </a:rPr>
               <a:t>各 DCC 适配器：Maya commandPort · Blender HTTP · Houdini hrpyc · …</a:t>
             </a:r>
@@ -9183,6 +10422,7 @@
                 </a:solidFill>
                 <a:latin typeface="Segoe UI"/>
                 <a:ea typeface="Microsoft YaHei"/>
+                <a:cs typeface="Segoe UI"/>
               </a:rPr>
               <a:t>5</a:t>
             </a:r>
@@ -9239,6 +10479,7 @@
                 </a:solidFill>
                 <a:latin typeface="Segoe UI"/>
                 <a:ea typeface="Microsoft YaHei"/>
+                <a:cs typeface="Segoe UI"/>
               </a:rPr>
               <a:t>DCC 应用：Maya / Blender / Houdini / Photoshop / Unity / Office</a:t>
             </a:r>
@@ -9312,6 +10553,7 @@
                 </a:solidFill>
                 <a:latin typeface="Segoe UI"/>
                 <a:ea typeface="Microsoft YaHei"/>
+                <a:cs typeface="Segoe UI"/>
               </a:rPr>
               <a:t>DCC-MCP 框架介绍</a:t>
             </a:r>
@@ -9349,8 +10591,9 @@
                 </a:solidFill>
                 <a:latin typeface="Segoe UI"/>
                 <a:ea typeface="Microsoft YaHei"/>
+                <a:cs typeface="Segoe UI"/>
               </a:rPr>
-              <a:t>04 / 14</a:t>
+              <a:t>04 / 16</a:t>
             </a:r>
           </a:p>
         </p:txBody>
@@ -9448,6 +10691,7 @@
                 </a:solidFill>
                 <a:latin typeface="Segoe UI"/>
                 <a:ea typeface="Microsoft YaHei"/>
+                <a:cs typeface="Segoe UI"/>
               </a:rPr>
               <a:t>能力与 Skills</a:t>
             </a:r>
@@ -9573,6 +10817,7 @@
                 </a:solidFill>
                 <a:latin typeface="Segoe UI"/>
                 <a:ea typeface="Microsoft YaHei"/>
+                <a:cs typeface="Segoe UI"/>
               </a:rPr>
               <a:t>任务级 Capability，不暴露原始对象模型</a:t>
             </a:r>
@@ -9698,6 +10943,7 @@
                 </a:solidFill>
                 <a:latin typeface="Segoe UI"/>
                 <a:ea typeface="Microsoft YaHei"/>
+                <a:cs typeface="Segoe UI"/>
               </a:rPr>
               <a:t>渐进式发现：初始上下文不塞满数百个工具</a:t>
             </a:r>
@@ -9823,6 +11069,7 @@
                 </a:solidFill>
                 <a:latin typeface="Segoe UI"/>
                 <a:ea typeface="Microsoft YaHei"/>
+                <a:cs typeface="Segoe UI"/>
               </a:rPr>
               <a:t>契约化技能包：SKILL.md + tools.yaml + scripts/&lt;name&gt;.py</a:t>
             </a:r>
@@ -9948,6 +11195,7 @@
                 </a:solidFill>
                 <a:latin typeface="Segoe UI"/>
                 <a:ea typeface="Microsoft YaHei"/>
+                <a:cs typeface="Segoe UI"/>
               </a:rPr>
               <a:t>Maya 单仓 25+ 域技能包、198 个结构化操作</a:t>
             </a:r>
@@ -9985,6 +11233,7 @@
                 </a:solidFill>
                 <a:latin typeface="Segoe UI"/>
                 <a:ea typeface="Microsoft YaHei"/>
+                <a:cs typeface="Segoe UI"/>
               </a:rPr>
               <a:t>DCC-MCP 框架介绍</a:t>
             </a:r>
@@ -10022,8 +11271,9 @@
                 </a:solidFill>
                 <a:latin typeface="Segoe UI"/>
                 <a:ea typeface="Microsoft YaHei"/>
+                <a:cs typeface="Segoe UI"/>
               </a:rPr>
-              <a:t>05 / 14</a:t>
+              <a:t>05 / 16</a:t>
             </a:r>
           </a:p>
         </p:txBody>
@@ -10121,6 +11371,7 @@
                 </a:solidFill>
                 <a:latin typeface="Segoe UI"/>
                 <a:ea typeface="Microsoft YaHei"/>
+                <a:cs typeface="Segoe UI"/>
               </a:rPr>
               <a:t>生态现状</a:t>
             </a:r>
@@ -10221,6 +11472,7 @@
                 </a:solidFill>
                 <a:latin typeface="Segoe UI"/>
                 <a:ea typeface="Microsoft YaHei"/>
+                <a:cs typeface="Segoe UI"/>
               </a:rPr>
               <a:t>30+</a:t>
             </a:r>
@@ -10234,6 +11486,7 @@
                 </a:solidFill>
                 <a:latin typeface="Segoe UI"/>
                 <a:ea typeface="Microsoft YaHei"/>
+                <a:cs typeface="Segoe UI"/>
               </a:rPr>
               <a:t>DCC 适配器仓库</a:t>
             </a:r>
@@ -10334,6 +11587,7 @@
                 </a:solidFill>
                 <a:latin typeface="Segoe UI"/>
                 <a:ea typeface="Microsoft YaHei"/>
+                <a:cs typeface="Segoe UI"/>
               </a:rPr>
               <a:t>198</a:t>
             </a:r>
@@ -10347,6 +11601,7 @@
                 </a:solidFill>
                 <a:latin typeface="Segoe UI"/>
                 <a:ea typeface="Microsoft YaHei"/>
+                <a:cs typeface="Segoe UI"/>
               </a:rPr>
               <a:t>Maya 结构化操作</a:t>
             </a:r>
@@ -10447,6 +11702,7 @@
                 </a:solidFill>
                 <a:latin typeface="Segoe UI"/>
                 <a:ea typeface="Microsoft YaHei"/>
+                <a:cs typeface="Segoe UI"/>
               </a:rPr>
               <a:t>25+</a:t>
             </a:r>
@@ -10460,6 +11716,7 @@
                 </a:solidFill>
                 <a:latin typeface="Segoe UI"/>
                 <a:ea typeface="Microsoft YaHei"/>
+                <a:cs typeface="Segoe UI"/>
               </a:rPr>
               <a:t>Maya 域技能包</a:t>
             </a:r>
@@ -10560,6 +11817,7 @@
                 </a:solidFill>
                 <a:latin typeface="Segoe UI"/>
                 <a:ea typeface="Microsoft YaHei"/>
+                <a:cs typeface="Segoe UI"/>
               </a:rPr>
               <a:t>5</a:t>
             </a:r>
@@ -10573,6 +11831,7 @@
                 </a:solidFill>
                 <a:latin typeface="Segoe UI"/>
                 <a:ea typeface="Microsoft YaHei"/>
+                <a:cs typeface="Segoe UI"/>
               </a:rPr>
               <a:t>Office 新域仓库（office / PPT / Word / Excel / Outlook）</a:t>
             </a:r>
@@ -10673,6 +11932,7 @@
                 </a:solidFill>
                 <a:latin typeface="Segoe UI"/>
                 <a:ea typeface="Microsoft YaHei"/>
+                <a:cs typeface="Segoe UI"/>
               </a:rPr>
               <a:t>6</a:t>
             </a:r>
@@ -10686,6 +11946,7 @@
                 </a:solidFill>
                 <a:latin typeface="Segoe UI"/>
                 <a:ea typeface="Microsoft YaHei"/>
+                <a:cs typeface="Segoe UI"/>
               </a:rPr>
               <a:t>执行后端路径（OpenXML / COM / Graph / Office.js / UIA / CUA）</a:t>
             </a:r>
@@ -10786,6 +12047,7 @@
                 </a:solidFill>
                 <a:latin typeface="Segoe UI"/>
                 <a:ea typeface="Microsoft YaHei"/>
+                <a:cs typeface="Segoe UI"/>
               </a:rPr>
               <a:t>12</a:t>
             </a:r>
@@ -10799,6 +12061,7 @@
                 </a:solidFill>
                 <a:latin typeface="Segoe UI"/>
                 <a:ea typeface="Microsoft YaHei"/>
+                <a:cs typeface="Segoe UI"/>
               </a:rPr>
               <a:t>Office MVP 验收标准</a:t>
             </a:r>
@@ -10880,6 +12143,7 @@
                 </a:solidFill>
                 <a:latin typeface="Segoe UI"/>
                 <a:ea typeface="Microsoft YaHei"/>
+                <a:cs typeface="Segoe UI"/>
               </a:rPr>
               <a:t>DCC-MCP 框架介绍</a:t>
             </a:r>
@@ -10917,8 +12181,9 @@
                 </a:solidFill>
                 <a:latin typeface="Segoe UI"/>
                 <a:ea typeface="Microsoft YaHei"/>
+                <a:cs typeface="Segoe UI"/>
               </a:rPr>
-              <a:t>06 / 14</a:t>
+              <a:t>06 / 16</a:t>
             </a:r>
           </a:p>
         </p:txBody>
@@ -11016,6 +12281,7 @@
                 </a:solidFill>
                 <a:latin typeface="Segoe UI"/>
                 <a:ea typeface="Microsoft YaHei"/>
+                <a:cs typeface="Segoe UI"/>
               </a:rPr>
               <a:t>覆盖的 DCC 工具</a:t>
             </a:r>
@@ -11168,6 +12434,7 @@
                 </a:solidFill>
                 <a:latin typeface="Segoe UI"/>
                 <a:ea typeface="Microsoft YaHei"/>
+                <a:cs typeface="Segoe UI"/>
               </a:rPr>
               <a:t>Maya</a:t>
             </a:r>
@@ -11276,6 +12543,7 @@
                 </a:solidFill>
                 <a:latin typeface="Segoe UI"/>
                 <a:ea typeface="Microsoft YaHei"/>
+                <a:cs typeface="Segoe UI"/>
               </a:rPr>
               <a:t>Blender</a:t>
             </a:r>
@@ -11384,6 +12652,7 @@
                 </a:solidFill>
                 <a:latin typeface="Segoe UI"/>
                 <a:ea typeface="Microsoft YaHei"/>
+                <a:cs typeface="Segoe UI"/>
               </a:rPr>
               <a:t>Houdini</a:t>
             </a:r>
@@ -11492,6 +12761,7 @@
                 </a:solidFill>
                 <a:latin typeface="Segoe UI"/>
                 <a:ea typeface="Microsoft YaHei"/>
+                <a:cs typeface="Segoe UI"/>
               </a:rPr>
               <a:t>Photoshop</a:t>
             </a:r>
@@ -11600,6 +12870,7 @@
                 </a:solidFill>
                 <a:latin typeface="Segoe UI"/>
                 <a:ea typeface="Microsoft YaHei"/>
+                <a:cs typeface="Segoe UI"/>
               </a:rPr>
               <a:t>Unity</a:t>
             </a:r>
@@ -11708,6 +12979,7 @@
                 </a:solidFill>
                 <a:latin typeface="Segoe UI"/>
                 <a:ea typeface="Microsoft YaHei"/>
+                <a:cs typeface="Segoe UI"/>
               </a:rPr>
               <a:t>Unreal</a:t>
             </a:r>
@@ -11816,6 +13088,7 @@
                 </a:solidFill>
                 <a:latin typeface="Segoe UI"/>
                 <a:ea typeface="Microsoft YaHei"/>
+                <a:cs typeface="Segoe UI"/>
               </a:rPr>
               <a:t>Nuke</a:t>
             </a:r>
@@ -11924,6 +13197,7 @@
                 </a:solidFill>
                 <a:latin typeface="Segoe UI"/>
                 <a:ea typeface="Microsoft YaHei"/>
+                <a:cs typeface="Segoe UI"/>
               </a:rPr>
               <a:t>3ds Max</a:t>
             </a:r>
@@ -12032,6 +13306,7 @@
                 </a:solidFill>
                 <a:latin typeface="Segoe UI"/>
                 <a:ea typeface="Microsoft YaHei"/>
+                <a:cs typeface="Segoe UI"/>
               </a:rPr>
               <a:t>Cinema 4D</a:t>
             </a:r>
@@ -12140,6 +13415,7 @@
                 </a:solidFill>
                 <a:latin typeface="Segoe UI"/>
                 <a:ea typeface="Microsoft YaHei"/>
+                <a:cs typeface="Segoe UI"/>
               </a:rPr>
               <a:t>Katana</a:t>
             </a:r>
@@ -12248,6 +13524,7 @@
                 </a:solidFill>
                 <a:latin typeface="Segoe UI"/>
                 <a:ea typeface="Microsoft YaHei"/>
+                <a:cs typeface="Segoe UI"/>
               </a:rPr>
               <a:t>Marmoset</a:t>
             </a:r>
@@ -12356,6 +13633,7 @@
                 </a:solidFill>
                 <a:latin typeface="Segoe UI"/>
                 <a:ea typeface="Microsoft YaHei"/>
+                <a:cs typeface="Segoe UI"/>
               </a:rPr>
               <a:t>Substance</a:t>
             </a:r>
@@ -12393,6 +13671,7 @@
                 </a:solidFill>
                 <a:latin typeface="Segoe UI"/>
                 <a:ea typeface="Microsoft YaHei"/>
+                <a:cs typeface="Segoe UI"/>
               </a:rPr>
               <a:t>DCC-MCP 框架介绍</a:t>
             </a:r>
@@ -12430,8 +13709,9 @@
                 </a:solidFill>
                 <a:latin typeface="Segoe UI"/>
                 <a:ea typeface="Microsoft YaHei"/>
+                <a:cs typeface="Segoe UI"/>
               </a:rPr>
-              <a:t>07 / 14</a:t>
+              <a:t>07 / 16</a:t>
             </a:r>
           </a:p>
         </p:txBody>
@@ -12529,6 +13809,7 @@
                 </a:solidFill>
                 <a:latin typeface="Segoe UI"/>
                 <a:ea typeface="Microsoft YaHei"/>
+                <a:cs typeface="Segoe UI"/>
               </a:rPr>
               <a:t>真实案例</a:t>
             </a:r>
@@ -12681,6 +13962,7 @@
                 </a:solidFill>
                 <a:latin typeface="Segoe UI"/>
                 <a:ea typeface="Microsoft YaHei"/>
+                <a:cs typeface="Segoe UI"/>
               </a:rPr>
               <a:t>Blender 螺旋星系</a:t>
             </a:r>
@@ -12789,6 +14071,7 @@
                 </a:solidFill>
                 <a:latin typeface="Segoe UI"/>
                 <a:ea typeface="Microsoft YaHei"/>
+                <a:cs typeface="Segoe UI"/>
               </a:rPr>
               <a:t>Marmoset PBR 材质</a:t>
             </a:r>
@@ -12897,6 +14180,7 @@
                 </a:solidFill>
                 <a:latin typeface="Segoe UI"/>
                 <a:ea typeface="Microsoft YaHei"/>
+                <a:cs typeface="Segoe UI"/>
               </a:rPr>
               <a:t>Hunyuan 3D 生成</a:t>
             </a:r>
@@ -13005,6 +14289,7 @@
                 </a:solidFill>
                 <a:latin typeface="Segoe UI"/>
                 <a:ea typeface="Microsoft YaHei"/>
+                <a:cs typeface="Segoe UI"/>
               </a:rPr>
               <a:t>ZBrush 重拓扑</a:t>
             </a:r>
@@ -13042,6 +14327,7 @@
                 </a:solidFill>
                 <a:latin typeface="Segoe UI"/>
                 <a:ea typeface="Microsoft YaHei"/>
+                <a:cs typeface="Segoe UI"/>
               </a:rPr>
               <a:t>DCC-MCP 框架介绍</a:t>
             </a:r>
@@ -13079,8 +14365,9 @@
                 </a:solidFill>
                 <a:latin typeface="Segoe UI"/>
                 <a:ea typeface="Microsoft YaHei"/>
+                <a:cs typeface="Segoe UI"/>
               </a:rPr>
-              <a:t>08 / 14</a:t>
+              <a:t>08 / 16</a:t>
             </a:r>
           </a:p>
         </p:txBody>
@@ -13149,20 +14436,58 @@
       </p:sp>
       <p:sp>
         <p:nvSpPr>
-          <p:cNvPr id="3" name="Rectangle 2"/>
+          <p:cNvPr id="3" name="TextBox 2"/>
+          <p:cNvSpPr txBox="1"/>
+          <p:nvPr/>
+        </p:nvSpPr>
+        <p:spPr>
+          <a:xfrm>
+            <a:off x="822960" y="502920"/>
+            <a:ext cx="10515600" cy="685800"/>
+          </a:xfrm>
+          <a:prstGeom prst="rect">
+            <a:avLst/>
+          </a:prstGeom>
+          <a:noFill/>
+          <a:effectLst/>
+        </p:spPr>
+        <p:txBody>
+          <a:bodyPr wrap="square" lIns="50800" rIns="50800">
+            <a:spAutoFit/>
+          </a:bodyPr>
+          <a:lstStyle/>
+          <a:p>
+            <a:pPr algn="l"/>
+            <a:r>
+              <a:rPr sz="2800" b="1">
+                <a:solidFill>
+                  <a:srgbClr val="E8ECF2"/>
+                </a:solidFill>
+                <a:latin typeface="Segoe UI"/>
+                <a:ea typeface="Microsoft YaHei"/>
+                <a:cs typeface="Segoe UI"/>
+              </a:rPr>
+              <a:t>本项目：dcc-mcp-PowerPoint 管线</a:t>
+            </a:r>
+          </a:p>
+        </p:txBody>
+      </p:sp>
+      <p:sp>
+        <p:nvSpPr>
+          <p:cNvPr id="4" name="Rectangle 3"/>
           <p:cNvSpPr/>
           <p:nvPr/>
         </p:nvSpPr>
         <p:spPr>
           <a:xfrm>
-            <a:off x="0" y="0"/>
-            <a:ext cx="12191695" cy="6858000"/>
+            <a:off x="822960" y="1298448"/>
+            <a:ext cx="822960" cy="44450"/>
           </a:xfrm>
           <a:prstGeom prst="rect">
             <a:avLst/>
           </a:prstGeom>
           <a:solidFill>
-            <a:srgbClr val="171F2E"/>
+            <a:srgbClr val="4D9DE0"/>
           </a:solidFill>
           <a:ln>
             <a:noFill/>
@@ -13184,32 +14509,34 @@
           </a:fontRef>
         </p:style>
         <p:txBody>
-          <a:bodyPr rtlCol="0" anchor="ctr"/>
-          <a:lstStyle/>
-          <a:p>
-            <a:pPr algn="ctr"/>
-          </a:p>
-        </p:txBody>
-      </p:sp>
-      <p:sp>
-        <p:nvSpPr>
-          <p:cNvPr id="4" name="Oval 3"/>
+          <a:bodyPr rtlCol="0" anchor="ctr" wrap="square"/>
+          <a:lstStyle/>
+          <a:p>
+            <a:pPr algn="ctr"/>
+          </a:p>
+        </p:txBody>
+      </p:sp>
+      <p:sp>
+        <p:nvSpPr>
+          <p:cNvPr id="5" name="Oval 4"/>
           <p:cNvSpPr/>
           <p:nvPr/>
         </p:nvSpPr>
         <p:spPr>
           <a:xfrm>
-            <a:off x="9601200" y="320040"/>
-            <a:ext cx="2468880" cy="2468880"/>
+            <a:off x="2148840" y="1819656"/>
+            <a:ext cx="384048" cy="384048"/>
           </a:xfrm>
           <a:prstGeom prst="ellipse">
             <a:avLst/>
           </a:prstGeom>
           <a:solidFill>
-            <a:srgbClr val="223047"/>
+            <a:srgbClr val="171F2E"/>
           </a:solidFill>
-          <a:ln>
-            <a:noFill/>
+          <a:ln w="15240">
+            <a:solidFill>
+              <a:srgbClr val="4D9DE0"/>
+            </a:solidFill>
           </a:ln>
           <a:effectLst/>
         </p:spPr>
@@ -13228,66 +14555,42 @@
           </a:fontRef>
         </p:style>
         <p:txBody>
-          <a:bodyPr rtlCol="0" anchor="ctr"/>
-          <a:lstStyle/>
-          <a:p>
-            <a:pPr algn="ctr"/>
-          </a:p>
-        </p:txBody>
-      </p:sp>
-      <p:sp>
-        <p:nvSpPr>
-          <p:cNvPr id="5" name="TextBox 4"/>
-          <p:cNvSpPr txBox="1"/>
-          <p:nvPr/>
-        </p:nvSpPr>
-        <p:spPr>
-          <a:xfrm>
-            <a:off x="640080" y="640080"/>
-            <a:ext cx="4572000" cy="3840480"/>
-          </a:xfrm>
-          <a:prstGeom prst="rect">
-            <a:avLst/>
-          </a:prstGeom>
-          <a:noFill/>
-          <a:effectLst/>
-        </p:spPr>
-        <p:txBody>
-          <a:bodyPr wrap="square" lIns="50800" rIns="50800">
-            <a:spAutoFit/>
-          </a:bodyPr>
-          <a:lstStyle/>
-          <a:p>
-            <a:pPr algn="l"/>
-            <a:r>
-              <a:rPr sz="20000" b="1">
-                <a:solidFill>
-                  <a:srgbClr val="223047"/>
+          <a:bodyPr rtlCol="0" anchor="ctr" wrap="square" lIns="101600" rIns="101600" tIns="76200" bIns="76200"/>
+          <a:lstStyle/>
+          <a:p>
+            <a:pPr algn="ctr"/>
+            <a:r>
+              <a:rPr sz="1200" b="1">
+                <a:solidFill>
+                  <a:srgbClr val="4D9DE0"/>
                 </a:solidFill>
                 <a:latin typeface="Segoe UI"/>
                 <a:ea typeface="Microsoft YaHei"/>
+                <a:cs typeface="Segoe UI"/>
               </a:rPr>
-              <a:t>02</a:t>
-            </a:r>
-          </a:p>
-        </p:txBody>
-      </p:sp>
-      <p:sp>
-        <p:nvSpPr>
-          <p:cNvPr id="6" name="Rectangle 5"/>
+              <a:t>1</a:t>
+            </a:r>
+          </a:p>
+        </p:txBody>
+      </p:sp>
+      <p:sp>
+        <p:nvSpPr>
+          <p:cNvPr id="6" name="Rounded Rectangle 5"/>
           <p:cNvSpPr/>
           <p:nvPr/>
         </p:nvSpPr>
         <p:spPr>
           <a:xfrm>
-            <a:off x="822960" y="2788920"/>
-            <a:ext cx="164592" cy="1097280"/>
-          </a:xfrm>
-          <a:prstGeom prst="rect">
-            <a:avLst/>
+            <a:off x="2788920" y="1673352"/>
+            <a:ext cx="8412480" cy="713232"/>
+          </a:xfrm>
+          <a:prstGeom prst="roundRect">
+            <a:avLst>
+              <a:gd name="adj" fmla="val 10000"/>
+            </a:avLst>
           </a:prstGeom>
           <a:solidFill>
-            <a:srgbClr val="7FC8A9"/>
+            <a:srgbClr val="1E2A3D"/>
           </a:solidFill>
           <a:ln>
             <a:noFill/>
@@ -13309,23 +14612,526 @@
           </a:fontRef>
         </p:style>
         <p:txBody>
-          <a:bodyPr rtlCol="0" anchor="ctr" wrap="square"/>
-          <a:lstStyle/>
-          <a:p>
-            <a:pPr algn="ctr"/>
-          </a:p>
-        </p:txBody>
-      </p:sp>
-      <p:sp>
-        <p:nvSpPr>
-          <p:cNvPr id="7" name="TextBox 6"/>
+          <a:bodyPr rtlCol="0" anchor="ctr" wrap="square" lIns="101600" rIns="101600" tIns="76200" bIns="76200"/>
+          <a:lstStyle/>
+          <a:p>
+            <a:pPr algn="ctr"/>
+            <a:r>
+              <a:rPr sz="1450" b="0">
+                <a:solidFill>
+                  <a:srgbClr val="E8ECF2"/>
+                </a:solidFill>
+                <a:latin typeface="Segoe UI"/>
+                <a:ea typeface="Microsoft YaHei"/>
+                <a:cs typeface="Segoe UI"/>
+              </a:rPr>
+              <a:t>Deck IR 契约（office-ir/1.0，镜像 dcc-mcp-office-ir）</a:t>
+            </a:r>
+          </a:p>
+        </p:txBody>
+      </p:sp>
+      <p:sp>
+        <p:nvSpPr>
+          <p:cNvPr id="7" name="Oval 6"/>
+          <p:cNvSpPr/>
+          <p:nvPr/>
+        </p:nvSpPr>
+        <p:spPr>
+          <a:xfrm>
+            <a:off x="2148840" y="2688336"/>
+            <a:ext cx="384048" cy="384048"/>
+          </a:xfrm>
+          <a:prstGeom prst="ellipse">
+            <a:avLst/>
+          </a:prstGeom>
+          <a:solidFill>
+            <a:srgbClr val="171F2E"/>
+          </a:solidFill>
+          <a:ln w="15240">
+            <a:solidFill>
+              <a:srgbClr val="4D9DE0"/>
+            </a:solidFill>
+          </a:ln>
+          <a:effectLst/>
+        </p:spPr>
+        <p:style>
+          <a:lnRef idx="1">
+            <a:schemeClr val="accent1"/>
+          </a:lnRef>
+          <a:fillRef idx="3">
+            <a:schemeClr val="accent1"/>
+          </a:fillRef>
+          <a:effectRef idx="2">
+            <a:schemeClr val="accent1"/>
+          </a:effectRef>
+          <a:fontRef idx="minor">
+            <a:schemeClr val="lt1"/>
+          </a:fontRef>
+        </p:style>
+        <p:txBody>
+          <a:bodyPr rtlCol="0" anchor="ctr" wrap="square" lIns="101600" rIns="101600" tIns="76200" bIns="76200"/>
+          <a:lstStyle/>
+          <a:p>
+            <a:pPr algn="ctr"/>
+            <a:r>
+              <a:rPr sz="1200" b="1">
+                <a:solidFill>
+                  <a:srgbClr val="4D9DE0"/>
+                </a:solidFill>
+                <a:latin typeface="Segoe UI"/>
+                <a:ea typeface="Microsoft YaHei"/>
+                <a:cs typeface="Segoe UI"/>
+              </a:rPr>
+              <a:t>2</a:t>
+            </a:r>
+          </a:p>
+        </p:txBody>
+      </p:sp>
+      <p:sp>
+        <p:nvSpPr>
+          <p:cNvPr id="8" name="Rounded Rectangle 7"/>
+          <p:cNvSpPr/>
+          <p:nvPr/>
+        </p:nvSpPr>
+        <p:spPr>
+          <a:xfrm>
+            <a:off x="2788920" y="2542032"/>
+            <a:ext cx="8412480" cy="713232"/>
+          </a:xfrm>
+          <a:prstGeom prst="roundRect">
+            <a:avLst>
+              <a:gd name="adj" fmla="val 10000"/>
+            </a:avLst>
+          </a:prstGeom>
+          <a:solidFill>
+            <a:srgbClr val="1E2A3D"/>
+          </a:solidFill>
+          <a:ln>
+            <a:noFill/>
+          </a:ln>
+          <a:effectLst/>
+        </p:spPr>
+        <p:style>
+          <a:lnRef idx="1">
+            <a:schemeClr val="accent1"/>
+          </a:lnRef>
+          <a:fillRef idx="3">
+            <a:schemeClr val="accent1"/>
+          </a:fillRef>
+          <a:effectRef idx="2">
+            <a:schemeClr val="accent1"/>
+          </a:effectRef>
+          <a:fontRef idx="minor">
+            <a:schemeClr val="lt1"/>
+          </a:fontRef>
+        </p:style>
+        <p:txBody>
+          <a:bodyPr rtlCol="0" anchor="ctr" wrap="square" lIns="101600" rIns="101600" tIns="76200" bIns="76200"/>
+          <a:lstStyle/>
+          <a:p>
+            <a:pPr algn="ctr"/>
+            <a:r>
+              <a:rPr sz="1450" b="0">
+                <a:solidFill>
+                  <a:srgbClr val="E8ECF2"/>
+                </a:solidFill>
+                <a:latin typeface="Segoe UI"/>
+                <a:ea typeface="Microsoft YaHei"/>
+                <a:cs typeface="Segoe UI"/>
+              </a:rPr>
+              <a:t>dcc-office-host（C#，零 NuGet）：Open XML 编译 · 路径寻址检查</a:t>
+            </a:r>
+          </a:p>
+        </p:txBody>
+      </p:sp>
+      <p:sp>
+        <p:nvSpPr>
+          <p:cNvPr id="9" name="Oval 8"/>
+          <p:cNvSpPr/>
+          <p:nvPr/>
+        </p:nvSpPr>
+        <p:spPr>
+          <a:xfrm>
+            <a:off x="2148840" y="3557016"/>
+            <a:ext cx="384048" cy="384048"/>
+          </a:xfrm>
+          <a:prstGeom prst="ellipse">
+            <a:avLst/>
+          </a:prstGeom>
+          <a:solidFill>
+            <a:srgbClr val="171F2E"/>
+          </a:solidFill>
+          <a:ln w="15240">
+            <a:solidFill>
+              <a:srgbClr val="4D9DE0"/>
+            </a:solidFill>
+          </a:ln>
+          <a:effectLst/>
+        </p:spPr>
+        <p:style>
+          <a:lnRef idx="1">
+            <a:schemeClr val="accent1"/>
+          </a:lnRef>
+          <a:fillRef idx="3">
+            <a:schemeClr val="accent1"/>
+          </a:fillRef>
+          <a:effectRef idx="2">
+            <a:schemeClr val="accent1"/>
+          </a:effectRef>
+          <a:fontRef idx="minor">
+            <a:schemeClr val="lt1"/>
+          </a:fontRef>
+        </p:style>
+        <p:txBody>
+          <a:bodyPr rtlCol="0" anchor="ctr" wrap="square" lIns="101600" rIns="101600" tIns="76200" bIns="76200"/>
+          <a:lstStyle/>
+          <a:p>
+            <a:pPr algn="ctr"/>
+            <a:r>
+              <a:rPr sz="1200" b="1">
+                <a:solidFill>
+                  <a:srgbClr val="4D9DE0"/>
+                </a:solidFill>
+                <a:latin typeface="Segoe UI"/>
+                <a:ea typeface="Microsoft YaHei"/>
+                <a:cs typeface="Segoe UI"/>
+              </a:rPr>
+              <a:t>3</a:t>
+            </a:r>
+          </a:p>
+        </p:txBody>
+      </p:sp>
+      <p:sp>
+        <p:nvSpPr>
+          <p:cNvPr id="10" name="Rounded Rectangle 9"/>
+          <p:cNvSpPr/>
+          <p:nvPr/>
+        </p:nvSpPr>
+        <p:spPr>
+          <a:xfrm>
+            <a:off x="2788920" y="3410712"/>
+            <a:ext cx="8412480" cy="713232"/>
+          </a:xfrm>
+          <a:prstGeom prst="roundRect">
+            <a:avLst>
+              <a:gd name="adj" fmla="val 10000"/>
+            </a:avLst>
+          </a:prstGeom>
+          <a:solidFill>
+            <a:srgbClr val="1E2A3D"/>
+          </a:solidFill>
+          <a:ln>
+            <a:noFill/>
+          </a:ln>
+          <a:effectLst/>
+        </p:spPr>
+        <p:style>
+          <a:lnRef idx="1">
+            <a:schemeClr val="accent1"/>
+          </a:lnRef>
+          <a:fillRef idx="3">
+            <a:schemeClr val="accent1"/>
+          </a:fillRef>
+          <a:effectRef idx="2">
+            <a:schemeClr val="accent1"/>
+          </a:effectRef>
+          <a:fontRef idx="minor">
+            <a:schemeClr val="lt1"/>
+          </a:fontRef>
+        </p:style>
+        <p:txBody>
+          <a:bodyPr rtlCol="0" anchor="ctr" wrap="square" lIns="101600" rIns="101600" tIns="76200" bIns="76200"/>
+          <a:lstStyle/>
+          <a:p>
+            <a:pPr algn="ctr"/>
+            <a:r>
+              <a:rPr sz="1450" b="0">
+                <a:solidFill>
+                  <a:srgbClr val="E8ECF2"/>
+                </a:solidFill>
+                <a:latin typeface="Segoe UI"/>
+                <a:ea typeface="Microsoft YaHei"/>
+                <a:cs typeface="Segoe UI"/>
+              </a:rPr>
+              <a:t>桌面 COM 渲染：PDF + 逐页 PNG（DispatchEx 专用实例）</a:t>
+            </a:r>
+          </a:p>
+        </p:txBody>
+      </p:sp>
+      <p:sp>
+        <p:nvSpPr>
+          <p:cNvPr id="11" name="Oval 10"/>
+          <p:cNvSpPr/>
+          <p:nvPr/>
+        </p:nvSpPr>
+        <p:spPr>
+          <a:xfrm>
+            <a:off x="2148840" y="4425696"/>
+            <a:ext cx="384048" cy="384048"/>
+          </a:xfrm>
+          <a:prstGeom prst="ellipse">
+            <a:avLst/>
+          </a:prstGeom>
+          <a:solidFill>
+            <a:srgbClr val="171F2E"/>
+          </a:solidFill>
+          <a:ln w="15240">
+            <a:solidFill>
+              <a:srgbClr val="4D9DE0"/>
+            </a:solidFill>
+          </a:ln>
+          <a:effectLst/>
+        </p:spPr>
+        <p:style>
+          <a:lnRef idx="1">
+            <a:schemeClr val="accent1"/>
+          </a:lnRef>
+          <a:fillRef idx="3">
+            <a:schemeClr val="accent1"/>
+          </a:fillRef>
+          <a:effectRef idx="2">
+            <a:schemeClr val="accent1"/>
+          </a:effectRef>
+          <a:fontRef idx="minor">
+            <a:schemeClr val="lt1"/>
+          </a:fontRef>
+        </p:style>
+        <p:txBody>
+          <a:bodyPr rtlCol="0" anchor="ctr" wrap="square" lIns="101600" rIns="101600" tIns="76200" bIns="76200"/>
+          <a:lstStyle/>
+          <a:p>
+            <a:pPr algn="ctr"/>
+            <a:r>
+              <a:rPr sz="1200" b="1">
+                <a:solidFill>
+                  <a:srgbClr val="4D9DE0"/>
+                </a:solidFill>
+                <a:latin typeface="Segoe UI"/>
+                <a:ea typeface="Microsoft YaHei"/>
+                <a:cs typeface="Segoe UI"/>
+              </a:rPr>
+              <a:t>4</a:t>
+            </a:r>
+          </a:p>
+        </p:txBody>
+      </p:sp>
+      <p:sp>
+        <p:nvSpPr>
+          <p:cNvPr id="12" name="Rounded Rectangle 11"/>
+          <p:cNvSpPr/>
+          <p:nvPr/>
+        </p:nvSpPr>
+        <p:spPr>
+          <a:xfrm>
+            <a:off x="2788920" y="4279392"/>
+            <a:ext cx="8412480" cy="713232"/>
+          </a:xfrm>
+          <a:prstGeom prst="roundRect">
+            <a:avLst>
+              <a:gd name="adj" fmla="val 10000"/>
+            </a:avLst>
+          </a:prstGeom>
+          <a:solidFill>
+            <a:srgbClr val="1E2A3D"/>
+          </a:solidFill>
+          <a:ln>
+            <a:noFill/>
+          </a:ln>
+          <a:effectLst/>
+        </p:spPr>
+        <p:style>
+          <a:lnRef idx="1">
+            <a:schemeClr val="accent1"/>
+          </a:lnRef>
+          <a:fillRef idx="3">
+            <a:schemeClr val="accent1"/>
+          </a:fillRef>
+          <a:effectRef idx="2">
+            <a:schemeClr val="accent1"/>
+          </a:effectRef>
+          <a:fontRef idx="minor">
+            <a:schemeClr val="lt1"/>
+          </a:fontRef>
+        </p:style>
+        <p:txBody>
+          <a:bodyPr rtlCol="0" anchor="ctr" wrap="square" lIns="101600" rIns="101600" tIns="76200" bIns="76200"/>
+          <a:lstStyle/>
+          <a:p>
+            <a:pPr algn="ctr"/>
+            <a:r>
+              <a:rPr sz="1450" b="0">
+                <a:solidFill>
+                  <a:srgbClr val="E8ECF2"/>
+                </a:solidFill>
+                <a:latin typeface="Segoe UI"/>
+                <a:ea typeface="Microsoft YaHei"/>
+                <a:cs typeface="Segoe UI"/>
+              </a:rPr>
+              <a:t>自研 issues 分析器：真实字体度量溢出 + WCAG 对比度</a:t>
+            </a:r>
+          </a:p>
+        </p:txBody>
+      </p:sp>
+      <p:sp>
+        <p:nvSpPr>
+          <p:cNvPr id="13" name="Oval 12"/>
+          <p:cNvSpPr/>
+          <p:nvPr/>
+        </p:nvSpPr>
+        <p:spPr>
+          <a:xfrm>
+            <a:off x="2148840" y="5294376"/>
+            <a:ext cx="384048" cy="384048"/>
+          </a:xfrm>
+          <a:prstGeom prst="ellipse">
+            <a:avLst/>
+          </a:prstGeom>
+          <a:solidFill>
+            <a:srgbClr val="171F2E"/>
+          </a:solidFill>
+          <a:ln w="15240">
+            <a:solidFill>
+              <a:srgbClr val="4D9DE0"/>
+            </a:solidFill>
+          </a:ln>
+          <a:effectLst/>
+        </p:spPr>
+        <p:style>
+          <a:lnRef idx="1">
+            <a:schemeClr val="accent1"/>
+          </a:lnRef>
+          <a:fillRef idx="3">
+            <a:schemeClr val="accent1"/>
+          </a:fillRef>
+          <a:effectRef idx="2">
+            <a:schemeClr val="accent1"/>
+          </a:effectRef>
+          <a:fontRef idx="minor">
+            <a:schemeClr val="lt1"/>
+          </a:fontRef>
+        </p:style>
+        <p:txBody>
+          <a:bodyPr rtlCol="0" anchor="ctr" wrap="square" lIns="101600" rIns="101600" tIns="76200" bIns="76200"/>
+          <a:lstStyle/>
+          <a:p>
+            <a:pPr algn="ctr"/>
+            <a:r>
+              <a:rPr sz="1200" b="1">
+                <a:solidFill>
+                  <a:srgbClr val="4D9DE0"/>
+                </a:solidFill>
+                <a:latin typeface="Segoe UI"/>
+                <a:ea typeface="Microsoft YaHei"/>
+                <a:cs typeface="Segoe UI"/>
+              </a:rPr>
+              <a:t>5</a:t>
+            </a:r>
+          </a:p>
+        </p:txBody>
+      </p:sp>
+      <p:sp>
+        <p:nvSpPr>
+          <p:cNvPr id="14" name="Rounded Rectangle 13"/>
+          <p:cNvSpPr/>
+          <p:nvPr/>
+        </p:nvSpPr>
+        <p:spPr>
+          <a:xfrm>
+            <a:off x="2788920" y="5148072"/>
+            <a:ext cx="8412480" cy="713232"/>
+          </a:xfrm>
+          <a:prstGeom prst="roundRect">
+            <a:avLst>
+              <a:gd name="adj" fmla="val 10000"/>
+            </a:avLst>
+          </a:prstGeom>
+          <a:solidFill>
+            <a:srgbClr val="1E2A3D"/>
+          </a:solidFill>
+          <a:ln>
+            <a:noFill/>
+          </a:ln>
+          <a:effectLst/>
+        </p:spPr>
+        <p:style>
+          <a:lnRef idx="1">
+            <a:schemeClr val="accent1"/>
+          </a:lnRef>
+          <a:fillRef idx="3">
+            <a:schemeClr val="accent1"/>
+          </a:fillRef>
+          <a:effectRef idx="2">
+            <a:schemeClr val="accent1"/>
+          </a:effectRef>
+          <a:fontRef idx="minor">
+            <a:schemeClr val="lt1"/>
+          </a:fontRef>
+        </p:style>
+        <p:txBody>
+          <a:bodyPr rtlCol="0" anchor="ctr" wrap="square" lIns="101600" rIns="101600" tIns="76200" bIns="76200"/>
+          <a:lstStyle/>
+          <a:p>
+            <a:pPr algn="ctr"/>
+            <a:r>
+              <a:rPr sz="1450" b="0">
+                <a:solidFill>
+                  <a:srgbClr val="E8ECF2"/>
+                </a:solidFill>
+                <a:latin typeface="Segoe UI"/>
+                <a:ea typeface="Microsoft YaHei"/>
+                <a:cs typeface="Segoe UI"/>
+              </a:rPr>
+              <a:t>像素级视觉 QA：覆盖率 + 边缘出血（背景自适应）</a:t>
+            </a:r>
+          </a:p>
+        </p:txBody>
+      </p:sp>
+      <p:cxnSp>
+        <p:nvCxnSpPr>
+          <p:cNvPr id="15" name="Connector 14"/>
+          <p:cNvCxnSpPr/>
+          <p:nvPr/>
+        </p:nvCxnSpPr>
+        <p:spPr>
+          <a:xfrm>
+            <a:off x="2340864" y="2194560"/>
+            <a:ext cx="0" cy="3474719"/>
+          </a:xfrm>
+          <a:prstGeom prst="line">
+            <a:avLst/>
+          </a:prstGeom>
+          <a:ln>
+            <a:solidFill>
+              <a:srgbClr val="4D9DE0"/>
+            </a:solidFill>
+          </a:ln>
+          <a:effectLst/>
+        </p:spPr>
+        <p:style>
+          <a:lnRef idx="2">
+            <a:schemeClr val="accent1"/>
+          </a:lnRef>
+          <a:fillRef idx="0">
+            <a:schemeClr val="accent1"/>
+          </a:fillRef>
+          <a:effectRef idx="1">
+            <a:schemeClr val="accent1"/>
+          </a:effectRef>
+          <a:fontRef idx="minor">
+            <a:schemeClr val="tx1"/>
+          </a:fontRef>
+        </p:style>
+      </p:cxnSp>
+      <p:sp>
+        <p:nvSpPr>
+          <p:cNvPr id="16" name="TextBox 15"/>
           <p:cNvSpPr txBox="1"/>
           <p:nvPr/>
         </p:nvSpPr>
         <p:spPr>
           <a:xfrm>
-            <a:off x="1188720" y="2743200"/>
-            <a:ext cx="10058400" cy="1280160"/>
+            <a:off x="822960" y="6473952"/>
+            <a:ext cx="7315200" cy="274320"/>
           </a:xfrm>
           <a:prstGeom prst="rect">
             <a:avLst/>
@@ -13341,49 +15147,13 @@
           <a:p>
             <a:pPr algn="l"/>
             <a:r>
-              <a:rPr sz="4400" b="1">
-                <a:solidFill>
-                  <a:srgbClr val="E8ECF2"/>
+              <a:rPr sz="1000" b="0">
+                <a:solidFill>
+                  <a:srgbClr val="9AA7BC"/>
                 </a:solidFill>
                 <a:latin typeface="Segoe UI"/>
                 <a:ea typeface="Microsoft YaHei"/>
-              </a:rPr>
-              <a:t>执行模型</a:t>
-            </a:r>
-          </a:p>
-        </p:txBody>
-      </p:sp>
-      <p:sp>
-        <p:nvSpPr>
-          <p:cNvPr id="8" name="TextBox 7"/>
-          <p:cNvSpPr txBox="1"/>
-          <p:nvPr/>
-        </p:nvSpPr>
-        <p:spPr>
-          <a:xfrm>
-            <a:off x="822960" y="6473952"/>
-            <a:ext cx="7315200" cy="274320"/>
-          </a:xfrm>
-          <a:prstGeom prst="rect">
-            <a:avLst/>
-          </a:prstGeom>
-          <a:noFill/>
-          <a:effectLst/>
-        </p:spPr>
-        <p:txBody>
-          <a:bodyPr wrap="square" lIns="50800" rIns="50800">
-            <a:spAutoFit/>
-          </a:bodyPr>
-          <a:lstStyle/>
-          <a:p>
-            <a:pPr algn="l"/>
-            <a:r>
-              <a:rPr sz="1000" b="0">
-                <a:solidFill>
-                  <a:srgbClr val="9AA7BC"/>
-                </a:solidFill>
-                <a:latin typeface="Segoe UI"/>
-                <a:ea typeface="Microsoft YaHei"/>
+                <a:cs typeface="Segoe UI"/>
               </a:rPr>
               <a:t>DCC-MCP 框架介绍</a:t>
             </a:r>
@@ -13392,7 +15162,7 @@
       </p:sp>
       <p:sp>
         <p:nvSpPr>
-          <p:cNvPr id="9" name="TextBox 8"/>
+          <p:cNvPr id="17" name="TextBox 16"/>
           <p:cNvSpPr txBox="1"/>
           <p:nvPr/>
         </p:nvSpPr>
@@ -13421,8 +15191,9 @@
                 </a:solidFill>
                 <a:latin typeface="Segoe UI"/>
                 <a:ea typeface="Microsoft YaHei"/>
+                <a:cs typeface="Segoe UI"/>
               </a:rPr>
-              <a:t>09 / 14</a:t>
+              <a:t>09 / 16</a:t>
             </a:r>
           </a:p>
         </p:txBody>

</xml_diff>